<commit_message>
Day 1: Integrate Dan's research — enterprise stats, CISO concerns, competitive positioning
Speaker notes updated on 7 key slides:
- Slide 4 (Model Family): 300K customers, 24% banks, market context
- Slide 8 (What Makes Claude Different): TELUS 500K hrs, Zapier 89%,
  Bridgewater 50-70% faster, competitive positioning vs Copilot
- Slide 11 (Capabilities): 82% weekly/5% at scale gap, Newfront 60%
  savings, Cognizant 350K employees, 77% coding automation
- Slide 44 (When NOT to Use AI): MIT 95% failure rate, 7 root causes,
  Zillow $500M loss, 42% kill rate
- Slide 45 (Security): 5 CISO objections with stats (76% visibility
  gaps, 58% unprepared for board, shadow AI), Anthropic mitigations
- Slide 81 (What We Covered): Stats-backed recap
- Slide 82 (Key Takeaways): MIT failure data, competitive gap framing

All stats sourced: Wharton, MIT, McKinsey, Anthropic, Checkmarx, ISG
Research by Dan (Perplexity sonar-pro, 8 queries)
</commit_message>
<xml_diff>
--- a/slides/Day1_Claude_for_Business.pptx
+++ b/slides/Day1_Claude_for_Business.pptx
@@ -685,107 +685,49 @@
           <a:lstStyle/>
           <a:p>
             <a:r>
-              <a:t>TIME: 3 min</a:t>
-            </a:r>
-          </a:p>
-          <a:p>
-            <a:endParaRPr/>
-          </a:p>
-          <a:p>
-            <a:r>
-              <a:t>OPEN WITH:</a:t>
-            </a:r>
-          </a:p>
-          <a:p>
-            <a:r>
-              <a:t>   Let me clarify what Claude can actually do - some older limitations no longer apply.</a:t>
-            </a:r>
-          </a:p>
-          <a:p>
-            <a:endParaRPr/>
-          </a:p>
-          <a:p>
-            <a:r>
-              <a:t>KEY POINTS:</a:t>
-            </a:r>
-          </a:p>
-          <a:p>
-            <a:r>
-              <a:t>   * Claude NOW has web search - can get current news, market data, weather, sports scores</a:t>
-            </a:r>
-          </a:p>
-          <a:p>
-            <a:r>
-              <a:t>   * Claude has memory across conversations - remembers context from previous chats</a:t>
-            </a:r>
-          </a:p>
-          <a:p>
-            <a:r>
-              <a:t>   * Knowledge cutoff is May 2025, but web search fills gaps for current information</a:t>
-            </a:r>
-          </a:p>
-          <a:p>
-            <a:r>
-              <a:t>   * 200K context window = ~500 pages of text in one conversation</a:t>
-            </a:r>
-          </a:p>
-          <a:p>
-            <a:r>
-              <a:t>   * Can analyze multiple files: PDFs, images, CSV, code - upload and ask</a:t>
-            </a:r>
-          </a:p>
-          <a:p>
-            <a:r>
-              <a:t>   * Best practices: Upload docs for highest accuracy (web search is backup), always verify critical facts (hallucination still possible), use Projects for ongoing work</a:t>
-            </a:r>
-          </a:p>
-          <a:p>
-            <a:r>
-              <a:t>   * The key shift: Claude is more capable than most people realize, but verification still matters</a:t>
-            </a:r>
-          </a:p>
-          <a:p>
-            <a:endParaRPr/>
-          </a:p>
-          <a:p>
-            <a:r>
-              <a:t>ASK THE CLASS:</a:t>
-            </a:r>
-          </a:p>
-          <a:p>
-            <a:r>
-              <a:t>   "What tasks have you avoided with AI because you thought it couldn't access current information?"</a:t>
-            </a:r>
-          </a:p>
-          <a:p>
-            <a:r>
-              <a:t>   [PAUSE for 30-60 seconds]</a:t>
-            </a:r>
-          </a:p>
-          <a:p>
-            <a:endParaRPr/>
-          </a:p>
-          <a:p>
-            <a:r>
-              <a:t>REAL-WORLD EXAMPLE:</a:t>
-            </a:r>
-          </a:p>
-          <a:p>
-            <a:r>
-              <a:t>   You can ask 'What's the current stock price for MSFT?' and Claude will search and tell you. BUT for financial decisions, upload your own data - higher accuracy than web sources.</a:t>
-            </a:r>
-          </a:p>
-          <a:p>
-            <a:endParaRPr/>
-          </a:p>
-          <a:p>
-            <a:r>
-              <a:t>TRANSITION:</a:t>
-            </a:r>
-          </a:p>
-          <a:p>
-            <a:r>
-              <a:t>   Now that you know what's possible, let's talk about Extended Thinking mode</a:t>
+              <a:t>DURATION: 3 min</a:t>
+            </a:r>
+          </a:p>
+          <a:p/>
+          <a:p>
+            <a:r>
+              <a:t>Let me ground these capabilities in real numbers.</a:t>
+            </a:r>
+          </a:p>
+          <a:p/>
+          <a:p>
+            <a:r>
+              <a:t>82 percent of enterprises now use generative AI weekly — that's up from 72 percent just last year. Global AI investment hit $225.8 billion in 2025, literally double the year before. This isn't a trend. This is a phase change.</a:t>
+            </a:r>
+          </a:p>
+          <a:p/>
+          <a:p>
+            <a:r>
+              <a:t>But here's the number that matters: only 5 percent of organizations have integrated AI at scale into their actual workflows. 82 percent are experimenting. 5 percent are operating. That gap — between experimenting and operating — is exactly what today's training closes.</a:t>
+            </a:r>
+          </a:p>
+          <a:p/>
+          <a:p>
+            <a:r>
+              <a:t>Newfront Insurance uses Claude for HR support, contract review, and knowledge management. They achieved 60 percent cost savings and reclaimed one month per year per employee. Not in theory — in production.</a:t>
+            </a:r>
+          </a:p>
+          <a:p/>
+          <a:p>
+            <a:r>
+              <a:t>Cognizant — 350,000 employees — adopted Claude in late 2025 for enterprise AI transformation. When a company that size makes that bet, pay attention.</a:t>
+            </a:r>
+          </a:p>
+          <a:p/>
+          <a:p>
+            <a:r>
+              <a:t>The coding and automation numbers are equally striking: 77 percent automation rate on coding and debugging tasks, the highest of any task category. Development teams report 30 percent faster PR cycles. And employees are 3 times more likely to use AI than their leaders expect — which means if you haven't rolled out a governed AI strategy, your people are already using ungoverned tools.</a:t>
+            </a:r>
+          </a:p>
+          <a:p/>
+          <a:p>
+            <a:r>
+              <a:t>SOURCES: Wharton 2025 AI Report, Vention 2026 Report, McKinsey, Anthropic case studies.</a:t>
             </a:r>
           </a:p>
         </p:txBody>
@@ -4569,107 +4511,49 @@
           <a:lstStyle/>
           <a:p>
             <a:r>
-              <a:t>TIME: 4 min</a:t>
-            </a:r>
-          </a:p>
-          <a:p>
-            <a:endParaRPr/>
-          </a:p>
-          <a:p>
-            <a:r>
-              <a:t>OPEN WITH:</a:t>
-            </a:r>
-          </a:p>
-          <a:p>
-            <a:r>
-              <a:t>   This is Frontier Recognition - knowing when AI can't help. The BCG study showed teams LOST 19% accuracy when they used AI on tasks it's bad at. Boundaries matter.</a:t>
-            </a:r>
-          </a:p>
-          <a:p>
-            <a:endParaRPr/>
-          </a:p>
-          <a:p>
-            <a:r>
-              <a:t>KEY POINTS:</a:t>
-            </a:r>
-          </a:p>
-          <a:p>
-            <a:r>
-              <a:t>   * Frontier Recognition = Skill #6 from our success framework</a:t>
-            </a:r>
-          </a:p>
-          <a:p>
-            <a:r>
-              <a:t>   * AI is a tool, not a decision-maker - you own the output</a:t>
-            </a:r>
-          </a:p>
-          <a:p>
-            <a:r>
-              <a:t>   * Red flag tasks: Legal advice, sensitive data, mission-critical decisions without verification</a:t>
-            </a:r>
-          </a:p>
-          <a:p>
-            <a:r>
-              <a:t>   * Claude CAN now do real-time lookups (news, prices, weather) - but always verify for high-stakes decisions</a:t>
-            </a:r>
-          </a:p>
-          <a:p>
-            <a:r>
-              <a:t>   * Green light tasks: Drafts, brainstorming, summarization, formatting, quick research</a:t>
-            </a:r>
-          </a:p>
-          <a:p>
-            <a:r>
-              <a:t>   * The rule: If you can't verify it or if stakes are high, human owns it (AI assists)</a:t>
-            </a:r>
-          </a:p>
-          <a:p>
-            <a:r>
-              <a:t>   * This prevents the 19% accuracy drop from misuse</a:t>
-            </a:r>
-          </a:p>
-          <a:p>
-            <a:endParaRPr/>
-          </a:p>
-          <a:p>
-            <a:r>
-              <a:t>ASK THE CLASS:</a:t>
-            </a:r>
-          </a:p>
-          <a:p>
-            <a:r>
-              <a:t>   "What's a task in your role where AI should assist but not decide?"</a:t>
-            </a:r>
-          </a:p>
-          <a:p>
-            <a:r>
-              <a:t>   [PAUSE for 30-60 seconds]</a:t>
-            </a:r>
-          </a:p>
-          <a:p>
-            <a:endParaRPr/>
-          </a:p>
-          <a:p>
-            <a:r>
-              <a:t>REAL-WORLD EXAMPLE:</a:t>
-            </a:r>
-          </a:p>
-          <a:p>
-            <a:r>
-              <a:t>   Contract review: Don't ask AI 'Is this contract good to sign?' (legal advice, high stakes). DO ask 'Summarize the key terms and flag any unusual clauses' (draft for lawyer review).</a:t>
-            </a:r>
-          </a:p>
-          <a:p>
-            <a:endParaRPr/>
-          </a:p>
-          <a:p>
-            <a:r>
-              <a:t>TRANSITION:</a:t>
-            </a:r>
-          </a:p>
-          <a:p>
-            <a:r>
-              <a:t>   With boundaries clear, let's practice these prompting skills in a lab</a:t>
+              <a:t>DURATION: 3 min</a:t>
+            </a:r>
+          </a:p>
+          <a:p/>
+          <a:p>
+            <a:r>
+              <a:t>This might be the most important slide in the deck.</a:t>
+            </a:r>
+          </a:p>
+          <a:p/>
+          <a:p>
+            <a:r>
+              <a:t>95 percent of enterprise AI projects fail to reach production. MIT's 2025 study — 150 leaders, 300 deployments. The number one root cause? No clear business problem. Companies buy AI and then figure out what to do with it. That's backwards.</a:t>
+            </a:r>
+          </a:p>
+          <a:p/>
+          <a:p>
+            <a:r>
+              <a:t>The second most common failure: unrealistic timelines. Executives demand 6-month ROI on something that realistically takes 18 to 36 months for full transformation. Quick wins? Absolutely — you can get those in 30 days. But enterprise-wide transformation requires sustained investment.</a:t>
+            </a:r>
+          </a:p>
+          <a:p/>
+          <a:p>
+            <a:r>
+              <a:t>Zillow's AI-powered home-buying algorithm is the cautionary tale. They trusted the model's real estate valuations without sufficient human oversight. Result: $500 million in losses and 25 percent of their workforce laid off.</a:t>
+            </a:r>
+          </a:p>
+          <a:p/>
+          <a:p>
+            <a:r>
+              <a:t>So when should you NOT use AI? When you can't define the success criteria. When the cost of being wrong exceeds the value of being fast. When you don't have a human review step. When the data isn't clean enough to trust.</a:t>
+            </a:r>
+          </a:p>
+          <a:p/>
+          <a:p>
+            <a:r>
+              <a:t>42 percent of firms now drop most AI projects before they reach production — that's up from 17 percent the prior year. Companies are learning that killing bad projects early is smarter than pushing failed experiments into production.</a:t>
+            </a:r>
+          </a:p>
+          <a:p/>
+          <a:p>
+            <a:r>
+              <a:t>The discipline to say "not this, not now" is what separates the 5 percent who succeed from the 95 percent who don't.</a:t>
             </a:r>
           </a:p>
         </p:txBody>
@@ -4739,107 +4623,55 @@
           <a:lstStyle/>
           <a:p>
             <a:r>
-              <a:t>TIME: 3 min</a:t>
-            </a:r>
-          </a:p>
-          <a:p>
-            <a:endParaRPr/>
-          </a:p>
-          <a:p>
-            <a:r>
-              <a:t>OPEN WITH:</a:t>
-            </a:r>
-          </a:p>
-          <a:p>
-            <a:r>
-              <a:t>   Before we dive into labs, let's address the elephant in the room: 'Is it safe to use Claude with company data?'</a:t>
-            </a:r>
-          </a:p>
-          <a:p>
-            <a:endParaRPr/>
-          </a:p>
-          <a:p>
-            <a:r>
-              <a:t>KEY POINTS:</a:t>
-            </a:r>
-          </a:p>
-          <a:p>
-            <a:r>
-              <a:t>   * Your conversations NOT used for training - this is contractual for Enterprise/Team</a:t>
-            </a:r>
-          </a:p>
-          <a:p>
-            <a:r>
-              <a:t>   * SOC 2 Type 2 certified, HIPAA-eligible, GDPR compliant - meets enterprise standards</a:t>
-            </a:r>
-          </a:p>
-          <a:p>
-            <a:r>
-              <a:t>   * Projects data (your custom instructions, uploaded files) stays within your org</a:t>
-            </a:r>
-          </a:p>
-          <a:p>
-            <a:r>
-              <a:t>   * 30-day retention for safety monitoring (abuse, illegal content), then deleted</a:t>
-            </a:r>
-          </a:p>
-          <a:p>
-            <a:r>
-              <a:t>   * Treat it like any cloud tool - don't paste passwords, API keys, SSN, credit cards</a:t>
-            </a:r>
-          </a:p>
-          <a:p>
-            <a:r>
-              <a:t>   * Enterprise plan adds: extended retention controls, SSO, detailed audit logs</a:t>
-            </a:r>
-          </a:p>
-          <a:p>
-            <a:r>
-              <a:t>   * Your IT team: anthropic.com/trust has full security documentation</a:t>
-            </a:r>
-          </a:p>
-          <a:p>
-            <a:endParaRPr/>
-          </a:p>
-          <a:p>
-            <a:r>
-              <a:t>ASK THE CLASS:</a:t>
-            </a:r>
-          </a:p>
-          <a:p>
-            <a:r>
-              <a:t>   "Anyone have security questions before we start working with real data in labs?"</a:t>
-            </a:r>
-          </a:p>
-          <a:p>
-            <a:r>
-              <a:t>   [PAUSE for 30-60 seconds]</a:t>
-            </a:r>
-          </a:p>
-          <a:p>
-            <a:endParaRPr/>
-          </a:p>
-          <a:p>
-            <a:r>
-              <a:t>REAL-WORLD EXAMPLE:</a:t>
-            </a:r>
-          </a:p>
-          <a:p>
-            <a:r>
-              <a:t>   Safe: Upload quarterly report for analysis. Not safe: Paste customer SSNs or employee salaries without anonymizing.</a:t>
-            </a:r>
-          </a:p>
-          <a:p>
-            <a:endParaRPr/>
-          </a:p>
-          <a:p>
-            <a:r>
-              <a:t>TRANSITION:</a:t>
-            </a:r>
-          </a:p>
-          <a:p>
-            <a:r>
-              <a:t>   With security addressed, let's practice with Lab 1</a:t>
+              <a:t>DURATION: 5 min</a:t>
+            </a:r>
+          </a:p>
+          <a:p/>
+          <a:p>
+            <a:r>
+              <a:t>This is the slide that matters to every IT leader and CISO in the room. Let me address the objections head-on.</a:t>
+            </a:r>
+          </a:p>
+          <a:p/>
+          <a:p>
+            <a:r>
+              <a:t>Objection one: "Our data goes to a third party." 76 percent of CISOs cite visibility gaps in GenAI environments. That's a real concern. Here's Anthropic's answer: Claude Enterprise offers data isolation, no-training guarantees on your data, and SOC 2 compliance. Your prompts and outputs are not used to train the model. Period.</a:t>
+            </a:r>
+          </a:p>
+          <a:p/>
+          <a:p>
+            <a:r>
+              <a:t>Objection two: "Shadow AI is already happening." This is the uncomfortable truth. 40 to 60 percent of code output in enterprises is already AI-generated, and much of it is untracked. 70 percent of organizations have more than 40 percent AI-generated code with no governance. The question isn't whether your people are using AI — they are. The question is whether you're governing it or ignoring it.</a:t>
+            </a:r>
+          </a:p>
+          <a:p/>
+          <a:p>
+            <a:r>
+              <a:t>Objection three: "Vibe coding — developers shipping code they don't understand." This is a legitimate risk. The fix isn't banning AI — it's training. Mandatory code reviews, static analysis in the IDE, and CLAUDE.md conventions that enforce your coding standards automatically.</a:t>
+            </a:r>
+          </a:p>
+          <a:p/>
+          <a:p>
+            <a:r>
+              <a:t>Objection four: compliance. SOC 2, HIPAA, FedRAMP. Anthropic's enterprise tier addresses data isolation, vendor audits, and no-retention policies. If Bridgewater Associates — under the strictest financial security standards in the world — trusts Claude, your compliance team can work with this.</a:t>
+            </a:r>
+          </a:p>
+          <a:p/>
+          <a:p>
+            <a:r>
+              <a:t>Objection five: over-privileged agents. Claude Code's permission model is read-only by default. Every file write, every terminal command requires explicit approval. Hooks give you PreToolUse and PostToolUse guardrails — automated gates that can block operations before they execute.</a:t>
+            </a:r>
+          </a:p>
+          <a:p/>
+          <a:p>
+            <a:r>
+              <a:t>The bottom line for your CISO: the risk isn't using AI. The risk is using AI without governance. 58 percent of CISOs feel unprepared to report AI risks to their board. This training — and the frameworks we're teaching — gives you something board-reportable.</a:t>
+            </a:r>
+          </a:p>
+          <a:p/>
+          <a:p>
+            <a:r>
+              <a:t>SOURCES: Checkmarx CISO survey, BeyondIdentity, Sentra, Cerbos enterprise research 2025-2026.</a:t>
             </a:r>
           </a:p>
         </p:txBody>
@@ -5370,74 +5202,43 @@
           <a:lstStyle/>
           <a:p>
             <a:r>
-              <a:t>TIME: 4 min</a:t>
-            </a:r>
-          </a:p>
-          <a:p>
-            <a:endParaRPr/>
-          </a:p>
-          <a:p>
-            <a:r>
-              <a:t>OPEN WITH:</a:t>
-            </a:r>
-          </a:p>
-          <a:p>
-            <a:r>
-              <a:t>   Think of these like cars: economy, mid-size, luxury. Different tools for different jobs.</a:t>
-            </a:r>
-          </a:p>
-          <a:p>
-            <a:endParaRPr/>
-          </a:p>
-          <a:p>
-            <a:r>
-              <a:t>KEY POINTS:</a:t>
-            </a:r>
-          </a:p>
-          <a:p>
-            <a:r>
-              <a:t>   * Haiku: Speed matters - quick summaries, lookups, simple tasks. Cheapest.</a:t>
-            </a:r>
-          </a:p>
-          <a:p>
-            <a:r>
-              <a:t>   * Sonnet: Your daily driver. Handles 90% of work. Good balance of quality and cost.</a:t>
-            </a:r>
-          </a:p>
-          <a:p>
-            <a:r>
-              <a:t>   * Opus: High stakes - board presentations, complex analysis, critical decisions. Most expensive.</a:t>
-            </a:r>
-          </a:p>
-          <a:p>
-            <a:r>
-              <a:t>   * You choose the model for each conversation - can switch mid-project</a:t>
-            </a:r>
-          </a:p>
-          <a:p>
-            <a:endParaRPr/>
-          </a:p>
-          <a:p>
-            <a:r>
-              <a:t>REAL-WORLD EXAMPLE:</a:t>
-            </a:r>
-          </a:p>
-          <a:p>
-            <a:r>
-              <a:t>   This morning I used Haiku to summarize my emails (30 seconds), Sonnet to draft a proposal (5 min), then Opus to review a contract (accuracy critical).</a:t>
-            </a:r>
-          </a:p>
-          <a:p>
-            <a:endParaRPr/>
-          </a:p>
-          <a:p>
-            <a:r>
-              <a:t>TRANSITION:</a:t>
-            </a:r>
-          </a:p>
-          <a:p>
-            <a:r>
-              <a:t>   When should you use each? Let's break it down</a:t>
+              <a:t>DURATION: 4 min</a:t>
+            </a:r>
+          </a:p>
+          <a:p/>
+          <a:p>
+            <a:r>
+              <a:t>Let me start with where Claude sits in the market. Anthropic now has over 300,000 business customers. 24 percent of major banks use Claude. 38 percent of retail and e-commerce chatbots are powered by Claude. 93 percent of companies are using AI in some form, and $225.8 billion was invested globally in AI in 2025 — literally double the year before.</a:t>
+            </a:r>
+          </a:p>
+          <a:p/>
+          <a:p>
+            <a:r>
+              <a:t>So this isn't emerging technology. This is the new infrastructure. And Claude is at the center of enterprise adoption.</a:t>
+            </a:r>
+          </a:p>
+          <a:p/>
+          <a:p>
+            <a:r>
+              <a:t>The model family gives you three tiers. Haiku is the fast, cheap option — use it for simple tasks where speed matters more than depth. Think quick summaries, classification, customer service responses. It responds in under a second and costs a fraction of the larger models.</a:t>
+            </a:r>
+          </a:p>
+          <a:p/>
+          <a:p>
+            <a:r>
+              <a:t>Sonnet is your daily driver. It balances intelligence with speed and cost. For 90 percent of business tasks — writing emails, analyzing documents, creating reports, building spreadsheets — Sonnet is the right choice. Most of what we'll do today uses Sonnet.</a:t>
+            </a:r>
+          </a:p>
+          <a:p/>
+          <a:p>
+            <a:r>
+              <a:t>Opus is the powerhouse. It handles complex reasoning, nuanced analysis, long documents, and multi-step problems. When you need to analyze a 50-page contract, build a financial model, or synthesize research from multiple sources, Opus is worth the extra cost and time. Bridgewater Associates — one of the world's largest hedge funds — uses Opus for investment research, cutting reporting time by 50 to 70 percent.</a:t>
+            </a:r>
+          </a:p>
+          <a:p/>
+          <a:p>
+            <a:r>
+              <a:t>The rule of thumb: start with Sonnet. Upgrade to Opus when the task requires deep reasoning. Use Haiku for high-volume simple tasks.</a:t>
             </a:r>
           </a:p>
         </p:txBody>
@@ -8738,48 +8539,31 @@
           <a:lstStyle/>
           <a:p>
             <a:r>
-              <a:t>TIME: 2 min</a:t>
-            </a:r>
-          </a:p>
-          <a:p>
-            <a:endParaRPr/>
-          </a:p>
-          <a:p>
-            <a:r>
-              <a:t>KEY POINTS:</a:t>
-            </a:r>
-          </a:p>
-          <a:p>
-            <a:r>
-              <a:t>   * You now have the foundation for using Claude effectively</a:t>
-            </a:r>
-          </a:p>
-          <a:p>
-            <a:r>
-              <a:t>   * Morning gave you the theory and framework</a:t>
-            </a:r>
-          </a:p>
-          <a:p>
-            <a:r>
-              <a:t>   * Afternoon gave you practical tools</a:t>
-            </a:r>
-          </a:p>
-          <a:p>
-            <a:r>
-              <a:t>   * Labs gave you hands-on practice</a:t>
-            </a:r>
-          </a:p>
-          <a:p>
-            <a:endParaRPr/>
-          </a:p>
-          <a:p>
-            <a:r>
-              <a:t>TRANSITION:</a:t>
-            </a:r>
-          </a:p>
-          <a:p>
-            <a:r>
-              <a:t>   Five key takeaways to remember</a:t>
+              <a:t>DURATION: 2 min</a:t>
+            </a:r>
+          </a:p>
+          <a:p/>
+          <a:p>
+            <a:r>
+              <a:t>Let's take stock. Today we covered the Claude model family and when to use each tier. We navigated the Claude.ai interface, set up Projects with custom instructions, and configured your Personal Preferences. We practiced prompt engineering with the GOLDEN framework and saw how iteration produces consistently better results.</a:t>
+            </a:r>
+          </a:p>
+          <a:p/>
+          <a:p>
+            <a:r>
+              <a:t>We explored Claude in Excel for formula assistance and data analysis. We built artifacts — documents, code, and diagrams that Claude creates as standalone deliverables. And we addressed the security and privacy model head-on, including the five objections your CISO will raise and the answers to each one.</a:t>
+            </a:r>
+          </a:p>
+          <a:p/>
+          <a:p>
+            <a:r>
+              <a:t>You now have practical skills that 40 percent of the US workforce is learning right now. The difference? You learned them systematically, with frameworks, not through trial and error.</a:t>
+            </a:r>
+          </a:p>
+          <a:p/>
+          <a:p>
+            <a:r>
+              <a:t>Remember the stat: 89 percent of leaders who implement AI properly agree it enhances rather than replaces employee skills. You're enhancing your skills today. Not being replaced by them.</a:t>
             </a:r>
           </a:p>
         </p:txBody>
@@ -8849,53 +8633,49 @@
           <a:lstStyle/>
           <a:p>
             <a:r>
-              <a:t>TIME: 3 min</a:t>
-            </a:r>
-          </a:p>
-          <a:p>
-            <a:endParaRPr/>
-          </a:p>
-          <a:p>
-            <a:r>
-              <a:t>KEY POINTS:</a:t>
-            </a:r>
-          </a:p>
-          <a:p>
-            <a:r>
-              <a:t>   * 1. Specificity: Vague prompts = vague outputs. Use GOLDEN when stuck.</a:t>
-            </a:r>
-          </a:p>
-          <a:p>
-            <a:r>
-              <a:t>   * 2. Projects: Set them up for monthly reports, client work, any recurring task.</a:t>
-            </a:r>
-          </a:p>
-          <a:p>
-            <a:r>
-              <a:t>   * 3. Iteration: First draft is rarely perfect - refine it.</a:t>
-            </a:r>
-          </a:p>
-          <a:p>
-            <a:r>
-              <a:t>   * 4. Excel add-in: Different from uploading files - it sees your spreadsheet context.</a:t>
-            </a:r>
-          </a:p>
-          <a:p>
-            <a:r>
-              <a:t>   * 5. Verification: You're still the expert - Claude is the assistant.</a:t>
-            </a:r>
-          </a:p>
-          <a:p>
-            <a:endParaRPr/>
-          </a:p>
-          <a:p>
-            <a:r>
-              <a:t>TRANSITION:</a:t>
-            </a:r>
-          </a:p>
-          <a:p>
-            <a:r>
-              <a:t>   Tomorrow preview for technical users</a:t>
+              <a:t>DURATION: 3 min</a:t>
+            </a:r>
+          </a:p>
+          <a:p/>
+          <a:p>
+            <a:r>
+              <a:t>Let me leave you with the framing that matters.</a:t>
+            </a:r>
+          </a:p>
+          <a:p/>
+          <a:p>
+            <a:r>
+              <a:t>95 percent of enterprise AI projects fail to reach production or deliver measurable ROI. That's MIT's 2025 finding from 150 leader interviews and 300 deployments. Global losses from failed AI projects hit $644 billion last year alone. Zillow's AI-powered home-buying algorithm cost them $500 million in losses and 25 percent of their workforce.</a:t>
+            </a:r>
+          </a:p>
+          <a:p/>
+          <a:p>
+            <a:r>
+              <a:t>These projects don't fail because the technology doesn't work. They fail because of implementation. No clear business problem. Unrealistic timelines. Poor integration with existing workflows. Lack of governance.</a:t>
+            </a:r>
+          </a:p>
+          <a:p/>
+          <a:p>
+            <a:r>
+              <a:t>Everything we covered today — the GOLDEN framework, Projects for organized context, Extended Thinking for complex analysis, the security model, the permission architecture — these are the implementation disciplines that separate the 5 percent who succeed from the 95 percent who don't.</a:t>
+            </a:r>
+          </a:p>
+          <a:p/>
+          <a:p>
+            <a:r>
+              <a:t>75 percent of leaders who DO implement AI properly see positive ROI. 89 percent agree it enhances rather than replaces employee skills. The technology works. The question is whether you have the discipline to implement it right.</a:t>
+            </a:r>
+          </a:p>
+          <a:p/>
+          <a:p>
+            <a:r>
+              <a:t>GitHub Copilot has a certification. It teaches you autocomplete. What we taught today — and what we'll go deeper on in Days 2 and 3 — covers autonomous agent development, memory architecture, multi-agent orchestration, and enterprise governance. Nobody else teaches this. You're in the 1 percent who will know how to actually use these tools.</a:t>
+            </a:r>
+          </a:p>
+          <a:p/>
+          <a:p>
+            <a:r>
+              <a:t>SOURCES: MIT 2025 State of AI, Fortune, Pythian Enterprise Research, Wharton 2025 AI Report.</a:t>
             </a:r>
           </a:p>
         </p:txBody>
@@ -9590,6 +9370,31 @@
 </p:notes>
 </file>
 
+<file path=ppt/notesSlides/notesSlide74.xml><?xml version="1.0" encoding="utf-8"?>
+<p:notes xmlns:a="http://schemas.openxmlformats.org/drawingml/2006/main" xmlns:p="http://schemas.openxmlformats.org/presentationml/2006/main" xmlns:r="http://schemas.openxmlformats.org/officeDocument/2006/relationships">
+  <p:cSld>
+    <p:spTree>
+      <p:nvGrpSpPr>
+        <p:cNvPr id="1" name=""/>
+        <p:cNvGrpSpPr/>
+        <p:nvPr/>
+      </p:nvGrpSpPr>
+      <p:grpSpPr>
+        <a:xfrm>
+          <a:off x="0" y="0"/>
+          <a:ext cx="0" cy="0"/>
+          <a:chOff x="0" y="0"/>
+          <a:chExt cx="0" cy="0"/>
+        </a:xfrm>
+      </p:grpSpPr>
+    </p:spTree>
+  </p:cSld>
+  <p:clrMapOvr>
+    <a:masterClrMapping/>
+  </p:clrMapOvr>
+</p:notes>
+</file>
+
 <file path=ppt/notesSlides/notesSlide8.xml><?xml version="1.0" encoding="utf-8"?>
 <p:notes xmlns:a="http://schemas.openxmlformats.org/drawingml/2006/main" xmlns:r="http://schemas.openxmlformats.org/officeDocument/2006/relationships" xmlns:p="http://schemas.openxmlformats.org/presentationml/2006/main">
   <p:cSld>
@@ -9635,66 +9440,55 @@
           <a:lstStyle/>
           <a:p>
             <a:r>
-              <a:t>TIME: 4 min</a:t>
-            </a:r>
-          </a:p>
-          <a:p>
-            <a:endParaRPr/>
-          </a:p>
-          <a:p>
-            <a:r>
-              <a:t>KEY POINTS:</a:t>
-            </a:r>
-          </a:p>
-          <a:p>
-            <a:r>
-              <a:t>   * Long context: Can read entire books (200K+ tokens). Upload your 300-page manual, ask questions.</a:t>
-            </a:r>
-          </a:p>
-          <a:p>
-            <a:r>
-              <a:t>   * Accurate: Lower hallucination rate. Won't make up facts as much as competitors.</a:t>
-            </a:r>
-          </a:p>
-          <a:p>
-            <a:r>
-              <a:t>   * Safe: Built for enterprise - safety controls, audit logs, data privacy.</a:t>
-            </a:r>
-          </a:p>
-          <a:p>
-            <a:r>
-              <a:t>   * Versatile: Code, writing, analysis, reasoning - does it all well.</a:t>
-            </a:r>
-          </a:p>
-          <a:p>
-            <a:r>
-              <a:t>   * Citations: When analyzing docs, shows you WHERE it found the info.</a:t>
-            </a:r>
-          </a:p>
-          <a:p>
-            <a:endParaRPr/>
-          </a:p>
-          <a:p>
-            <a:r>
-              <a:t>REAL-WORLD EXAMPLE:</a:t>
-            </a:r>
-          </a:p>
-          <a:p>
-            <a:r>
-              <a:t>   Last week a client uploaded their entire employee handbook (150 pages) and asked 'What's our policy on remote work?' Claude cited page 47 with the exact paragraph.</a:t>
-            </a:r>
-          </a:p>
-          <a:p>
-            <a:endParaRPr/>
-          </a:p>
-          <a:p>
-            <a:r>
-              <a:t>TRANSITION:</a:t>
-            </a:r>
-          </a:p>
-          <a:p>
-            <a:r>
-              <a:t>   Claude comes in multiple flavors - let's see the ecosystem</a:t>
+              <a:t>DURATION: 4 min</a:t>
+            </a:r>
+          </a:p>
+          <a:p/>
+          <a:p>
+            <a:r>
+              <a:t>Here's what makes Claude different from every other AI assistant on the market — and I'm going to give you the numbers to prove it.</a:t>
+            </a:r>
+          </a:p>
+          <a:p/>
+          <a:p>
+            <a:r>
+              <a:t>First, the enterprise story. TELUS — 57,000 employees — deployed Claude across their entire organization. Result? Half a million staff hours saved and over $90 million in business benefit. That's not a pilot. That's production at scale.</a:t>
+            </a:r>
+          </a:p>
+          <a:p/>
+          <a:p>
+            <a:r>
+              <a:t>Zapier built over 800 internal AI agents powered by Claude. Their adoption rate? 89 percent. That wasn't mandated from the top — it was organic. People chose to use it because it made them faster.</a:t>
+            </a:r>
+          </a:p>
+          <a:p/>
+          <a:p>
+            <a:r>
+              <a:t>Bridgewater Associates — one of the most secretive, security-conscious hedge funds in the world — uses Claude Opus for investment research. They cut reporting time by 50 to 70 percent with analyst-level precision. If Bridgewater trusts it with their financial models, that tells you something about the security posture.</a:t>
+            </a:r>
+          </a:p>
+          <a:p/>
+          <a:p>
+            <a:r>
+              <a:t>Now, competitive positioning. GitHub Copilot is the industry standard for code autocomplete — 110 millisecond response time, inline suggestions. It's great at what it does. But Claude is a different category entirely. Copilot autocompletes your lines. Claude reads your entire codebase, understands the architecture, runs terminal commands, edits multiple files, and explains what it did and why.</a:t>
+            </a:r>
+          </a:p>
+          <a:p/>
+          <a:p>
+            <a:r>
+              <a:t>Claude has a 200,000 token context window versus Copilot's file-based approach. It has native terminal access, custom commands, skills, hooks, MCP integration — none of which Copilot offers. For business users, Claude is the only AI assistant that handles document creation, data analysis, Excel formulas, and complex multi-step workflows in a single conversation.</a:t>
+            </a:r>
+          </a:p>
+          <a:p/>
+          <a:p>
+            <a:r>
+              <a:t>The key stat: 300,000 business customers. 24 percent of major banks. 38 percent of retail chatbots. This isn't early-adopter territory anymore — this is mainstream enterprise adoption.</a:t>
+            </a:r>
+          </a:p>
+          <a:p/>
+          <a:p>
+            <a:r>
+              <a:t>SOURCE: Anthropic enterprise case studies (datastudios.org), UncoverAlpha market analysis 2026.</a:t>
             </a:r>
           </a:p>
         </p:txBody>

</xml_diff>

<commit_message>
Day 1: Add 'Microsoft Runs Both' positioning slide (new slide 9)
- Microsoft mandated engineers test Claude Code alongside Copilot
- Side-by-side comparison: Copilot (autocomplete) vs Claude Code (autonomous)
- Benchmark data: 40-55% vs 48%/77.2% SWE-bench, 110ms vs 200K context
- Scott's MCT differentiator: teaches both sides
- Day 1 now 87 slides

Source: DevGenius Feb 2026, microsoft-claude-vs-copilot-intel.md
</commit_message>
<xml_diff>
--- a/slides/Day1_Claude_for_Business.pptx
+++ b/slides/Day1_Claude_for_Business.pptx
@@ -16,6 +16,7 @@
     <p:sldId id="261" r:id="rId7"/>
     <p:sldId id="262" r:id="rId8"/>
     <p:sldId id="263" r:id="rId9"/>
+    <p:sldId id="342" r:id="rId94"/>
     <p:sldId id="264" r:id="rId10"/>
     <p:sldId id="338" r:id="rId90"/>
     <p:sldId id="265" r:id="rId11"/>
@@ -9395,6 +9396,31 @@
 </p:notes>
 </file>
 
+<file path=ppt/notesSlides/notesSlide75.xml><?xml version="1.0" encoding="utf-8"?>
+<p:notes xmlns:a="http://schemas.openxmlformats.org/drawingml/2006/main" xmlns:p="http://schemas.openxmlformats.org/presentationml/2006/main" xmlns:r="http://schemas.openxmlformats.org/officeDocument/2006/relationships">
+  <p:cSld>
+    <p:spTree>
+      <p:nvGrpSpPr>
+        <p:cNvPr id="1" name=""/>
+        <p:cNvGrpSpPr/>
+        <p:nvPr/>
+      </p:nvGrpSpPr>
+      <p:grpSpPr>
+        <a:xfrm>
+          <a:off x="0" y="0"/>
+          <a:ext cx="0" cy="0"/>
+          <a:chOff x="0" y="0"/>
+          <a:chExt cx="0" cy="0"/>
+        </a:xfrm>
+      </p:grpSpPr>
+    </p:spTree>
+  </p:cSld>
+  <p:clrMapOvr>
+    <a:masterClrMapping/>
+  </p:clrMapOvr>
+</p:notes>
+</file>
+
 <file path=ppt/notesSlides/notesSlide8.xml><?xml version="1.0" encoding="utf-8"?>
 <p:notes xmlns:a="http://schemas.openxmlformats.org/drawingml/2006/main" xmlns:r="http://schemas.openxmlformats.org/officeDocument/2006/relationships" xmlns:p="http://schemas.openxmlformats.org/presentationml/2006/main">
   <p:cSld>
@@ -44544,6 +44570,446 @@
             </a:pPr>
             <a:r>
               <a:t>- © 2026 AIA Copilot</a:t>
+            </a:r>
+          </a:p>
+        </p:txBody>
+      </p:sp>
+    </p:spTree>
+  </p:cSld>
+  <p:clrMapOvr>
+    <a:masterClrMapping/>
+  </p:clrMapOvr>
+</p:sld>
+</file>
+
+<file path=ppt/slides/slide87.xml><?xml version="1.0" encoding="utf-8"?>
+<p:sld xmlns:a="http://schemas.openxmlformats.org/drawingml/2006/main" xmlns:p="http://schemas.openxmlformats.org/presentationml/2006/main" xmlns:r="http://schemas.openxmlformats.org/officeDocument/2006/relationships">
+  <p:cSld>
+    <p:bg>
+      <p:bgPr>
+        <a:solidFill>
+          <a:srgbClr val="1F2D3D"/>
+        </a:solidFill>
+        <a:effectLst/>
+      </p:bgPr>
+    </p:bg>
+    <p:spTree>
+      <p:nvGrpSpPr>
+        <p:cNvPr id="1" name=""/>
+        <p:cNvGrpSpPr/>
+        <p:nvPr/>
+      </p:nvGrpSpPr>
+      <p:grpSpPr/>
+      <p:sp>
+        <p:nvSpPr>
+          <p:cNvPr id="2" name="TextBox 1"/>
+          <p:cNvSpPr txBox="1"/>
+          <p:nvPr/>
+        </p:nvSpPr>
+        <p:spPr>
+          <a:xfrm>
+            <a:off x="457200" y="274320"/>
+            <a:ext cx="11247120" cy="822960"/>
+          </a:xfrm>
+          <a:prstGeom prst="rect">
+            <a:avLst/>
+          </a:prstGeom>
+          <a:noFill/>
+        </p:spPr>
+        <p:txBody>
+          <a:bodyPr wrap="none">
+            <a:spAutoFit/>
+          </a:bodyPr>
+          <a:lstStyle/>
+          <a:p>
+            <a:pPr>
+              <a:defRPr sz="4000" b="1">
+                <a:solidFill>
+                  <a:srgbClr val="FFFFFF"/>
+                </a:solidFill>
+              </a:defRPr>
+            </a:pPr>
+            <a:r>
+              <a:t>Microsoft Runs Both. Shouldn't You?</a:t>
+            </a:r>
+          </a:p>
+        </p:txBody>
+      </p:sp>
+      <p:sp>
+        <p:nvSpPr>
+          <p:cNvPr id="3" name="TextBox 2"/>
+          <p:cNvSpPr txBox="1"/>
+          <p:nvPr/>
+        </p:nvSpPr>
+        <p:spPr>
+          <a:xfrm>
+            <a:off x="457200" y="1097280"/>
+            <a:ext cx="11247120" cy="457200"/>
+          </a:xfrm>
+          <a:prstGeom prst="rect">
+            <a:avLst/>
+          </a:prstGeom>
+          <a:noFill/>
+        </p:spPr>
+        <p:txBody>
+          <a:bodyPr wrap="none">
+            <a:spAutoFit/>
+          </a:bodyPr>
+          <a:lstStyle/>
+          <a:p>
+            <a:pPr>
+              <a:defRPr sz="2000" i="1">
+                <a:solidFill>
+                  <a:srgbClr val="9CA3AF"/>
+                </a:solidFill>
+              </a:defRPr>
+            </a:pPr>
+            <a:r>
+              <a:t>Microsoft mandated its engineers test Claude Code alongside Copilot — and submit comparative feedback.</a:t>
+            </a:r>
+          </a:p>
+        </p:txBody>
+      </p:sp>
+      <p:sp>
+        <p:nvSpPr>
+          <p:cNvPr id="4" name="TextBox 3"/>
+          <p:cNvSpPr txBox="1"/>
+          <p:nvPr/>
+        </p:nvSpPr>
+        <p:spPr>
+          <a:xfrm>
+            <a:off x="457200" y="1828800"/>
+            <a:ext cx="5029200" cy="457200"/>
+          </a:xfrm>
+          <a:prstGeom prst="rect">
+            <a:avLst/>
+          </a:prstGeom>
+          <a:noFill/>
+        </p:spPr>
+        <p:txBody>
+          <a:bodyPr wrap="none">
+            <a:spAutoFit/>
+          </a:bodyPr>
+          <a:lstStyle/>
+          <a:p>
+            <a:pPr algn="ctr">
+              <a:defRPr sz="2800" b="1">
+                <a:solidFill>
+                  <a:srgbClr val="FFFFFF"/>
+                </a:solidFill>
+              </a:defRPr>
+            </a:pPr>
+            <a:r>
+              <a:t>GitHub Copilot</a:t>
+            </a:r>
+          </a:p>
+        </p:txBody>
+      </p:sp>
+      <p:sp>
+        <p:nvSpPr>
+          <p:cNvPr id="5" name="TextBox 4"/>
+          <p:cNvSpPr txBox="1"/>
+          <p:nvPr/>
+        </p:nvSpPr>
+        <p:spPr>
+          <a:xfrm>
+            <a:off x="6217920" y="1828800"/>
+            <a:ext cx="5029200" cy="457200"/>
+          </a:xfrm>
+          <a:prstGeom prst="rect">
+            <a:avLst/>
+          </a:prstGeom>
+          <a:noFill/>
+        </p:spPr>
+        <p:txBody>
+          <a:bodyPr wrap="none">
+            <a:spAutoFit/>
+          </a:bodyPr>
+          <a:lstStyle/>
+          <a:p>
+            <a:pPr algn="ctr">
+              <a:defRPr sz="2800" b="1">
+                <a:solidFill>
+                  <a:srgbClr val="FFFFFF"/>
+                </a:solidFill>
+              </a:defRPr>
+            </a:pPr>
+            <a:r>
+              <a:t>Claude Code</a:t>
+            </a:r>
+          </a:p>
+        </p:txBody>
+      </p:sp>
+      <p:sp>
+        <p:nvSpPr>
+          <p:cNvPr id="6" name="TextBox 5"/>
+          <p:cNvSpPr txBox="1"/>
+          <p:nvPr/>
+        </p:nvSpPr>
+        <p:spPr>
+          <a:xfrm>
+            <a:off x="457200" y="2377440"/>
+            <a:ext cx="5029200" cy="3200400"/>
+          </a:xfrm>
+          <a:prstGeom prst="rect">
+            <a:avLst/>
+          </a:prstGeom>
+          <a:noFill/>
+        </p:spPr>
+        <p:txBody>
+          <a:bodyPr wrap="square">
+            <a:spAutoFit/>
+          </a:bodyPr>
+          <a:lstStyle/>
+          <a:p>
+            <a:pPr>
+              <a:spcAft>
+                <a:spcPts val="800"/>
+              </a:spcAft>
+              <a:defRPr sz="1800">
+                <a:solidFill>
+                  <a:srgbClr val="D1D5DB"/>
+                </a:solidFill>
+              </a:defRPr>
+            </a:pPr>
+            <a:r>
+              <a:t>•  40-55% productivity gain</a:t>
+            </a:r>
+          </a:p>
+          <a:p>
+            <a:pPr>
+              <a:spcAft>
+                <a:spcPts val="800"/>
+              </a:spcAft>
+              <a:defRPr sz="1800">
+                <a:solidFill>
+                  <a:srgbClr val="D1D5DB"/>
+                </a:solidFill>
+              </a:defRPr>
+            </a:pPr>
+            <a:r>
+              <a:t>•  Best: IDE autocomplete, inline suggestions</a:t>
+            </a:r>
+          </a:p>
+          <a:p>
+            <a:pPr>
+              <a:spcAft>
+                <a:spcPts val="800"/>
+              </a:spcAft>
+              <a:defRPr sz="1800">
+                <a:solidFill>
+                  <a:srgbClr val="D1D5DB"/>
+                </a:solidFill>
+              </a:defRPr>
+            </a:pPr>
+            <a:r>
+              <a:t>•  Best: Boilerplate, data science, MS ecosystem</a:t>
+            </a:r>
+          </a:p>
+          <a:p>
+            <a:pPr>
+              <a:spcAft>
+                <a:spcPts val="800"/>
+              </a:spcAft>
+              <a:defRPr sz="1800">
+                <a:solidFill>
+                  <a:srgbClr val="D1D5DB"/>
+                </a:solidFill>
+              </a:defRPr>
+            </a:pPr>
+            <a:r>
+              <a:t>•  15M developers, 42% market share</a:t>
+            </a:r>
+          </a:p>
+          <a:p>
+            <a:pPr>
+              <a:spcAft>
+                <a:spcPts val="800"/>
+              </a:spcAft>
+              <a:defRPr sz="1800">
+                <a:solidFill>
+                  <a:srgbClr val="D1D5DB"/>
+                </a:solidFill>
+              </a:defRPr>
+            </a:pPr>
+            <a:r>
+              <a:t>•  110ms response time</a:t>
+            </a:r>
+          </a:p>
+        </p:txBody>
+      </p:sp>
+      <p:sp>
+        <p:nvSpPr>
+          <p:cNvPr id="7" name="TextBox 6"/>
+          <p:cNvSpPr txBox="1"/>
+          <p:nvPr/>
+        </p:nvSpPr>
+        <p:spPr>
+          <a:xfrm>
+            <a:off x="6217920" y="2377440"/>
+            <a:ext cx="5029200" cy="3200400"/>
+          </a:xfrm>
+          <a:prstGeom prst="rect">
+            <a:avLst/>
+          </a:prstGeom>
+          <a:noFill/>
+        </p:spPr>
+        <p:txBody>
+          <a:bodyPr wrap="square">
+            <a:spAutoFit/>
+          </a:bodyPr>
+          <a:lstStyle/>
+          <a:p>
+            <a:pPr>
+              <a:spcAft>
+                <a:spcPts val="800"/>
+              </a:spcAft>
+              <a:defRPr sz="1800">
+                <a:solidFill>
+                  <a:srgbClr val="D1D5DB"/>
+                </a:solidFill>
+              </a:defRPr>
+            </a:pPr>
+            <a:r>
+              <a:t>•  48% productivity, 77.2% SWE-bench</a:t>
+            </a:r>
+          </a:p>
+          <a:p>
+            <a:pPr>
+              <a:spcAft>
+                <a:spcPts val="800"/>
+              </a:spcAft>
+              <a:defRPr sz="1800">
+                <a:solidFill>
+                  <a:srgbClr val="D1D5DB"/>
+                </a:solidFill>
+              </a:defRPr>
+            </a:pPr>
+            <a:r>
+              <a:t>•  Best: Complex reasoning, multi-file edits</a:t>
+            </a:r>
+          </a:p>
+          <a:p>
+            <a:pPr>
+              <a:spcAft>
+                <a:spcPts val="800"/>
+              </a:spcAft>
+              <a:defRPr sz="1800">
+                <a:solidFill>
+                  <a:srgbClr val="D1D5DB"/>
+                </a:solidFill>
+              </a:defRPr>
+            </a:pPr>
+            <a:r>
+              <a:t>•  Best: Backend, CLI, infra, large codebases</a:t>
+            </a:r>
+          </a:p>
+          <a:p>
+            <a:pPr>
+              <a:spcAft>
+                <a:spcPts val="800"/>
+              </a:spcAft>
+              <a:defRPr sz="1800">
+                <a:solidFill>
+                  <a:srgbClr val="D1D5DB"/>
+                </a:solidFill>
+              </a:defRPr>
+            </a:pPr>
+            <a:r>
+              <a:t>•  Terminal-native, growing fast</a:t>
+            </a:r>
+          </a:p>
+          <a:p>
+            <a:pPr>
+              <a:spcAft>
+                <a:spcPts val="800"/>
+              </a:spcAft>
+              <a:defRPr sz="1800">
+                <a:solidFill>
+                  <a:srgbClr val="D1D5DB"/>
+                </a:solidFill>
+              </a:defRPr>
+            </a:pPr>
+            <a:r>
+              <a:t>•  200K token context window</a:t>
+            </a:r>
+          </a:p>
+        </p:txBody>
+      </p:sp>
+      <p:sp>
+        <p:nvSpPr>
+          <p:cNvPr id="8" name="Rectangle 7"/>
+          <p:cNvSpPr/>
+          <p:nvPr/>
+        </p:nvSpPr>
+        <p:spPr>
+          <a:xfrm>
+            <a:off x="5852160" y="1828800"/>
+            <a:ext cx="27432" cy="3657600"/>
+          </a:xfrm>
+          <a:prstGeom prst="rect">
+            <a:avLst/>
+          </a:prstGeom>
+          <a:solidFill>
+            <a:srgbClr val="4B5563"/>
+          </a:solidFill>
+          <a:ln>
+            <a:noFill/>
+          </a:ln>
+        </p:spPr>
+        <p:style>
+          <a:lnRef idx="1">
+            <a:schemeClr val="accent1"/>
+          </a:lnRef>
+          <a:fillRef idx="3">
+            <a:schemeClr val="accent1"/>
+          </a:fillRef>
+          <a:effectRef idx="2">
+            <a:schemeClr val="accent1"/>
+          </a:effectRef>
+          <a:fontRef idx="minor">
+            <a:schemeClr val="lt1"/>
+          </a:fontRef>
+        </p:style>
+        <p:txBody>
+          <a:bodyPr rtlCol="0" anchor="ctr"/>
+          <a:lstStyle/>
+          <a:p>
+            <a:pPr algn="ctr"/>
+          </a:p>
+        </p:txBody>
+      </p:sp>
+      <p:sp>
+        <p:nvSpPr>
+          <p:cNvPr id="9" name="TextBox 8"/>
+          <p:cNvSpPr txBox="1"/>
+          <p:nvPr/>
+        </p:nvSpPr>
+        <p:spPr>
+          <a:xfrm>
+            <a:off x="457200" y="5943600"/>
+            <a:ext cx="11247120" cy="731520"/>
+          </a:xfrm>
+          <a:prstGeom prst="rect">
+            <a:avLst/>
+          </a:prstGeom>
+          <a:noFill/>
+        </p:spPr>
+        <p:txBody>
+          <a:bodyPr wrap="square">
+            <a:spAutoFit/>
+          </a:bodyPr>
+          <a:lstStyle/>
+          <a:p>
+            <a:pPr algn="ctr">
+              <a:defRPr sz="1800" b="1">
+                <a:solidFill>
+                  <a:srgbClr val="0078D4"/>
+                </a:solidFill>
+              </a:defRPr>
+            </a:pPr>
+            <a:r>
+              <a:t>Your instructor is a Microsoft Certified Trainer who teaches both Copilot and Claude Code — the same multi-tool approach Microsoft uses internally.</a:t>
             </a:r>
           </a:p>
         </p:txBody>

</xml_diff>

<commit_message>
Fix: Clean PPTX ZIP — remove duplicate entries causing repair prompt
</commit_message>
<xml_diff>
--- a/slides/Day1_Claude_for_Business.pptx
+++ b/slides/Day1_Claude_for_Business.pptx
@@ -42152,153 +42152,6 @@
 </p:sld>
 </file>
 
-<file path=ppt/slides/slide71.xml><?xml version="1.0" encoding="utf-8"?>
-<p:sld xmlns:a="http://schemas.openxmlformats.org/drawingml/2006/main" xmlns:r="http://schemas.openxmlformats.org/officeDocument/2006/relationships" xmlns:p="http://schemas.openxmlformats.org/presentationml/2006/main">
-  <p:cSld>
-    <p:bg>
-      <p:bgPr>
-        <a:solidFill>
-          <a:srgbClr val="0B0F1A"/>
-        </a:solidFill>
-        <a:effectLst/>
-      </p:bgPr>
-    </p:bg>
-    <p:spTree>
-      <p:nvGrpSpPr>
-        <p:cNvPr id="1" name=""/>
-        <p:cNvGrpSpPr/>
-        <p:nvPr/>
-      </p:nvGrpSpPr>
-      <p:grpSpPr>
-        <a:xfrm>
-          <a:off x="0" y="0"/>
-          <a:ext cx="0" cy="0"/>
-          <a:chOff x="0" y="0"/>
-          <a:chExt cx="0" cy="0"/>
-        </a:xfrm>
-      </p:grpSpPr>
-      <p:sp>
-        <p:nvSpPr>
-          <p:cNvPr id="2" name="Rectangle 1"/>
-          <p:cNvSpPr/>
-          <p:nvPr/>
-        </p:nvSpPr>
-        <p:spPr>
-          <a:xfrm>
-            <a:off x="0" y="1828800"/>
-            <a:ext cx="137160" cy="3200400"/>
-          </a:xfrm>
-          <a:prstGeom prst="rect">
-            <a:avLst/>
-          </a:prstGeom>
-          <a:solidFill>
-            <a:srgbClr val="00D4AA"/>
-          </a:solidFill>
-          <a:ln>
-            <a:noFill/>
-          </a:ln>
-        </p:spPr>
-        <p:style>
-          <a:lnRef idx="1">
-            <a:schemeClr val="accent1"/>
-          </a:lnRef>
-          <a:fillRef idx="3">
-            <a:schemeClr val="accent1"/>
-          </a:fillRef>
-          <a:effectRef idx="2">
-            <a:schemeClr val="accent1"/>
-          </a:effectRef>
-          <a:fontRef idx="minor">
-            <a:schemeClr val="lt1"/>
-          </a:fontRef>
-        </p:style>
-        <p:txBody>
-          <a:bodyPr rtlCol="0" anchor="ctr"/>
-          <a:lstStyle/>
-          <a:p>
-            <a:pPr algn="ctr"/>
-            <a:endParaRPr/>
-          </a:p>
-        </p:txBody>
-      </p:sp>
-      <p:sp>
-        <p:nvSpPr>
-          <p:cNvPr id="3" name="TextBox 2"/>
-          <p:cNvSpPr txBox="1"/>
-          <p:nvPr/>
-        </p:nvSpPr>
-        <p:spPr>
-          <a:xfrm>
-            <a:off x="457200" y="2286000"/>
-            <a:ext cx="11277295" cy="1371600"/>
-          </a:xfrm>
-          <a:prstGeom prst="rect">
-            <a:avLst/>
-          </a:prstGeom>
-          <a:noFill/>
-        </p:spPr>
-        <p:txBody>
-          <a:bodyPr wrap="square">
-            <a:spAutoFit/>
-          </a:bodyPr>
-          <a:lstStyle/>
-          <a:p>
-            <a:pPr>
-              <a:defRPr sz="5600" b="1">
-                <a:solidFill>
-                  <a:srgbClr val="FFFFFF"/>
-                </a:solidFill>
-              </a:defRPr>
-            </a:pPr>
-            <a:r>
-              <a:t>Role-Specific Workflows</a:t>
-            </a:r>
-          </a:p>
-        </p:txBody>
-      </p:sp>
-      <p:sp>
-        <p:nvSpPr>
-          <p:cNvPr id="4" name="TextBox 3"/>
-          <p:cNvSpPr txBox="1"/>
-          <p:nvPr/>
-        </p:nvSpPr>
-        <p:spPr>
-          <a:xfrm>
-            <a:off x="457200" y="3840480"/>
-            <a:ext cx="11277295" cy="914400"/>
-          </a:xfrm>
-          <a:prstGeom prst="rect">
-            <a:avLst/>
-          </a:prstGeom>
-          <a:noFill/>
-        </p:spPr>
-        <p:txBody>
-          <a:bodyPr wrap="square">
-            <a:spAutoFit/>
-          </a:bodyPr>
-          <a:lstStyle/>
-          <a:p>
-            <a:pPr>
-              <a:defRPr sz="2400">
-                <a:solidFill>
-                  <a:srgbClr val="8B95A5"/>
-                </a:solidFill>
-              </a:defRPr>
-            </a:pPr>
-            <a:r>
-              <a:t>Claude in action for different jobs</a:t>
-            </a:r>
-          </a:p>
-        </p:txBody>
-      </p:sp>
-    </p:spTree>
-  </p:cSld>
-  <p:clrMapOvr>
-    <a:masterClrMapping/>
-  </p:clrMapOvr>
-</p:sld>
-</file>
-
 <file path=ppt/slides/slide72.xml><?xml version="1.0" encoding="utf-8"?>
 <p:sld xmlns:a="http://schemas.openxmlformats.org/drawingml/2006/main" xmlns:r="http://schemas.openxmlformats.org/officeDocument/2006/relationships" xmlns:p="http://schemas.openxmlformats.org/presentationml/2006/main">
   <p:cSld>

</xml_diff>

<commit_message>
Day 1: Update Learning Objectives to match current content
8 objectives aligned to actual slide blocks:
1. Interface + Voice Mode
2. GOLDEN framework prompting
3. Models + Extended Thinking
4. Settings + Preferences + privacy
5. Desktop/Mobile apps + Claude for Work
6. Projects + Custom Instructions
7. Data analysis + Claude in Excel
8. Artifacts + file uploads + integrations
</commit_message>
<xml_diff>
--- a/slides/Day1_Claude_for_Business.pptx
+++ b/slides/Day1_Claude_for_Business.pptx
@@ -24130,7 +24130,7 @@
     <p:bg>
       <p:bgPr>
         <a:solidFill>
-          <a:srgbClr val="0B0F1A"/>
+          <a:srgbClr val="1F2D3D"/>
         </a:solidFill>
         <a:effectLst/>
       </p:bgPr>
@@ -24151,58 +24151,14 @@
       </p:grpSpPr>
       <p:sp>
         <p:nvSpPr>
-          <p:cNvPr id="2" name="Rectangle 1"/>
-          <p:cNvSpPr/>
-          <p:nvPr/>
-        </p:nvSpPr>
-        <p:spPr>
-          <a:xfrm>
-            <a:off x="0" y="1188720"/>
-            <a:ext cx="91440" cy="5029200"/>
-          </a:xfrm>
-          <a:prstGeom prst="rect">
-            <a:avLst/>
-          </a:prstGeom>
-          <a:solidFill>
-            <a:srgbClr val="00D4AA"/>
-          </a:solidFill>
-          <a:ln>
-            <a:noFill/>
-          </a:ln>
-        </p:spPr>
-        <p:style>
-          <a:lnRef idx="1">
-            <a:schemeClr val="accent1"/>
-          </a:lnRef>
-          <a:fillRef idx="3">
-            <a:schemeClr val="accent1"/>
-          </a:fillRef>
-          <a:effectRef idx="2">
-            <a:schemeClr val="accent1"/>
-          </a:effectRef>
-          <a:fontRef idx="minor">
-            <a:schemeClr val="lt1"/>
-          </a:fontRef>
-        </p:style>
-        <p:txBody>
-          <a:bodyPr rtlCol="0" anchor="ctr"/>
-          <a:lstStyle/>
-          <a:p>
-            <a:pPr algn="ctr"/>
-            <a:endParaRPr/>
-          </a:p>
-        </p:txBody>
-      </p:sp>
-      <p:sp>
-        <p:nvSpPr>
-          <p:cNvPr id="3" name="TextBox 2"/>
+          <p:cNvPr id="2" name="TextBox 1"/>
           <p:cNvSpPr txBox="1"/>
           <p:nvPr/>
         </p:nvSpPr>
         <p:spPr>
           <a:xfrm>
-            <a:off x="457200" y="365760"/>
-            <a:ext cx="11277295" cy="822960"/>
+            <a:off x="457200" y="274320"/>
+            <a:ext cx="11247120" cy="731520"/>
           </a:xfrm>
           <a:prstGeom prst="rect">
             <a:avLst/>
@@ -24230,13 +24186,13 @@
       </p:sp>
       <p:sp>
         <p:nvSpPr>
-          <p:cNvPr id="4" name="Oval 3"/>
+          <p:cNvPr id="3" name="Oval 2"/>
           <p:cNvSpPr/>
           <p:nvPr/>
         </p:nvSpPr>
         <p:spPr>
           <a:xfrm>
-            <a:off x="457200" y="1280160"/>
+            <a:off x="548640" y="1280160"/>
             <a:ext cx="365760" cy="365760"/>
           </a:xfrm>
           <a:prstGeom prst="ellipse">
@@ -24275,21 +24231,21 @@
               </a:defRPr>
             </a:pPr>
             <a:r>
-              <a:t>v</a:t>
-            </a:r>
-          </a:p>
-        </p:txBody>
-      </p:sp>
-      <p:sp>
-        <p:nvSpPr>
-          <p:cNvPr id="5" name="TextBox 4"/>
+              <a:t>✓</a:t>
+            </a:r>
+          </a:p>
+        </p:txBody>
+      </p:sp>
+      <p:sp>
+        <p:nvSpPr>
+          <p:cNvPr id="4" name="TextBox 3"/>
           <p:cNvSpPr txBox="1"/>
           <p:nvPr/>
         </p:nvSpPr>
         <p:spPr>
           <a:xfrm>
-            <a:off x="1005840" y="1298448"/>
-            <a:ext cx="10725912" cy="502920"/>
+            <a:off x="1097280" y="1280160"/>
+            <a:ext cx="10515600" cy="411480"/>
           </a:xfrm>
           <a:prstGeom prst="rect">
             <a:avLst/>
@@ -24297,34 +24253,33 @@
           <a:noFill/>
         </p:spPr>
         <p:txBody>
-          <a:bodyPr wrap="square">
+          <a:bodyPr wrap="none">
             <a:spAutoFit/>
           </a:bodyPr>
           <a:lstStyle/>
           <a:p>
             <a:pPr>
-              <a:defRPr sz="2200">
-                <a:solidFill>
-                  <a:srgbClr val="FFFFFF"/>
-                </a:solidFill>
-              </a:defRPr>
-            </a:pPr>
-            <a:r>
-              <a:rPr dirty="0"/>
-              <a:t>Choose the right Claude model for different tasks</a:t>
-            </a:r>
-          </a:p>
-        </p:txBody>
-      </p:sp>
-      <p:sp>
-        <p:nvSpPr>
-          <p:cNvPr id="6" name="Oval 5"/>
+              <a:defRPr sz="2000">
+                <a:solidFill>
+                  <a:srgbClr val="D1D5DB"/>
+                </a:solidFill>
+              </a:defRPr>
+            </a:pPr>
+            <a:r>
+              <a:t>Navigate the Claude.ai interface and use Voice Mode</a:t>
+            </a:r>
+          </a:p>
+        </p:txBody>
+      </p:sp>
+      <p:sp>
+        <p:nvSpPr>
+          <p:cNvPr id="5" name="Oval 4"/>
           <p:cNvSpPr/>
           <p:nvPr/>
         </p:nvSpPr>
         <p:spPr>
           <a:xfrm>
-            <a:off x="457200" y="1938528"/>
+            <a:off x="548640" y="1874519"/>
             <a:ext cx="365760" cy="365760"/>
           </a:xfrm>
           <a:prstGeom prst="ellipse">
@@ -24363,21 +24318,21 @@
               </a:defRPr>
             </a:pPr>
             <a:r>
-              <a:t>v</a:t>
-            </a:r>
-          </a:p>
-        </p:txBody>
-      </p:sp>
-      <p:sp>
-        <p:nvSpPr>
-          <p:cNvPr id="7" name="TextBox 6"/>
+              <a:t>✓</a:t>
+            </a:r>
+          </a:p>
+        </p:txBody>
+      </p:sp>
+      <p:sp>
+        <p:nvSpPr>
+          <p:cNvPr id="6" name="TextBox 5"/>
           <p:cNvSpPr txBox="1"/>
           <p:nvPr/>
         </p:nvSpPr>
         <p:spPr>
           <a:xfrm>
-            <a:off x="1005840" y="1956816"/>
-            <a:ext cx="10725912" cy="502920"/>
+            <a:off x="1097280" y="1874519"/>
+            <a:ext cx="10515600" cy="411480"/>
           </a:xfrm>
           <a:prstGeom prst="rect">
             <a:avLst/>
@@ -24385,33 +24340,33 @@
           <a:noFill/>
         </p:spPr>
         <p:txBody>
-          <a:bodyPr wrap="square">
+          <a:bodyPr wrap="none">
             <a:spAutoFit/>
           </a:bodyPr>
           <a:lstStyle/>
           <a:p>
             <a:pPr>
-              <a:defRPr sz="2200">
-                <a:solidFill>
-                  <a:srgbClr val="FFFFFF"/>
-                </a:solidFill>
-              </a:defRPr>
-            </a:pPr>
-            <a:r>
-              <a:t>Navigate Claude.ai interface and manage Projects</a:t>
-            </a:r>
-          </a:p>
-        </p:txBody>
-      </p:sp>
-      <p:sp>
-        <p:nvSpPr>
-          <p:cNvPr id="8" name="Oval 7"/>
+              <a:defRPr sz="2000">
+                <a:solidFill>
+                  <a:srgbClr val="D1D5DB"/>
+                </a:solidFill>
+              </a:defRPr>
+            </a:pPr>
+            <a:r>
+              <a:t>Write effective prompts using the GOLDEN framework</a:t>
+            </a:r>
+          </a:p>
+        </p:txBody>
+      </p:sp>
+      <p:sp>
+        <p:nvSpPr>
+          <p:cNvPr id="7" name="Oval 6"/>
           <p:cNvSpPr/>
           <p:nvPr/>
         </p:nvSpPr>
         <p:spPr>
           <a:xfrm>
-            <a:off x="457200" y="2596896"/>
+            <a:off x="548640" y="2468880"/>
             <a:ext cx="365760" cy="365760"/>
           </a:xfrm>
           <a:prstGeom prst="ellipse">
@@ -24450,21 +24405,21 @@
               </a:defRPr>
             </a:pPr>
             <a:r>
-              <a:t>v</a:t>
-            </a:r>
-          </a:p>
-        </p:txBody>
-      </p:sp>
-      <p:sp>
-        <p:nvSpPr>
-          <p:cNvPr id="9" name="TextBox 8"/>
+              <a:t>✓</a:t>
+            </a:r>
+          </a:p>
+        </p:txBody>
+      </p:sp>
+      <p:sp>
+        <p:nvSpPr>
+          <p:cNvPr id="8" name="TextBox 7"/>
           <p:cNvSpPr txBox="1"/>
           <p:nvPr/>
         </p:nvSpPr>
         <p:spPr>
           <a:xfrm>
-            <a:off x="1005840" y="2615184"/>
-            <a:ext cx="10725912" cy="502920"/>
+            <a:off x="1097280" y="2468880"/>
+            <a:ext cx="10515600" cy="411480"/>
           </a:xfrm>
           <a:prstGeom prst="rect">
             <a:avLst/>
@@ -24472,33 +24427,33 @@
           <a:noFill/>
         </p:spPr>
         <p:txBody>
-          <a:bodyPr wrap="square">
+          <a:bodyPr wrap="none">
             <a:spAutoFit/>
           </a:bodyPr>
           <a:lstStyle/>
           <a:p>
             <a:pPr>
-              <a:defRPr sz="2200">
-                <a:solidFill>
-                  <a:srgbClr val="FFFFFF"/>
-                </a:solidFill>
-              </a:defRPr>
-            </a:pPr>
-            <a:r>
-              <a:t>Write effective prompts and use Extended Thinking for complex tasks</a:t>
-            </a:r>
-          </a:p>
-        </p:txBody>
-      </p:sp>
-      <p:sp>
-        <p:nvSpPr>
-          <p:cNvPr id="10" name="Oval 9"/>
+              <a:defRPr sz="2000">
+                <a:solidFill>
+                  <a:srgbClr val="D1D5DB"/>
+                </a:solidFill>
+              </a:defRPr>
+            </a:pPr>
+            <a:r>
+              <a:t>Choose the right Claude model and use Extended Thinking</a:t>
+            </a:r>
+          </a:p>
+        </p:txBody>
+      </p:sp>
+      <p:sp>
+        <p:nvSpPr>
+          <p:cNvPr id="9" name="Oval 8"/>
           <p:cNvSpPr/>
           <p:nvPr/>
         </p:nvSpPr>
         <p:spPr>
           <a:xfrm>
-            <a:off x="457200" y="3255264"/>
+            <a:off x="548640" y="3063240"/>
             <a:ext cx="365760" cy="365760"/>
           </a:xfrm>
           <a:prstGeom prst="ellipse">
@@ -24537,21 +24492,21 @@
               </a:defRPr>
             </a:pPr>
             <a:r>
-              <a:t>v</a:t>
-            </a:r>
-          </a:p>
-        </p:txBody>
-      </p:sp>
-      <p:sp>
-        <p:nvSpPr>
-          <p:cNvPr id="11" name="TextBox 10"/>
+              <a:t>✓</a:t>
+            </a:r>
+          </a:p>
+        </p:txBody>
+      </p:sp>
+      <p:sp>
+        <p:nvSpPr>
+          <p:cNvPr id="10" name="TextBox 9"/>
           <p:cNvSpPr txBox="1"/>
           <p:nvPr/>
         </p:nvSpPr>
         <p:spPr>
           <a:xfrm>
-            <a:off x="1005840" y="3273552"/>
-            <a:ext cx="10725912" cy="502920"/>
+            <a:off x="1097280" y="3063240"/>
+            <a:ext cx="10515600" cy="411480"/>
           </a:xfrm>
           <a:prstGeom prst="rect">
             <a:avLst/>
@@ -24559,33 +24514,33 @@
           <a:noFill/>
         </p:spPr>
         <p:txBody>
-          <a:bodyPr wrap="square">
+          <a:bodyPr wrap="none">
             <a:spAutoFit/>
           </a:bodyPr>
           <a:lstStyle/>
           <a:p>
             <a:pPr>
-              <a:defRPr sz="2200">
-                <a:solidFill>
-                  <a:srgbClr val="FFFFFF"/>
-                </a:solidFill>
-              </a:defRPr>
-            </a:pPr>
-            <a:r>
-              <a:t>Use Claude in Excel for formula assistance and data analysis</a:t>
-            </a:r>
-          </a:p>
-        </p:txBody>
-      </p:sp>
-      <p:sp>
-        <p:nvSpPr>
-          <p:cNvPr id="12" name="Oval 11"/>
+              <a:defRPr sz="2000">
+                <a:solidFill>
+                  <a:srgbClr val="D1D5DB"/>
+                </a:solidFill>
+              </a:defRPr>
+            </a:pPr>
+            <a:r>
+              <a:t>Configure settings, Personal Preferences, and privacy controls</a:t>
+            </a:r>
+          </a:p>
+        </p:txBody>
+      </p:sp>
+      <p:sp>
+        <p:nvSpPr>
+          <p:cNvPr id="11" name="Oval 10"/>
           <p:cNvSpPr/>
           <p:nvPr/>
         </p:nvSpPr>
         <p:spPr>
           <a:xfrm>
-            <a:off x="457200" y="3913631"/>
+            <a:off x="548640" y="3657600"/>
             <a:ext cx="365760" cy="365760"/>
           </a:xfrm>
           <a:prstGeom prst="ellipse">
@@ -24624,21 +24579,21 @@
               </a:defRPr>
             </a:pPr>
             <a:r>
-              <a:t>v</a:t>
-            </a:r>
-          </a:p>
-        </p:txBody>
-      </p:sp>
-      <p:sp>
-        <p:nvSpPr>
-          <p:cNvPr id="13" name="TextBox 12"/>
+              <a:t>✓</a:t>
+            </a:r>
+          </a:p>
+        </p:txBody>
+      </p:sp>
+      <p:sp>
+        <p:nvSpPr>
+          <p:cNvPr id="12" name="TextBox 11"/>
           <p:cNvSpPr txBox="1"/>
           <p:nvPr/>
         </p:nvSpPr>
         <p:spPr>
           <a:xfrm>
-            <a:off x="1005840" y="3931919"/>
-            <a:ext cx="10725912" cy="502920"/>
+            <a:off x="1097280" y="3657600"/>
+            <a:ext cx="10515600" cy="411480"/>
           </a:xfrm>
           <a:prstGeom prst="rect">
             <a:avLst/>
@@ -24646,33 +24601,33 @@
           <a:noFill/>
         </p:spPr>
         <p:txBody>
-          <a:bodyPr wrap="square">
+          <a:bodyPr wrap="none">
             <a:spAutoFit/>
           </a:bodyPr>
           <a:lstStyle/>
           <a:p>
             <a:pPr>
-              <a:defRPr sz="2200">
-                <a:solidFill>
-                  <a:srgbClr val="FFFFFF"/>
-                </a:solidFill>
-              </a:defRPr>
-            </a:pPr>
-            <a:r>
-              <a:t>Use artifacts for code, documents, and diagrams</a:t>
-            </a:r>
-          </a:p>
-        </p:txBody>
-      </p:sp>
-      <p:sp>
-        <p:nvSpPr>
-          <p:cNvPr id="14" name="Oval 13"/>
+              <a:defRPr sz="2000">
+                <a:solidFill>
+                  <a:srgbClr val="D1D5DB"/>
+                </a:solidFill>
+              </a:defRPr>
+            </a:pPr>
+            <a:r>
+              <a:t>Set up and use Claude Apps (Desktop, Mobile) and Claude for Work</a:t>
+            </a:r>
+          </a:p>
+        </p:txBody>
+      </p:sp>
+      <p:sp>
+        <p:nvSpPr>
+          <p:cNvPr id="13" name="Oval 12"/>
           <p:cNvSpPr/>
           <p:nvPr/>
         </p:nvSpPr>
         <p:spPr>
           <a:xfrm>
-            <a:off x="457200" y="4572000"/>
+            <a:off x="548640" y="4251960"/>
             <a:ext cx="365760" cy="365760"/>
           </a:xfrm>
           <a:prstGeom prst="ellipse">
@@ -24711,21 +24666,21 @@
               </a:defRPr>
             </a:pPr>
             <a:r>
-              <a:t>v</a:t>
-            </a:r>
-          </a:p>
-        </p:txBody>
-      </p:sp>
-      <p:sp>
-        <p:nvSpPr>
-          <p:cNvPr id="15" name="TextBox 14"/>
+              <a:t>✓</a:t>
+            </a:r>
+          </a:p>
+        </p:txBody>
+      </p:sp>
+      <p:sp>
+        <p:nvSpPr>
+          <p:cNvPr id="14" name="TextBox 13"/>
           <p:cNvSpPr txBox="1"/>
           <p:nvPr/>
         </p:nvSpPr>
         <p:spPr>
           <a:xfrm>
-            <a:off x="1005840" y="4590288"/>
-            <a:ext cx="10725912" cy="502920"/>
+            <a:off x="1097280" y="4251960"/>
+            <a:ext cx="10515600" cy="411480"/>
           </a:xfrm>
           <a:prstGeom prst="rect">
             <a:avLst/>
@@ -24733,33 +24688,33 @@
           <a:noFill/>
         </p:spPr>
         <p:txBody>
-          <a:bodyPr wrap="square">
+          <a:bodyPr wrap="none">
             <a:spAutoFit/>
           </a:bodyPr>
           <a:lstStyle/>
           <a:p>
             <a:pPr>
-              <a:defRPr sz="2200">
-                <a:solidFill>
-                  <a:srgbClr val="FFFFFF"/>
-                </a:solidFill>
-              </a:defRPr>
-            </a:pPr>
-            <a:r>
-              <a:t>Apply Claude to common business workflows</a:t>
-            </a:r>
-          </a:p>
-        </p:txBody>
-      </p:sp>
-      <p:sp>
-        <p:nvSpPr>
-          <p:cNvPr id="16" name="Oval 15"/>
+              <a:defRPr sz="2000">
+                <a:solidFill>
+                  <a:srgbClr val="D1D5DB"/>
+                </a:solidFill>
+              </a:defRPr>
+            </a:pPr>
+            <a:r>
+              <a:t>Create and manage Projects with Custom Instructions</a:t>
+            </a:r>
+          </a:p>
+        </p:txBody>
+      </p:sp>
+      <p:sp>
+        <p:nvSpPr>
+          <p:cNvPr id="15" name="Oval 14"/>
           <p:cNvSpPr/>
           <p:nvPr/>
         </p:nvSpPr>
         <p:spPr>
           <a:xfrm>
-            <a:off x="457200" y="5230368"/>
+            <a:off x="548640" y="4846320"/>
             <a:ext cx="365760" cy="365760"/>
           </a:xfrm>
           <a:prstGeom prst="ellipse">
@@ -24798,21 +24753,21 @@
               </a:defRPr>
             </a:pPr>
             <a:r>
-              <a:t>v</a:t>
-            </a:r>
-          </a:p>
-        </p:txBody>
-      </p:sp>
-      <p:sp>
-        <p:nvSpPr>
-          <p:cNvPr id="17" name="TextBox 16"/>
+              <a:t>✓</a:t>
+            </a:r>
+          </a:p>
+        </p:txBody>
+      </p:sp>
+      <p:sp>
+        <p:nvSpPr>
+          <p:cNvPr id="16" name="TextBox 15"/>
           <p:cNvSpPr txBox="1"/>
           <p:nvPr/>
         </p:nvSpPr>
         <p:spPr>
           <a:xfrm>
-            <a:off x="1005840" y="5248656"/>
-            <a:ext cx="10725912" cy="502920"/>
+            <a:off x="1097280" y="4846320"/>
+            <a:ext cx="10515600" cy="411480"/>
           </a:xfrm>
           <a:prstGeom prst="rect">
             <a:avLst/>
@@ -24820,33 +24775,33 @@
           <a:noFill/>
         </p:spPr>
         <p:txBody>
-          <a:bodyPr wrap="square">
+          <a:bodyPr wrap="none">
             <a:spAutoFit/>
           </a:bodyPr>
           <a:lstStyle/>
           <a:p>
             <a:pPr>
-              <a:defRPr sz="2200">
-                <a:solidFill>
-                  <a:srgbClr val="FFFFFF"/>
-                </a:solidFill>
-              </a:defRPr>
-            </a:pPr>
-            <a:r>
-              <a:t>Configure Claude Desktop, Voice Mode, and Personal Preferences</a:t>
-            </a:r>
-          </a:p>
-        </p:txBody>
-      </p:sp>
-      <p:sp>
-        <p:nvSpPr>
-          <p:cNvPr id="18" name="Oval 17"/>
+              <a:defRPr sz="2000">
+                <a:solidFill>
+                  <a:srgbClr val="D1D5DB"/>
+                </a:solidFill>
+              </a:defRPr>
+            </a:pPr>
+            <a:r>
+              <a:t>Analyze data in Claude.ai and Claude in Excel</a:t>
+            </a:r>
+          </a:p>
+        </p:txBody>
+      </p:sp>
+      <p:sp>
+        <p:nvSpPr>
+          <p:cNvPr id="17" name="Oval 16"/>
           <p:cNvSpPr/>
           <p:nvPr/>
         </p:nvSpPr>
         <p:spPr>
           <a:xfrm>
-            <a:off x="457200" y="5888736"/>
+            <a:off x="548640" y="5440679"/>
             <a:ext cx="365760" cy="365760"/>
           </a:xfrm>
           <a:prstGeom prst="ellipse">
@@ -24885,21 +24840,21 @@
               </a:defRPr>
             </a:pPr>
             <a:r>
-              <a:t>v</a:t>
-            </a:r>
-          </a:p>
-        </p:txBody>
-      </p:sp>
-      <p:sp>
-        <p:nvSpPr>
-          <p:cNvPr id="19" name="TextBox 18"/>
+              <a:t>✓</a:t>
+            </a:r>
+          </a:p>
+        </p:txBody>
+      </p:sp>
+      <p:sp>
+        <p:nvSpPr>
+          <p:cNvPr id="18" name="TextBox 17"/>
           <p:cNvSpPr txBox="1"/>
           <p:nvPr/>
         </p:nvSpPr>
         <p:spPr>
           <a:xfrm>
-            <a:off x="1005840" y="5907023"/>
-            <a:ext cx="10725912" cy="502920"/>
+            <a:off x="1097280" y="5440679"/>
+            <a:ext cx="10515600" cy="411480"/>
           </a:xfrm>
           <a:prstGeom prst="rect">
             <a:avLst/>
@@ -24907,20 +24862,20 @@
           <a:noFill/>
         </p:spPr>
         <p:txBody>
-          <a:bodyPr wrap="square">
+          <a:bodyPr wrap="none">
             <a:spAutoFit/>
           </a:bodyPr>
           <a:lstStyle/>
           <a:p>
             <a:pPr>
-              <a:defRPr sz="2200">
-                <a:solidFill>
-                  <a:srgbClr val="FFFFFF"/>
-                </a:solidFill>
-              </a:defRPr>
-            </a:pPr>
-            <a:r>
-              <a:t>Understand Claude's security model and data privacy controls</a:t>
+              <a:defRPr sz="2000">
+                <a:solidFill>
+                  <a:srgbClr val="D1D5DB"/>
+                </a:solidFill>
+              </a:defRPr>
+            </a:pPr>
+            <a:r>
+              <a:t>Use artifacts, file uploads, and integrations for business workflows</a:t>
             </a:r>
           </a:p>
         </p:txBody>

</xml_diff>

<commit_message>
Day 1: Update agenda slide to match 4-lab structure
Morning: Claude Interface (30) → Prompt Engineering & Lab 1 (60) →
Break → Claude Settings (45) → Projects & Lab 2 (45)

Afternoon: Analysis Prompts & Claude in Excel (45) → Lab 3 (30) →
Break → Artifacts & Files (45) → Lab 4, Wrap-up & Q&A (45)
</commit_message>
<xml_diff>
--- a/slides/Day1_Claude_for_Business.pptx
+++ b/slides/Day1_Claude_for_Business.pptx
@@ -2637,19 +2637,22 @@
           <a:lstStyle/>
           <a:p>
             <a:r>
+              <a:rPr dirty="0"/>
               <a:t>TIME: 2 min</a:t>
             </a:r>
           </a:p>
           <a:p>
-            <a:endParaRPr/>
-          </a:p>
-          <a:p>
-            <a:r>
+            <a:endParaRPr dirty="0"/>
+          </a:p>
+          <a:p>
+            <a:r>
+              <a:rPr dirty="0"/>
               <a:t>KEY POINTS:</a:t>
             </a:r>
           </a:p>
           <a:p>
             <a:r>
+              <a:rPr dirty="0"/>
               <a:t>   * Morning: Understanding Claude and how to talk to it effectively</a:t>
             </a:r>
           </a:p>
@@ -2660,24 +2663,28 @@
           </a:p>
           <a:p>
             <a:r>
+              <a:rPr dirty="0"/>
               <a:t>   * Two 15-minute breaks plus 1-hour lunch</a:t>
             </a:r>
           </a:p>
           <a:p>
             <a:r>
+              <a:rPr dirty="0"/>
               <a:t>   * Hands-on practice twice today</a:t>
             </a:r>
           </a:p>
           <a:p>
-            <a:endParaRPr/>
-          </a:p>
-          <a:p>
-            <a:r>
+            <a:endParaRPr dirty="0"/>
+          </a:p>
+          <a:p>
+            <a:r>
+              <a:rPr dirty="0"/>
               <a:t>TRANSITION:</a:t>
             </a:r>
           </a:p>
           <a:p>
             <a:r>
+              <a:rPr dirty="0"/>
               <a:t>   Let's see what you'll be able to do by end of day</a:t>
             </a:r>
           </a:p>
@@ -17591,7 +17598,7 @@
               </a:defRPr>
             </a:pPr>
             <a:r>
-              <a:t>Claude Landscape</a:t>
+              <a:t>Claude Interface</a:t>
             </a:r>
           </a:p>
         </p:txBody>
@@ -17707,7 +17714,8 @@
               </a:defRPr>
             </a:pPr>
             <a:r>
-              <a:t>Interface &amp; Projects</a:t>
+              <a:rPr dirty="0"/>
+              <a:t>Prompt Engineering &amp; Lab 1</a:t>
             </a:r>
           </a:p>
         </p:txBody>
@@ -17788,7 +17796,7 @@
               </a:defRPr>
             </a:pPr>
             <a:r>
-              <a:t>45 min</a:t>
+              <a:t>60 min</a:t>
             </a:r>
           </a:p>
         </p:txBody>
@@ -17983,7 +17991,7 @@
               </a:defRPr>
             </a:pPr>
             <a:r>
-              <a:t>Prompt Engineering</a:t>
+              <a:t>Claude Settings</a:t>
             </a:r>
           </a:p>
         </p:txBody>
@@ -18143,7 +18151,7 @@
               </a:defRPr>
             </a:pPr>
             <a:r>
-              <a:t>Lab 1</a:t>
+              <a:t>Projects &amp; Lab 2</a:t>
             </a:r>
           </a:p>
         </p:txBody>
@@ -18382,7 +18390,7 @@
               </a:defRPr>
             </a:pPr>
             <a:r>
-              <a:t>Claude in Excel</a:t>
+              <a:t>Analysis Prompts &amp; Claude in Excel</a:t>
             </a:r>
           </a:p>
         </p:txBody>
@@ -18498,7 +18506,7 @@
               </a:defRPr>
             </a:pPr>
             <a:r>
-              <a:t>Artifacts &amp; Files</a:t>
+              <a:t>Lab 3</a:t>
             </a:r>
           </a:p>
         </p:txBody>
@@ -18774,7 +18782,7 @@
               </a:defRPr>
             </a:pPr>
             <a:r>
-              <a:t>Lab 2</a:t>
+              <a:t>Artifacts &amp; Files</a:t>
             </a:r>
           </a:p>
         </p:txBody>
@@ -18934,7 +18942,7 @@
               </a:defRPr>
             </a:pPr>
             <a:r>
-              <a:t>Wrap-up &amp; Q&amp;A</a:t>
+              <a:t>Lab 4, Wrap-up &amp; Q&amp;A</a:t>
             </a:r>
           </a:p>
         </p:txBody>
@@ -20180,6 +20188,88 @@
       <p:sp>
         <p:nvSpPr>
           <p:cNvPr id="24" name="TextBox 23"/>
+          <p:cNvSpPr txBox="1"/>
+          <p:nvPr/>
+        </p:nvSpPr>
+        <p:spPr>
+          <a:xfrm>
+            <a:off x="9144000" y="5303520"/>
+            <a:ext cx="2194560" cy="365760"/>
+          </a:xfrm>
+          <a:prstGeom prst="rect">
+            <a:avLst/>
+          </a:prstGeom>
+          <a:noFill/>
+        </p:spPr>
+        <p:txBody>
+          <a:bodyPr wrap="none">
+            <a:spAutoFit/>
+          </a:bodyPr>
+          <a:lstStyle/>
+          <a:p>
+            <a:pPr algn="ctr">
+              <a:defRPr sz="1200" i="1">
+                <a:solidFill>
+                  <a:srgbClr val="14B8A6"/>
+                </a:solidFill>
+              </a:defRPr>
+            </a:pPr>
+            <a:r>
+              <a:t>5 min</a:t>
+            </a:r>
+          </a:p>
+        </p:txBody>
+      </p:sp>
+      <p:sp>
+        <p:nvSpPr>
+          <p:cNvPr id="25" name="TextBox 24"/>
+          <p:cNvSpPr txBox="1"/>
+          <p:nvPr/>
+        </p:nvSpPr>
+        <p:spPr>
+          <a:xfrm>
+            <a:off x="9144000" y="3749039"/>
+            <a:ext cx="2194560" cy="1645920"/>
+          </a:xfrm>
+          <a:prstGeom prst="rect">
+            <a:avLst/>
+          </a:prstGeom>
+          <a:noFill/>
+        </p:spPr>
+        <p:txBody>
+          <a:bodyPr wrap="square">
+            <a:spAutoFit/>
+          </a:bodyPr>
+          <a:lstStyle/>
+          <a:p>
+            <a:pPr algn="ctr">
+              <a:defRPr sz="1300">
+                <a:solidFill>
+                  <a:srgbClr val="D1D5DB"/>
+                </a:solidFill>
+              </a:defRPr>
+            </a:pPr>
+            <a:r>
+              <a:t>5 rapid-fire prompts</a:t>
+            </a:r>
+            <a:br/>
+            <a:r>
+              <a:t>for your actual job.</a:t>
+            </a:r>
+            <a:br/>
+            <a:r>
+              <a:t>Use what you learned.</a:t>
+            </a:r>
+            <a:br/>
+            <a:r>
+              <a:t>Keep the best outputs.</a:t>
+            </a:r>
+          </a:p>
+        </p:txBody>
+      </p:sp>
+      <p:sp>
+        <p:nvSpPr>
+          <p:cNvPr id="26" name="TextBox 25"/>
           <p:cNvSpPr txBox="1"/>
           <p:nvPr/>
         </p:nvSpPr>
@@ -25995,14 +26085,20 @@
       </p:grpSpPr>
       <p:sp>
         <p:nvSpPr>
-          <p:cNvPr id="2" name="TextBox 1"/>
+          <p:cNvPr id="2" name="TextBox 1">
+            <a:extLst>
+              <a:ext uri="{FF2B5EF4-FFF2-40B4-BE49-F238E27FC236}">
+                <a16:creationId xmlns:a16="http://schemas.microsoft.com/office/drawing/2014/main" id="{2512AD6E-847D-17B1-15AD-6F52430D57A3}"/>
+              </a:ext>
+            </a:extLst>
+          </p:cNvPr>
           <p:cNvSpPr txBox="1"/>
           <p:nvPr/>
         </p:nvSpPr>
         <p:spPr>
           <a:xfrm>
-            <a:off x="457200" y="274320"/>
-            <a:ext cx="11247120" cy="822960"/>
+            <a:off x="457200" y="457200"/>
+            <a:ext cx="11277295" cy="731520"/>
           </a:xfrm>
           <a:prstGeom prst="rect">
             <a:avLst/>
@@ -26015,29 +26111,142 @@
           </a:bodyPr>
           <a:lstStyle/>
           <a:p>
-            <a:pPr>
-              <a:defRPr sz="4000" b="1">
+            <a:pPr marL="0" marR="0" lvl="0" indent="0" algn="ctr" defTabSz="457200" rtl="0" eaLnBrk="1" fontAlgn="auto" latinLnBrk="0" hangingPunct="1">
+              <a:lnSpc>
+                <a:spcPct val="100000"/>
+              </a:lnSpc>
+              <a:spcBef>
+                <a:spcPts val="0"/>
+              </a:spcBef>
+              <a:spcAft>
+                <a:spcPts val="0"/>
+              </a:spcAft>
+              <a:buClrTx/>
+              <a:buSzTx/>
+              <a:buFontTx/>
+              <a:buNone/>
+              <a:tabLst/>
+              <a:defRPr sz="3600" b="1">
                 <a:solidFill>
                   <a:srgbClr val="FFFFFF"/>
                 </a:solidFill>
               </a:defRPr>
             </a:pPr>
             <a:r>
-              <a:t>Claude Apps: Desktop &amp; Mobile</a:t>
-            </a:r>
-          </a:p>
-        </p:txBody>
-      </p:sp>
-      <p:sp>
-        <p:nvSpPr>
-          <p:cNvPr id="3" name="TextBox 2"/>
+              <a:rPr kumimoji="0" sz="3600" b="1" i="0" u="none" strike="noStrike" kern="1200" cap="none" spc="0" normalizeH="0" baseline="0" noProof="0">
+                <a:ln>
+                  <a:noFill/>
+                </a:ln>
+                <a:solidFill>
+                  <a:srgbClr val="FFFFFF"/>
+                </a:solidFill>
+                <a:effectLst/>
+                <a:uLnTx/>
+                <a:uFillTx/>
+                <a:latin typeface="Calibri"/>
+                <a:ea typeface="+mn-ea"/>
+                <a:cs typeface="+mn-cs"/>
+              </a:rPr>
+              <a:t>Claude Desktop App: Autonomous Features</a:t>
+            </a:r>
+          </a:p>
+        </p:txBody>
+      </p:sp>
+      <p:sp>
+        <p:nvSpPr>
+          <p:cNvPr id="3" name="Rectangle 2">
+            <a:extLst>
+              <a:ext uri="{FF2B5EF4-FFF2-40B4-BE49-F238E27FC236}">
+                <a16:creationId xmlns:a16="http://schemas.microsoft.com/office/drawing/2014/main" id="{F2342D46-CB66-679A-1AF0-A4EC62C02D83}"/>
+              </a:ext>
+            </a:extLst>
+          </p:cNvPr>
+          <p:cNvSpPr/>
+          <p:nvPr/>
+        </p:nvSpPr>
+        <p:spPr>
+          <a:xfrm>
+            <a:off x="6077559" y="1371600"/>
+            <a:ext cx="36576" cy="4572000"/>
+          </a:xfrm>
+          <a:prstGeom prst="rect">
+            <a:avLst/>
+          </a:prstGeom>
+          <a:solidFill>
+            <a:srgbClr val="00D4AA"/>
+          </a:solidFill>
+          <a:ln>
+            <a:noFill/>
+          </a:ln>
+        </p:spPr>
+        <p:style>
+          <a:lnRef idx="1">
+            <a:schemeClr val="accent1"/>
+          </a:lnRef>
+          <a:fillRef idx="3">
+            <a:schemeClr val="accent1"/>
+          </a:fillRef>
+          <a:effectRef idx="2">
+            <a:schemeClr val="accent1"/>
+          </a:effectRef>
+          <a:fontRef idx="minor">
+            <a:schemeClr val="lt1"/>
+          </a:fontRef>
+        </p:style>
+        <p:txBody>
+          <a:bodyPr rtlCol="0" anchor="ctr"/>
+          <a:lstStyle/>
+          <a:p>
+            <a:pPr marL="0" marR="0" lvl="0" indent="0" algn="ctr" defTabSz="457200" rtl="0" eaLnBrk="1" fontAlgn="auto" latinLnBrk="0" hangingPunct="1">
+              <a:lnSpc>
+                <a:spcPct val="100000"/>
+              </a:lnSpc>
+              <a:spcBef>
+                <a:spcPts val="0"/>
+              </a:spcBef>
+              <a:spcAft>
+                <a:spcPts val="0"/>
+              </a:spcAft>
+              <a:buClrTx/>
+              <a:buSzTx/>
+              <a:buFontTx/>
+              <a:buNone/>
+              <a:tabLst/>
+              <a:defRPr/>
+            </a:pPr>
+            <a:endParaRPr kumimoji="0" sz="1800" b="0" i="0" u="none" strike="noStrike" kern="1200" cap="none" spc="0" normalizeH="0" baseline="0" noProof="0">
+              <a:ln>
+                <a:noFill/>
+              </a:ln>
+              <a:solidFill>
+                <a:prstClr val="white"/>
+              </a:solidFill>
+              <a:effectLst/>
+              <a:uLnTx/>
+              <a:uFillTx/>
+              <a:latin typeface="Calibri"/>
+              <a:ea typeface="+mn-ea"/>
+              <a:cs typeface="+mn-cs"/>
+            </a:endParaRPr>
+          </a:p>
+        </p:txBody>
+      </p:sp>
+      <p:sp>
+        <p:nvSpPr>
+          <p:cNvPr id="4" name="TextBox 3">
+            <a:extLst>
+              <a:ext uri="{FF2B5EF4-FFF2-40B4-BE49-F238E27FC236}">
+                <a16:creationId xmlns:a16="http://schemas.microsoft.com/office/drawing/2014/main" id="{73C77848-149A-A14D-E3EE-836747772290}"/>
+              </a:ext>
+            </a:extLst>
+          </p:cNvPr>
           <p:cNvSpPr txBox="1"/>
           <p:nvPr/>
         </p:nvSpPr>
         <p:spPr>
           <a:xfrm>
-            <a:off x="457200" y="1097280"/>
-            <a:ext cx="11247120" cy="457200"/>
+            <a:off x="457200" y="1463040"/>
+            <a:ext cx="5364327" cy="731520"/>
           </a:xfrm>
           <a:prstGeom prst="rect">
             <a:avLst/>
@@ -26050,6 +26259,751 @@
           </a:bodyPr>
           <a:lstStyle/>
           <a:p>
+            <a:pPr marL="0" marR="0" lvl="0" indent="0" algn="ctr" defTabSz="457200" rtl="0" eaLnBrk="1" fontAlgn="auto" latinLnBrk="0" hangingPunct="1">
+              <a:lnSpc>
+                <a:spcPct val="100000"/>
+              </a:lnSpc>
+              <a:spcBef>
+                <a:spcPts val="0"/>
+              </a:spcBef>
+              <a:spcAft>
+                <a:spcPts val="0"/>
+              </a:spcAft>
+              <a:buClrTx/>
+              <a:buSzTx/>
+              <a:buFontTx/>
+              <a:buNone/>
+              <a:tabLst/>
+              <a:defRPr sz="2800" b="1">
+                <a:solidFill>
+                  <a:srgbClr val="0078D4"/>
+                </a:solidFill>
+              </a:defRPr>
+            </a:pPr>
+            <a:r>
+              <a:rPr kumimoji="0" sz="2800" b="1" i="0" u="none" strike="noStrike" kern="1200" cap="none" spc="0" normalizeH="0" baseline="0" noProof="0">
+                <a:ln>
+                  <a:noFill/>
+                </a:ln>
+                <a:solidFill>
+                  <a:srgbClr val="0078D4"/>
+                </a:solidFill>
+                <a:effectLst/>
+                <a:uLnTx/>
+                <a:uFillTx/>
+                <a:latin typeface="Calibri"/>
+                <a:ea typeface="+mn-ea"/>
+                <a:cs typeface="+mn-cs"/>
+              </a:rPr>
+              <a:t>Claude.ai (What You Know)</a:t>
+            </a:r>
+          </a:p>
+        </p:txBody>
+      </p:sp>
+      <p:sp>
+        <p:nvSpPr>
+          <p:cNvPr id="5" name="TextBox 4">
+            <a:extLst>
+              <a:ext uri="{FF2B5EF4-FFF2-40B4-BE49-F238E27FC236}">
+                <a16:creationId xmlns:a16="http://schemas.microsoft.com/office/drawing/2014/main" id="{1C183914-50C0-E52E-1C75-A7BCAB4D4A0A}"/>
+              </a:ext>
+            </a:extLst>
+          </p:cNvPr>
+          <p:cNvSpPr txBox="1"/>
+          <p:nvPr/>
+        </p:nvSpPr>
+        <p:spPr>
+          <a:xfrm>
+            <a:off x="457200" y="2286000"/>
+            <a:ext cx="5364327" cy="3657600"/>
+          </a:xfrm>
+          <a:prstGeom prst="rect">
+            <a:avLst/>
+          </a:prstGeom>
+          <a:noFill/>
+        </p:spPr>
+        <p:txBody>
+          <a:bodyPr wrap="square">
+            <a:spAutoFit/>
+          </a:bodyPr>
+          <a:lstStyle/>
+          <a:p>
+            <a:pPr marL="0" marR="0" lvl="0" indent="0" algn="l" defTabSz="457200" rtl="0" eaLnBrk="1" fontAlgn="auto" latinLnBrk="0" hangingPunct="1">
+              <a:lnSpc>
+                <a:spcPct val="100000"/>
+              </a:lnSpc>
+              <a:spcBef>
+                <a:spcPts val="0"/>
+              </a:spcBef>
+              <a:spcAft>
+                <a:spcPts val="1200"/>
+              </a:spcAft>
+              <a:buClrTx/>
+              <a:buSzTx/>
+              <a:buFontTx/>
+              <a:buNone/>
+              <a:tabLst/>
+              <a:defRPr sz="1800">
+                <a:solidFill>
+                  <a:srgbClr val="FFFFFF"/>
+                </a:solidFill>
+              </a:defRPr>
+            </a:pPr>
+            <a:r>
+              <a:rPr kumimoji="0" sz="1800" b="0" i="0" u="none" strike="noStrike" kern="1200" cap="none" spc="0" normalizeH="0" baseline="0" noProof="0">
+                <a:ln>
+                  <a:noFill/>
+                </a:ln>
+                <a:solidFill>
+                  <a:srgbClr val="FFFFFF"/>
+                </a:solidFill>
+                <a:effectLst/>
+                <a:uLnTx/>
+                <a:uFillTx/>
+                <a:latin typeface="Calibri"/>
+                <a:ea typeface="+mn-ea"/>
+                <a:cs typeface="+mn-cs"/>
+              </a:rPr>
+              <a:t>  Back-and-forth conversation</a:t>
+            </a:r>
+          </a:p>
+          <a:p>
+            <a:pPr marL="0" marR="0" lvl="0" indent="0" algn="l" defTabSz="457200" rtl="0" eaLnBrk="1" fontAlgn="auto" latinLnBrk="0" hangingPunct="1">
+              <a:lnSpc>
+                <a:spcPct val="100000"/>
+              </a:lnSpc>
+              <a:spcBef>
+                <a:spcPts val="0"/>
+              </a:spcBef>
+              <a:spcAft>
+                <a:spcPts val="1200"/>
+              </a:spcAft>
+              <a:buClrTx/>
+              <a:buSzTx/>
+              <a:buFontTx/>
+              <a:buNone/>
+              <a:tabLst/>
+              <a:defRPr sz="1800">
+                <a:solidFill>
+                  <a:srgbClr val="FFFFFF"/>
+                </a:solidFill>
+              </a:defRPr>
+            </a:pPr>
+            <a:r>
+              <a:rPr kumimoji="0" sz="1800" b="0" i="0" u="none" strike="noStrike" kern="1200" cap="none" spc="0" normalizeH="0" baseline="0" noProof="0">
+                <a:ln>
+                  <a:noFill/>
+                </a:ln>
+                <a:solidFill>
+                  <a:srgbClr val="FFFFFF"/>
+                </a:solidFill>
+                <a:effectLst/>
+                <a:uLnTx/>
+                <a:uFillTx/>
+                <a:latin typeface="Calibri"/>
+                <a:ea typeface="+mn-ea"/>
+                <a:cs typeface="+mn-cs"/>
+              </a:rPr>
+              <a:t>  You ask → Claude answers → repeat</a:t>
+            </a:r>
+          </a:p>
+          <a:p>
+            <a:pPr marL="0" marR="0" lvl="0" indent="0" algn="l" defTabSz="457200" rtl="0" eaLnBrk="1" fontAlgn="auto" latinLnBrk="0" hangingPunct="1">
+              <a:lnSpc>
+                <a:spcPct val="100000"/>
+              </a:lnSpc>
+              <a:spcBef>
+                <a:spcPts val="0"/>
+              </a:spcBef>
+              <a:spcAft>
+                <a:spcPts val="1200"/>
+              </a:spcAft>
+              <a:buClrTx/>
+              <a:buSzTx/>
+              <a:buFontTx/>
+              <a:buNone/>
+              <a:tabLst/>
+              <a:defRPr sz="1800">
+                <a:solidFill>
+                  <a:srgbClr val="FFFFFF"/>
+                </a:solidFill>
+              </a:defRPr>
+            </a:pPr>
+            <a:r>
+              <a:rPr kumimoji="0" sz="1800" b="0" i="0" u="none" strike="noStrike" kern="1200" cap="none" spc="0" normalizeH="0" baseline="0" noProof="0">
+                <a:ln>
+                  <a:noFill/>
+                </a:ln>
+                <a:solidFill>
+                  <a:srgbClr val="FFFFFF"/>
+                </a:solidFill>
+                <a:effectLst/>
+                <a:uLnTx/>
+                <a:uFillTx/>
+                <a:latin typeface="Calibri"/>
+                <a:ea typeface="+mn-ea"/>
+                <a:cs typeface="+mn-cs"/>
+              </a:rPr>
+              <a:t>  You stay in the chat the whole time</a:t>
+            </a:r>
+          </a:p>
+          <a:p>
+            <a:pPr marL="0" marR="0" lvl="0" indent="0" algn="l" defTabSz="457200" rtl="0" eaLnBrk="1" fontAlgn="auto" latinLnBrk="0" hangingPunct="1">
+              <a:lnSpc>
+                <a:spcPct val="100000"/>
+              </a:lnSpc>
+              <a:spcBef>
+                <a:spcPts val="0"/>
+              </a:spcBef>
+              <a:spcAft>
+                <a:spcPts val="1200"/>
+              </a:spcAft>
+              <a:buClrTx/>
+              <a:buSzTx/>
+              <a:buFontTx/>
+              <a:buNone/>
+              <a:tabLst/>
+              <a:defRPr sz="1800">
+                <a:solidFill>
+                  <a:srgbClr val="FFFFFF"/>
+                </a:solidFill>
+              </a:defRPr>
+            </a:pPr>
+            <a:r>
+              <a:rPr kumimoji="0" sz="1800" b="0" i="0" u="none" strike="noStrike" kern="1200" cap="none" spc="0" normalizeH="0" baseline="0" noProof="0">
+                <a:ln>
+                  <a:noFill/>
+                </a:ln>
+                <a:solidFill>
+                  <a:srgbClr val="FFFFFF"/>
+                </a:solidFill>
+                <a:effectLst/>
+                <a:uLnTx/>
+                <a:uFillTx/>
+                <a:latin typeface="Calibri"/>
+                <a:ea typeface="+mn-ea"/>
+                <a:cs typeface="+mn-cs"/>
+              </a:rPr>
+              <a:t>  Great for real-time collaboration</a:t>
+            </a:r>
+          </a:p>
+          <a:p>
+            <a:pPr marL="0" marR="0" lvl="0" indent="0" algn="l" defTabSz="457200" rtl="0" eaLnBrk="1" fontAlgn="auto" latinLnBrk="0" hangingPunct="1">
+              <a:lnSpc>
+                <a:spcPct val="100000"/>
+              </a:lnSpc>
+              <a:spcBef>
+                <a:spcPts val="0"/>
+              </a:spcBef>
+              <a:spcAft>
+                <a:spcPts val="1200"/>
+              </a:spcAft>
+              <a:buClrTx/>
+              <a:buSzTx/>
+              <a:buFontTx/>
+              <a:buNone/>
+              <a:tabLst/>
+              <a:defRPr sz="1800">
+                <a:solidFill>
+                  <a:srgbClr val="FFFFFF"/>
+                </a:solidFill>
+              </a:defRPr>
+            </a:pPr>
+            <a:r>
+              <a:rPr kumimoji="0" sz="1800" b="0" i="0" u="none" strike="noStrike" kern="1200" cap="none" spc="0" normalizeH="0" baseline="0" noProof="0">
+                <a:ln>
+                  <a:noFill/>
+                </a:ln>
+                <a:solidFill>
+                  <a:srgbClr val="FFFFFF"/>
+                </a:solidFill>
+                <a:effectLst/>
+                <a:uLnTx/>
+                <a:uFillTx/>
+                <a:latin typeface="Calibri"/>
+                <a:ea typeface="+mn-ea"/>
+                <a:cs typeface="+mn-cs"/>
+              </a:rPr>
+              <a:t>  Immediate feedback and iteration</a:t>
+            </a:r>
+          </a:p>
+        </p:txBody>
+      </p:sp>
+      <p:sp>
+        <p:nvSpPr>
+          <p:cNvPr id="6" name="TextBox 5">
+            <a:extLst>
+              <a:ext uri="{FF2B5EF4-FFF2-40B4-BE49-F238E27FC236}">
+                <a16:creationId xmlns:a16="http://schemas.microsoft.com/office/drawing/2014/main" id="{1B1B1D5D-E934-7C33-E35D-0D76F7A0930D}"/>
+              </a:ext>
+            </a:extLst>
+          </p:cNvPr>
+          <p:cNvSpPr txBox="1"/>
+          <p:nvPr/>
+        </p:nvSpPr>
+        <p:spPr>
+          <a:xfrm>
+            <a:off x="6370167" y="1463040"/>
+            <a:ext cx="5364327" cy="731520"/>
+          </a:xfrm>
+          <a:prstGeom prst="rect">
+            <a:avLst/>
+          </a:prstGeom>
+          <a:noFill/>
+        </p:spPr>
+        <p:txBody>
+          <a:bodyPr wrap="none">
+            <a:spAutoFit/>
+          </a:bodyPr>
+          <a:lstStyle/>
+          <a:p>
+            <a:pPr marL="0" marR="0" lvl="0" indent="0" algn="ctr" defTabSz="457200" rtl="0" eaLnBrk="1" fontAlgn="auto" latinLnBrk="0" hangingPunct="1">
+              <a:lnSpc>
+                <a:spcPct val="100000"/>
+              </a:lnSpc>
+              <a:spcBef>
+                <a:spcPts val="0"/>
+              </a:spcBef>
+              <a:spcAft>
+                <a:spcPts val="0"/>
+              </a:spcAft>
+              <a:buClrTx/>
+              <a:buSzTx/>
+              <a:buFontTx/>
+              <a:buNone/>
+              <a:tabLst/>
+              <a:defRPr sz="2800" b="1">
+                <a:solidFill>
+                  <a:srgbClr val="00D4AA"/>
+                </a:solidFill>
+              </a:defRPr>
+            </a:pPr>
+            <a:r>
+              <a:rPr kumimoji="0" sz="2800" b="1" i="0" u="none" strike="noStrike" kern="1200" cap="none" spc="0" normalizeH="0" baseline="0" noProof="0">
+                <a:ln>
+                  <a:noFill/>
+                </a:ln>
+                <a:solidFill>
+                  <a:srgbClr val="00D4AA"/>
+                </a:solidFill>
+                <a:effectLst/>
+                <a:uLnTx/>
+                <a:uFillTx/>
+                <a:latin typeface="Calibri"/>
+                <a:ea typeface="+mn-ea"/>
+                <a:cs typeface="+mn-cs"/>
+              </a:rPr>
+              <a:t>Claude for Work (NEW Preview)</a:t>
+            </a:r>
+          </a:p>
+        </p:txBody>
+      </p:sp>
+      <p:sp>
+        <p:nvSpPr>
+          <p:cNvPr id="7" name="TextBox 6">
+            <a:extLst>
+              <a:ext uri="{FF2B5EF4-FFF2-40B4-BE49-F238E27FC236}">
+                <a16:creationId xmlns:a16="http://schemas.microsoft.com/office/drawing/2014/main" id="{9AEEBC51-4FB4-1A8D-646C-94CAA517A4B3}"/>
+              </a:ext>
+            </a:extLst>
+          </p:cNvPr>
+          <p:cNvSpPr txBox="1"/>
+          <p:nvPr/>
+        </p:nvSpPr>
+        <p:spPr>
+          <a:xfrm>
+            <a:off x="6370167" y="2286000"/>
+            <a:ext cx="5364327" cy="3657600"/>
+          </a:xfrm>
+          <a:prstGeom prst="rect">
+            <a:avLst/>
+          </a:prstGeom>
+          <a:noFill/>
+        </p:spPr>
+        <p:txBody>
+          <a:bodyPr wrap="square">
+            <a:spAutoFit/>
+          </a:bodyPr>
+          <a:lstStyle/>
+          <a:p>
+            <a:pPr marL="0" marR="0" lvl="0" indent="0" algn="l" defTabSz="457200" rtl="0" eaLnBrk="1" fontAlgn="auto" latinLnBrk="0" hangingPunct="1">
+              <a:lnSpc>
+                <a:spcPct val="100000"/>
+              </a:lnSpc>
+              <a:spcBef>
+                <a:spcPts val="0"/>
+              </a:spcBef>
+              <a:spcAft>
+                <a:spcPts val="1200"/>
+              </a:spcAft>
+              <a:buClrTx/>
+              <a:buSzTx/>
+              <a:buFontTx/>
+              <a:buNone/>
+              <a:tabLst/>
+              <a:defRPr sz="1800">
+                <a:solidFill>
+                  <a:srgbClr val="FFFFFF"/>
+                </a:solidFill>
+              </a:defRPr>
+            </a:pPr>
+            <a:r>
+              <a:rPr kumimoji="0" sz="1800" b="0" i="0" u="none" strike="noStrike" kern="1200" cap="none" spc="0" normalizeH="0" baseline="0" noProof="0">
+                <a:ln>
+                  <a:noFill/>
+                </a:ln>
+                <a:solidFill>
+                  <a:srgbClr val="FFFFFF"/>
+                </a:solidFill>
+                <a:effectLst/>
+                <a:uLnTx/>
+                <a:uFillTx/>
+                <a:latin typeface="Calibri"/>
+                <a:ea typeface="+mn-ea"/>
+                <a:cs typeface="+mn-cs"/>
+              </a:rPr>
+              <a:t>  Three modes: Chat, Cowork, Code tabs</a:t>
+            </a:r>
+          </a:p>
+          <a:p>
+            <a:pPr marL="0" marR="0" lvl="0" indent="0" algn="l" defTabSz="457200" rtl="0" eaLnBrk="1" fontAlgn="auto" latinLnBrk="0" hangingPunct="1">
+              <a:lnSpc>
+                <a:spcPct val="100000"/>
+              </a:lnSpc>
+              <a:spcBef>
+                <a:spcPts val="0"/>
+              </a:spcBef>
+              <a:spcAft>
+                <a:spcPts val="1200"/>
+              </a:spcAft>
+              <a:buClrTx/>
+              <a:buSzTx/>
+              <a:buFontTx/>
+              <a:buNone/>
+              <a:tabLst/>
+              <a:defRPr sz="1800">
+                <a:solidFill>
+                  <a:srgbClr val="FFFFFF"/>
+                </a:solidFill>
+              </a:defRPr>
+            </a:pPr>
+            <a:r>
+              <a:rPr kumimoji="0" sz="1800" b="0" i="0" u="none" strike="noStrike" kern="1200" cap="none" spc="0" normalizeH="0" baseline="0" noProof="0">
+                <a:ln>
+                  <a:noFill/>
+                </a:ln>
+                <a:solidFill>
+                  <a:srgbClr val="FFFFFF"/>
+                </a:solidFill>
+                <a:effectLst/>
+                <a:uLnTx/>
+                <a:uFillTx/>
+                <a:latin typeface="Calibri"/>
+                <a:ea typeface="+mn-ea"/>
+                <a:cs typeface="+mn-cs"/>
+              </a:rPr>
+              <a:t>  Set goal → Walk away → Come back later</a:t>
+            </a:r>
+          </a:p>
+          <a:p>
+            <a:pPr marL="0" marR="0" lvl="0" indent="0" algn="l" defTabSz="457200" rtl="0" eaLnBrk="1" fontAlgn="auto" latinLnBrk="0" hangingPunct="1">
+              <a:lnSpc>
+                <a:spcPct val="100000"/>
+              </a:lnSpc>
+              <a:spcBef>
+                <a:spcPts val="0"/>
+              </a:spcBef>
+              <a:spcAft>
+                <a:spcPts val="1200"/>
+              </a:spcAft>
+              <a:buClrTx/>
+              <a:buSzTx/>
+              <a:buFontTx/>
+              <a:buNone/>
+              <a:tabLst/>
+              <a:defRPr sz="1800">
+                <a:solidFill>
+                  <a:srgbClr val="FFFFFF"/>
+                </a:solidFill>
+              </a:defRPr>
+            </a:pPr>
+            <a:r>
+              <a:rPr kumimoji="0" sz="1800" b="0" i="0" u="none" strike="noStrike" kern="1200" cap="none" spc="0" normalizeH="0" baseline="0" noProof="0">
+                <a:ln>
+                  <a:noFill/>
+                </a:ln>
+                <a:solidFill>
+                  <a:srgbClr val="FFFFFF"/>
+                </a:solidFill>
+                <a:effectLst/>
+                <a:uLnTx/>
+                <a:uFillTx/>
+                <a:latin typeface="Calibri"/>
+                <a:ea typeface="+mn-ea"/>
+                <a:cs typeface="+mn-cs"/>
+              </a:rPr>
+              <a:t>  Works autonomously in background</a:t>
+            </a:r>
+          </a:p>
+          <a:p>
+            <a:pPr marL="0" marR="0" lvl="0" indent="0" algn="l" defTabSz="457200" rtl="0" eaLnBrk="1" fontAlgn="auto" latinLnBrk="0" hangingPunct="1">
+              <a:lnSpc>
+                <a:spcPct val="100000"/>
+              </a:lnSpc>
+              <a:spcBef>
+                <a:spcPts val="0"/>
+              </a:spcBef>
+              <a:spcAft>
+                <a:spcPts val="1200"/>
+              </a:spcAft>
+              <a:buClrTx/>
+              <a:buSzTx/>
+              <a:buFontTx/>
+              <a:buNone/>
+              <a:tabLst/>
+              <a:defRPr sz="1800">
+                <a:solidFill>
+                  <a:srgbClr val="FFFFFF"/>
+                </a:solidFill>
+              </a:defRPr>
+            </a:pPr>
+            <a:r>
+              <a:rPr kumimoji="0" sz="1800" b="0" i="0" u="none" strike="noStrike" kern="1200" cap="none" spc="0" normalizeH="0" baseline="0" noProof="0">
+                <a:ln>
+                  <a:noFill/>
+                </a:ln>
+                <a:solidFill>
+                  <a:srgbClr val="FFFFFF"/>
+                </a:solidFill>
+                <a:effectLst/>
+                <a:uLnTx/>
+                <a:uFillTx/>
+                <a:latin typeface="Calibri"/>
+                <a:ea typeface="+mn-ea"/>
+                <a:cs typeface="+mn-cs"/>
+              </a:rPr>
+              <a:t>  Handles complex multi-step tasks</a:t>
+            </a:r>
+          </a:p>
+          <a:p>
+            <a:pPr marL="0" marR="0" lvl="0" indent="0" algn="l" defTabSz="457200" rtl="0" eaLnBrk="1" fontAlgn="auto" latinLnBrk="0" hangingPunct="1">
+              <a:lnSpc>
+                <a:spcPct val="100000"/>
+              </a:lnSpc>
+              <a:spcBef>
+                <a:spcPts val="0"/>
+              </a:spcBef>
+              <a:spcAft>
+                <a:spcPts val="1200"/>
+              </a:spcAft>
+              <a:buClrTx/>
+              <a:buSzTx/>
+              <a:buFontTx/>
+              <a:buNone/>
+              <a:tabLst/>
+              <a:defRPr sz="1800">
+                <a:solidFill>
+                  <a:srgbClr val="FFFFFF"/>
+                </a:solidFill>
+              </a:defRPr>
+            </a:pPr>
+            <a:r>
+              <a:rPr kumimoji="0" sz="1800" b="0" i="0" u="none" strike="noStrike" kern="1200" cap="none" spc="0" normalizeH="0" baseline="0" noProof="0">
+                <a:ln>
+                  <a:noFill/>
+                </a:ln>
+                <a:solidFill>
+                  <a:srgbClr val="FFFFFF"/>
+                </a:solidFill>
+                <a:effectLst/>
+                <a:uLnTx/>
+                <a:uFillTx/>
+                <a:latin typeface="Calibri"/>
+                <a:ea typeface="+mn-ea"/>
+                <a:cs typeface="+mn-cs"/>
+              </a:rPr>
+              <a:t>  Task presets: 'Optimize my week', 'Organize screenshots', etc.</a:t>
+            </a:r>
+          </a:p>
+          <a:p>
+            <a:pPr marL="0" marR="0" lvl="0" indent="0" algn="l" defTabSz="457200" rtl="0" eaLnBrk="1" fontAlgn="auto" latinLnBrk="0" hangingPunct="1">
+              <a:lnSpc>
+                <a:spcPct val="100000"/>
+              </a:lnSpc>
+              <a:spcBef>
+                <a:spcPts val="0"/>
+              </a:spcBef>
+              <a:spcAft>
+                <a:spcPts val="1200"/>
+              </a:spcAft>
+              <a:buClrTx/>
+              <a:buSzTx/>
+              <a:buFontTx/>
+              <a:buNone/>
+              <a:tabLst/>
+              <a:defRPr sz="1800">
+                <a:solidFill>
+                  <a:srgbClr val="FFFFFF"/>
+                </a:solidFill>
+              </a:defRPr>
+            </a:pPr>
+            <a:r>
+              <a:rPr kumimoji="0" sz="1800" b="0" i="0" u="none" strike="noStrike" kern="1200" cap="none" spc="0" normalizeH="0" baseline="0" noProof="0">
+                <a:ln>
+                  <a:noFill/>
+                </a:ln>
+                <a:solidFill>
+                  <a:srgbClr val="FFFFFF"/>
+                </a:solidFill>
+                <a:effectLst/>
+                <a:uLnTx/>
+                <a:uFillTx/>
+                <a:latin typeface="Calibri"/>
+                <a:ea typeface="+mn-ea"/>
+                <a:cs typeface="+mn-cs"/>
+              </a:rPr>
+              <a:t>  You check in when YOU want</a:t>
+            </a:r>
+          </a:p>
+          <a:p>
+            <a:pPr marL="0" marR="0" lvl="0" indent="0" algn="l" defTabSz="457200" rtl="0" eaLnBrk="1" fontAlgn="auto" latinLnBrk="0" hangingPunct="1">
+              <a:lnSpc>
+                <a:spcPct val="100000"/>
+              </a:lnSpc>
+              <a:spcBef>
+                <a:spcPts val="0"/>
+              </a:spcBef>
+              <a:spcAft>
+                <a:spcPts val="1200"/>
+              </a:spcAft>
+              <a:buClrTx/>
+              <a:buSzTx/>
+              <a:buFontTx/>
+              <a:buNone/>
+              <a:tabLst/>
+              <a:defRPr sz="1800">
+                <a:solidFill>
+                  <a:srgbClr val="FFFFFF"/>
+                </a:solidFill>
+              </a:defRPr>
+            </a:pPr>
+            <a:r>
+              <a:rPr kumimoji="0" sz="1800" b="0" i="0" u="none" strike="noStrike" kern="1200" cap="none" spc="0" normalizeH="0" baseline="0" noProof="0">
+                <a:ln>
+                  <a:noFill/>
+                </a:ln>
+                <a:solidFill>
+                  <a:srgbClr val="FFFFFF"/>
+                </a:solidFill>
+                <a:effectLst/>
+                <a:uLnTx/>
+                <a:uFillTx/>
+                <a:latin typeface="Calibri"/>
+                <a:ea typeface="+mn-ea"/>
+                <a:cs typeface="+mn-cs"/>
+              </a:rPr>
+              <a:t>  Available: Windows + Mac Preview</a:t>
+            </a:r>
+          </a:p>
+          <a:p>
+            <a:pPr marL="0" marR="0" lvl="0" indent="0" algn="l" defTabSz="457200" rtl="0" eaLnBrk="1" fontAlgn="auto" latinLnBrk="0" hangingPunct="1">
+              <a:lnSpc>
+                <a:spcPct val="100000"/>
+              </a:lnSpc>
+              <a:spcBef>
+                <a:spcPts val="0"/>
+              </a:spcBef>
+              <a:spcAft>
+                <a:spcPts val="1200"/>
+              </a:spcAft>
+              <a:buClrTx/>
+              <a:buSzTx/>
+              <a:buFontTx/>
+              <a:buNone/>
+              <a:tabLst/>
+              <a:defRPr sz="1800">
+                <a:solidFill>
+                  <a:srgbClr val="FFFFFF"/>
+                </a:solidFill>
+              </a:defRPr>
+            </a:pPr>
+            <a:r>
+              <a:rPr kumimoji="0" sz="1800" b="0" i="0" u="none" strike="noStrike" kern="1200" cap="none" spc="0" normalizeH="0" baseline="0" noProof="0">
+                <a:ln>
+                  <a:noFill/>
+                </a:ln>
+                <a:solidFill>
+                  <a:srgbClr val="FFFFFF"/>
+                </a:solidFill>
+                <a:effectLst/>
+                <a:uLnTx/>
+                <a:uFillTx/>
+                <a:latin typeface="Calibri"/>
+                <a:ea typeface="+mn-ea"/>
+                <a:cs typeface="+mn-cs"/>
+              </a:rPr>
+              <a:t>  Plugin integration (customize workflows)</a:t>
+            </a:r>
+          </a:p>
+        </p:txBody>
+      </p:sp>
+      <p:sp>
+        <p:nvSpPr>
+          <p:cNvPr id="14" name="TextBox 13"/>
+          <p:cNvSpPr txBox="1"/>
+          <p:nvPr/>
+        </p:nvSpPr>
+        <p:spPr>
+          <a:xfrm>
+            <a:off x="457200" y="274320"/>
+            <a:ext cx="11247120" cy="822960"/>
+          </a:xfrm>
+          <a:prstGeom prst="rect">
+            <a:avLst/>
+          </a:prstGeom>
+          <a:noFill/>
+        </p:spPr>
+        <p:txBody>
+          <a:bodyPr wrap="none">
+            <a:spAutoFit/>
+          </a:bodyPr>
+          <a:lstStyle/>
+          <a:p>
+            <a:pPr>
+              <a:defRPr sz="4000" b="1">
+                <a:solidFill>
+                  <a:srgbClr val="FFFFFF"/>
+                </a:solidFill>
+              </a:defRPr>
+            </a:pPr>
+            <a:r>
+              <a:t>Claude Apps: Desktop &amp; Mobile</a:t>
+            </a:r>
+          </a:p>
+        </p:txBody>
+      </p:sp>
+      <p:sp>
+        <p:nvSpPr>
+          <p:cNvPr id="15" name="TextBox 14"/>
+          <p:cNvSpPr txBox="1"/>
+          <p:nvPr/>
+        </p:nvSpPr>
+        <p:spPr>
+          <a:xfrm>
+            <a:off x="457200" y="1097280"/>
+            <a:ext cx="11247120" cy="457200"/>
+          </a:xfrm>
+          <a:prstGeom prst="rect">
+            <a:avLst/>
+          </a:prstGeom>
+          <a:noFill/>
+        </p:spPr>
+        <p:txBody>
+          <a:bodyPr wrap="none">
+            <a:spAutoFit/>
+          </a:bodyPr>
+          <a:lstStyle/>
+          <a:p>
             <a:pPr>
               <a:defRPr sz="2000" i="1">
                 <a:solidFill>
@@ -26065,7 +27019,7 @@
       </p:sp>
       <p:sp>
         <p:nvSpPr>
-          <p:cNvPr id="4" name="Rounded Rectangle 3"/>
+          <p:cNvPr id="16" name="Rounded Rectangle 3"/>
           <p:cNvSpPr/>
           <p:nvPr/>
         </p:nvSpPr>
@@ -26105,12 +27059,13 @@
           <a:lstStyle/>
           <a:p>
             <a:pPr algn="ctr"/>
-          </a:p>
-        </p:txBody>
-      </p:sp>
-      <p:sp>
-        <p:nvSpPr>
-          <p:cNvPr id="5" name="TextBox 4"/>
+            <a:endParaRPr/>
+          </a:p>
+        </p:txBody>
+      </p:sp>
+      <p:sp>
+        <p:nvSpPr>
+          <p:cNvPr id="17" name="TextBox 16"/>
           <p:cNvSpPr txBox="1"/>
           <p:nvPr/>
         </p:nvSpPr>
@@ -26141,7 +27096,7 @@
       </p:sp>
       <p:sp>
         <p:nvSpPr>
-          <p:cNvPr id="6" name="TextBox 5"/>
+          <p:cNvPr id="18" name="TextBox 17"/>
           <p:cNvSpPr txBox="1"/>
           <p:nvPr/>
         </p:nvSpPr>
@@ -26176,7 +27131,7 @@
       </p:sp>
       <p:sp>
         <p:nvSpPr>
-          <p:cNvPr id="7" name="TextBox 6"/>
+          <p:cNvPr id="19" name="TextBox 18"/>
           <p:cNvSpPr txBox="1"/>
           <p:nvPr/>
         </p:nvSpPr>
@@ -26309,6 +27264,7 @@
           <a:lstStyle/>
           <a:p>
             <a:pPr algn="ctr"/>
+            <a:endParaRPr/>
           </a:p>
         </p:txBody>
       </p:sp>
@@ -26517,14 +27473,20 @@
       </p:grpSpPr>
       <p:sp>
         <p:nvSpPr>
-          <p:cNvPr id="2" name="TextBox 1"/>
+          <p:cNvPr id="2" name="TextBox 1">
+            <a:extLst>
+              <a:ext uri="{FF2B5EF4-FFF2-40B4-BE49-F238E27FC236}">
+                <a16:creationId xmlns:a16="http://schemas.microsoft.com/office/drawing/2014/main" id="{BB6F2101-4F98-C246-7F6A-CA3CC9B094DC}"/>
+              </a:ext>
+            </a:extLst>
+          </p:cNvPr>
           <p:cNvSpPr txBox="1"/>
           <p:nvPr/>
         </p:nvSpPr>
         <p:spPr>
           <a:xfrm>
-            <a:off x="457200" y="274320"/>
-            <a:ext cx="11247120" cy="822960"/>
+            <a:off x="457200" y="365760"/>
+            <a:ext cx="11277295" cy="822960"/>
           </a:xfrm>
           <a:prstGeom prst="rect">
             <a:avLst/>
@@ -26537,7 +27499,21 @@
           </a:bodyPr>
           <a:lstStyle/>
           <a:p>
-            <a:pPr>
+            <a:pPr marL="0" marR="0" lvl="0" indent="0" algn="l" defTabSz="457200" rtl="0" eaLnBrk="1" fontAlgn="auto" latinLnBrk="0" hangingPunct="1">
+              <a:lnSpc>
+                <a:spcPct val="100000"/>
+              </a:lnSpc>
+              <a:spcBef>
+                <a:spcPts val="0"/>
+              </a:spcBef>
+              <a:spcAft>
+                <a:spcPts val="0"/>
+              </a:spcAft>
+              <a:buClrTx/>
+              <a:buSzTx/>
+              <a:buFontTx/>
+              <a:buNone/>
+              <a:tabLst/>
               <a:defRPr sz="4000" b="1">
                 <a:solidFill>
                   <a:srgbClr val="FFFFFF"/>
@@ -26545,21 +27521,503 @@
               </a:defRPr>
             </a:pPr>
             <a:r>
-              <a:t>Claude for Work: Autonomous AI</a:t>
-            </a:r>
-          </a:p>
-        </p:txBody>
-      </p:sp>
-      <p:sp>
-        <p:nvSpPr>
-          <p:cNvPr id="3" name="TextBox 2"/>
+              <a:rPr kumimoji="0" sz="4000" b="1" i="0" u="none" strike="noStrike" kern="1200" cap="none" spc="0" normalizeH="0" baseline="0" noProof="0">
+                <a:ln>
+                  <a:noFill/>
+                </a:ln>
+                <a:solidFill>
+                  <a:srgbClr val="FFFFFF"/>
+                </a:solidFill>
+                <a:effectLst/>
+                <a:uLnTx/>
+                <a:uFillTx/>
+                <a:latin typeface="Calibri"/>
+                <a:ea typeface="+mn-ea"/>
+                <a:cs typeface="+mn-cs"/>
+              </a:rPr>
+              <a:t>When to Use Claude for Work</a:t>
+            </a:r>
+          </a:p>
+        </p:txBody>
+      </p:sp>
+      <p:sp>
+        <p:nvSpPr>
+          <p:cNvPr id="3" name="Rectangle 2">
+            <a:extLst>
+              <a:ext uri="{FF2B5EF4-FFF2-40B4-BE49-F238E27FC236}">
+                <a16:creationId xmlns:a16="http://schemas.microsoft.com/office/drawing/2014/main" id="{D1BA573A-E4B7-822F-B58F-C8B4687FAE8F}"/>
+              </a:ext>
+            </a:extLst>
+          </p:cNvPr>
+          <p:cNvSpPr/>
+          <p:nvPr/>
+        </p:nvSpPr>
+        <p:spPr>
+          <a:xfrm>
+            <a:off x="457200" y="1234440"/>
+            <a:ext cx="1828800" cy="36576"/>
+          </a:xfrm>
+          <a:prstGeom prst="rect">
+            <a:avLst/>
+          </a:prstGeom>
+          <a:solidFill>
+            <a:srgbClr val="00D4AA"/>
+          </a:solidFill>
+          <a:ln>
+            <a:noFill/>
+          </a:ln>
+        </p:spPr>
+        <p:style>
+          <a:lnRef idx="1">
+            <a:schemeClr val="accent1"/>
+          </a:lnRef>
+          <a:fillRef idx="3">
+            <a:schemeClr val="accent1"/>
+          </a:fillRef>
+          <a:effectRef idx="2">
+            <a:schemeClr val="accent1"/>
+          </a:effectRef>
+          <a:fontRef idx="minor">
+            <a:schemeClr val="lt1"/>
+          </a:fontRef>
+        </p:style>
+        <p:txBody>
+          <a:bodyPr rtlCol="0" anchor="ctr"/>
+          <a:lstStyle/>
+          <a:p>
+            <a:pPr marL="0" marR="0" lvl="0" indent="0" algn="ctr" defTabSz="457200" rtl="0" eaLnBrk="1" fontAlgn="auto" latinLnBrk="0" hangingPunct="1">
+              <a:lnSpc>
+                <a:spcPct val="100000"/>
+              </a:lnSpc>
+              <a:spcBef>
+                <a:spcPts val="0"/>
+              </a:spcBef>
+              <a:spcAft>
+                <a:spcPts val="0"/>
+              </a:spcAft>
+              <a:buClrTx/>
+              <a:buSzTx/>
+              <a:buFontTx/>
+              <a:buNone/>
+              <a:tabLst/>
+              <a:defRPr/>
+            </a:pPr>
+            <a:endParaRPr kumimoji="0" sz="1800" b="0" i="0" u="none" strike="noStrike" kern="1200" cap="none" spc="0" normalizeH="0" baseline="0" noProof="0">
+              <a:ln>
+                <a:noFill/>
+              </a:ln>
+              <a:solidFill>
+                <a:prstClr val="white"/>
+              </a:solidFill>
+              <a:effectLst/>
+              <a:uLnTx/>
+              <a:uFillTx/>
+              <a:latin typeface="Calibri"/>
+              <a:ea typeface="+mn-ea"/>
+              <a:cs typeface="+mn-cs"/>
+            </a:endParaRPr>
+          </a:p>
+        </p:txBody>
+      </p:sp>
+      <p:sp>
+        <p:nvSpPr>
+          <p:cNvPr id="4" name="TextBox 3">
+            <a:extLst>
+              <a:ext uri="{FF2B5EF4-FFF2-40B4-BE49-F238E27FC236}">
+                <a16:creationId xmlns:a16="http://schemas.microsoft.com/office/drawing/2014/main" id="{DF607436-CA4A-12EA-4CC2-583FD5C95E76}"/>
+              </a:ext>
+            </a:extLst>
+          </p:cNvPr>
           <p:cNvSpPr txBox="1"/>
           <p:nvPr/>
         </p:nvSpPr>
         <p:spPr>
           <a:xfrm>
-            <a:off x="457200" y="1097280"/>
-            <a:ext cx="11247120" cy="457200"/>
+            <a:off x="457200" y="1463040"/>
+            <a:ext cx="11277295" cy="4572000"/>
+          </a:xfrm>
+          <a:prstGeom prst="rect">
+            <a:avLst/>
+          </a:prstGeom>
+          <a:noFill/>
+        </p:spPr>
+        <p:txBody>
+          <a:bodyPr wrap="square">
+            <a:spAutoFit/>
+          </a:bodyPr>
+          <a:lstStyle/>
+          <a:p>
+            <a:pPr marL="0" marR="0" lvl="0" indent="0" algn="l" defTabSz="457200" rtl="0" eaLnBrk="1" fontAlgn="auto" latinLnBrk="0" hangingPunct="1">
+              <a:lnSpc>
+                <a:spcPct val="100000"/>
+              </a:lnSpc>
+              <a:spcBef>
+                <a:spcPts val="800"/>
+              </a:spcBef>
+              <a:spcAft>
+                <a:spcPts val="800"/>
+              </a:spcAft>
+              <a:buClrTx/>
+              <a:buSzTx/>
+              <a:buFontTx/>
+              <a:buNone/>
+              <a:tabLst/>
+              <a:defRPr sz="2200">
+                <a:solidFill>
+                  <a:srgbClr val="FFFFFF"/>
+                </a:solidFill>
+              </a:defRPr>
+            </a:pPr>
+            <a:r>
+              <a:rPr kumimoji="0" sz="2200" b="0" i="0" u="none" strike="noStrike" kern="1200" cap="none" spc="0" normalizeH="0" baseline="0" noProof="0">
+                <a:ln>
+                  <a:noFill/>
+                </a:ln>
+                <a:solidFill>
+                  <a:srgbClr val="FFFFFF"/>
+                </a:solidFill>
+                <a:effectLst/>
+                <a:uLnTx/>
+                <a:uFillTx/>
+                <a:latin typeface="Calibri"/>
+                <a:ea typeface="+mn-ea"/>
+                <a:cs typeface="+mn-cs"/>
+              </a:rPr>
+              <a:t>  ✅ PERFECT FOR: Complex multi-step tasks (2+ hours of work)</a:t>
+            </a:r>
+          </a:p>
+          <a:p>
+            <a:pPr marL="0" marR="0" lvl="0" indent="0" algn="l" defTabSz="457200" rtl="0" eaLnBrk="1" fontAlgn="auto" latinLnBrk="0" hangingPunct="1">
+              <a:lnSpc>
+                <a:spcPct val="100000"/>
+              </a:lnSpc>
+              <a:spcBef>
+                <a:spcPts val="800"/>
+              </a:spcBef>
+              <a:spcAft>
+                <a:spcPts val="800"/>
+              </a:spcAft>
+              <a:buClrTx/>
+              <a:buSzTx/>
+              <a:buFontTx/>
+              <a:buNone/>
+              <a:tabLst/>
+              <a:defRPr sz="2200">
+                <a:solidFill>
+                  <a:srgbClr val="FFFFFF"/>
+                </a:solidFill>
+              </a:defRPr>
+            </a:pPr>
+            <a:r>
+              <a:rPr kumimoji="0" sz="2200" b="0" i="0" u="none" strike="noStrike" kern="1200" cap="none" spc="0" normalizeH="0" baseline="0" noProof="0">
+                <a:ln>
+                  <a:noFill/>
+                </a:ln>
+                <a:solidFill>
+                  <a:srgbClr val="FFFFFF"/>
+                </a:solidFill>
+                <a:effectLst/>
+                <a:uLnTx/>
+                <a:uFillTx/>
+                <a:latin typeface="Calibri"/>
+                <a:ea typeface="+mn-ea"/>
+                <a:cs typeface="+mn-cs"/>
+              </a:rPr>
+              <a:t>     • Competitive research &amp; analysis</a:t>
+            </a:r>
+          </a:p>
+          <a:p>
+            <a:pPr marL="0" marR="0" lvl="0" indent="0" algn="l" defTabSz="457200" rtl="0" eaLnBrk="1" fontAlgn="auto" latinLnBrk="0" hangingPunct="1">
+              <a:lnSpc>
+                <a:spcPct val="100000"/>
+              </a:lnSpc>
+              <a:spcBef>
+                <a:spcPts val="800"/>
+              </a:spcBef>
+              <a:spcAft>
+                <a:spcPts val="800"/>
+              </a:spcAft>
+              <a:buClrTx/>
+              <a:buSzTx/>
+              <a:buFontTx/>
+              <a:buNone/>
+              <a:tabLst/>
+              <a:defRPr sz="2200">
+                <a:solidFill>
+                  <a:srgbClr val="FFFFFF"/>
+                </a:solidFill>
+              </a:defRPr>
+            </a:pPr>
+            <a:r>
+              <a:rPr kumimoji="0" sz="2200" b="0" i="0" u="none" strike="noStrike" kern="1200" cap="none" spc="0" normalizeH="0" baseline="0" noProof="0">
+                <a:ln>
+                  <a:noFill/>
+                </a:ln>
+                <a:solidFill>
+                  <a:srgbClr val="FFFFFF"/>
+                </a:solidFill>
+                <a:effectLst/>
+                <a:uLnTx/>
+                <a:uFillTx/>
+                <a:latin typeface="Calibri"/>
+                <a:ea typeface="+mn-ea"/>
+                <a:cs typeface="+mn-cs"/>
+              </a:rPr>
+              <a:t>     • Writing long documents (PRDs, reports, proposals)</a:t>
+            </a:r>
+          </a:p>
+          <a:p>
+            <a:pPr marL="0" marR="0" lvl="0" indent="0" algn="l" defTabSz="457200" rtl="0" eaLnBrk="1" fontAlgn="auto" latinLnBrk="0" hangingPunct="1">
+              <a:lnSpc>
+                <a:spcPct val="100000"/>
+              </a:lnSpc>
+              <a:spcBef>
+                <a:spcPts val="800"/>
+              </a:spcBef>
+              <a:spcAft>
+                <a:spcPts val="800"/>
+              </a:spcAft>
+              <a:buClrTx/>
+              <a:buSzTx/>
+              <a:buFontTx/>
+              <a:buNone/>
+              <a:tabLst/>
+              <a:defRPr sz="2200">
+                <a:solidFill>
+                  <a:srgbClr val="FFFFFF"/>
+                </a:solidFill>
+              </a:defRPr>
+            </a:pPr>
+            <a:r>
+              <a:rPr kumimoji="0" sz="2200" b="0" i="0" u="none" strike="noStrike" kern="1200" cap="none" spc="0" normalizeH="0" baseline="0" noProof="0">
+                <a:ln>
+                  <a:noFill/>
+                </a:ln>
+                <a:solidFill>
+                  <a:srgbClr val="FFFFFF"/>
+                </a:solidFill>
+                <a:effectLst/>
+                <a:uLnTx/>
+                <a:uFillTx/>
+                <a:latin typeface="Calibri"/>
+                <a:ea typeface="+mn-ea"/>
+                <a:cs typeface="+mn-cs"/>
+              </a:rPr>
+              <a:t>     • Data analysis across multiple files</a:t>
+            </a:r>
+          </a:p>
+          <a:p>
+            <a:pPr marL="0" marR="0" lvl="0" indent="0" algn="l" defTabSz="457200" rtl="0" eaLnBrk="1" fontAlgn="auto" latinLnBrk="0" hangingPunct="1">
+              <a:lnSpc>
+                <a:spcPct val="100000"/>
+              </a:lnSpc>
+              <a:spcBef>
+                <a:spcPts val="800"/>
+              </a:spcBef>
+              <a:spcAft>
+                <a:spcPts val="800"/>
+              </a:spcAft>
+              <a:buClrTx/>
+              <a:buSzTx/>
+              <a:buFontTx/>
+              <a:buNone/>
+              <a:tabLst/>
+              <a:defRPr sz="2200">
+                <a:solidFill>
+                  <a:srgbClr val="FFFFFF"/>
+                </a:solidFill>
+              </a:defRPr>
+            </a:pPr>
+            <a:r>
+              <a:rPr kumimoji="0" sz="2200" b="0" i="0" u="none" strike="noStrike" kern="1200" cap="none" spc="0" normalizeH="0" baseline="0" noProof="0">
+                <a:ln>
+                  <a:noFill/>
+                </a:ln>
+                <a:solidFill>
+                  <a:srgbClr val="FFFFFF"/>
+                </a:solidFill>
+                <a:effectLst/>
+                <a:uLnTx/>
+                <a:uFillTx/>
+                <a:latin typeface="Calibri"/>
+                <a:ea typeface="+mn-ea"/>
+                <a:cs typeface="+mn-cs"/>
+              </a:rPr>
+              <a:t>     • Content creation with multiple iterations</a:t>
+            </a:r>
+          </a:p>
+          <a:p>
+            <a:pPr marL="0" marR="0" lvl="0" indent="0" algn="l" defTabSz="457200" rtl="0" eaLnBrk="1" fontAlgn="auto" latinLnBrk="0" hangingPunct="1">
+              <a:lnSpc>
+                <a:spcPct val="100000"/>
+              </a:lnSpc>
+              <a:spcBef>
+                <a:spcPts val="800"/>
+              </a:spcBef>
+              <a:spcAft>
+                <a:spcPts val="800"/>
+              </a:spcAft>
+              <a:buClrTx/>
+              <a:buSzTx/>
+              <a:buFontTx/>
+              <a:buNone/>
+              <a:tabLst/>
+              <a:defRPr sz="2200">
+                <a:solidFill>
+                  <a:srgbClr val="FFFFFF"/>
+                </a:solidFill>
+              </a:defRPr>
+            </a:pPr>
+            <a:r>
+              <a:rPr kumimoji="0" sz="2200" b="0" i="0" u="none" strike="noStrike" kern="1200" cap="none" spc="0" normalizeH="0" baseline="0" noProof="0">
+                <a:ln>
+                  <a:noFill/>
+                </a:ln>
+                <a:solidFill>
+                  <a:srgbClr val="FFFFFF"/>
+                </a:solidFill>
+                <a:effectLst/>
+                <a:uLnTx/>
+                <a:uFillTx/>
+                <a:latin typeface="Calibri"/>
+                <a:ea typeface="+mn-ea"/>
+                <a:cs typeface="+mn-cs"/>
+              </a:rPr>
+              <a:t>  ❌ NOT IDEAL FOR: Quick questions, real-time collaboration, learning/exploration</a:t>
+            </a:r>
+          </a:p>
+          <a:p>
+            <a:pPr marL="0" marR="0" lvl="0" indent="0" algn="l" defTabSz="457200" rtl="0" eaLnBrk="1" fontAlgn="auto" latinLnBrk="0" hangingPunct="1">
+              <a:lnSpc>
+                <a:spcPct val="100000"/>
+              </a:lnSpc>
+              <a:spcBef>
+                <a:spcPts val="800"/>
+              </a:spcBef>
+              <a:spcAft>
+                <a:spcPts val="800"/>
+              </a:spcAft>
+              <a:buClrTx/>
+              <a:buSzTx/>
+              <a:buFontTx/>
+              <a:buNone/>
+              <a:tabLst/>
+              <a:defRPr sz="2200">
+                <a:solidFill>
+                  <a:srgbClr val="FFFFFF"/>
+                </a:solidFill>
+              </a:defRPr>
+            </a:pPr>
+            <a:r>
+              <a:rPr kumimoji="0" sz="2200" b="0" i="0" u="none" strike="noStrike" kern="1200" cap="none" spc="0" normalizeH="0" baseline="0" noProof="0">
+                <a:ln>
+                  <a:noFill/>
+                </a:ln>
+                <a:solidFill>
+                  <a:srgbClr val="FFFFFF"/>
+                </a:solidFill>
+                <a:effectLst/>
+                <a:uLnTx/>
+                <a:uFillTx/>
+                <a:latin typeface="Calibri"/>
+                <a:ea typeface="+mn-ea"/>
+                <a:cs typeface="+mn-cs"/>
+              </a:rPr>
+              <a:t>  🎯 THE RULE: If you'd normally block 2+ hours on calendar → Use Cowork. Quick task → Use Claude.ai</a:t>
+            </a:r>
+          </a:p>
+          <a:p>
+            <a:pPr marL="0" marR="0" lvl="0" indent="0" algn="l" defTabSz="457200" rtl="0" eaLnBrk="1" fontAlgn="auto" latinLnBrk="0" hangingPunct="1">
+              <a:lnSpc>
+                <a:spcPct val="100000"/>
+              </a:lnSpc>
+              <a:spcBef>
+                <a:spcPts val="800"/>
+              </a:spcBef>
+              <a:spcAft>
+                <a:spcPts val="800"/>
+              </a:spcAft>
+              <a:buClrTx/>
+              <a:buSzTx/>
+              <a:buFontTx/>
+              <a:buNone/>
+              <a:tabLst/>
+              <a:defRPr sz="2200">
+                <a:solidFill>
+                  <a:srgbClr val="FFFFFF"/>
+                </a:solidFill>
+              </a:defRPr>
+            </a:pPr>
+            <a:r>
+              <a:rPr kumimoji="0" sz="2200" b="0" i="0" u="none" strike="noStrike" kern="1200" cap="none" spc="0" normalizeH="0" baseline="0" noProof="0">
+                <a:ln>
+                  <a:noFill/>
+                </a:ln>
+                <a:solidFill>
+                  <a:srgbClr val="FFFFFF"/>
+                </a:solidFill>
+                <a:effectLst/>
+                <a:uLnTx/>
+                <a:uFillTx/>
+                <a:latin typeface="Calibri"/>
+                <a:ea typeface="+mn-ea"/>
+                <a:cs typeface="+mn-cs"/>
+              </a:rPr>
+              <a:t>  💻 HOW TO GET IT: Download Claude Desktop App (Windows/Mac) - Pro/Team subscribers get autonomous features in Preview</a:t>
+            </a:r>
+          </a:p>
+          <a:p>
+            <a:pPr marL="0" marR="0" lvl="0" indent="0" algn="l" defTabSz="457200" rtl="0" eaLnBrk="1" fontAlgn="auto" latinLnBrk="0" hangingPunct="1">
+              <a:lnSpc>
+                <a:spcPct val="100000"/>
+              </a:lnSpc>
+              <a:spcBef>
+                <a:spcPts val="800"/>
+              </a:spcBef>
+              <a:spcAft>
+                <a:spcPts val="800"/>
+              </a:spcAft>
+              <a:buClrTx/>
+              <a:buSzTx/>
+              <a:buFontTx/>
+              <a:buNone/>
+              <a:tabLst/>
+              <a:defRPr sz="2200">
+                <a:solidFill>
+                  <a:srgbClr val="FFFFFF"/>
+                </a:solidFill>
+              </a:defRPr>
+            </a:pPr>
+            <a:r>
+              <a:rPr kumimoji="0" sz="2200" b="0" i="0" u="none" strike="noStrike" kern="1200" cap="none" spc="0" normalizeH="0" baseline="0" noProof="0">
+                <a:ln>
+                  <a:noFill/>
+                </a:ln>
+                <a:solidFill>
+                  <a:srgbClr val="FFFFFF"/>
+                </a:solidFill>
+                <a:effectLst/>
+                <a:uLnTx/>
+                <a:uFillTx/>
+                <a:latin typeface="Calibri"/>
+                <a:ea typeface="+mn-ea"/>
+                <a:cs typeface="+mn-cs"/>
+              </a:rPr>
+              <a:t>  ⚠️ PREVIEW NOTE: Early access = expect bugs, limited rollout, features evolving</a:t>
+            </a:r>
+          </a:p>
+        </p:txBody>
+      </p:sp>
+      <p:sp>
+        <p:nvSpPr>
+          <p:cNvPr id="18" name="TextBox 17"/>
+          <p:cNvSpPr txBox="1"/>
+          <p:nvPr/>
+        </p:nvSpPr>
+        <p:spPr>
+          <a:xfrm>
+            <a:off x="457200" y="274320"/>
+            <a:ext cx="11247120" cy="822960"/>
           </a:xfrm>
           <a:prstGeom prst="rect">
             <a:avLst/>
@@ -26573,6 +28031,41 @@
           <a:lstStyle/>
           <a:p>
             <a:pPr>
+              <a:defRPr sz="4000" b="1">
+                <a:solidFill>
+                  <a:srgbClr val="FFFFFF"/>
+                </a:solidFill>
+              </a:defRPr>
+            </a:pPr>
+            <a:r>
+              <a:t>Claude for Work: Autonomous AI</a:t>
+            </a:r>
+          </a:p>
+        </p:txBody>
+      </p:sp>
+      <p:sp>
+        <p:nvSpPr>
+          <p:cNvPr id="19" name="TextBox 18"/>
+          <p:cNvSpPr txBox="1"/>
+          <p:nvPr/>
+        </p:nvSpPr>
+        <p:spPr>
+          <a:xfrm>
+            <a:off x="457200" y="1097280"/>
+            <a:ext cx="11247120" cy="457200"/>
+          </a:xfrm>
+          <a:prstGeom prst="rect">
+            <a:avLst/>
+          </a:prstGeom>
+          <a:noFill/>
+        </p:spPr>
+        <p:txBody>
+          <a:bodyPr wrap="none">
+            <a:spAutoFit/>
+          </a:bodyPr>
+          <a:lstStyle/>
+          <a:p>
+            <a:pPr>
               <a:defRPr sz="2000" i="1">
                 <a:solidFill>
                   <a:srgbClr val="9CA3AF"/>
@@ -26587,7 +28080,7 @@
       </p:sp>
       <p:sp>
         <p:nvSpPr>
-          <p:cNvPr id="4" name="Rounded Rectangle 3"/>
+          <p:cNvPr id="20" name="Rounded Rectangle 3"/>
           <p:cNvSpPr/>
           <p:nvPr/>
         </p:nvSpPr>
@@ -26627,6 +28120,7 @@
           <a:lstStyle/>
           <a:p>
             <a:pPr algn="ctr"/>
+            <a:endParaRPr/>
           </a:p>
         </p:txBody>
       </p:sp>
@@ -26785,6 +28279,7 @@
           <a:lstStyle/>
           <a:p>
             <a:pPr algn="ctr"/>
+            <a:endParaRPr/>
           </a:p>
         </p:txBody>
       </p:sp>
@@ -26943,6 +28438,7 @@
           <a:lstStyle/>
           <a:p>
             <a:pPr algn="ctr"/>
+            <a:endParaRPr/>
           </a:p>
         </p:txBody>
       </p:sp>
@@ -27101,6 +28597,7 @@
           <a:lstStyle/>
           <a:p>
             <a:pPr algn="ctr"/>
+            <a:endParaRPr/>
           </a:p>
         </p:txBody>
       </p:sp>

</xml_diff>

<commit_message>
Fix: Remove overlapping old shapes from slides 33-34
Slide 33 had old 'Claude Desktop App' text under new 'Claude Apps' content
Slide 34 had old 'When to Use Claude for Work' under new 'Claude for Work' content
Clean ZIP, no repair prompt
</commit_message>
<xml_diff>
--- a/slides/Day1_Claude_for_Business.pptx
+++ b/slides/Day1_Claude_for_Business.pptx
@@ -26085,870 +26085,6 @@
       </p:grpSpPr>
       <p:sp>
         <p:nvSpPr>
-          <p:cNvPr id="2" name="TextBox 1">
-            <a:extLst>
-              <a:ext uri="{FF2B5EF4-FFF2-40B4-BE49-F238E27FC236}">
-                <a16:creationId xmlns:a16="http://schemas.microsoft.com/office/drawing/2014/main" id="{2512AD6E-847D-17B1-15AD-6F52430D57A3}"/>
-              </a:ext>
-            </a:extLst>
-          </p:cNvPr>
-          <p:cNvSpPr txBox="1"/>
-          <p:nvPr/>
-        </p:nvSpPr>
-        <p:spPr>
-          <a:xfrm>
-            <a:off x="457200" y="457200"/>
-            <a:ext cx="11277295" cy="731520"/>
-          </a:xfrm>
-          <a:prstGeom prst="rect">
-            <a:avLst/>
-          </a:prstGeom>
-          <a:noFill/>
-        </p:spPr>
-        <p:txBody>
-          <a:bodyPr wrap="none">
-            <a:spAutoFit/>
-          </a:bodyPr>
-          <a:lstStyle/>
-          <a:p>
-            <a:pPr marL="0" marR="0" lvl="0" indent="0" algn="ctr" defTabSz="457200" rtl="0" eaLnBrk="1" fontAlgn="auto" latinLnBrk="0" hangingPunct="1">
-              <a:lnSpc>
-                <a:spcPct val="100000"/>
-              </a:lnSpc>
-              <a:spcBef>
-                <a:spcPts val="0"/>
-              </a:spcBef>
-              <a:spcAft>
-                <a:spcPts val="0"/>
-              </a:spcAft>
-              <a:buClrTx/>
-              <a:buSzTx/>
-              <a:buFontTx/>
-              <a:buNone/>
-              <a:tabLst/>
-              <a:defRPr sz="3600" b="1">
-                <a:solidFill>
-                  <a:srgbClr val="FFFFFF"/>
-                </a:solidFill>
-              </a:defRPr>
-            </a:pPr>
-            <a:r>
-              <a:rPr kumimoji="0" sz="3600" b="1" i="0" u="none" strike="noStrike" kern="1200" cap="none" spc="0" normalizeH="0" baseline="0" noProof="0">
-                <a:ln>
-                  <a:noFill/>
-                </a:ln>
-                <a:solidFill>
-                  <a:srgbClr val="FFFFFF"/>
-                </a:solidFill>
-                <a:effectLst/>
-                <a:uLnTx/>
-                <a:uFillTx/>
-                <a:latin typeface="Calibri"/>
-                <a:ea typeface="+mn-ea"/>
-                <a:cs typeface="+mn-cs"/>
-              </a:rPr>
-              <a:t>Claude Desktop App: Autonomous Features</a:t>
-            </a:r>
-          </a:p>
-        </p:txBody>
-      </p:sp>
-      <p:sp>
-        <p:nvSpPr>
-          <p:cNvPr id="3" name="Rectangle 2">
-            <a:extLst>
-              <a:ext uri="{FF2B5EF4-FFF2-40B4-BE49-F238E27FC236}">
-                <a16:creationId xmlns:a16="http://schemas.microsoft.com/office/drawing/2014/main" id="{F2342D46-CB66-679A-1AF0-A4EC62C02D83}"/>
-              </a:ext>
-            </a:extLst>
-          </p:cNvPr>
-          <p:cNvSpPr/>
-          <p:nvPr/>
-        </p:nvSpPr>
-        <p:spPr>
-          <a:xfrm>
-            <a:off x="6077559" y="1371600"/>
-            <a:ext cx="36576" cy="4572000"/>
-          </a:xfrm>
-          <a:prstGeom prst="rect">
-            <a:avLst/>
-          </a:prstGeom>
-          <a:solidFill>
-            <a:srgbClr val="00D4AA"/>
-          </a:solidFill>
-          <a:ln>
-            <a:noFill/>
-          </a:ln>
-        </p:spPr>
-        <p:style>
-          <a:lnRef idx="1">
-            <a:schemeClr val="accent1"/>
-          </a:lnRef>
-          <a:fillRef idx="3">
-            <a:schemeClr val="accent1"/>
-          </a:fillRef>
-          <a:effectRef idx="2">
-            <a:schemeClr val="accent1"/>
-          </a:effectRef>
-          <a:fontRef idx="minor">
-            <a:schemeClr val="lt1"/>
-          </a:fontRef>
-        </p:style>
-        <p:txBody>
-          <a:bodyPr rtlCol="0" anchor="ctr"/>
-          <a:lstStyle/>
-          <a:p>
-            <a:pPr marL="0" marR="0" lvl="0" indent="0" algn="ctr" defTabSz="457200" rtl="0" eaLnBrk="1" fontAlgn="auto" latinLnBrk="0" hangingPunct="1">
-              <a:lnSpc>
-                <a:spcPct val="100000"/>
-              </a:lnSpc>
-              <a:spcBef>
-                <a:spcPts val="0"/>
-              </a:spcBef>
-              <a:spcAft>
-                <a:spcPts val="0"/>
-              </a:spcAft>
-              <a:buClrTx/>
-              <a:buSzTx/>
-              <a:buFontTx/>
-              <a:buNone/>
-              <a:tabLst/>
-              <a:defRPr/>
-            </a:pPr>
-            <a:endParaRPr kumimoji="0" sz="1800" b="0" i="0" u="none" strike="noStrike" kern="1200" cap="none" spc="0" normalizeH="0" baseline="0" noProof="0">
-              <a:ln>
-                <a:noFill/>
-              </a:ln>
-              <a:solidFill>
-                <a:prstClr val="white"/>
-              </a:solidFill>
-              <a:effectLst/>
-              <a:uLnTx/>
-              <a:uFillTx/>
-              <a:latin typeface="Calibri"/>
-              <a:ea typeface="+mn-ea"/>
-              <a:cs typeface="+mn-cs"/>
-            </a:endParaRPr>
-          </a:p>
-        </p:txBody>
-      </p:sp>
-      <p:sp>
-        <p:nvSpPr>
-          <p:cNvPr id="4" name="TextBox 3">
-            <a:extLst>
-              <a:ext uri="{FF2B5EF4-FFF2-40B4-BE49-F238E27FC236}">
-                <a16:creationId xmlns:a16="http://schemas.microsoft.com/office/drawing/2014/main" id="{73C77848-149A-A14D-E3EE-836747772290}"/>
-              </a:ext>
-            </a:extLst>
-          </p:cNvPr>
-          <p:cNvSpPr txBox="1"/>
-          <p:nvPr/>
-        </p:nvSpPr>
-        <p:spPr>
-          <a:xfrm>
-            <a:off x="457200" y="1463040"/>
-            <a:ext cx="5364327" cy="731520"/>
-          </a:xfrm>
-          <a:prstGeom prst="rect">
-            <a:avLst/>
-          </a:prstGeom>
-          <a:noFill/>
-        </p:spPr>
-        <p:txBody>
-          <a:bodyPr wrap="none">
-            <a:spAutoFit/>
-          </a:bodyPr>
-          <a:lstStyle/>
-          <a:p>
-            <a:pPr marL="0" marR="0" lvl="0" indent="0" algn="ctr" defTabSz="457200" rtl="0" eaLnBrk="1" fontAlgn="auto" latinLnBrk="0" hangingPunct="1">
-              <a:lnSpc>
-                <a:spcPct val="100000"/>
-              </a:lnSpc>
-              <a:spcBef>
-                <a:spcPts val="0"/>
-              </a:spcBef>
-              <a:spcAft>
-                <a:spcPts val="0"/>
-              </a:spcAft>
-              <a:buClrTx/>
-              <a:buSzTx/>
-              <a:buFontTx/>
-              <a:buNone/>
-              <a:tabLst/>
-              <a:defRPr sz="2800" b="1">
-                <a:solidFill>
-                  <a:srgbClr val="0078D4"/>
-                </a:solidFill>
-              </a:defRPr>
-            </a:pPr>
-            <a:r>
-              <a:rPr kumimoji="0" sz="2800" b="1" i="0" u="none" strike="noStrike" kern="1200" cap="none" spc="0" normalizeH="0" baseline="0" noProof="0">
-                <a:ln>
-                  <a:noFill/>
-                </a:ln>
-                <a:solidFill>
-                  <a:srgbClr val="0078D4"/>
-                </a:solidFill>
-                <a:effectLst/>
-                <a:uLnTx/>
-                <a:uFillTx/>
-                <a:latin typeface="Calibri"/>
-                <a:ea typeface="+mn-ea"/>
-                <a:cs typeface="+mn-cs"/>
-              </a:rPr>
-              <a:t>Claude.ai (What You Know)</a:t>
-            </a:r>
-          </a:p>
-        </p:txBody>
-      </p:sp>
-      <p:sp>
-        <p:nvSpPr>
-          <p:cNvPr id="5" name="TextBox 4">
-            <a:extLst>
-              <a:ext uri="{FF2B5EF4-FFF2-40B4-BE49-F238E27FC236}">
-                <a16:creationId xmlns:a16="http://schemas.microsoft.com/office/drawing/2014/main" id="{1C183914-50C0-E52E-1C75-A7BCAB4D4A0A}"/>
-              </a:ext>
-            </a:extLst>
-          </p:cNvPr>
-          <p:cNvSpPr txBox="1"/>
-          <p:nvPr/>
-        </p:nvSpPr>
-        <p:spPr>
-          <a:xfrm>
-            <a:off x="457200" y="2286000"/>
-            <a:ext cx="5364327" cy="3657600"/>
-          </a:xfrm>
-          <a:prstGeom prst="rect">
-            <a:avLst/>
-          </a:prstGeom>
-          <a:noFill/>
-        </p:spPr>
-        <p:txBody>
-          <a:bodyPr wrap="square">
-            <a:spAutoFit/>
-          </a:bodyPr>
-          <a:lstStyle/>
-          <a:p>
-            <a:pPr marL="0" marR="0" lvl="0" indent="0" algn="l" defTabSz="457200" rtl="0" eaLnBrk="1" fontAlgn="auto" latinLnBrk="0" hangingPunct="1">
-              <a:lnSpc>
-                <a:spcPct val="100000"/>
-              </a:lnSpc>
-              <a:spcBef>
-                <a:spcPts val="0"/>
-              </a:spcBef>
-              <a:spcAft>
-                <a:spcPts val="1200"/>
-              </a:spcAft>
-              <a:buClrTx/>
-              <a:buSzTx/>
-              <a:buFontTx/>
-              <a:buNone/>
-              <a:tabLst/>
-              <a:defRPr sz="1800">
-                <a:solidFill>
-                  <a:srgbClr val="FFFFFF"/>
-                </a:solidFill>
-              </a:defRPr>
-            </a:pPr>
-            <a:r>
-              <a:rPr kumimoji="0" sz="1800" b="0" i="0" u="none" strike="noStrike" kern="1200" cap="none" spc="0" normalizeH="0" baseline="0" noProof="0">
-                <a:ln>
-                  <a:noFill/>
-                </a:ln>
-                <a:solidFill>
-                  <a:srgbClr val="FFFFFF"/>
-                </a:solidFill>
-                <a:effectLst/>
-                <a:uLnTx/>
-                <a:uFillTx/>
-                <a:latin typeface="Calibri"/>
-                <a:ea typeface="+mn-ea"/>
-                <a:cs typeface="+mn-cs"/>
-              </a:rPr>
-              <a:t>  Back-and-forth conversation</a:t>
-            </a:r>
-          </a:p>
-          <a:p>
-            <a:pPr marL="0" marR="0" lvl="0" indent="0" algn="l" defTabSz="457200" rtl="0" eaLnBrk="1" fontAlgn="auto" latinLnBrk="0" hangingPunct="1">
-              <a:lnSpc>
-                <a:spcPct val="100000"/>
-              </a:lnSpc>
-              <a:spcBef>
-                <a:spcPts val="0"/>
-              </a:spcBef>
-              <a:spcAft>
-                <a:spcPts val="1200"/>
-              </a:spcAft>
-              <a:buClrTx/>
-              <a:buSzTx/>
-              <a:buFontTx/>
-              <a:buNone/>
-              <a:tabLst/>
-              <a:defRPr sz="1800">
-                <a:solidFill>
-                  <a:srgbClr val="FFFFFF"/>
-                </a:solidFill>
-              </a:defRPr>
-            </a:pPr>
-            <a:r>
-              <a:rPr kumimoji="0" sz="1800" b="0" i="0" u="none" strike="noStrike" kern="1200" cap="none" spc="0" normalizeH="0" baseline="0" noProof="0">
-                <a:ln>
-                  <a:noFill/>
-                </a:ln>
-                <a:solidFill>
-                  <a:srgbClr val="FFFFFF"/>
-                </a:solidFill>
-                <a:effectLst/>
-                <a:uLnTx/>
-                <a:uFillTx/>
-                <a:latin typeface="Calibri"/>
-                <a:ea typeface="+mn-ea"/>
-                <a:cs typeface="+mn-cs"/>
-              </a:rPr>
-              <a:t>  You ask → Claude answers → repeat</a:t>
-            </a:r>
-          </a:p>
-          <a:p>
-            <a:pPr marL="0" marR="0" lvl="0" indent="0" algn="l" defTabSz="457200" rtl="0" eaLnBrk="1" fontAlgn="auto" latinLnBrk="0" hangingPunct="1">
-              <a:lnSpc>
-                <a:spcPct val="100000"/>
-              </a:lnSpc>
-              <a:spcBef>
-                <a:spcPts val="0"/>
-              </a:spcBef>
-              <a:spcAft>
-                <a:spcPts val="1200"/>
-              </a:spcAft>
-              <a:buClrTx/>
-              <a:buSzTx/>
-              <a:buFontTx/>
-              <a:buNone/>
-              <a:tabLst/>
-              <a:defRPr sz="1800">
-                <a:solidFill>
-                  <a:srgbClr val="FFFFFF"/>
-                </a:solidFill>
-              </a:defRPr>
-            </a:pPr>
-            <a:r>
-              <a:rPr kumimoji="0" sz="1800" b="0" i="0" u="none" strike="noStrike" kern="1200" cap="none" spc="0" normalizeH="0" baseline="0" noProof="0">
-                <a:ln>
-                  <a:noFill/>
-                </a:ln>
-                <a:solidFill>
-                  <a:srgbClr val="FFFFFF"/>
-                </a:solidFill>
-                <a:effectLst/>
-                <a:uLnTx/>
-                <a:uFillTx/>
-                <a:latin typeface="Calibri"/>
-                <a:ea typeface="+mn-ea"/>
-                <a:cs typeface="+mn-cs"/>
-              </a:rPr>
-              <a:t>  You stay in the chat the whole time</a:t>
-            </a:r>
-          </a:p>
-          <a:p>
-            <a:pPr marL="0" marR="0" lvl="0" indent="0" algn="l" defTabSz="457200" rtl="0" eaLnBrk="1" fontAlgn="auto" latinLnBrk="0" hangingPunct="1">
-              <a:lnSpc>
-                <a:spcPct val="100000"/>
-              </a:lnSpc>
-              <a:spcBef>
-                <a:spcPts val="0"/>
-              </a:spcBef>
-              <a:spcAft>
-                <a:spcPts val="1200"/>
-              </a:spcAft>
-              <a:buClrTx/>
-              <a:buSzTx/>
-              <a:buFontTx/>
-              <a:buNone/>
-              <a:tabLst/>
-              <a:defRPr sz="1800">
-                <a:solidFill>
-                  <a:srgbClr val="FFFFFF"/>
-                </a:solidFill>
-              </a:defRPr>
-            </a:pPr>
-            <a:r>
-              <a:rPr kumimoji="0" sz="1800" b="0" i="0" u="none" strike="noStrike" kern="1200" cap="none" spc="0" normalizeH="0" baseline="0" noProof="0">
-                <a:ln>
-                  <a:noFill/>
-                </a:ln>
-                <a:solidFill>
-                  <a:srgbClr val="FFFFFF"/>
-                </a:solidFill>
-                <a:effectLst/>
-                <a:uLnTx/>
-                <a:uFillTx/>
-                <a:latin typeface="Calibri"/>
-                <a:ea typeface="+mn-ea"/>
-                <a:cs typeface="+mn-cs"/>
-              </a:rPr>
-              <a:t>  Great for real-time collaboration</a:t>
-            </a:r>
-          </a:p>
-          <a:p>
-            <a:pPr marL="0" marR="0" lvl="0" indent="0" algn="l" defTabSz="457200" rtl="0" eaLnBrk="1" fontAlgn="auto" latinLnBrk="0" hangingPunct="1">
-              <a:lnSpc>
-                <a:spcPct val="100000"/>
-              </a:lnSpc>
-              <a:spcBef>
-                <a:spcPts val="0"/>
-              </a:spcBef>
-              <a:spcAft>
-                <a:spcPts val="1200"/>
-              </a:spcAft>
-              <a:buClrTx/>
-              <a:buSzTx/>
-              <a:buFontTx/>
-              <a:buNone/>
-              <a:tabLst/>
-              <a:defRPr sz="1800">
-                <a:solidFill>
-                  <a:srgbClr val="FFFFFF"/>
-                </a:solidFill>
-              </a:defRPr>
-            </a:pPr>
-            <a:r>
-              <a:rPr kumimoji="0" sz="1800" b="0" i="0" u="none" strike="noStrike" kern="1200" cap="none" spc="0" normalizeH="0" baseline="0" noProof="0">
-                <a:ln>
-                  <a:noFill/>
-                </a:ln>
-                <a:solidFill>
-                  <a:srgbClr val="FFFFFF"/>
-                </a:solidFill>
-                <a:effectLst/>
-                <a:uLnTx/>
-                <a:uFillTx/>
-                <a:latin typeface="Calibri"/>
-                <a:ea typeface="+mn-ea"/>
-                <a:cs typeface="+mn-cs"/>
-              </a:rPr>
-              <a:t>  Immediate feedback and iteration</a:t>
-            </a:r>
-          </a:p>
-        </p:txBody>
-      </p:sp>
-      <p:sp>
-        <p:nvSpPr>
-          <p:cNvPr id="6" name="TextBox 5">
-            <a:extLst>
-              <a:ext uri="{FF2B5EF4-FFF2-40B4-BE49-F238E27FC236}">
-                <a16:creationId xmlns:a16="http://schemas.microsoft.com/office/drawing/2014/main" id="{1B1B1D5D-E934-7C33-E35D-0D76F7A0930D}"/>
-              </a:ext>
-            </a:extLst>
-          </p:cNvPr>
-          <p:cNvSpPr txBox="1"/>
-          <p:nvPr/>
-        </p:nvSpPr>
-        <p:spPr>
-          <a:xfrm>
-            <a:off x="6370167" y="1463040"/>
-            <a:ext cx="5364327" cy="731520"/>
-          </a:xfrm>
-          <a:prstGeom prst="rect">
-            <a:avLst/>
-          </a:prstGeom>
-          <a:noFill/>
-        </p:spPr>
-        <p:txBody>
-          <a:bodyPr wrap="none">
-            <a:spAutoFit/>
-          </a:bodyPr>
-          <a:lstStyle/>
-          <a:p>
-            <a:pPr marL="0" marR="0" lvl="0" indent="0" algn="ctr" defTabSz="457200" rtl="0" eaLnBrk="1" fontAlgn="auto" latinLnBrk="0" hangingPunct="1">
-              <a:lnSpc>
-                <a:spcPct val="100000"/>
-              </a:lnSpc>
-              <a:spcBef>
-                <a:spcPts val="0"/>
-              </a:spcBef>
-              <a:spcAft>
-                <a:spcPts val="0"/>
-              </a:spcAft>
-              <a:buClrTx/>
-              <a:buSzTx/>
-              <a:buFontTx/>
-              <a:buNone/>
-              <a:tabLst/>
-              <a:defRPr sz="2800" b="1">
-                <a:solidFill>
-                  <a:srgbClr val="00D4AA"/>
-                </a:solidFill>
-              </a:defRPr>
-            </a:pPr>
-            <a:r>
-              <a:rPr kumimoji="0" sz="2800" b="1" i="0" u="none" strike="noStrike" kern="1200" cap="none" spc="0" normalizeH="0" baseline="0" noProof="0">
-                <a:ln>
-                  <a:noFill/>
-                </a:ln>
-                <a:solidFill>
-                  <a:srgbClr val="00D4AA"/>
-                </a:solidFill>
-                <a:effectLst/>
-                <a:uLnTx/>
-                <a:uFillTx/>
-                <a:latin typeface="Calibri"/>
-                <a:ea typeface="+mn-ea"/>
-                <a:cs typeface="+mn-cs"/>
-              </a:rPr>
-              <a:t>Claude for Work (NEW Preview)</a:t>
-            </a:r>
-          </a:p>
-        </p:txBody>
-      </p:sp>
-      <p:sp>
-        <p:nvSpPr>
-          <p:cNvPr id="7" name="TextBox 6">
-            <a:extLst>
-              <a:ext uri="{FF2B5EF4-FFF2-40B4-BE49-F238E27FC236}">
-                <a16:creationId xmlns:a16="http://schemas.microsoft.com/office/drawing/2014/main" id="{9AEEBC51-4FB4-1A8D-646C-94CAA517A4B3}"/>
-              </a:ext>
-            </a:extLst>
-          </p:cNvPr>
-          <p:cNvSpPr txBox="1"/>
-          <p:nvPr/>
-        </p:nvSpPr>
-        <p:spPr>
-          <a:xfrm>
-            <a:off x="6370167" y="2286000"/>
-            <a:ext cx="5364327" cy="3657600"/>
-          </a:xfrm>
-          <a:prstGeom prst="rect">
-            <a:avLst/>
-          </a:prstGeom>
-          <a:noFill/>
-        </p:spPr>
-        <p:txBody>
-          <a:bodyPr wrap="square">
-            <a:spAutoFit/>
-          </a:bodyPr>
-          <a:lstStyle/>
-          <a:p>
-            <a:pPr marL="0" marR="0" lvl="0" indent="0" algn="l" defTabSz="457200" rtl="0" eaLnBrk="1" fontAlgn="auto" latinLnBrk="0" hangingPunct="1">
-              <a:lnSpc>
-                <a:spcPct val="100000"/>
-              </a:lnSpc>
-              <a:spcBef>
-                <a:spcPts val="0"/>
-              </a:spcBef>
-              <a:spcAft>
-                <a:spcPts val="1200"/>
-              </a:spcAft>
-              <a:buClrTx/>
-              <a:buSzTx/>
-              <a:buFontTx/>
-              <a:buNone/>
-              <a:tabLst/>
-              <a:defRPr sz="1800">
-                <a:solidFill>
-                  <a:srgbClr val="FFFFFF"/>
-                </a:solidFill>
-              </a:defRPr>
-            </a:pPr>
-            <a:r>
-              <a:rPr kumimoji="0" sz="1800" b="0" i="0" u="none" strike="noStrike" kern="1200" cap="none" spc="0" normalizeH="0" baseline="0" noProof="0">
-                <a:ln>
-                  <a:noFill/>
-                </a:ln>
-                <a:solidFill>
-                  <a:srgbClr val="FFFFFF"/>
-                </a:solidFill>
-                <a:effectLst/>
-                <a:uLnTx/>
-                <a:uFillTx/>
-                <a:latin typeface="Calibri"/>
-                <a:ea typeface="+mn-ea"/>
-                <a:cs typeface="+mn-cs"/>
-              </a:rPr>
-              <a:t>  Three modes: Chat, Cowork, Code tabs</a:t>
-            </a:r>
-          </a:p>
-          <a:p>
-            <a:pPr marL="0" marR="0" lvl="0" indent="0" algn="l" defTabSz="457200" rtl="0" eaLnBrk="1" fontAlgn="auto" latinLnBrk="0" hangingPunct="1">
-              <a:lnSpc>
-                <a:spcPct val="100000"/>
-              </a:lnSpc>
-              <a:spcBef>
-                <a:spcPts val="0"/>
-              </a:spcBef>
-              <a:spcAft>
-                <a:spcPts val="1200"/>
-              </a:spcAft>
-              <a:buClrTx/>
-              <a:buSzTx/>
-              <a:buFontTx/>
-              <a:buNone/>
-              <a:tabLst/>
-              <a:defRPr sz="1800">
-                <a:solidFill>
-                  <a:srgbClr val="FFFFFF"/>
-                </a:solidFill>
-              </a:defRPr>
-            </a:pPr>
-            <a:r>
-              <a:rPr kumimoji="0" sz="1800" b="0" i="0" u="none" strike="noStrike" kern="1200" cap="none" spc="0" normalizeH="0" baseline="0" noProof="0">
-                <a:ln>
-                  <a:noFill/>
-                </a:ln>
-                <a:solidFill>
-                  <a:srgbClr val="FFFFFF"/>
-                </a:solidFill>
-                <a:effectLst/>
-                <a:uLnTx/>
-                <a:uFillTx/>
-                <a:latin typeface="Calibri"/>
-                <a:ea typeface="+mn-ea"/>
-                <a:cs typeface="+mn-cs"/>
-              </a:rPr>
-              <a:t>  Set goal → Walk away → Come back later</a:t>
-            </a:r>
-          </a:p>
-          <a:p>
-            <a:pPr marL="0" marR="0" lvl="0" indent="0" algn="l" defTabSz="457200" rtl="0" eaLnBrk="1" fontAlgn="auto" latinLnBrk="0" hangingPunct="1">
-              <a:lnSpc>
-                <a:spcPct val="100000"/>
-              </a:lnSpc>
-              <a:spcBef>
-                <a:spcPts val="0"/>
-              </a:spcBef>
-              <a:spcAft>
-                <a:spcPts val="1200"/>
-              </a:spcAft>
-              <a:buClrTx/>
-              <a:buSzTx/>
-              <a:buFontTx/>
-              <a:buNone/>
-              <a:tabLst/>
-              <a:defRPr sz="1800">
-                <a:solidFill>
-                  <a:srgbClr val="FFFFFF"/>
-                </a:solidFill>
-              </a:defRPr>
-            </a:pPr>
-            <a:r>
-              <a:rPr kumimoji="0" sz="1800" b="0" i="0" u="none" strike="noStrike" kern="1200" cap="none" spc="0" normalizeH="0" baseline="0" noProof="0">
-                <a:ln>
-                  <a:noFill/>
-                </a:ln>
-                <a:solidFill>
-                  <a:srgbClr val="FFFFFF"/>
-                </a:solidFill>
-                <a:effectLst/>
-                <a:uLnTx/>
-                <a:uFillTx/>
-                <a:latin typeface="Calibri"/>
-                <a:ea typeface="+mn-ea"/>
-                <a:cs typeface="+mn-cs"/>
-              </a:rPr>
-              <a:t>  Works autonomously in background</a:t>
-            </a:r>
-          </a:p>
-          <a:p>
-            <a:pPr marL="0" marR="0" lvl="0" indent="0" algn="l" defTabSz="457200" rtl="0" eaLnBrk="1" fontAlgn="auto" latinLnBrk="0" hangingPunct="1">
-              <a:lnSpc>
-                <a:spcPct val="100000"/>
-              </a:lnSpc>
-              <a:spcBef>
-                <a:spcPts val="0"/>
-              </a:spcBef>
-              <a:spcAft>
-                <a:spcPts val="1200"/>
-              </a:spcAft>
-              <a:buClrTx/>
-              <a:buSzTx/>
-              <a:buFontTx/>
-              <a:buNone/>
-              <a:tabLst/>
-              <a:defRPr sz="1800">
-                <a:solidFill>
-                  <a:srgbClr val="FFFFFF"/>
-                </a:solidFill>
-              </a:defRPr>
-            </a:pPr>
-            <a:r>
-              <a:rPr kumimoji="0" sz="1800" b="0" i="0" u="none" strike="noStrike" kern="1200" cap="none" spc="0" normalizeH="0" baseline="0" noProof="0">
-                <a:ln>
-                  <a:noFill/>
-                </a:ln>
-                <a:solidFill>
-                  <a:srgbClr val="FFFFFF"/>
-                </a:solidFill>
-                <a:effectLst/>
-                <a:uLnTx/>
-                <a:uFillTx/>
-                <a:latin typeface="Calibri"/>
-                <a:ea typeface="+mn-ea"/>
-                <a:cs typeface="+mn-cs"/>
-              </a:rPr>
-              <a:t>  Handles complex multi-step tasks</a:t>
-            </a:r>
-          </a:p>
-          <a:p>
-            <a:pPr marL="0" marR="0" lvl="0" indent="0" algn="l" defTabSz="457200" rtl="0" eaLnBrk="1" fontAlgn="auto" latinLnBrk="0" hangingPunct="1">
-              <a:lnSpc>
-                <a:spcPct val="100000"/>
-              </a:lnSpc>
-              <a:spcBef>
-                <a:spcPts val="0"/>
-              </a:spcBef>
-              <a:spcAft>
-                <a:spcPts val="1200"/>
-              </a:spcAft>
-              <a:buClrTx/>
-              <a:buSzTx/>
-              <a:buFontTx/>
-              <a:buNone/>
-              <a:tabLst/>
-              <a:defRPr sz="1800">
-                <a:solidFill>
-                  <a:srgbClr val="FFFFFF"/>
-                </a:solidFill>
-              </a:defRPr>
-            </a:pPr>
-            <a:r>
-              <a:rPr kumimoji="0" sz="1800" b="0" i="0" u="none" strike="noStrike" kern="1200" cap="none" spc="0" normalizeH="0" baseline="0" noProof="0">
-                <a:ln>
-                  <a:noFill/>
-                </a:ln>
-                <a:solidFill>
-                  <a:srgbClr val="FFFFFF"/>
-                </a:solidFill>
-                <a:effectLst/>
-                <a:uLnTx/>
-                <a:uFillTx/>
-                <a:latin typeface="Calibri"/>
-                <a:ea typeface="+mn-ea"/>
-                <a:cs typeface="+mn-cs"/>
-              </a:rPr>
-              <a:t>  Task presets: 'Optimize my week', 'Organize screenshots', etc.</a:t>
-            </a:r>
-          </a:p>
-          <a:p>
-            <a:pPr marL="0" marR="0" lvl="0" indent="0" algn="l" defTabSz="457200" rtl="0" eaLnBrk="1" fontAlgn="auto" latinLnBrk="0" hangingPunct="1">
-              <a:lnSpc>
-                <a:spcPct val="100000"/>
-              </a:lnSpc>
-              <a:spcBef>
-                <a:spcPts val="0"/>
-              </a:spcBef>
-              <a:spcAft>
-                <a:spcPts val="1200"/>
-              </a:spcAft>
-              <a:buClrTx/>
-              <a:buSzTx/>
-              <a:buFontTx/>
-              <a:buNone/>
-              <a:tabLst/>
-              <a:defRPr sz="1800">
-                <a:solidFill>
-                  <a:srgbClr val="FFFFFF"/>
-                </a:solidFill>
-              </a:defRPr>
-            </a:pPr>
-            <a:r>
-              <a:rPr kumimoji="0" sz="1800" b="0" i="0" u="none" strike="noStrike" kern="1200" cap="none" spc="0" normalizeH="0" baseline="0" noProof="0">
-                <a:ln>
-                  <a:noFill/>
-                </a:ln>
-                <a:solidFill>
-                  <a:srgbClr val="FFFFFF"/>
-                </a:solidFill>
-                <a:effectLst/>
-                <a:uLnTx/>
-                <a:uFillTx/>
-                <a:latin typeface="Calibri"/>
-                <a:ea typeface="+mn-ea"/>
-                <a:cs typeface="+mn-cs"/>
-              </a:rPr>
-              <a:t>  You check in when YOU want</a:t>
-            </a:r>
-          </a:p>
-          <a:p>
-            <a:pPr marL="0" marR="0" lvl="0" indent="0" algn="l" defTabSz="457200" rtl="0" eaLnBrk="1" fontAlgn="auto" latinLnBrk="0" hangingPunct="1">
-              <a:lnSpc>
-                <a:spcPct val="100000"/>
-              </a:lnSpc>
-              <a:spcBef>
-                <a:spcPts val="0"/>
-              </a:spcBef>
-              <a:spcAft>
-                <a:spcPts val="1200"/>
-              </a:spcAft>
-              <a:buClrTx/>
-              <a:buSzTx/>
-              <a:buFontTx/>
-              <a:buNone/>
-              <a:tabLst/>
-              <a:defRPr sz="1800">
-                <a:solidFill>
-                  <a:srgbClr val="FFFFFF"/>
-                </a:solidFill>
-              </a:defRPr>
-            </a:pPr>
-            <a:r>
-              <a:rPr kumimoji="0" sz="1800" b="0" i="0" u="none" strike="noStrike" kern="1200" cap="none" spc="0" normalizeH="0" baseline="0" noProof="0">
-                <a:ln>
-                  <a:noFill/>
-                </a:ln>
-                <a:solidFill>
-                  <a:srgbClr val="FFFFFF"/>
-                </a:solidFill>
-                <a:effectLst/>
-                <a:uLnTx/>
-                <a:uFillTx/>
-                <a:latin typeface="Calibri"/>
-                <a:ea typeface="+mn-ea"/>
-                <a:cs typeface="+mn-cs"/>
-              </a:rPr>
-              <a:t>  Available: Windows + Mac Preview</a:t>
-            </a:r>
-          </a:p>
-          <a:p>
-            <a:pPr marL="0" marR="0" lvl="0" indent="0" algn="l" defTabSz="457200" rtl="0" eaLnBrk="1" fontAlgn="auto" latinLnBrk="0" hangingPunct="1">
-              <a:lnSpc>
-                <a:spcPct val="100000"/>
-              </a:lnSpc>
-              <a:spcBef>
-                <a:spcPts val="0"/>
-              </a:spcBef>
-              <a:spcAft>
-                <a:spcPts val="1200"/>
-              </a:spcAft>
-              <a:buClrTx/>
-              <a:buSzTx/>
-              <a:buFontTx/>
-              <a:buNone/>
-              <a:tabLst/>
-              <a:defRPr sz="1800">
-                <a:solidFill>
-                  <a:srgbClr val="FFFFFF"/>
-                </a:solidFill>
-              </a:defRPr>
-            </a:pPr>
-            <a:r>
-              <a:rPr kumimoji="0" sz="1800" b="0" i="0" u="none" strike="noStrike" kern="1200" cap="none" spc="0" normalizeH="0" baseline="0" noProof="0">
-                <a:ln>
-                  <a:noFill/>
-                </a:ln>
-                <a:solidFill>
-                  <a:srgbClr val="FFFFFF"/>
-                </a:solidFill>
-                <a:effectLst/>
-                <a:uLnTx/>
-                <a:uFillTx/>
-                <a:latin typeface="Calibri"/>
-                <a:ea typeface="+mn-ea"/>
-                <a:cs typeface="+mn-cs"/>
-              </a:rPr>
-              <a:t>  Plugin integration (customize workflows)</a:t>
-            </a:r>
-          </a:p>
-        </p:txBody>
-      </p:sp>
-      <p:sp>
-        <p:nvSpPr>
           <p:cNvPr id="14" name="TextBox 13"/>
           <p:cNvSpPr txBox="1"/>
           <p:nvPr/>
@@ -27471,543 +26607,6 @@
           <a:chExt cx="0" cy="0"/>
         </a:xfrm>
       </p:grpSpPr>
-      <p:sp>
-        <p:nvSpPr>
-          <p:cNvPr id="2" name="TextBox 1">
-            <a:extLst>
-              <a:ext uri="{FF2B5EF4-FFF2-40B4-BE49-F238E27FC236}">
-                <a16:creationId xmlns:a16="http://schemas.microsoft.com/office/drawing/2014/main" id="{BB6F2101-4F98-C246-7F6A-CA3CC9B094DC}"/>
-              </a:ext>
-            </a:extLst>
-          </p:cNvPr>
-          <p:cNvSpPr txBox="1"/>
-          <p:nvPr/>
-        </p:nvSpPr>
-        <p:spPr>
-          <a:xfrm>
-            <a:off x="457200" y="365760"/>
-            <a:ext cx="11277295" cy="822960"/>
-          </a:xfrm>
-          <a:prstGeom prst="rect">
-            <a:avLst/>
-          </a:prstGeom>
-          <a:noFill/>
-        </p:spPr>
-        <p:txBody>
-          <a:bodyPr wrap="none">
-            <a:spAutoFit/>
-          </a:bodyPr>
-          <a:lstStyle/>
-          <a:p>
-            <a:pPr marL="0" marR="0" lvl="0" indent="0" algn="l" defTabSz="457200" rtl="0" eaLnBrk="1" fontAlgn="auto" latinLnBrk="0" hangingPunct="1">
-              <a:lnSpc>
-                <a:spcPct val="100000"/>
-              </a:lnSpc>
-              <a:spcBef>
-                <a:spcPts val="0"/>
-              </a:spcBef>
-              <a:spcAft>
-                <a:spcPts val="0"/>
-              </a:spcAft>
-              <a:buClrTx/>
-              <a:buSzTx/>
-              <a:buFontTx/>
-              <a:buNone/>
-              <a:tabLst/>
-              <a:defRPr sz="4000" b="1">
-                <a:solidFill>
-                  <a:srgbClr val="FFFFFF"/>
-                </a:solidFill>
-              </a:defRPr>
-            </a:pPr>
-            <a:r>
-              <a:rPr kumimoji="0" sz="4000" b="1" i="0" u="none" strike="noStrike" kern="1200" cap="none" spc="0" normalizeH="0" baseline="0" noProof="0">
-                <a:ln>
-                  <a:noFill/>
-                </a:ln>
-                <a:solidFill>
-                  <a:srgbClr val="FFFFFF"/>
-                </a:solidFill>
-                <a:effectLst/>
-                <a:uLnTx/>
-                <a:uFillTx/>
-                <a:latin typeface="Calibri"/>
-                <a:ea typeface="+mn-ea"/>
-                <a:cs typeface="+mn-cs"/>
-              </a:rPr>
-              <a:t>When to Use Claude for Work</a:t>
-            </a:r>
-          </a:p>
-        </p:txBody>
-      </p:sp>
-      <p:sp>
-        <p:nvSpPr>
-          <p:cNvPr id="3" name="Rectangle 2">
-            <a:extLst>
-              <a:ext uri="{FF2B5EF4-FFF2-40B4-BE49-F238E27FC236}">
-                <a16:creationId xmlns:a16="http://schemas.microsoft.com/office/drawing/2014/main" id="{D1BA573A-E4B7-822F-B58F-C8B4687FAE8F}"/>
-              </a:ext>
-            </a:extLst>
-          </p:cNvPr>
-          <p:cNvSpPr/>
-          <p:nvPr/>
-        </p:nvSpPr>
-        <p:spPr>
-          <a:xfrm>
-            <a:off x="457200" y="1234440"/>
-            <a:ext cx="1828800" cy="36576"/>
-          </a:xfrm>
-          <a:prstGeom prst="rect">
-            <a:avLst/>
-          </a:prstGeom>
-          <a:solidFill>
-            <a:srgbClr val="00D4AA"/>
-          </a:solidFill>
-          <a:ln>
-            <a:noFill/>
-          </a:ln>
-        </p:spPr>
-        <p:style>
-          <a:lnRef idx="1">
-            <a:schemeClr val="accent1"/>
-          </a:lnRef>
-          <a:fillRef idx="3">
-            <a:schemeClr val="accent1"/>
-          </a:fillRef>
-          <a:effectRef idx="2">
-            <a:schemeClr val="accent1"/>
-          </a:effectRef>
-          <a:fontRef idx="minor">
-            <a:schemeClr val="lt1"/>
-          </a:fontRef>
-        </p:style>
-        <p:txBody>
-          <a:bodyPr rtlCol="0" anchor="ctr"/>
-          <a:lstStyle/>
-          <a:p>
-            <a:pPr marL="0" marR="0" lvl="0" indent="0" algn="ctr" defTabSz="457200" rtl="0" eaLnBrk="1" fontAlgn="auto" latinLnBrk="0" hangingPunct="1">
-              <a:lnSpc>
-                <a:spcPct val="100000"/>
-              </a:lnSpc>
-              <a:spcBef>
-                <a:spcPts val="0"/>
-              </a:spcBef>
-              <a:spcAft>
-                <a:spcPts val="0"/>
-              </a:spcAft>
-              <a:buClrTx/>
-              <a:buSzTx/>
-              <a:buFontTx/>
-              <a:buNone/>
-              <a:tabLst/>
-              <a:defRPr/>
-            </a:pPr>
-            <a:endParaRPr kumimoji="0" sz="1800" b="0" i="0" u="none" strike="noStrike" kern="1200" cap="none" spc="0" normalizeH="0" baseline="0" noProof="0">
-              <a:ln>
-                <a:noFill/>
-              </a:ln>
-              <a:solidFill>
-                <a:prstClr val="white"/>
-              </a:solidFill>
-              <a:effectLst/>
-              <a:uLnTx/>
-              <a:uFillTx/>
-              <a:latin typeface="Calibri"/>
-              <a:ea typeface="+mn-ea"/>
-              <a:cs typeface="+mn-cs"/>
-            </a:endParaRPr>
-          </a:p>
-        </p:txBody>
-      </p:sp>
-      <p:sp>
-        <p:nvSpPr>
-          <p:cNvPr id="4" name="TextBox 3">
-            <a:extLst>
-              <a:ext uri="{FF2B5EF4-FFF2-40B4-BE49-F238E27FC236}">
-                <a16:creationId xmlns:a16="http://schemas.microsoft.com/office/drawing/2014/main" id="{DF607436-CA4A-12EA-4CC2-583FD5C95E76}"/>
-              </a:ext>
-            </a:extLst>
-          </p:cNvPr>
-          <p:cNvSpPr txBox="1"/>
-          <p:nvPr/>
-        </p:nvSpPr>
-        <p:spPr>
-          <a:xfrm>
-            <a:off x="457200" y="1463040"/>
-            <a:ext cx="11277295" cy="4572000"/>
-          </a:xfrm>
-          <a:prstGeom prst="rect">
-            <a:avLst/>
-          </a:prstGeom>
-          <a:noFill/>
-        </p:spPr>
-        <p:txBody>
-          <a:bodyPr wrap="square">
-            <a:spAutoFit/>
-          </a:bodyPr>
-          <a:lstStyle/>
-          <a:p>
-            <a:pPr marL="0" marR="0" lvl="0" indent="0" algn="l" defTabSz="457200" rtl="0" eaLnBrk="1" fontAlgn="auto" latinLnBrk="0" hangingPunct="1">
-              <a:lnSpc>
-                <a:spcPct val="100000"/>
-              </a:lnSpc>
-              <a:spcBef>
-                <a:spcPts val="800"/>
-              </a:spcBef>
-              <a:spcAft>
-                <a:spcPts val="800"/>
-              </a:spcAft>
-              <a:buClrTx/>
-              <a:buSzTx/>
-              <a:buFontTx/>
-              <a:buNone/>
-              <a:tabLst/>
-              <a:defRPr sz="2200">
-                <a:solidFill>
-                  <a:srgbClr val="FFFFFF"/>
-                </a:solidFill>
-              </a:defRPr>
-            </a:pPr>
-            <a:r>
-              <a:rPr kumimoji="0" sz="2200" b="0" i="0" u="none" strike="noStrike" kern="1200" cap="none" spc="0" normalizeH="0" baseline="0" noProof="0">
-                <a:ln>
-                  <a:noFill/>
-                </a:ln>
-                <a:solidFill>
-                  <a:srgbClr val="FFFFFF"/>
-                </a:solidFill>
-                <a:effectLst/>
-                <a:uLnTx/>
-                <a:uFillTx/>
-                <a:latin typeface="Calibri"/>
-                <a:ea typeface="+mn-ea"/>
-                <a:cs typeface="+mn-cs"/>
-              </a:rPr>
-              <a:t>  ✅ PERFECT FOR: Complex multi-step tasks (2+ hours of work)</a:t>
-            </a:r>
-          </a:p>
-          <a:p>
-            <a:pPr marL="0" marR="0" lvl="0" indent="0" algn="l" defTabSz="457200" rtl="0" eaLnBrk="1" fontAlgn="auto" latinLnBrk="0" hangingPunct="1">
-              <a:lnSpc>
-                <a:spcPct val="100000"/>
-              </a:lnSpc>
-              <a:spcBef>
-                <a:spcPts val="800"/>
-              </a:spcBef>
-              <a:spcAft>
-                <a:spcPts val="800"/>
-              </a:spcAft>
-              <a:buClrTx/>
-              <a:buSzTx/>
-              <a:buFontTx/>
-              <a:buNone/>
-              <a:tabLst/>
-              <a:defRPr sz="2200">
-                <a:solidFill>
-                  <a:srgbClr val="FFFFFF"/>
-                </a:solidFill>
-              </a:defRPr>
-            </a:pPr>
-            <a:r>
-              <a:rPr kumimoji="0" sz="2200" b="0" i="0" u="none" strike="noStrike" kern="1200" cap="none" spc="0" normalizeH="0" baseline="0" noProof="0">
-                <a:ln>
-                  <a:noFill/>
-                </a:ln>
-                <a:solidFill>
-                  <a:srgbClr val="FFFFFF"/>
-                </a:solidFill>
-                <a:effectLst/>
-                <a:uLnTx/>
-                <a:uFillTx/>
-                <a:latin typeface="Calibri"/>
-                <a:ea typeface="+mn-ea"/>
-                <a:cs typeface="+mn-cs"/>
-              </a:rPr>
-              <a:t>     • Competitive research &amp; analysis</a:t>
-            </a:r>
-          </a:p>
-          <a:p>
-            <a:pPr marL="0" marR="0" lvl="0" indent="0" algn="l" defTabSz="457200" rtl="0" eaLnBrk="1" fontAlgn="auto" latinLnBrk="0" hangingPunct="1">
-              <a:lnSpc>
-                <a:spcPct val="100000"/>
-              </a:lnSpc>
-              <a:spcBef>
-                <a:spcPts val="800"/>
-              </a:spcBef>
-              <a:spcAft>
-                <a:spcPts val="800"/>
-              </a:spcAft>
-              <a:buClrTx/>
-              <a:buSzTx/>
-              <a:buFontTx/>
-              <a:buNone/>
-              <a:tabLst/>
-              <a:defRPr sz="2200">
-                <a:solidFill>
-                  <a:srgbClr val="FFFFFF"/>
-                </a:solidFill>
-              </a:defRPr>
-            </a:pPr>
-            <a:r>
-              <a:rPr kumimoji="0" sz="2200" b="0" i="0" u="none" strike="noStrike" kern="1200" cap="none" spc="0" normalizeH="0" baseline="0" noProof="0">
-                <a:ln>
-                  <a:noFill/>
-                </a:ln>
-                <a:solidFill>
-                  <a:srgbClr val="FFFFFF"/>
-                </a:solidFill>
-                <a:effectLst/>
-                <a:uLnTx/>
-                <a:uFillTx/>
-                <a:latin typeface="Calibri"/>
-                <a:ea typeface="+mn-ea"/>
-                <a:cs typeface="+mn-cs"/>
-              </a:rPr>
-              <a:t>     • Writing long documents (PRDs, reports, proposals)</a:t>
-            </a:r>
-          </a:p>
-          <a:p>
-            <a:pPr marL="0" marR="0" lvl="0" indent="0" algn="l" defTabSz="457200" rtl="0" eaLnBrk="1" fontAlgn="auto" latinLnBrk="0" hangingPunct="1">
-              <a:lnSpc>
-                <a:spcPct val="100000"/>
-              </a:lnSpc>
-              <a:spcBef>
-                <a:spcPts val="800"/>
-              </a:spcBef>
-              <a:spcAft>
-                <a:spcPts val="800"/>
-              </a:spcAft>
-              <a:buClrTx/>
-              <a:buSzTx/>
-              <a:buFontTx/>
-              <a:buNone/>
-              <a:tabLst/>
-              <a:defRPr sz="2200">
-                <a:solidFill>
-                  <a:srgbClr val="FFFFFF"/>
-                </a:solidFill>
-              </a:defRPr>
-            </a:pPr>
-            <a:r>
-              <a:rPr kumimoji="0" sz="2200" b="0" i="0" u="none" strike="noStrike" kern="1200" cap="none" spc="0" normalizeH="0" baseline="0" noProof="0">
-                <a:ln>
-                  <a:noFill/>
-                </a:ln>
-                <a:solidFill>
-                  <a:srgbClr val="FFFFFF"/>
-                </a:solidFill>
-                <a:effectLst/>
-                <a:uLnTx/>
-                <a:uFillTx/>
-                <a:latin typeface="Calibri"/>
-                <a:ea typeface="+mn-ea"/>
-                <a:cs typeface="+mn-cs"/>
-              </a:rPr>
-              <a:t>     • Data analysis across multiple files</a:t>
-            </a:r>
-          </a:p>
-          <a:p>
-            <a:pPr marL="0" marR="0" lvl="0" indent="0" algn="l" defTabSz="457200" rtl="0" eaLnBrk="1" fontAlgn="auto" latinLnBrk="0" hangingPunct="1">
-              <a:lnSpc>
-                <a:spcPct val="100000"/>
-              </a:lnSpc>
-              <a:spcBef>
-                <a:spcPts val="800"/>
-              </a:spcBef>
-              <a:spcAft>
-                <a:spcPts val="800"/>
-              </a:spcAft>
-              <a:buClrTx/>
-              <a:buSzTx/>
-              <a:buFontTx/>
-              <a:buNone/>
-              <a:tabLst/>
-              <a:defRPr sz="2200">
-                <a:solidFill>
-                  <a:srgbClr val="FFFFFF"/>
-                </a:solidFill>
-              </a:defRPr>
-            </a:pPr>
-            <a:r>
-              <a:rPr kumimoji="0" sz="2200" b="0" i="0" u="none" strike="noStrike" kern="1200" cap="none" spc="0" normalizeH="0" baseline="0" noProof="0">
-                <a:ln>
-                  <a:noFill/>
-                </a:ln>
-                <a:solidFill>
-                  <a:srgbClr val="FFFFFF"/>
-                </a:solidFill>
-                <a:effectLst/>
-                <a:uLnTx/>
-                <a:uFillTx/>
-                <a:latin typeface="Calibri"/>
-                <a:ea typeface="+mn-ea"/>
-                <a:cs typeface="+mn-cs"/>
-              </a:rPr>
-              <a:t>     • Content creation with multiple iterations</a:t>
-            </a:r>
-          </a:p>
-          <a:p>
-            <a:pPr marL="0" marR="0" lvl="0" indent="0" algn="l" defTabSz="457200" rtl="0" eaLnBrk="1" fontAlgn="auto" latinLnBrk="0" hangingPunct="1">
-              <a:lnSpc>
-                <a:spcPct val="100000"/>
-              </a:lnSpc>
-              <a:spcBef>
-                <a:spcPts val="800"/>
-              </a:spcBef>
-              <a:spcAft>
-                <a:spcPts val="800"/>
-              </a:spcAft>
-              <a:buClrTx/>
-              <a:buSzTx/>
-              <a:buFontTx/>
-              <a:buNone/>
-              <a:tabLst/>
-              <a:defRPr sz="2200">
-                <a:solidFill>
-                  <a:srgbClr val="FFFFFF"/>
-                </a:solidFill>
-              </a:defRPr>
-            </a:pPr>
-            <a:r>
-              <a:rPr kumimoji="0" sz="2200" b="0" i="0" u="none" strike="noStrike" kern="1200" cap="none" spc="0" normalizeH="0" baseline="0" noProof="0">
-                <a:ln>
-                  <a:noFill/>
-                </a:ln>
-                <a:solidFill>
-                  <a:srgbClr val="FFFFFF"/>
-                </a:solidFill>
-                <a:effectLst/>
-                <a:uLnTx/>
-                <a:uFillTx/>
-                <a:latin typeface="Calibri"/>
-                <a:ea typeface="+mn-ea"/>
-                <a:cs typeface="+mn-cs"/>
-              </a:rPr>
-              <a:t>  ❌ NOT IDEAL FOR: Quick questions, real-time collaboration, learning/exploration</a:t>
-            </a:r>
-          </a:p>
-          <a:p>
-            <a:pPr marL="0" marR="0" lvl="0" indent="0" algn="l" defTabSz="457200" rtl="0" eaLnBrk="1" fontAlgn="auto" latinLnBrk="0" hangingPunct="1">
-              <a:lnSpc>
-                <a:spcPct val="100000"/>
-              </a:lnSpc>
-              <a:spcBef>
-                <a:spcPts val="800"/>
-              </a:spcBef>
-              <a:spcAft>
-                <a:spcPts val="800"/>
-              </a:spcAft>
-              <a:buClrTx/>
-              <a:buSzTx/>
-              <a:buFontTx/>
-              <a:buNone/>
-              <a:tabLst/>
-              <a:defRPr sz="2200">
-                <a:solidFill>
-                  <a:srgbClr val="FFFFFF"/>
-                </a:solidFill>
-              </a:defRPr>
-            </a:pPr>
-            <a:r>
-              <a:rPr kumimoji="0" sz="2200" b="0" i="0" u="none" strike="noStrike" kern="1200" cap="none" spc="0" normalizeH="0" baseline="0" noProof="0">
-                <a:ln>
-                  <a:noFill/>
-                </a:ln>
-                <a:solidFill>
-                  <a:srgbClr val="FFFFFF"/>
-                </a:solidFill>
-                <a:effectLst/>
-                <a:uLnTx/>
-                <a:uFillTx/>
-                <a:latin typeface="Calibri"/>
-                <a:ea typeface="+mn-ea"/>
-                <a:cs typeface="+mn-cs"/>
-              </a:rPr>
-              <a:t>  🎯 THE RULE: If you'd normally block 2+ hours on calendar → Use Cowork. Quick task → Use Claude.ai</a:t>
-            </a:r>
-          </a:p>
-          <a:p>
-            <a:pPr marL="0" marR="0" lvl="0" indent="0" algn="l" defTabSz="457200" rtl="0" eaLnBrk="1" fontAlgn="auto" latinLnBrk="0" hangingPunct="1">
-              <a:lnSpc>
-                <a:spcPct val="100000"/>
-              </a:lnSpc>
-              <a:spcBef>
-                <a:spcPts val="800"/>
-              </a:spcBef>
-              <a:spcAft>
-                <a:spcPts val="800"/>
-              </a:spcAft>
-              <a:buClrTx/>
-              <a:buSzTx/>
-              <a:buFontTx/>
-              <a:buNone/>
-              <a:tabLst/>
-              <a:defRPr sz="2200">
-                <a:solidFill>
-                  <a:srgbClr val="FFFFFF"/>
-                </a:solidFill>
-              </a:defRPr>
-            </a:pPr>
-            <a:r>
-              <a:rPr kumimoji="0" sz="2200" b="0" i="0" u="none" strike="noStrike" kern="1200" cap="none" spc="0" normalizeH="0" baseline="0" noProof="0">
-                <a:ln>
-                  <a:noFill/>
-                </a:ln>
-                <a:solidFill>
-                  <a:srgbClr val="FFFFFF"/>
-                </a:solidFill>
-                <a:effectLst/>
-                <a:uLnTx/>
-                <a:uFillTx/>
-                <a:latin typeface="Calibri"/>
-                <a:ea typeface="+mn-ea"/>
-                <a:cs typeface="+mn-cs"/>
-              </a:rPr>
-              <a:t>  💻 HOW TO GET IT: Download Claude Desktop App (Windows/Mac) - Pro/Team subscribers get autonomous features in Preview</a:t>
-            </a:r>
-          </a:p>
-          <a:p>
-            <a:pPr marL="0" marR="0" lvl="0" indent="0" algn="l" defTabSz="457200" rtl="0" eaLnBrk="1" fontAlgn="auto" latinLnBrk="0" hangingPunct="1">
-              <a:lnSpc>
-                <a:spcPct val="100000"/>
-              </a:lnSpc>
-              <a:spcBef>
-                <a:spcPts val="800"/>
-              </a:spcBef>
-              <a:spcAft>
-                <a:spcPts val="800"/>
-              </a:spcAft>
-              <a:buClrTx/>
-              <a:buSzTx/>
-              <a:buFontTx/>
-              <a:buNone/>
-              <a:tabLst/>
-              <a:defRPr sz="2200">
-                <a:solidFill>
-                  <a:srgbClr val="FFFFFF"/>
-                </a:solidFill>
-              </a:defRPr>
-            </a:pPr>
-            <a:r>
-              <a:rPr kumimoji="0" sz="2200" b="0" i="0" u="none" strike="noStrike" kern="1200" cap="none" spc="0" normalizeH="0" baseline="0" noProof="0">
-                <a:ln>
-                  <a:noFill/>
-                </a:ln>
-                <a:solidFill>
-                  <a:srgbClr val="FFFFFF"/>
-                </a:solidFill>
-                <a:effectLst/>
-                <a:uLnTx/>
-                <a:uFillTx/>
-                <a:latin typeface="Calibri"/>
-                <a:ea typeface="+mn-ea"/>
-                <a:cs typeface="+mn-cs"/>
-              </a:rPr>
-              <a:t>  ⚠️ PREVIEW NOTE: Early access = expect bugs, limited rollout, features evolving</a:t>
-            </a:r>
-          </a:p>
-        </p:txBody>
-      </p:sp>
       <p:sp>
         <p:nvSpPr>
           <p:cNvPr id="18" name="TextBox 17"/>

</xml_diff>

<commit_message>
Day 1: Add 4 section dividers + title consistency — 85 slides
Section dividers (teal accent bar, section number, title, duration):
- Section 1: Claude Interface & Prompt Engineering (2h 30m)
- Section 2: Models, Settings & Projects (1h 30m)
- Section 3: Analysis Prompts & Claude in Excel (1h 15m)
- Section 4: Artifacts, Files & Integrations (1h 30m)

Title fixes: 'What are' → 'What Are' for Projects and Artifacts
Clean ZIP, no repair prompt
</commit_message>
<xml_diff>
--- a/slides/Day1_Claude_for_Business.pptx
+++ b/slides/Day1_Claude_for_Business.pptx
@@ -11,6 +11,7 @@
     <p:sldId id="256" r:id="rId2"/>
     <p:sldId id="257" r:id="rId3"/>
     <p:sldId id="258" r:id="rId4"/>
+    <p:sldId id="346" r:id="rId90"/>
     <p:sldId id="264" r:id="rId5"/>
     <p:sldId id="268" r:id="rId6"/>
     <p:sldId id="269" r:id="rId7"/>
@@ -32,6 +33,7 @@
     <p:sldId id="297" r:id="rId23"/>
     <p:sldId id="293" r:id="rId24"/>
     <p:sldId id="280" r:id="rId25"/>
+    <p:sldId id="347" r:id="rId91"/>
     <p:sldId id="259" r:id="rId26"/>
     <p:sldId id="260" r:id="rId27"/>
     <p:sldId id="261" r:id="rId28"/>
@@ -50,6 +52,7 @@
     <p:sldId id="276" r:id="rId41"/>
     <p:sldId id="343" r:id="rId42"/>
     <p:sldId id="298" r:id="rId43"/>
+    <p:sldId id="348" r:id="rId92"/>
     <p:sldId id="277" r:id="rId44"/>
     <p:sldId id="315" r:id="rId45"/>
     <p:sldId id="279" r:id="rId46"/>
@@ -65,6 +68,7 @@
     <p:sldId id="278" r:id="rId56"/>
     <p:sldId id="344" r:id="rId57"/>
     <p:sldId id="309" r:id="rId58"/>
+    <p:sldId id="349" r:id="rId93"/>
     <p:sldId id="310" r:id="rId59"/>
     <p:sldId id="311" r:id="rId60"/>
     <p:sldId id="312" r:id="rId61"/>
@@ -28715,7 +28719,7 @@
               </a:defRPr>
             </a:pPr>
             <a:r>
-              <a:t>What are Projects?</a:t>
+              <a:t>What Are Projects?</a:t>
             </a:r>
           </a:p>
         </p:txBody>
@@ -38508,7 +38512,7 @@
               </a:defRPr>
             </a:pPr>
             <a:r>
-              <a:t>What are Artifacts?</a:t>
+              <a:t>What Are Artifacts?</a:t>
             </a:r>
           </a:p>
         </p:txBody>
@@ -48224,6 +48228,934 @@
             </a:pPr>
             <a:r>
               <a:t>- © 2026 AIA Copilot</a:t>
+            </a:r>
+          </a:p>
+        </p:txBody>
+      </p:sp>
+    </p:spTree>
+  </p:cSld>
+  <p:clrMapOvr>
+    <a:masterClrMapping/>
+  </p:clrMapOvr>
+</p:sld>
+</file>
+
+<file path=ppt/slides/slide82.xml><?xml version="1.0" encoding="utf-8"?>
+<p:sld xmlns:a="http://schemas.openxmlformats.org/drawingml/2006/main" xmlns:p="http://schemas.openxmlformats.org/presentationml/2006/main" xmlns:r="http://schemas.openxmlformats.org/officeDocument/2006/relationships">
+  <p:cSld>
+    <p:bg>
+      <p:bgPr>
+        <a:solidFill>
+          <a:srgbClr val="1F2D3D"/>
+        </a:solidFill>
+        <a:effectLst/>
+      </p:bgPr>
+    </p:bg>
+    <p:spTree>
+      <p:nvGrpSpPr>
+        <p:cNvPr id="1" name=""/>
+        <p:cNvGrpSpPr/>
+        <p:nvPr/>
+      </p:nvGrpSpPr>
+      <p:grpSpPr/>
+      <p:sp>
+        <p:nvSpPr>
+          <p:cNvPr id="2" name="Rectangle 1"/>
+          <p:cNvSpPr/>
+          <p:nvPr/>
+        </p:nvSpPr>
+        <p:spPr>
+          <a:xfrm>
+            <a:off x="365760" y="1371600"/>
+            <a:ext cx="73152" cy="2743200"/>
+          </a:xfrm>
+          <a:prstGeom prst="rect">
+            <a:avLst/>
+          </a:prstGeom>
+          <a:solidFill>
+            <a:srgbClr val="14B8A6"/>
+          </a:solidFill>
+          <a:ln>
+            <a:noFill/>
+          </a:ln>
+        </p:spPr>
+        <p:style>
+          <a:lnRef idx="1">
+            <a:schemeClr val="accent1"/>
+          </a:lnRef>
+          <a:fillRef idx="3">
+            <a:schemeClr val="accent1"/>
+          </a:fillRef>
+          <a:effectRef idx="2">
+            <a:schemeClr val="accent1"/>
+          </a:effectRef>
+          <a:fontRef idx="minor">
+            <a:schemeClr val="lt1"/>
+          </a:fontRef>
+        </p:style>
+        <p:txBody>
+          <a:bodyPr rtlCol="0" anchor="ctr"/>
+          <a:lstStyle/>
+          <a:p>
+            <a:pPr algn="ctr"/>
+          </a:p>
+        </p:txBody>
+      </p:sp>
+      <p:sp>
+        <p:nvSpPr>
+          <p:cNvPr id="3" name="TextBox 2"/>
+          <p:cNvSpPr txBox="1"/>
+          <p:nvPr/>
+        </p:nvSpPr>
+        <p:spPr>
+          <a:xfrm>
+            <a:off x="731520" y="1371600"/>
+            <a:ext cx="2743200" cy="548640"/>
+          </a:xfrm>
+          <a:prstGeom prst="rect">
+            <a:avLst/>
+          </a:prstGeom>
+          <a:noFill/>
+        </p:spPr>
+        <p:txBody>
+          <a:bodyPr wrap="none">
+            <a:spAutoFit/>
+          </a:bodyPr>
+          <a:lstStyle/>
+          <a:p>
+            <a:pPr>
+              <a:defRPr sz="1600" b="1">
+                <a:solidFill>
+                  <a:srgbClr val="14B8A6"/>
+                </a:solidFill>
+              </a:defRPr>
+            </a:pPr>
+            <a:r>
+              <a:t>SECTION 1</a:t>
+            </a:r>
+          </a:p>
+        </p:txBody>
+      </p:sp>
+      <p:sp>
+        <p:nvSpPr>
+          <p:cNvPr id="4" name="TextBox 3"/>
+          <p:cNvSpPr txBox="1"/>
+          <p:nvPr/>
+        </p:nvSpPr>
+        <p:spPr>
+          <a:xfrm>
+            <a:off x="731520" y="2011680"/>
+            <a:ext cx="10058400" cy="1097280"/>
+          </a:xfrm>
+          <a:prstGeom prst="rect">
+            <a:avLst/>
+          </a:prstGeom>
+          <a:noFill/>
+        </p:spPr>
+        <p:txBody>
+          <a:bodyPr wrap="none">
+            <a:spAutoFit/>
+          </a:bodyPr>
+          <a:lstStyle/>
+          <a:p>
+            <a:pPr>
+              <a:defRPr sz="5600" b="1">
+                <a:solidFill>
+                  <a:srgbClr val="FFFFFF"/>
+                </a:solidFill>
+              </a:defRPr>
+            </a:pPr>
+            <a:r>
+              <a:t>Claude Interface</a:t>
+            </a:r>
+            <a:br/>
+            <a:r>
+              <a:t>&amp; Prompt Engineering</a:t>
+            </a:r>
+          </a:p>
+        </p:txBody>
+      </p:sp>
+      <p:sp>
+        <p:nvSpPr>
+          <p:cNvPr id="5" name="TextBox 4"/>
+          <p:cNvSpPr txBox="1"/>
+          <p:nvPr/>
+        </p:nvSpPr>
+        <p:spPr>
+          <a:xfrm>
+            <a:off x="731520" y="3200400"/>
+            <a:ext cx="10058400" cy="548640"/>
+          </a:xfrm>
+          <a:prstGeom prst="rect">
+            <a:avLst/>
+          </a:prstGeom>
+          <a:noFill/>
+        </p:spPr>
+        <p:txBody>
+          <a:bodyPr wrap="none">
+            <a:spAutoFit/>
+          </a:bodyPr>
+          <a:lstStyle/>
+          <a:p>
+            <a:pPr>
+              <a:defRPr sz="2200">
+                <a:solidFill>
+                  <a:srgbClr val="9CA3AF"/>
+                </a:solidFill>
+              </a:defRPr>
+            </a:pPr>
+            <a:r>
+              <a:t>Navigate the tool, then master the core skill</a:t>
+            </a:r>
+          </a:p>
+        </p:txBody>
+      </p:sp>
+      <p:sp>
+        <p:nvSpPr>
+          <p:cNvPr id="6" name="Rounded Rectangle 5"/>
+          <p:cNvSpPr/>
+          <p:nvPr/>
+        </p:nvSpPr>
+        <p:spPr>
+          <a:xfrm>
+            <a:off x="731520" y="4023360"/>
+            <a:ext cx="1828800" cy="457200"/>
+          </a:xfrm>
+          <a:prstGeom prst="roundRect">
+            <a:avLst/>
+          </a:prstGeom>
+          <a:solidFill>
+            <a:srgbClr val="24354A"/>
+          </a:solidFill>
+          <a:ln w="12700">
+            <a:solidFill>
+              <a:srgbClr val="14B8A6"/>
+            </a:solidFill>
+          </a:ln>
+        </p:spPr>
+        <p:style>
+          <a:lnRef idx="1">
+            <a:schemeClr val="accent1"/>
+          </a:lnRef>
+          <a:fillRef idx="3">
+            <a:schemeClr val="accent1"/>
+          </a:fillRef>
+          <a:effectRef idx="2">
+            <a:schemeClr val="accent1"/>
+          </a:effectRef>
+          <a:fontRef idx="minor">
+            <a:schemeClr val="lt1"/>
+          </a:fontRef>
+        </p:style>
+        <p:txBody>
+          <a:bodyPr rtlCol="0" anchor="ctr"/>
+          <a:lstStyle/>
+          <a:p>
+            <a:pPr algn="ctr">
+              <a:defRPr sz="1400" b="1">
+                <a:solidFill>
+                  <a:srgbClr val="14B8A6"/>
+                </a:solidFill>
+              </a:defRPr>
+            </a:pPr>
+            <a:r>
+              <a:t>2 hours 30 min</a:t>
+            </a:r>
+          </a:p>
+        </p:txBody>
+      </p:sp>
+    </p:spTree>
+  </p:cSld>
+  <p:clrMapOvr>
+    <a:masterClrMapping/>
+  </p:clrMapOvr>
+</p:sld>
+</file>
+
+<file path=ppt/slides/slide83.xml><?xml version="1.0" encoding="utf-8"?>
+<p:sld xmlns:a="http://schemas.openxmlformats.org/drawingml/2006/main" xmlns:p="http://schemas.openxmlformats.org/presentationml/2006/main" xmlns:r="http://schemas.openxmlformats.org/officeDocument/2006/relationships">
+  <p:cSld>
+    <p:bg>
+      <p:bgPr>
+        <a:solidFill>
+          <a:srgbClr val="1F2D3D"/>
+        </a:solidFill>
+        <a:effectLst/>
+      </p:bgPr>
+    </p:bg>
+    <p:spTree>
+      <p:nvGrpSpPr>
+        <p:cNvPr id="1" name=""/>
+        <p:cNvGrpSpPr/>
+        <p:nvPr/>
+      </p:nvGrpSpPr>
+      <p:grpSpPr/>
+      <p:sp>
+        <p:nvSpPr>
+          <p:cNvPr id="2" name="Rectangle 1"/>
+          <p:cNvSpPr/>
+          <p:nvPr/>
+        </p:nvSpPr>
+        <p:spPr>
+          <a:xfrm>
+            <a:off x="365760" y="1371600"/>
+            <a:ext cx="73152" cy="2743200"/>
+          </a:xfrm>
+          <a:prstGeom prst="rect">
+            <a:avLst/>
+          </a:prstGeom>
+          <a:solidFill>
+            <a:srgbClr val="14B8A6"/>
+          </a:solidFill>
+          <a:ln>
+            <a:noFill/>
+          </a:ln>
+        </p:spPr>
+        <p:style>
+          <a:lnRef idx="1">
+            <a:schemeClr val="accent1"/>
+          </a:lnRef>
+          <a:fillRef idx="3">
+            <a:schemeClr val="accent1"/>
+          </a:fillRef>
+          <a:effectRef idx="2">
+            <a:schemeClr val="accent1"/>
+          </a:effectRef>
+          <a:fontRef idx="minor">
+            <a:schemeClr val="lt1"/>
+          </a:fontRef>
+        </p:style>
+        <p:txBody>
+          <a:bodyPr rtlCol="0" anchor="ctr"/>
+          <a:lstStyle/>
+          <a:p>
+            <a:pPr algn="ctr"/>
+          </a:p>
+        </p:txBody>
+      </p:sp>
+      <p:sp>
+        <p:nvSpPr>
+          <p:cNvPr id="3" name="TextBox 2"/>
+          <p:cNvSpPr txBox="1"/>
+          <p:nvPr/>
+        </p:nvSpPr>
+        <p:spPr>
+          <a:xfrm>
+            <a:off x="731520" y="1371600"/>
+            <a:ext cx="2743200" cy="548640"/>
+          </a:xfrm>
+          <a:prstGeom prst="rect">
+            <a:avLst/>
+          </a:prstGeom>
+          <a:noFill/>
+        </p:spPr>
+        <p:txBody>
+          <a:bodyPr wrap="none">
+            <a:spAutoFit/>
+          </a:bodyPr>
+          <a:lstStyle/>
+          <a:p>
+            <a:pPr>
+              <a:defRPr sz="1600" b="1">
+                <a:solidFill>
+                  <a:srgbClr val="14B8A6"/>
+                </a:solidFill>
+              </a:defRPr>
+            </a:pPr>
+            <a:r>
+              <a:t>SECTION 2</a:t>
+            </a:r>
+          </a:p>
+        </p:txBody>
+      </p:sp>
+      <p:sp>
+        <p:nvSpPr>
+          <p:cNvPr id="4" name="TextBox 3"/>
+          <p:cNvSpPr txBox="1"/>
+          <p:nvPr/>
+        </p:nvSpPr>
+        <p:spPr>
+          <a:xfrm>
+            <a:off x="731520" y="2011680"/>
+            <a:ext cx="10058400" cy="1097280"/>
+          </a:xfrm>
+          <a:prstGeom prst="rect">
+            <a:avLst/>
+          </a:prstGeom>
+          <a:noFill/>
+        </p:spPr>
+        <p:txBody>
+          <a:bodyPr wrap="none">
+            <a:spAutoFit/>
+          </a:bodyPr>
+          <a:lstStyle/>
+          <a:p>
+            <a:pPr>
+              <a:defRPr sz="5600" b="1">
+                <a:solidFill>
+                  <a:srgbClr val="FFFFFF"/>
+                </a:solidFill>
+              </a:defRPr>
+            </a:pPr>
+            <a:r>
+              <a:t>Models, Settings</a:t>
+            </a:r>
+            <a:br/>
+            <a:r>
+              <a:t>&amp; Projects</a:t>
+            </a:r>
+          </a:p>
+        </p:txBody>
+      </p:sp>
+      <p:sp>
+        <p:nvSpPr>
+          <p:cNvPr id="5" name="TextBox 4"/>
+          <p:cNvSpPr txBox="1"/>
+          <p:nvPr/>
+        </p:nvSpPr>
+        <p:spPr>
+          <a:xfrm>
+            <a:off x="731520" y="3200400"/>
+            <a:ext cx="10058400" cy="548640"/>
+          </a:xfrm>
+          <a:prstGeom prst="rect">
+            <a:avLst/>
+          </a:prstGeom>
+          <a:noFill/>
+        </p:spPr>
+        <p:txBody>
+          <a:bodyPr wrap="none">
+            <a:spAutoFit/>
+          </a:bodyPr>
+          <a:lstStyle/>
+          <a:p>
+            <a:pPr>
+              <a:defRPr sz="2200">
+                <a:solidFill>
+                  <a:srgbClr val="9CA3AF"/>
+                </a:solidFill>
+              </a:defRPr>
+            </a:pPr>
+            <a:r>
+              <a:t>Choose the right engine, configure your workspace, organize your work</a:t>
+            </a:r>
+          </a:p>
+        </p:txBody>
+      </p:sp>
+      <p:sp>
+        <p:nvSpPr>
+          <p:cNvPr id="6" name="Rounded Rectangle 5"/>
+          <p:cNvSpPr/>
+          <p:nvPr/>
+        </p:nvSpPr>
+        <p:spPr>
+          <a:xfrm>
+            <a:off x="731520" y="4023360"/>
+            <a:ext cx="1828800" cy="457200"/>
+          </a:xfrm>
+          <a:prstGeom prst="roundRect">
+            <a:avLst/>
+          </a:prstGeom>
+          <a:solidFill>
+            <a:srgbClr val="24354A"/>
+          </a:solidFill>
+          <a:ln w="12700">
+            <a:solidFill>
+              <a:srgbClr val="14B8A6"/>
+            </a:solidFill>
+          </a:ln>
+        </p:spPr>
+        <p:style>
+          <a:lnRef idx="1">
+            <a:schemeClr val="accent1"/>
+          </a:lnRef>
+          <a:fillRef idx="3">
+            <a:schemeClr val="accent1"/>
+          </a:fillRef>
+          <a:effectRef idx="2">
+            <a:schemeClr val="accent1"/>
+          </a:effectRef>
+          <a:fontRef idx="minor">
+            <a:schemeClr val="lt1"/>
+          </a:fontRef>
+        </p:style>
+        <p:txBody>
+          <a:bodyPr rtlCol="0" anchor="ctr"/>
+          <a:lstStyle/>
+          <a:p>
+            <a:pPr algn="ctr">
+              <a:defRPr sz="1400" b="1">
+                <a:solidFill>
+                  <a:srgbClr val="14B8A6"/>
+                </a:solidFill>
+              </a:defRPr>
+            </a:pPr>
+            <a:r>
+              <a:t>1 hour 30 min</a:t>
+            </a:r>
+          </a:p>
+        </p:txBody>
+      </p:sp>
+    </p:spTree>
+  </p:cSld>
+  <p:clrMapOvr>
+    <a:masterClrMapping/>
+  </p:clrMapOvr>
+</p:sld>
+</file>
+
+<file path=ppt/slides/slide84.xml><?xml version="1.0" encoding="utf-8"?>
+<p:sld xmlns:a="http://schemas.openxmlformats.org/drawingml/2006/main" xmlns:p="http://schemas.openxmlformats.org/presentationml/2006/main" xmlns:r="http://schemas.openxmlformats.org/officeDocument/2006/relationships">
+  <p:cSld>
+    <p:bg>
+      <p:bgPr>
+        <a:solidFill>
+          <a:srgbClr val="1F2D3D"/>
+        </a:solidFill>
+        <a:effectLst/>
+      </p:bgPr>
+    </p:bg>
+    <p:spTree>
+      <p:nvGrpSpPr>
+        <p:cNvPr id="1" name=""/>
+        <p:cNvGrpSpPr/>
+        <p:nvPr/>
+      </p:nvGrpSpPr>
+      <p:grpSpPr/>
+      <p:sp>
+        <p:nvSpPr>
+          <p:cNvPr id="2" name="Rectangle 1"/>
+          <p:cNvSpPr/>
+          <p:nvPr/>
+        </p:nvSpPr>
+        <p:spPr>
+          <a:xfrm>
+            <a:off x="365760" y="1371600"/>
+            <a:ext cx="73152" cy="2743200"/>
+          </a:xfrm>
+          <a:prstGeom prst="rect">
+            <a:avLst/>
+          </a:prstGeom>
+          <a:solidFill>
+            <a:srgbClr val="14B8A6"/>
+          </a:solidFill>
+          <a:ln>
+            <a:noFill/>
+          </a:ln>
+        </p:spPr>
+        <p:style>
+          <a:lnRef idx="1">
+            <a:schemeClr val="accent1"/>
+          </a:lnRef>
+          <a:fillRef idx="3">
+            <a:schemeClr val="accent1"/>
+          </a:fillRef>
+          <a:effectRef idx="2">
+            <a:schemeClr val="accent1"/>
+          </a:effectRef>
+          <a:fontRef idx="minor">
+            <a:schemeClr val="lt1"/>
+          </a:fontRef>
+        </p:style>
+        <p:txBody>
+          <a:bodyPr rtlCol="0" anchor="ctr"/>
+          <a:lstStyle/>
+          <a:p>
+            <a:pPr algn="ctr"/>
+          </a:p>
+        </p:txBody>
+      </p:sp>
+      <p:sp>
+        <p:nvSpPr>
+          <p:cNvPr id="3" name="TextBox 2"/>
+          <p:cNvSpPr txBox="1"/>
+          <p:nvPr/>
+        </p:nvSpPr>
+        <p:spPr>
+          <a:xfrm>
+            <a:off x="731520" y="1371600"/>
+            <a:ext cx="2743200" cy="548640"/>
+          </a:xfrm>
+          <a:prstGeom prst="rect">
+            <a:avLst/>
+          </a:prstGeom>
+          <a:noFill/>
+        </p:spPr>
+        <p:txBody>
+          <a:bodyPr wrap="none">
+            <a:spAutoFit/>
+          </a:bodyPr>
+          <a:lstStyle/>
+          <a:p>
+            <a:pPr>
+              <a:defRPr sz="1600" b="1">
+                <a:solidFill>
+                  <a:srgbClr val="14B8A6"/>
+                </a:solidFill>
+              </a:defRPr>
+            </a:pPr>
+            <a:r>
+              <a:t>SECTION 3</a:t>
+            </a:r>
+          </a:p>
+        </p:txBody>
+      </p:sp>
+      <p:sp>
+        <p:nvSpPr>
+          <p:cNvPr id="4" name="TextBox 3"/>
+          <p:cNvSpPr txBox="1"/>
+          <p:nvPr/>
+        </p:nvSpPr>
+        <p:spPr>
+          <a:xfrm>
+            <a:off x="731520" y="2011680"/>
+            <a:ext cx="10058400" cy="1097280"/>
+          </a:xfrm>
+          <a:prstGeom prst="rect">
+            <a:avLst/>
+          </a:prstGeom>
+          <a:noFill/>
+        </p:spPr>
+        <p:txBody>
+          <a:bodyPr wrap="none">
+            <a:spAutoFit/>
+          </a:bodyPr>
+          <a:lstStyle/>
+          <a:p>
+            <a:pPr>
+              <a:defRPr sz="5600" b="1">
+                <a:solidFill>
+                  <a:srgbClr val="FFFFFF"/>
+                </a:solidFill>
+              </a:defRPr>
+            </a:pPr>
+            <a:r>
+              <a:t>Analysis Prompts</a:t>
+            </a:r>
+            <a:br/>
+            <a:r>
+              <a:t>&amp; Claude in Excel</a:t>
+            </a:r>
+          </a:p>
+        </p:txBody>
+      </p:sp>
+      <p:sp>
+        <p:nvSpPr>
+          <p:cNvPr id="5" name="TextBox 4"/>
+          <p:cNvSpPr txBox="1"/>
+          <p:nvPr/>
+        </p:nvSpPr>
+        <p:spPr>
+          <a:xfrm>
+            <a:off x="731520" y="3200400"/>
+            <a:ext cx="10058400" cy="548640"/>
+          </a:xfrm>
+          <a:prstGeom prst="rect">
+            <a:avLst/>
+          </a:prstGeom>
+          <a:noFill/>
+        </p:spPr>
+        <p:txBody>
+          <a:bodyPr wrap="none">
+            <a:spAutoFit/>
+          </a:bodyPr>
+          <a:lstStyle/>
+          <a:p>
+            <a:pPr>
+              <a:defRPr sz="2200">
+                <a:solidFill>
+                  <a:srgbClr val="9CA3AF"/>
+                </a:solidFill>
+              </a:defRPr>
+            </a:pPr>
+            <a:r>
+              <a:t>Turn data into decisions — in the browser and in your spreadsheets</a:t>
+            </a:r>
+          </a:p>
+        </p:txBody>
+      </p:sp>
+      <p:sp>
+        <p:nvSpPr>
+          <p:cNvPr id="6" name="Rounded Rectangle 5"/>
+          <p:cNvSpPr/>
+          <p:nvPr/>
+        </p:nvSpPr>
+        <p:spPr>
+          <a:xfrm>
+            <a:off x="731520" y="4023360"/>
+            <a:ext cx="1828800" cy="457200"/>
+          </a:xfrm>
+          <a:prstGeom prst="roundRect">
+            <a:avLst/>
+          </a:prstGeom>
+          <a:solidFill>
+            <a:srgbClr val="24354A"/>
+          </a:solidFill>
+          <a:ln w="12700">
+            <a:solidFill>
+              <a:srgbClr val="14B8A6"/>
+            </a:solidFill>
+          </a:ln>
+        </p:spPr>
+        <p:style>
+          <a:lnRef idx="1">
+            <a:schemeClr val="accent1"/>
+          </a:lnRef>
+          <a:fillRef idx="3">
+            <a:schemeClr val="accent1"/>
+          </a:fillRef>
+          <a:effectRef idx="2">
+            <a:schemeClr val="accent1"/>
+          </a:effectRef>
+          <a:fontRef idx="minor">
+            <a:schemeClr val="lt1"/>
+          </a:fontRef>
+        </p:style>
+        <p:txBody>
+          <a:bodyPr rtlCol="0" anchor="ctr"/>
+          <a:lstStyle/>
+          <a:p>
+            <a:pPr algn="ctr">
+              <a:defRPr sz="1400" b="1">
+                <a:solidFill>
+                  <a:srgbClr val="14B8A6"/>
+                </a:solidFill>
+              </a:defRPr>
+            </a:pPr>
+            <a:r>
+              <a:t>1 hour 15 min</a:t>
+            </a:r>
+          </a:p>
+        </p:txBody>
+      </p:sp>
+    </p:spTree>
+  </p:cSld>
+  <p:clrMapOvr>
+    <a:masterClrMapping/>
+  </p:clrMapOvr>
+</p:sld>
+</file>
+
+<file path=ppt/slides/slide85.xml><?xml version="1.0" encoding="utf-8"?>
+<p:sld xmlns:a="http://schemas.openxmlformats.org/drawingml/2006/main" xmlns:p="http://schemas.openxmlformats.org/presentationml/2006/main" xmlns:r="http://schemas.openxmlformats.org/officeDocument/2006/relationships">
+  <p:cSld>
+    <p:bg>
+      <p:bgPr>
+        <a:solidFill>
+          <a:srgbClr val="1F2D3D"/>
+        </a:solidFill>
+        <a:effectLst/>
+      </p:bgPr>
+    </p:bg>
+    <p:spTree>
+      <p:nvGrpSpPr>
+        <p:cNvPr id="1" name=""/>
+        <p:cNvGrpSpPr/>
+        <p:nvPr/>
+      </p:nvGrpSpPr>
+      <p:grpSpPr/>
+      <p:sp>
+        <p:nvSpPr>
+          <p:cNvPr id="2" name="Rectangle 1"/>
+          <p:cNvSpPr/>
+          <p:nvPr/>
+        </p:nvSpPr>
+        <p:spPr>
+          <a:xfrm>
+            <a:off x="365760" y="1371600"/>
+            <a:ext cx="73152" cy="2743200"/>
+          </a:xfrm>
+          <a:prstGeom prst="rect">
+            <a:avLst/>
+          </a:prstGeom>
+          <a:solidFill>
+            <a:srgbClr val="14B8A6"/>
+          </a:solidFill>
+          <a:ln>
+            <a:noFill/>
+          </a:ln>
+        </p:spPr>
+        <p:style>
+          <a:lnRef idx="1">
+            <a:schemeClr val="accent1"/>
+          </a:lnRef>
+          <a:fillRef idx="3">
+            <a:schemeClr val="accent1"/>
+          </a:fillRef>
+          <a:effectRef idx="2">
+            <a:schemeClr val="accent1"/>
+          </a:effectRef>
+          <a:fontRef idx="minor">
+            <a:schemeClr val="lt1"/>
+          </a:fontRef>
+        </p:style>
+        <p:txBody>
+          <a:bodyPr rtlCol="0" anchor="ctr"/>
+          <a:lstStyle/>
+          <a:p>
+            <a:pPr algn="ctr"/>
+          </a:p>
+        </p:txBody>
+      </p:sp>
+      <p:sp>
+        <p:nvSpPr>
+          <p:cNvPr id="3" name="TextBox 2"/>
+          <p:cNvSpPr txBox="1"/>
+          <p:nvPr/>
+        </p:nvSpPr>
+        <p:spPr>
+          <a:xfrm>
+            <a:off x="731520" y="1371600"/>
+            <a:ext cx="2743200" cy="548640"/>
+          </a:xfrm>
+          <a:prstGeom prst="rect">
+            <a:avLst/>
+          </a:prstGeom>
+          <a:noFill/>
+        </p:spPr>
+        <p:txBody>
+          <a:bodyPr wrap="none">
+            <a:spAutoFit/>
+          </a:bodyPr>
+          <a:lstStyle/>
+          <a:p>
+            <a:pPr>
+              <a:defRPr sz="1600" b="1">
+                <a:solidFill>
+                  <a:srgbClr val="14B8A6"/>
+                </a:solidFill>
+              </a:defRPr>
+            </a:pPr>
+            <a:r>
+              <a:t>SECTION 4</a:t>
+            </a:r>
+          </a:p>
+        </p:txBody>
+      </p:sp>
+      <p:sp>
+        <p:nvSpPr>
+          <p:cNvPr id="4" name="TextBox 3"/>
+          <p:cNvSpPr txBox="1"/>
+          <p:nvPr/>
+        </p:nvSpPr>
+        <p:spPr>
+          <a:xfrm>
+            <a:off x="731520" y="2011680"/>
+            <a:ext cx="10058400" cy="1097280"/>
+          </a:xfrm>
+          <a:prstGeom prst="rect">
+            <a:avLst/>
+          </a:prstGeom>
+          <a:noFill/>
+        </p:spPr>
+        <p:txBody>
+          <a:bodyPr wrap="none">
+            <a:spAutoFit/>
+          </a:bodyPr>
+          <a:lstStyle/>
+          <a:p>
+            <a:pPr>
+              <a:defRPr sz="5600" b="1">
+                <a:solidFill>
+                  <a:srgbClr val="FFFFFF"/>
+                </a:solidFill>
+              </a:defRPr>
+            </a:pPr>
+            <a:r>
+              <a:t>Artifacts, Files</a:t>
+            </a:r>
+            <a:br/>
+            <a:r>
+              <a:t>&amp; Integrations</a:t>
+            </a:r>
+          </a:p>
+        </p:txBody>
+      </p:sp>
+      <p:sp>
+        <p:nvSpPr>
+          <p:cNvPr id="5" name="TextBox 4"/>
+          <p:cNvSpPr txBox="1"/>
+          <p:nvPr/>
+        </p:nvSpPr>
+        <p:spPr>
+          <a:xfrm>
+            <a:off x="731520" y="3200400"/>
+            <a:ext cx="10058400" cy="548640"/>
+          </a:xfrm>
+          <a:prstGeom prst="rect">
+            <a:avLst/>
+          </a:prstGeom>
+          <a:noFill/>
+        </p:spPr>
+        <p:txBody>
+          <a:bodyPr wrap="none">
+            <a:spAutoFit/>
+          </a:bodyPr>
+          <a:lstStyle/>
+          <a:p>
+            <a:pPr>
+              <a:defRPr sz="2200">
+                <a:solidFill>
+                  <a:srgbClr val="9CA3AF"/>
+                </a:solidFill>
+              </a:defRPr>
+            </a:pPr>
+            <a:r>
+              <a:t>Create deliverables, work with files, and connect your tools</a:t>
+            </a:r>
+          </a:p>
+        </p:txBody>
+      </p:sp>
+      <p:sp>
+        <p:nvSpPr>
+          <p:cNvPr id="6" name="Rounded Rectangle 5"/>
+          <p:cNvSpPr/>
+          <p:nvPr/>
+        </p:nvSpPr>
+        <p:spPr>
+          <a:xfrm>
+            <a:off x="731520" y="4023360"/>
+            <a:ext cx="1828800" cy="457200"/>
+          </a:xfrm>
+          <a:prstGeom prst="roundRect">
+            <a:avLst/>
+          </a:prstGeom>
+          <a:solidFill>
+            <a:srgbClr val="24354A"/>
+          </a:solidFill>
+          <a:ln w="12700">
+            <a:solidFill>
+              <a:srgbClr val="14B8A6"/>
+            </a:solidFill>
+          </a:ln>
+        </p:spPr>
+        <p:style>
+          <a:lnRef idx="1">
+            <a:schemeClr val="accent1"/>
+          </a:lnRef>
+          <a:fillRef idx="3">
+            <a:schemeClr val="accent1"/>
+          </a:fillRef>
+          <a:effectRef idx="2">
+            <a:schemeClr val="accent1"/>
+          </a:effectRef>
+          <a:fontRef idx="minor">
+            <a:schemeClr val="lt1"/>
+          </a:fontRef>
+        </p:style>
+        <p:txBody>
+          <a:bodyPr rtlCol="0" anchor="ctr"/>
+          <a:lstStyle/>
+          <a:p>
+            <a:pPr algn="ctr">
+              <a:defRPr sz="1400" b="1">
+                <a:solidFill>
+                  <a:srgbClr val="14B8A6"/>
+                </a:solidFill>
+              </a:defRPr>
+            </a:pPr>
+            <a:r>
+              <a:t>1 hour 30 min</a:t>
             </a:r>
           </a:p>
         </p:txBody>

</xml_diff>

<commit_message>
Fix: Section dividers — remove duration badges, fix subtitle overlap
</commit_message>
<xml_diff>
--- a/slides/Day1_Claude_for_Business.pptx
+++ b/slides/Day1_Claude_for_Business.pptx
@@ -21230,7 +21230,7 @@
         </p:nvSpPr>
         <p:spPr>
           <a:xfrm>
-            <a:off x="731520" y="3200400"/>
+            <a:off x="731520" y="3840480"/>
             <a:ext cx="10058400" cy="548640"/>
           </a:xfrm>
           <a:prstGeom prst="rect">
@@ -21253,60 +21253,6 @@
             </a:pPr>
             <a:r>
               <a:t>Choose the right engine, configure your workspace, organize your work</a:t>
-            </a:r>
-          </a:p>
-        </p:txBody>
-      </p:sp>
-      <p:sp>
-        <p:nvSpPr>
-          <p:cNvPr id="6" name="Rounded Rectangle 5"/>
-          <p:cNvSpPr/>
-          <p:nvPr/>
-        </p:nvSpPr>
-        <p:spPr>
-          <a:xfrm>
-            <a:off x="731520" y="4023360"/>
-            <a:ext cx="1828800" cy="457200"/>
-          </a:xfrm>
-          <a:prstGeom prst="roundRect">
-            <a:avLst/>
-          </a:prstGeom>
-          <a:solidFill>
-            <a:srgbClr val="24354A"/>
-          </a:solidFill>
-          <a:ln w="12700">
-            <a:solidFill>
-              <a:srgbClr val="14B8A6"/>
-            </a:solidFill>
-          </a:ln>
-        </p:spPr>
-        <p:style>
-          <a:lnRef idx="1">
-            <a:schemeClr val="accent1"/>
-          </a:lnRef>
-          <a:fillRef idx="3">
-            <a:schemeClr val="accent1"/>
-          </a:fillRef>
-          <a:effectRef idx="2">
-            <a:schemeClr val="accent1"/>
-          </a:effectRef>
-          <a:fontRef idx="minor">
-            <a:schemeClr val="lt1"/>
-          </a:fontRef>
-        </p:style>
-        <p:txBody>
-          <a:bodyPr rtlCol="0" anchor="ctr"/>
-          <a:lstStyle/>
-          <a:p>
-            <a:pPr algn="ctr">
-              <a:defRPr sz="1400" b="1">
-                <a:solidFill>
-                  <a:srgbClr val="14B8A6"/>
-                </a:solidFill>
-              </a:defRPr>
-            </a:pPr>
-            <a:r>
-              <a:t>1 hour 30 min</a:t>
             </a:r>
           </a:p>
         </p:txBody>
@@ -30029,7 +29975,7 @@
         </p:nvSpPr>
         <p:spPr>
           <a:xfrm>
-            <a:off x="731520" y="3200400"/>
+            <a:off x="731520" y="3840480"/>
             <a:ext cx="10058400" cy="548640"/>
           </a:xfrm>
           <a:prstGeom prst="rect">
@@ -30052,60 +29998,6 @@
             </a:pPr>
             <a:r>
               <a:t>Navigate the tool, then master the core skill</a:t>
-            </a:r>
-          </a:p>
-        </p:txBody>
-      </p:sp>
-      <p:sp>
-        <p:nvSpPr>
-          <p:cNvPr id="6" name="Rounded Rectangle 5"/>
-          <p:cNvSpPr/>
-          <p:nvPr/>
-        </p:nvSpPr>
-        <p:spPr>
-          <a:xfrm>
-            <a:off x="731520" y="4023360"/>
-            <a:ext cx="1828800" cy="457200"/>
-          </a:xfrm>
-          <a:prstGeom prst="roundRect">
-            <a:avLst/>
-          </a:prstGeom>
-          <a:solidFill>
-            <a:srgbClr val="24354A"/>
-          </a:solidFill>
-          <a:ln w="12700">
-            <a:solidFill>
-              <a:srgbClr val="14B8A6"/>
-            </a:solidFill>
-          </a:ln>
-        </p:spPr>
-        <p:style>
-          <a:lnRef idx="1">
-            <a:schemeClr val="accent1"/>
-          </a:lnRef>
-          <a:fillRef idx="3">
-            <a:schemeClr val="accent1"/>
-          </a:fillRef>
-          <a:effectRef idx="2">
-            <a:schemeClr val="accent1"/>
-          </a:effectRef>
-          <a:fontRef idx="minor">
-            <a:schemeClr val="lt1"/>
-          </a:fontRef>
-        </p:style>
-        <p:txBody>
-          <a:bodyPr rtlCol="0" anchor="ctr"/>
-          <a:lstStyle/>
-          <a:p>
-            <a:pPr algn="ctr">
-              <a:defRPr sz="1400" b="1">
-                <a:solidFill>
-                  <a:srgbClr val="14B8A6"/>
-                </a:solidFill>
-              </a:defRPr>
-            </a:pPr>
-            <a:r>
-              <a:t>2 hours 30 min</a:t>
             </a:r>
           </a:p>
         </p:txBody>
@@ -32594,7 +32486,7 @@
         </p:nvSpPr>
         <p:spPr>
           <a:xfrm>
-            <a:off x="731520" y="3200400"/>
+            <a:off x="731520" y="3840480"/>
             <a:ext cx="10058400" cy="548640"/>
           </a:xfrm>
           <a:prstGeom prst="rect">
@@ -32617,60 +32509,6 @@
             </a:pPr>
             <a:r>
               <a:t>Turn data into decisions — in the browser and in your spreadsheets</a:t>
-            </a:r>
-          </a:p>
-        </p:txBody>
-      </p:sp>
-      <p:sp>
-        <p:nvSpPr>
-          <p:cNvPr id="6" name="Rounded Rectangle 5"/>
-          <p:cNvSpPr/>
-          <p:nvPr/>
-        </p:nvSpPr>
-        <p:spPr>
-          <a:xfrm>
-            <a:off x="731520" y="4023360"/>
-            <a:ext cx="1828800" cy="457200"/>
-          </a:xfrm>
-          <a:prstGeom prst="roundRect">
-            <a:avLst/>
-          </a:prstGeom>
-          <a:solidFill>
-            <a:srgbClr val="24354A"/>
-          </a:solidFill>
-          <a:ln w="12700">
-            <a:solidFill>
-              <a:srgbClr val="14B8A6"/>
-            </a:solidFill>
-          </a:ln>
-        </p:spPr>
-        <p:style>
-          <a:lnRef idx="1">
-            <a:schemeClr val="accent1"/>
-          </a:lnRef>
-          <a:fillRef idx="3">
-            <a:schemeClr val="accent1"/>
-          </a:fillRef>
-          <a:effectRef idx="2">
-            <a:schemeClr val="accent1"/>
-          </a:effectRef>
-          <a:fontRef idx="minor">
-            <a:schemeClr val="lt1"/>
-          </a:fontRef>
-        </p:style>
-        <p:txBody>
-          <a:bodyPr rtlCol="0" anchor="ctr"/>
-          <a:lstStyle/>
-          <a:p>
-            <a:pPr algn="ctr">
-              <a:defRPr sz="1400" b="1">
-                <a:solidFill>
-                  <a:srgbClr val="14B8A6"/>
-                </a:solidFill>
-              </a:defRPr>
-            </a:pPr>
-            <a:r>
-              <a:t>1 hour 15 min</a:t>
             </a:r>
           </a:p>
         </p:txBody>
@@ -39240,7 +39078,7 @@
         </p:nvSpPr>
         <p:spPr>
           <a:xfrm>
-            <a:off x="731520" y="3200400"/>
+            <a:off x="731520" y="3840480"/>
             <a:ext cx="10058400" cy="548640"/>
           </a:xfrm>
           <a:prstGeom prst="rect">
@@ -39263,60 +39101,6 @@
             </a:pPr>
             <a:r>
               <a:t>Create deliverables, work with files, and connect your tools</a:t>
-            </a:r>
-          </a:p>
-        </p:txBody>
-      </p:sp>
-      <p:sp>
-        <p:nvSpPr>
-          <p:cNvPr id="6" name="Rounded Rectangle 5"/>
-          <p:cNvSpPr/>
-          <p:nvPr/>
-        </p:nvSpPr>
-        <p:spPr>
-          <a:xfrm>
-            <a:off x="731520" y="4023360"/>
-            <a:ext cx="1828800" cy="457200"/>
-          </a:xfrm>
-          <a:prstGeom prst="roundRect">
-            <a:avLst/>
-          </a:prstGeom>
-          <a:solidFill>
-            <a:srgbClr val="24354A"/>
-          </a:solidFill>
-          <a:ln w="12700">
-            <a:solidFill>
-              <a:srgbClr val="14B8A6"/>
-            </a:solidFill>
-          </a:ln>
-        </p:spPr>
-        <p:style>
-          <a:lnRef idx="1">
-            <a:schemeClr val="accent1"/>
-          </a:lnRef>
-          <a:fillRef idx="3">
-            <a:schemeClr val="accent1"/>
-          </a:fillRef>
-          <a:effectRef idx="2">
-            <a:schemeClr val="accent1"/>
-          </a:effectRef>
-          <a:fontRef idx="minor">
-            <a:schemeClr val="lt1"/>
-          </a:fontRef>
-        </p:style>
-        <p:txBody>
-          <a:bodyPr rtlCol="0" anchor="ctr"/>
-          <a:lstStyle/>
-          <a:p>
-            <a:pPr algn="ctr">
-              <a:defRPr sz="1400" b="1">
-                <a:solidFill>
-                  <a:srgbClr val="14B8A6"/>
-                </a:solidFill>
-              </a:defRPr>
-            </a:pPr>
-            <a:r>
-              <a:t>1 hour 30 min</a:t>
             </a:r>
           </a:p>
         </p:txBody>

</xml_diff>

<commit_message>
Day 1: Add 'Claude in PowerPoint' slide in Integrations section
Research Preview (Feb 5, 2026) for Max/Team/Enterprise users.
Three capabilities: Build & Design, Edit & Refine, Analyze & Advise.
Powered by Opus 4.6. Bottom callout: Excel + PowerPoint + Google Docs.
86 slides total.
</commit_message>
<xml_diff>
--- a/slides/Day1_Claude_for_Business.pptx
+++ b/slides/Day1_Claude_for_Business.pptx
@@ -82,6 +82,7 @@
     <p:sldId id="321" r:id="rId69"/>
     <p:sldId id="322" r:id="rId70"/>
     <p:sldId id="323" r:id="rId71"/>
+    <p:sldId id="350" r:id="rId94"/>
     <p:sldId id="325" r:id="rId72"/>
     <p:sldId id="326" r:id="rId73"/>
     <p:sldId id="327" r:id="rId74"/>
@@ -48940,6 +48941,668 @@
 </p:sld>
 </file>
 
+<file path=ppt/slides/slide86.xml><?xml version="1.0" encoding="utf-8"?>
+<p:sld xmlns:a="http://schemas.openxmlformats.org/drawingml/2006/main" xmlns:p="http://schemas.openxmlformats.org/presentationml/2006/main" xmlns:r="http://schemas.openxmlformats.org/officeDocument/2006/relationships">
+  <p:cSld>
+    <p:bg>
+      <p:bgPr>
+        <a:solidFill>
+          <a:srgbClr val="0B0F1A"/>
+        </a:solidFill>
+        <a:effectLst/>
+      </p:bgPr>
+    </p:bg>
+    <p:spTree>
+      <p:nvGrpSpPr>
+        <p:cNvPr id="1" name=""/>
+        <p:cNvGrpSpPr/>
+        <p:nvPr/>
+      </p:nvGrpSpPr>
+      <p:grpSpPr/>
+      <p:sp>
+        <p:nvSpPr>
+          <p:cNvPr id="2" name="TextBox 1"/>
+          <p:cNvSpPr txBox="1"/>
+          <p:nvPr/>
+        </p:nvSpPr>
+        <p:spPr>
+          <a:xfrm>
+            <a:off x="457200" y="274320"/>
+            <a:ext cx="11247120" cy="822960"/>
+          </a:xfrm>
+          <a:prstGeom prst="rect">
+            <a:avLst/>
+          </a:prstGeom>
+          <a:noFill/>
+        </p:spPr>
+        <p:txBody>
+          <a:bodyPr wrap="none">
+            <a:spAutoFit/>
+          </a:bodyPr>
+          <a:lstStyle/>
+          <a:p>
+            <a:pPr>
+              <a:defRPr sz="4000" b="1">
+                <a:solidFill>
+                  <a:srgbClr val="FFFFFF"/>
+                </a:solidFill>
+              </a:defRPr>
+            </a:pPr>
+            <a:r>
+              <a:t>Claude in PowerPoint</a:t>
+            </a:r>
+          </a:p>
+        </p:txBody>
+      </p:sp>
+      <p:sp>
+        <p:nvSpPr>
+          <p:cNvPr id="3" name="TextBox 2"/>
+          <p:cNvSpPr txBox="1"/>
+          <p:nvPr/>
+        </p:nvSpPr>
+        <p:spPr>
+          <a:xfrm>
+            <a:off x="457200" y="1005840"/>
+            <a:ext cx="11247120" cy="457200"/>
+          </a:xfrm>
+          <a:prstGeom prst="rect">
+            <a:avLst/>
+          </a:prstGeom>
+          <a:noFill/>
+        </p:spPr>
+        <p:txBody>
+          <a:bodyPr wrap="none">
+            <a:spAutoFit/>
+          </a:bodyPr>
+          <a:lstStyle/>
+          <a:p>
+            <a:pPr>
+              <a:defRPr sz="1800" i="1">
+                <a:solidFill>
+                  <a:srgbClr val="14B8A6"/>
+                </a:solidFill>
+              </a:defRPr>
+            </a:pPr>
+            <a:r>
+              <a:t>Research Preview  •  Available for Max, Team, and Enterprise</a:t>
+            </a:r>
+          </a:p>
+        </p:txBody>
+      </p:sp>
+      <p:sp>
+        <p:nvSpPr>
+          <p:cNvPr id="4" name="Rounded Rectangle 3"/>
+          <p:cNvSpPr/>
+          <p:nvPr/>
+        </p:nvSpPr>
+        <p:spPr>
+          <a:xfrm>
+            <a:off x="457200" y="1737360"/>
+            <a:ext cx="3474720" cy="3200400"/>
+          </a:xfrm>
+          <a:prstGeom prst="roundRect">
+            <a:avLst/>
+          </a:prstGeom>
+          <a:solidFill>
+            <a:srgbClr val="141A2A"/>
+          </a:solidFill>
+          <a:ln w="19050">
+            <a:solidFill>
+              <a:srgbClr val="14B8A6"/>
+            </a:solidFill>
+          </a:ln>
+        </p:spPr>
+        <p:style>
+          <a:lnRef idx="1">
+            <a:schemeClr val="accent1"/>
+          </a:lnRef>
+          <a:fillRef idx="3">
+            <a:schemeClr val="accent1"/>
+          </a:fillRef>
+          <a:effectRef idx="2">
+            <a:schemeClr val="accent1"/>
+          </a:effectRef>
+          <a:fontRef idx="minor">
+            <a:schemeClr val="lt1"/>
+          </a:fontRef>
+        </p:style>
+        <p:txBody>
+          <a:bodyPr rtlCol="0" anchor="ctr"/>
+          <a:lstStyle/>
+          <a:p>
+            <a:pPr algn="ctr"/>
+          </a:p>
+        </p:txBody>
+      </p:sp>
+      <p:sp>
+        <p:nvSpPr>
+          <p:cNvPr id="5" name="TextBox 4"/>
+          <p:cNvSpPr txBox="1"/>
+          <p:nvPr/>
+        </p:nvSpPr>
+        <p:spPr>
+          <a:xfrm>
+            <a:off x="640080" y="1920240"/>
+            <a:ext cx="3108960" cy="457200"/>
+          </a:xfrm>
+          <a:prstGeom prst="rect">
+            <a:avLst/>
+          </a:prstGeom>
+          <a:noFill/>
+        </p:spPr>
+        <p:txBody>
+          <a:bodyPr wrap="none">
+            <a:spAutoFit/>
+          </a:bodyPr>
+          <a:lstStyle/>
+          <a:p>
+            <a:pPr algn="ctr">
+              <a:defRPr sz="3000"/>
+            </a:pPr>
+            <a:r>
+              <a:t>🎨</a:t>
+            </a:r>
+          </a:p>
+        </p:txBody>
+      </p:sp>
+      <p:sp>
+        <p:nvSpPr>
+          <p:cNvPr id="6" name="TextBox 5"/>
+          <p:cNvSpPr txBox="1"/>
+          <p:nvPr/>
+        </p:nvSpPr>
+        <p:spPr>
+          <a:xfrm>
+            <a:off x="640080" y="2377440"/>
+            <a:ext cx="3108960" cy="457200"/>
+          </a:xfrm>
+          <a:prstGeom prst="rect">
+            <a:avLst/>
+          </a:prstGeom>
+          <a:noFill/>
+        </p:spPr>
+        <p:txBody>
+          <a:bodyPr wrap="none">
+            <a:spAutoFit/>
+          </a:bodyPr>
+          <a:lstStyle/>
+          <a:p>
+            <a:pPr algn="ctr">
+              <a:defRPr sz="2000" b="1">
+                <a:solidFill>
+                  <a:srgbClr val="FFFFFF"/>
+                </a:solidFill>
+              </a:defRPr>
+            </a:pPr>
+            <a:r>
+              <a:t>Build &amp; Design</a:t>
+            </a:r>
+          </a:p>
+        </p:txBody>
+      </p:sp>
+      <p:sp>
+        <p:nvSpPr>
+          <p:cNvPr id="7" name="TextBox 6"/>
+          <p:cNvSpPr txBox="1"/>
+          <p:nvPr/>
+        </p:nvSpPr>
+        <p:spPr>
+          <a:xfrm>
+            <a:off x="640080" y="2926080"/>
+            <a:ext cx="3108960" cy="1828800"/>
+          </a:xfrm>
+          <a:prstGeom prst="rect">
+            <a:avLst/>
+          </a:prstGeom>
+          <a:noFill/>
+        </p:spPr>
+        <p:txBody>
+          <a:bodyPr wrap="square">
+            <a:spAutoFit/>
+          </a:bodyPr>
+          <a:lstStyle/>
+          <a:p>
+            <a:pPr algn="ctr">
+              <a:defRPr sz="1400">
+                <a:solidFill>
+                  <a:srgbClr val="D1D5DB"/>
+                </a:solidFill>
+              </a:defRPr>
+            </a:pPr>
+            <a:r>
+              <a:t>Create new slides from</a:t>
+            </a:r>
+            <a:br/>
+            <a:r>
+              <a:t>a prompt or outline</a:t>
+            </a:r>
+            <a:br/>
+            <a:r>
+              <a:t>Apply consistent branding</a:t>
+            </a:r>
+            <a:br/>
+            <a:r>
+              <a:t>Redesign existing decks</a:t>
+            </a:r>
+            <a:br/>
+            <a:r>
+              <a:t>Powered by Opus 4.6</a:t>
+            </a:r>
+          </a:p>
+        </p:txBody>
+      </p:sp>
+      <p:sp>
+        <p:nvSpPr>
+          <p:cNvPr id="8" name="Rounded Rectangle 7"/>
+          <p:cNvSpPr/>
+          <p:nvPr/>
+        </p:nvSpPr>
+        <p:spPr>
+          <a:xfrm>
+            <a:off x="4206240" y="1737360"/>
+            <a:ext cx="3474720" cy="3200400"/>
+          </a:xfrm>
+          <a:prstGeom prst="roundRect">
+            <a:avLst/>
+          </a:prstGeom>
+          <a:solidFill>
+            <a:srgbClr val="141A2A"/>
+          </a:solidFill>
+          <a:ln w="19050">
+            <a:solidFill>
+              <a:srgbClr val="14B8A6"/>
+            </a:solidFill>
+          </a:ln>
+        </p:spPr>
+        <p:style>
+          <a:lnRef idx="1">
+            <a:schemeClr val="accent1"/>
+          </a:lnRef>
+          <a:fillRef idx="3">
+            <a:schemeClr val="accent1"/>
+          </a:fillRef>
+          <a:effectRef idx="2">
+            <a:schemeClr val="accent1"/>
+          </a:effectRef>
+          <a:fontRef idx="minor">
+            <a:schemeClr val="lt1"/>
+          </a:fontRef>
+        </p:style>
+        <p:txBody>
+          <a:bodyPr rtlCol="0" anchor="ctr"/>
+          <a:lstStyle/>
+          <a:p>
+            <a:pPr algn="ctr"/>
+          </a:p>
+        </p:txBody>
+      </p:sp>
+      <p:sp>
+        <p:nvSpPr>
+          <p:cNvPr id="9" name="TextBox 8"/>
+          <p:cNvSpPr txBox="1"/>
+          <p:nvPr/>
+        </p:nvSpPr>
+        <p:spPr>
+          <a:xfrm>
+            <a:off x="4389120" y="1920240"/>
+            <a:ext cx="3108960" cy="457200"/>
+          </a:xfrm>
+          <a:prstGeom prst="rect">
+            <a:avLst/>
+          </a:prstGeom>
+          <a:noFill/>
+        </p:spPr>
+        <p:txBody>
+          <a:bodyPr wrap="none">
+            <a:spAutoFit/>
+          </a:bodyPr>
+          <a:lstStyle/>
+          <a:p>
+            <a:pPr algn="ctr">
+              <a:defRPr sz="3000"/>
+            </a:pPr>
+            <a:r>
+              <a:t>📝</a:t>
+            </a:r>
+          </a:p>
+        </p:txBody>
+      </p:sp>
+      <p:sp>
+        <p:nvSpPr>
+          <p:cNvPr id="10" name="TextBox 9"/>
+          <p:cNvSpPr txBox="1"/>
+          <p:nvPr/>
+        </p:nvSpPr>
+        <p:spPr>
+          <a:xfrm>
+            <a:off x="4389120" y="2377440"/>
+            <a:ext cx="3108960" cy="457200"/>
+          </a:xfrm>
+          <a:prstGeom prst="rect">
+            <a:avLst/>
+          </a:prstGeom>
+          <a:noFill/>
+        </p:spPr>
+        <p:txBody>
+          <a:bodyPr wrap="none">
+            <a:spAutoFit/>
+          </a:bodyPr>
+          <a:lstStyle/>
+          <a:p>
+            <a:pPr algn="ctr">
+              <a:defRPr sz="2000" b="1">
+                <a:solidFill>
+                  <a:srgbClr val="FFFFFF"/>
+                </a:solidFill>
+              </a:defRPr>
+            </a:pPr>
+            <a:r>
+              <a:t>Edit &amp; Refine</a:t>
+            </a:r>
+          </a:p>
+        </p:txBody>
+      </p:sp>
+      <p:sp>
+        <p:nvSpPr>
+          <p:cNvPr id="11" name="TextBox 10"/>
+          <p:cNvSpPr txBox="1"/>
+          <p:nvPr/>
+        </p:nvSpPr>
+        <p:spPr>
+          <a:xfrm>
+            <a:off x="4389120" y="2926080"/>
+            <a:ext cx="3108960" cy="1828800"/>
+          </a:xfrm>
+          <a:prstGeom prst="rect">
+            <a:avLst/>
+          </a:prstGeom>
+          <a:noFill/>
+        </p:spPr>
+        <p:txBody>
+          <a:bodyPr wrap="square">
+            <a:spAutoFit/>
+          </a:bodyPr>
+          <a:lstStyle/>
+          <a:p>
+            <a:pPr algn="ctr">
+              <a:defRPr sz="1400">
+                <a:solidFill>
+                  <a:srgbClr val="D1D5DB"/>
+                </a:solidFill>
+              </a:defRPr>
+            </a:pPr>
+            <a:r>
+              <a:t>Rewrite slide content</a:t>
+            </a:r>
+            <a:br/>
+            <a:r>
+              <a:t>Fix formatting issues</a:t>
+            </a:r>
+            <a:br/>
+            <a:r>
+              <a:t>Improve data visualizations</a:t>
+            </a:r>
+            <a:br/>
+            <a:r>
+              <a:t>Condense or expand sections</a:t>
+            </a:r>
+            <a:br/>
+            <a:r>
+              <a:t>Maintain brand guidelines</a:t>
+            </a:r>
+          </a:p>
+        </p:txBody>
+      </p:sp>
+      <p:sp>
+        <p:nvSpPr>
+          <p:cNvPr id="12" name="Rounded Rectangle 11"/>
+          <p:cNvSpPr/>
+          <p:nvPr/>
+        </p:nvSpPr>
+        <p:spPr>
+          <a:xfrm>
+            <a:off x="7955279" y="1737360"/>
+            <a:ext cx="3474720" cy="3200400"/>
+          </a:xfrm>
+          <a:prstGeom prst="roundRect">
+            <a:avLst/>
+          </a:prstGeom>
+          <a:solidFill>
+            <a:srgbClr val="141A2A"/>
+          </a:solidFill>
+          <a:ln w="19050">
+            <a:solidFill>
+              <a:srgbClr val="14B8A6"/>
+            </a:solidFill>
+          </a:ln>
+        </p:spPr>
+        <p:style>
+          <a:lnRef idx="1">
+            <a:schemeClr val="accent1"/>
+          </a:lnRef>
+          <a:fillRef idx="3">
+            <a:schemeClr val="accent1"/>
+          </a:fillRef>
+          <a:effectRef idx="2">
+            <a:schemeClr val="accent1"/>
+          </a:effectRef>
+          <a:fontRef idx="minor">
+            <a:schemeClr val="lt1"/>
+          </a:fontRef>
+        </p:style>
+        <p:txBody>
+          <a:bodyPr rtlCol="0" anchor="ctr"/>
+          <a:lstStyle/>
+          <a:p>
+            <a:pPr algn="ctr"/>
+          </a:p>
+        </p:txBody>
+      </p:sp>
+      <p:sp>
+        <p:nvSpPr>
+          <p:cNvPr id="13" name="TextBox 12"/>
+          <p:cNvSpPr txBox="1"/>
+          <p:nvPr/>
+        </p:nvSpPr>
+        <p:spPr>
+          <a:xfrm>
+            <a:off x="8138159" y="1920240"/>
+            <a:ext cx="3108960" cy="457200"/>
+          </a:xfrm>
+          <a:prstGeom prst="rect">
+            <a:avLst/>
+          </a:prstGeom>
+          <a:noFill/>
+        </p:spPr>
+        <p:txBody>
+          <a:bodyPr wrap="none">
+            <a:spAutoFit/>
+          </a:bodyPr>
+          <a:lstStyle/>
+          <a:p>
+            <a:pPr algn="ctr">
+              <a:defRPr sz="3000"/>
+            </a:pPr>
+            <a:r>
+              <a:t>💡</a:t>
+            </a:r>
+          </a:p>
+        </p:txBody>
+      </p:sp>
+      <p:sp>
+        <p:nvSpPr>
+          <p:cNvPr id="14" name="TextBox 13"/>
+          <p:cNvSpPr txBox="1"/>
+          <p:nvPr/>
+        </p:nvSpPr>
+        <p:spPr>
+          <a:xfrm>
+            <a:off x="8138159" y="2377440"/>
+            <a:ext cx="3108960" cy="457200"/>
+          </a:xfrm>
+          <a:prstGeom prst="rect">
+            <a:avLst/>
+          </a:prstGeom>
+          <a:noFill/>
+        </p:spPr>
+        <p:txBody>
+          <a:bodyPr wrap="none">
+            <a:spAutoFit/>
+          </a:bodyPr>
+          <a:lstStyle/>
+          <a:p>
+            <a:pPr algn="ctr">
+              <a:defRPr sz="2000" b="1">
+                <a:solidFill>
+                  <a:srgbClr val="FFFFFF"/>
+                </a:solidFill>
+              </a:defRPr>
+            </a:pPr>
+            <a:r>
+              <a:t>Analyze &amp; Advise</a:t>
+            </a:r>
+          </a:p>
+        </p:txBody>
+      </p:sp>
+      <p:sp>
+        <p:nvSpPr>
+          <p:cNvPr id="15" name="TextBox 14"/>
+          <p:cNvSpPr txBox="1"/>
+          <p:nvPr/>
+        </p:nvSpPr>
+        <p:spPr>
+          <a:xfrm>
+            <a:off x="8138159" y="2926080"/>
+            <a:ext cx="3108960" cy="1828800"/>
+          </a:xfrm>
+          <a:prstGeom prst="rect">
+            <a:avLst/>
+          </a:prstGeom>
+          <a:noFill/>
+        </p:spPr>
+        <p:txBody>
+          <a:bodyPr wrap="square">
+            <a:spAutoFit/>
+          </a:bodyPr>
+          <a:lstStyle/>
+          <a:p>
+            <a:pPr algn="ctr">
+              <a:defRPr sz="1400">
+                <a:solidFill>
+                  <a:srgbClr val="D1D5DB"/>
+                </a:solidFill>
+              </a:defRPr>
+            </a:pPr>
+            <a:r>
+              <a:t>Review your deck for</a:t>
+            </a:r>
+            <a:br/>
+            <a:r>
+              <a:t>clarity and flow</a:t>
+            </a:r>
+            <a:br/>
+            <a:r>
+              <a:t>Suggest better layouts</a:t>
+            </a:r>
+            <a:br/>
+            <a:r>
+              <a:t>Extract key messages</a:t>
+            </a:r>
+            <a:br/>
+            <a:r>
+              <a:t>Prepare speaker notes</a:t>
+            </a:r>
+          </a:p>
+        </p:txBody>
+      </p:sp>
+      <p:sp>
+        <p:nvSpPr>
+          <p:cNvPr id="16" name="Rounded Rectangle 15"/>
+          <p:cNvSpPr/>
+          <p:nvPr/>
+        </p:nvSpPr>
+        <p:spPr>
+          <a:xfrm>
+            <a:off x="457200" y="5212080"/>
+            <a:ext cx="11247120" cy="731520"/>
+          </a:xfrm>
+          <a:prstGeom prst="roundRect">
+            <a:avLst/>
+          </a:prstGeom>
+          <a:solidFill>
+            <a:srgbClr val="141A2A"/>
+          </a:solidFill>
+          <a:ln w="12700">
+            <a:solidFill>
+              <a:srgbClr val="14B8A6"/>
+            </a:solidFill>
+          </a:ln>
+        </p:spPr>
+        <p:style>
+          <a:lnRef idx="1">
+            <a:schemeClr val="accent1"/>
+          </a:lnRef>
+          <a:fillRef idx="3">
+            <a:schemeClr val="accent1"/>
+          </a:fillRef>
+          <a:effectRef idx="2">
+            <a:schemeClr val="accent1"/>
+          </a:effectRef>
+          <a:fontRef idx="minor">
+            <a:schemeClr val="lt1"/>
+          </a:fontRef>
+        </p:style>
+        <p:txBody>
+          <a:bodyPr rtlCol="0" anchor="ctr"/>
+          <a:lstStyle/>
+          <a:p>
+            <a:pPr algn="ctr"/>
+          </a:p>
+        </p:txBody>
+      </p:sp>
+      <p:sp>
+        <p:nvSpPr>
+          <p:cNvPr id="17" name="TextBox 16"/>
+          <p:cNvSpPr txBox="1"/>
+          <p:nvPr/>
+        </p:nvSpPr>
+        <p:spPr>
+          <a:xfrm>
+            <a:off x="731520" y="5303520"/>
+            <a:ext cx="10698480" cy="548640"/>
+          </a:xfrm>
+          <a:prstGeom prst="rect">
+            <a:avLst/>
+          </a:prstGeom>
+          <a:noFill/>
+        </p:spPr>
+        <p:txBody>
+          <a:bodyPr wrap="square">
+            <a:spAutoFit/>
+          </a:bodyPr>
+          <a:lstStyle/>
+          <a:p>
+            <a:pPr algn="ctr">
+              <a:defRPr sz="1500">
+                <a:solidFill>
+                  <a:srgbClr val="9CA3AF"/>
+                </a:solidFill>
+              </a:defRPr>
+            </a:pPr>
+            <a:r>
+              <a:t>Claude now integrates directly into Excel, PowerPoint, and Google Docs — your AI assistant lives inside the tools you already use</a:t>
+            </a:r>
+          </a:p>
+        </p:txBody>
+      </p:sp>
+    </p:spTree>
+  </p:cSld>
+  <p:clrMapOvr>
+    <a:masterClrMapping/>
+  </p:clrMapOvr>
+</p:sld>
+</file>
+
 <file path=ppt/slides/slide9.xml><?xml version="1.0" encoding="utf-8"?>
 <p:sld xmlns:a="http://schemas.openxmlformats.org/drawingml/2006/main" xmlns:r="http://schemas.openxmlformats.org/officeDocument/2006/relationships" xmlns:p="http://schemas.openxmlformats.org/presentationml/2006/main">
   <p:cSld>

</xml_diff>

<commit_message>
Day 1: Restore Thank You slide — 89 slides
</commit_message>
<xml_diff>
--- a/slides/Day1_Claude_for_Business.pptx
+++ b/slides/Day1_Claude_for_Business.pptx
@@ -96,6 +96,7 @@
     <p:sldId id="331" r:id="rId84"/>
     <p:sldId id="332" r:id="rId85"/>
     <p:sldId id="333" r:id="rId86"/>
+    <p:sldId id="355" r:id="rId99"/>
   </p:sldIdLst>
   <p:sldSz cx="12192000" cy="6858000"/>
   <p:notesSz cx="6858000" cy="9144000"/>
@@ -27802,6 +27803,635 @@
 </p:sld>
 </file>
 
+<file path=ppt/slides/slide35.xml><?xml version="1.0" encoding="utf-8"?>
+<p:sld xmlns:a="http://schemas.openxmlformats.org/drawingml/2006/main" xmlns:p="http://schemas.openxmlformats.org/presentationml/2006/main" xmlns:r="http://schemas.openxmlformats.org/officeDocument/2006/relationships">
+  <p:cSld>
+    <p:bg>
+      <p:bgPr>
+        <a:solidFill>
+          <a:srgbClr val="0B0F1A"/>
+        </a:solidFill>
+        <a:effectLst/>
+      </p:bgPr>
+    </p:bg>
+    <p:spTree>
+      <p:nvGrpSpPr>
+        <p:cNvPr id="1" name=""/>
+        <p:cNvGrpSpPr/>
+        <p:nvPr/>
+      </p:nvGrpSpPr>
+      <p:grpSpPr/>
+      <p:sp>
+        <p:nvSpPr>
+          <p:cNvPr id="2" name="TextBox 1"/>
+          <p:cNvSpPr txBox="1"/>
+          <p:nvPr/>
+        </p:nvSpPr>
+        <p:spPr>
+          <a:xfrm>
+            <a:off x="457200" y="274320"/>
+            <a:ext cx="11247120" cy="822960"/>
+          </a:xfrm>
+          <a:prstGeom prst="rect">
+            <a:avLst/>
+          </a:prstGeom>
+          <a:noFill/>
+        </p:spPr>
+        <p:txBody>
+          <a:bodyPr wrap="none">
+            <a:spAutoFit/>
+          </a:bodyPr>
+          <a:lstStyle/>
+          <a:p>
+            <a:pPr>
+              <a:defRPr sz="4000" b="1">
+                <a:solidFill>
+                  <a:srgbClr val="FFFFFF"/>
+                </a:solidFill>
+              </a:defRPr>
+            </a:pPr>
+            <a:r>
+              <a:t>Claude's Memory</a:t>
+            </a:r>
+          </a:p>
+        </p:txBody>
+      </p:sp>
+      <p:sp>
+        <p:nvSpPr>
+          <p:cNvPr id="3" name="TextBox 2"/>
+          <p:cNvSpPr txBox="1"/>
+          <p:nvPr/>
+        </p:nvSpPr>
+        <p:spPr>
+          <a:xfrm>
+            <a:off x="457200" y="1005840"/>
+            <a:ext cx="11247120" cy="457200"/>
+          </a:xfrm>
+          <a:prstGeom prst="rect">
+            <a:avLst/>
+          </a:prstGeom>
+          <a:noFill/>
+        </p:spPr>
+        <p:txBody>
+          <a:bodyPr wrap="none">
+            <a:spAutoFit/>
+          </a:bodyPr>
+          <a:lstStyle/>
+          <a:p>
+            <a:pPr>
+              <a:defRPr sz="1800" i="1">
+                <a:solidFill>
+                  <a:srgbClr val="9CA3AF"/>
+                </a:solidFill>
+              </a:defRPr>
+            </a:pPr>
+            <a:r>
+              <a:t>Claude remembers context across conversations — so you don't have to repeat yourself</a:t>
+            </a:r>
+          </a:p>
+        </p:txBody>
+      </p:sp>
+      <p:sp>
+        <p:nvSpPr>
+          <p:cNvPr id="4" name="Rounded Rectangle 3"/>
+          <p:cNvSpPr/>
+          <p:nvPr/>
+        </p:nvSpPr>
+        <p:spPr>
+          <a:xfrm>
+            <a:off x="457200" y="1737360"/>
+            <a:ext cx="3474720" cy="3474720"/>
+          </a:xfrm>
+          <a:prstGeom prst="roundRect">
+            <a:avLst/>
+          </a:prstGeom>
+          <a:solidFill>
+            <a:srgbClr val="141A2A"/>
+          </a:solidFill>
+          <a:ln w="19050">
+            <a:solidFill>
+              <a:srgbClr val="14B8A6"/>
+            </a:solidFill>
+          </a:ln>
+        </p:spPr>
+        <p:style>
+          <a:lnRef idx="1">
+            <a:schemeClr val="accent1"/>
+          </a:lnRef>
+          <a:fillRef idx="3">
+            <a:schemeClr val="accent1"/>
+          </a:fillRef>
+          <a:effectRef idx="2">
+            <a:schemeClr val="accent1"/>
+          </a:effectRef>
+          <a:fontRef idx="minor">
+            <a:schemeClr val="lt1"/>
+          </a:fontRef>
+        </p:style>
+        <p:txBody>
+          <a:bodyPr rtlCol="0" anchor="ctr"/>
+          <a:lstStyle/>
+          <a:p>
+            <a:pPr algn="ctr"/>
+          </a:p>
+        </p:txBody>
+      </p:sp>
+      <p:sp>
+        <p:nvSpPr>
+          <p:cNvPr id="5" name="TextBox 4"/>
+          <p:cNvSpPr txBox="1"/>
+          <p:nvPr/>
+        </p:nvSpPr>
+        <p:spPr>
+          <a:xfrm>
+            <a:off x="640080" y="1920240"/>
+            <a:ext cx="3108960" cy="457200"/>
+          </a:xfrm>
+          <a:prstGeom prst="rect">
+            <a:avLst/>
+          </a:prstGeom>
+          <a:noFill/>
+        </p:spPr>
+        <p:txBody>
+          <a:bodyPr wrap="none">
+            <a:spAutoFit/>
+          </a:bodyPr>
+          <a:lstStyle/>
+          <a:p>
+            <a:pPr algn="ctr">
+              <a:defRPr sz="3000"/>
+            </a:pPr>
+            <a:r>
+              <a:t>🔍</a:t>
+            </a:r>
+          </a:p>
+        </p:txBody>
+      </p:sp>
+      <p:sp>
+        <p:nvSpPr>
+          <p:cNvPr id="6" name="TextBox 5"/>
+          <p:cNvSpPr txBox="1"/>
+          <p:nvPr/>
+        </p:nvSpPr>
+        <p:spPr>
+          <a:xfrm>
+            <a:off x="640080" y="2377440"/>
+            <a:ext cx="3108960" cy="640080"/>
+          </a:xfrm>
+          <a:prstGeom prst="rect">
+            <a:avLst/>
+          </a:prstGeom>
+          <a:noFill/>
+        </p:spPr>
+        <p:txBody>
+          <a:bodyPr wrap="square">
+            <a:spAutoFit/>
+          </a:bodyPr>
+          <a:lstStyle/>
+          <a:p>
+            <a:pPr algn="ctr">
+              <a:defRPr sz="1800" b="1">
+                <a:solidFill>
+                  <a:srgbClr val="FFFFFF"/>
+                </a:solidFill>
+              </a:defRPr>
+            </a:pPr>
+            <a:r>
+              <a:t>Search &amp; Reference</a:t>
+            </a:r>
+            <a:br/>
+            <a:r>
+              <a:t>Past Chats</a:t>
+            </a:r>
+          </a:p>
+        </p:txBody>
+      </p:sp>
+      <p:sp>
+        <p:nvSpPr>
+          <p:cNvPr id="7" name="TextBox 6"/>
+          <p:cNvSpPr txBox="1"/>
+          <p:nvPr/>
+        </p:nvSpPr>
+        <p:spPr>
+          <a:xfrm>
+            <a:off x="640080" y="3108960"/>
+            <a:ext cx="3108960" cy="1828800"/>
+          </a:xfrm>
+          <a:prstGeom prst="rect">
+            <a:avLst/>
+          </a:prstGeom>
+          <a:noFill/>
+        </p:spPr>
+        <p:txBody>
+          <a:bodyPr wrap="square">
+            <a:spAutoFit/>
+          </a:bodyPr>
+          <a:lstStyle/>
+          <a:p>
+            <a:pPr algn="ctr">
+              <a:defRPr sz="1400">
+                <a:solidFill>
+                  <a:srgbClr val="D1D5DB"/>
+                </a:solidFill>
+              </a:defRPr>
+            </a:pPr>
+            <a:r>
+              <a:t>Claude searches your</a:t>
+            </a:r>
+            <a:br/>
+            <a:r>
+              <a:t>previous conversations</a:t>
+            </a:r>
+            <a:br/>
+            <a:r>
+              <a:t>for relevant context.</a:t>
+            </a:r>
+            <a:br/>
+            <a:r>
+              <a:t>Finds details you forgot.</a:t>
+            </a:r>
+            <a:br/>
+            <a:r>
+              <a:t>Works across all chats.</a:t>
+            </a:r>
+          </a:p>
+        </p:txBody>
+      </p:sp>
+      <p:sp>
+        <p:nvSpPr>
+          <p:cNvPr id="8" name="Rounded Rectangle 7"/>
+          <p:cNvSpPr/>
+          <p:nvPr/>
+        </p:nvSpPr>
+        <p:spPr>
+          <a:xfrm>
+            <a:off x="4206240" y="1737360"/>
+            <a:ext cx="3474720" cy="3474720"/>
+          </a:xfrm>
+          <a:prstGeom prst="roundRect">
+            <a:avLst/>
+          </a:prstGeom>
+          <a:solidFill>
+            <a:srgbClr val="141A2A"/>
+          </a:solidFill>
+          <a:ln w="19050">
+            <a:solidFill>
+              <a:srgbClr val="14B8A6"/>
+            </a:solidFill>
+          </a:ln>
+        </p:spPr>
+        <p:style>
+          <a:lnRef idx="1">
+            <a:schemeClr val="accent1"/>
+          </a:lnRef>
+          <a:fillRef idx="3">
+            <a:schemeClr val="accent1"/>
+          </a:fillRef>
+          <a:effectRef idx="2">
+            <a:schemeClr val="accent1"/>
+          </a:effectRef>
+          <a:fontRef idx="minor">
+            <a:schemeClr val="lt1"/>
+          </a:fontRef>
+        </p:style>
+        <p:txBody>
+          <a:bodyPr rtlCol="0" anchor="ctr"/>
+          <a:lstStyle/>
+          <a:p>
+            <a:pPr algn="ctr"/>
+          </a:p>
+        </p:txBody>
+      </p:sp>
+      <p:sp>
+        <p:nvSpPr>
+          <p:cNvPr id="9" name="TextBox 8"/>
+          <p:cNvSpPr txBox="1"/>
+          <p:nvPr/>
+        </p:nvSpPr>
+        <p:spPr>
+          <a:xfrm>
+            <a:off x="4389120" y="1920240"/>
+            <a:ext cx="3108960" cy="457200"/>
+          </a:xfrm>
+          <a:prstGeom prst="rect">
+            <a:avLst/>
+          </a:prstGeom>
+          <a:noFill/>
+        </p:spPr>
+        <p:txBody>
+          <a:bodyPr wrap="none">
+            <a:spAutoFit/>
+          </a:bodyPr>
+          <a:lstStyle/>
+          <a:p>
+            <a:pPr algn="ctr">
+              <a:defRPr sz="3000"/>
+            </a:pPr>
+            <a:r>
+              <a:t>🧠</a:t>
+            </a:r>
+          </a:p>
+        </p:txBody>
+      </p:sp>
+      <p:sp>
+        <p:nvSpPr>
+          <p:cNvPr id="10" name="TextBox 9"/>
+          <p:cNvSpPr txBox="1"/>
+          <p:nvPr/>
+        </p:nvSpPr>
+        <p:spPr>
+          <a:xfrm>
+            <a:off x="4389120" y="2377440"/>
+            <a:ext cx="3108960" cy="640080"/>
+          </a:xfrm>
+          <a:prstGeom prst="rect">
+            <a:avLst/>
+          </a:prstGeom>
+          <a:noFill/>
+        </p:spPr>
+        <p:txBody>
+          <a:bodyPr wrap="square">
+            <a:spAutoFit/>
+          </a:bodyPr>
+          <a:lstStyle/>
+          <a:p>
+            <a:pPr algn="ctr">
+              <a:defRPr sz="1800" b="1">
+                <a:solidFill>
+                  <a:srgbClr val="FFFFFF"/>
+                </a:solidFill>
+              </a:defRPr>
+            </a:pPr>
+            <a:r>
+              <a:t>Generate Memory</a:t>
+            </a:r>
+            <a:br/>
+            <a:r>
+              <a:t>from History</a:t>
+            </a:r>
+          </a:p>
+        </p:txBody>
+      </p:sp>
+      <p:sp>
+        <p:nvSpPr>
+          <p:cNvPr id="11" name="TextBox 10"/>
+          <p:cNvSpPr txBox="1"/>
+          <p:nvPr/>
+        </p:nvSpPr>
+        <p:spPr>
+          <a:xfrm>
+            <a:off x="4389120" y="3108960"/>
+            <a:ext cx="3108960" cy="1828800"/>
+          </a:xfrm>
+          <a:prstGeom prst="rect">
+            <a:avLst/>
+          </a:prstGeom>
+          <a:noFill/>
+        </p:spPr>
+        <p:txBody>
+          <a:bodyPr wrap="square">
+            <a:spAutoFit/>
+          </a:bodyPr>
+          <a:lstStyle/>
+          <a:p>
+            <a:pPr algn="ctr">
+              <a:defRPr sz="1400">
+                <a:solidFill>
+                  <a:srgbClr val="D1D5DB"/>
+                </a:solidFill>
+              </a:defRPr>
+            </a:pPr>
+            <a:r>
+              <a:t>Claude builds memory</a:t>
+            </a:r>
+            <a:br/>
+            <a:r>
+              <a:t>from your chat patterns.</a:t>
+            </a:r>
+            <a:br/>
+            <a:r>
+              <a:t>Remembers preferences,</a:t>
+            </a:r>
+            <a:br/>
+            <a:r>
+              <a:t>projects, and context.</a:t>
+            </a:r>
+            <a:br/>
+            <a:r>
+              <a:t>Controls both chats</a:t>
+            </a:r>
+            <a:br/>
+            <a:r>
+              <a:t>and Projects.</a:t>
+            </a:r>
+          </a:p>
+        </p:txBody>
+      </p:sp>
+      <p:sp>
+        <p:nvSpPr>
+          <p:cNvPr id="12" name="Rounded Rectangle 11"/>
+          <p:cNvSpPr/>
+          <p:nvPr/>
+        </p:nvSpPr>
+        <p:spPr>
+          <a:xfrm>
+            <a:off x="7955279" y="1737360"/>
+            <a:ext cx="3474720" cy="3474720"/>
+          </a:xfrm>
+          <a:prstGeom prst="roundRect">
+            <a:avLst/>
+          </a:prstGeom>
+          <a:solidFill>
+            <a:srgbClr val="141A2A"/>
+          </a:solidFill>
+          <a:ln w="19050">
+            <a:solidFill>
+              <a:srgbClr val="14B8A6"/>
+            </a:solidFill>
+          </a:ln>
+        </p:spPr>
+        <p:style>
+          <a:lnRef idx="1">
+            <a:schemeClr val="accent1"/>
+          </a:lnRef>
+          <a:fillRef idx="3">
+            <a:schemeClr val="accent1"/>
+          </a:fillRef>
+          <a:effectRef idx="2">
+            <a:schemeClr val="accent1"/>
+          </a:effectRef>
+          <a:fontRef idx="minor">
+            <a:schemeClr val="lt1"/>
+          </a:fontRef>
+        </p:style>
+        <p:txBody>
+          <a:bodyPr rtlCol="0" anchor="ctr"/>
+          <a:lstStyle/>
+          <a:p>
+            <a:pPr algn="ctr"/>
+          </a:p>
+        </p:txBody>
+      </p:sp>
+      <p:sp>
+        <p:nvSpPr>
+          <p:cNvPr id="13" name="TextBox 12"/>
+          <p:cNvSpPr txBox="1"/>
+          <p:nvPr/>
+        </p:nvSpPr>
+        <p:spPr>
+          <a:xfrm>
+            <a:off x="8138159" y="1920240"/>
+            <a:ext cx="3108960" cy="457200"/>
+          </a:xfrm>
+          <a:prstGeom prst="rect">
+            <a:avLst/>
+          </a:prstGeom>
+          <a:noFill/>
+        </p:spPr>
+        <p:txBody>
+          <a:bodyPr wrap="none">
+            <a:spAutoFit/>
+          </a:bodyPr>
+          <a:lstStyle/>
+          <a:p>
+            <a:pPr algn="ctr">
+              <a:defRPr sz="3000"/>
+            </a:pPr>
+            <a:r>
+              <a:t>👁️</a:t>
+            </a:r>
+          </a:p>
+        </p:txBody>
+      </p:sp>
+      <p:sp>
+        <p:nvSpPr>
+          <p:cNvPr id="14" name="TextBox 13"/>
+          <p:cNvSpPr txBox="1"/>
+          <p:nvPr/>
+        </p:nvSpPr>
+        <p:spPr>
+          <a:xfrm>
+            <a:off x="8138159" y="2377440"/>
+            <a:ext cx="3108960" cy="640080"/>
+          </a:xfrm>
+          <a:prstGeom prst="rect">
+            <a:avLst/>
+          </a:prstGeom>
+          <a:noFill/>
+        </p:spPr>
+        <p:txBody>
+          <a:bodyPr wrap="square">
+            <a:spAutoFit/>
+          </a:bodyPr>
+          <a:lstStyle/>
+          <a:p>
+            <a:pPr algn="ctr">
+              <a:defRPr sz="1800" b="1">
+                <a:solidFill>
+                  <a:srgbClr val="FFFFFF"/>
+                </a:solidFill>
+              </a:defRPr>
+            </a:pPr>
+            <a:r>
+              <a:t>View Your Memory</a:t>
+            </a:r>
+          </a:p>
+        </p:txBody>
+      </p:sp>
+      <p:sp>
+        <p:nvSpPr>
+          <p:cNvPr id="15" name="TextBox 14"/>
+          <p:cNvSpPr txBox="1"/>
+          <p:nvPr/>
+        </p:nvSpPr>
+        <p:spPr>
+          <a:xfrm>
+            <a:off x="8138159" y="3108960"/>
+            <a:ext cx="3108960" cy="1828800"/>
+          </a:xfrm>
+          <a:prstGeom prst="rect">
+            <a:avLst/>
+          </a:prstGeom>
+          <a:noFill/>
+        </p:spPr>
+        <p:txBody>
+          <a:bodyPr wrap="square">
+            <a:spAutoFit/>
+          </a:bodyPr>
+          <a:lstStyle/>
+          <a:p>
+            <a:pPr algn="ctr">
+              <a:defRPr sz="1400">
+                <a:solidFill>
+                  <a:srgbClr val="D1D5DB"/>
+                </a:solidFill>
+              </a:defRPr>
+            </a:pPr>
+            <a:r>
+              <a:t>See exactly what Claude</a:t>
+            </a:r>
+            <a:br/>
+            <a:r>
+              <a:t>remembers about you.</a:t>
+            </a:r>
+            <a:br/>
+            <a:r>
+              <a:t>Edit or delete entries.</a:t>
+            </a:r>
+            <a:br/>
+            <a:r>
+              <a:t>Full transparency —</a:t>
+            </a:r>
+            <a:br/>
+            <a:r>
+              <a:t>no hidden knowledge.</a:t>
+            </a:r>
+          </a:p>
+        </p:txBody>
+      </p:sp>
+      <p:sp>
+        <p:nvSpPr>
+          <p:cNvPr id="16" name="TextBox 15"/>
+          <p:cNvSpPr txBox="1"/>
+          <p:nvPr/>
+        </p:nvSpPr>
+        <p:spPr>
+          <a:xfrm>
+            <a:off x="457200" y="5486400"/>
+            <a:ext cx="11247120" cy="457200"/>
+          </a:xfrm>
+          <a:prstGeom prst="rect">
+            <a:avLst/>
+          </a:prstGeom>
+          <a:noFill/>
+        </p:spPr>
+        <p:txBody>
+          <a:bodyPr wrap="none">
+            <a:spAutoFit/>
+          </a:bodyPr>
+          <a:lstStyle/>
+          <a:p>
+            <a:pPr algn="ctr">
+              <a:defRPr sz="1500" i="1">
+                <a:solidFill>
+                  <a:srgbClr val="14B8A6"/>
+                </a:solidFill>
+              </a:defRPr>
+            </a:pPr>
+            <a:r>
+              <a:t>Settings → Memory → Enable both toggles for the best experience</a:t>
+            </a:r>
+          </a:p>
+        </p:txBody>
+      </p:sp>
+    </p:spTree>
+  </p:cSld>
+  <p:clrMapOvr>
+    <a:masterClrMapping/>
+  </p:clrMapOvr>
+</p:sld>
+</file>
+
 <file path=ppt/slides/slide36.xml><?xml version="1.0" encoding="utf-8"?>
 <p:sld xmlns:a="http://schemas.openxmlformats.org/drawingml/2006/main" xmlns:p="http://schemas.openxmlformats.org/presentationml/2006/main" xmlns:r="http://schemas.openxmlformats.org/officeDocument/2006/relationships">
   <p:cSld>
@@ -52020,8 +52650,8 @@
         </p:nvSpPr>
         <p:spPr>
           <a:xfrm>
-            <a:off x="457200" y="274320"/>
-            <a:ext cx="11247120" cy="822960"/>
+            <a:off x="457200" y="2286000"/>
+            <a:ext cx="11247120" cy="1371600"/>
           </a:xfrm>
           <a:prstGeom prst="rect">
             <a:avLst/>
@@ -52034,15 +52664,15 @@
           </a:bodyPr>
           <a:lstStyle/>
           <a:p>
-            <a:pPr>
-              <a:defRPr sz="4000" b="1">
+            <a:pPr algn="ctr">
+              <a:defRPr sz="5600" b="1">
                 <a:solidFill>
                   <a:srgbClr val="FFFFFF"/>
                 </a:solidFill>
               </a:defRPr>
             </a:pPr>
             <a:r>
-              <a:t>Claude's Memory</a:t>
+              <a:t>Thank You</a:t>
             </a:r>
           </a:p>
         </p:txBody>
@@ -52055,7 +52685,7 @@
         </p:nvSpPr>
         <p:spPr>
           <a:xfrm>
-            <a:off x="457200" y="1005840"/>
+            <a:off x="457200" y="3657600"/>
             <a:ext cx="11247120" cy="457200"/>
           </a:xfrm>
           <a:prstGeom prst="rect">
@@ -52069,548 +52699,15 @@
           </a:bodyPr>
           <a:lstStyle/>
           <a:p>
-            <a:pPr>
-              <a:defRPr sz="1800" i="1">
-                <a:solidFill>
-                  <a:srgbClr val="9CA3AF"/>
-                </a:solidFill>
-              </a:defRPr>
-            </a:pPr>
-            <a:r>
-              <a:t>Claude remembers context across conversations — so you don't have to repeat yourself</a:t>
-            </a:r>
-          </a:p>
-        </p:txBody>
-      </p:sp>
-      <p:sp>
-        <p:nvSpPr>
-          <p:cNvPr id="4" name="Rounded Rectangle 3"/>
-          <p:cNvSpPr/>
-          <p:nvPr/>
-        </p:nvSpPr>
-        <p:spPr>
-          <a:xfrm>
-            <a:off x="457200" y="1737360"/>
-            <a:ext cx="3474720" cy="3474720"/>
-          </a:xfrm>
-          <a:prstGeom prst="roundRect">
-            <a:avLst/>
-          </a:prstGeom>
-          <a:solidFill>
-            <a:srgbClr val="141A2A"/>
-          </a:solidFill>
-          <a:ln w="19050">
-            <a:solidFill>
-              <a:srgbClr val="14B8A6"/>
-            </a:solidFill>
-          </a:ln>
-        </p:spPr>
-        <p:style>
-          <a:lnRef idx="1">
-            <a:schemeClr val="accent1"/>
-          </a:lnRef>
-          <a:fillRef idx="3">
-            <a:schemeClr val="accent1"/>
-          </a:fillRef>
-          <a:effectRef idx="2">
-            <a:schemeClr val="accent1"/>
-          </a:effectRef>
-          <a:fontRef idx="minor">
-            <a:schemeClr val="lt1"/>
-          </a:fontRef>
-        </p:style>
-        <p:txBody>
-          <a:bodyPr rtlCol="0" anchor="ctr"/>
-          <a:lstStyle/>
-          <a:p>
-            <a:pPr algn="ctr"/>
-          </a:p>
-        </p:txBody>
-      </p:sp>
-      <p:sp>
-        <p:nvSpPr>
-          <p:cNvPr id="5" name="TextBox 4"/>
-          <p:cNvSpPr txBox="1"/>
-          <p:nvPr/>
-        </p:nvSpPr>
-        <p:spPr>
-          <a:xfrm>
-            <a:off x="640080" y="1920240"/>
-            <a:ext cx="3108960" cy="457200"/>
-          </a:xfrm>
-          <a:prstGeom prst="rect">
-            <a:avLst/>
-          </a:prstGeom>
-          <a:noFill/>
-        </p:spPr>
-        <p:txBody>
-          <a:bodyPr wrap="none">
-            <a:spAutoFit/>
-          </a:bodyPr>
-          <a:lstStyle/>
-          <a:p>
             <a:pPr algn="ctr">
-              <a:defRPr sz="3000"/>
-            </a:pPr>
-            <a:r>
-              <a:t>🔍</a:t>
-            </a:r>
-          </a:p>
-        </p:txBody>
-      </p:sp>
-      <p:sp>
-        <p:nvSpPr>
-          <p:cNvPr id="6" name="TextBox 5"/>
-          <p:cNvSpPr txBox="1"/>
-          <p:nvPr/>
-        </p:nvSpPr>
-        <p:spPr>
-          <a:xfrm>
-            <a:off x="640080" y="2377440"/>
-            <a:ext cx="3108960" cy="640080"/>
-          </a:xfrm>
-          <a:prstGeom prst="rect">
-            <a:avLst/>
-          </a:prstGeom>
-          <a:noFill/>
-        </p:spPr>
-        <p:txBody>
-          <a:bodyPr wrap="square">
-            <a:spAutoFit/>
-          </a:bodyPr>
-          <a:lstStyle/>
-          <a:p>
-            <a:pPr algn="ctr">
-              <a:defRPr sz="1800" b="1">
-                <a:solidFill>
-                  <a:srgbClr val="FFFFFF"/>
-                </a:solidFill>
-              </a:defRPr>
-            </a:pPr>
-            <a:r>
-              <a:t>Search &amp; Reference</a:t>
-            </a:r>
-            <a:br/>
-            <a:r>
-              <a:t>Past Chats</a:t>
-            </a:r>
-          </a:p>
-        </p:txBody>
-      </p:sp>
-      <p:sp>
-        <p:nvSpPr>
-          <p:cNvPr id="7" name="TextBox 6"/>
-          <p:cNvSpPr txBox="1"/>
-          <p:nvPr/>
-        </p:nvSpPr>
-        <p:spPr>
-          <a:xfrm>
-            <a:off x="640080" y="3108960"/>
-            <a:ext cx="3108960" cy="1828800"/>
-          </a:xfrm>
-          <a:prstGeom prst="rect">
-            <a:avLst/>
-          </a:prstGeom>
-          <a:noFill/>
-        </p:spPr>
-        <p:txBody>
-          <a:bodyPr wrap="square">
-            <a:spAutoFit/>
-          </a:bodyPr>
-          <a:lstStyle/>
-          <a:p>
-            <a:pPr algn="ctr">
-              <a:defRPr sz="1400">
-                <a:solidFill>
-                  <a:srgbClr val="D1D5DB"/>
-                </a:solidFill>
-              </a:defRPr>
-            </a:pPr>
-            <a:r>
-              <a:t>Claude searches your</a:t>
-            </a:r>
-            <a:br/>
-            <a:r>
-              <a:t>previous conversations</a:t>
-            </a:r>
-            <a:br/>
-            <a:r>
-              <a:t>for relevant context.</a:t>
-            </a:r>
-            <a:br/>
-            <a:r>
-              <a:t>Finds details you forgot.</a:t>
-            </a:r>
-            <a:br/>
-            <a:r>
-              <a:t>Works across all chats.</a:t>
-            </a:r>
-          </a:p>
-        </p:txBody>
-      </p:sp>
-      <p:sp>
-        <p:nvSpPr>
-          <p:cNvPr id="8" name="Rounded Rectangle 7"/>
-          <p:cNvSpPr/>
-          <p:nvPr/>
-        </p:nvSpPr>
-        <p:spPr>
-          <a:xfrm>
-            <a:off x="4206240" y="1737360"/>
-            <a:ext cx="3474720" cy="3474720"/>
-          </a:xfrm>
-          <a:prstGeom prst="roundRect">
-            <a:avLst/>
-          </a:prstGeom>
-          <a:solidFill>
-            <a:srgbClr val="141A2A"/>
-          </a:solidFill>
-          <a:ln w="19050">
-            <a:solidFill>
-              <a:srgbClr val="14B8A6"/>
-            </a:solidFill>
-          </a:ln>
-        </p:spPr>
-        <p:style>
-          <a:lnRef idx="1">
-            <a:schemeClr val="accent1"/>
-          </a:lnRef>
-          <a:fillRef idx="3">
-            <a:schemeClr val="accent1"/>
-          </a:fillRef>
-          <a:effectRef idx="2">
-            <a:schemeClr val="accent1"/>
-          </a:effectRef>
-          <a:fontRef idx="minor">
-            <a:schemeClr val="lt1"/>
-          </a:fontRef>
-        </p:style>
-        <p:txBody>
-          <a:bodyPr rtlCol="0" anchor="ctr"/>
-          <a:lstStyle/>
-          <a:p>
-            <a:pPr algn="ctr"/>
-          </a:p>
-        </p:txBody>
-      </p:sp>
-      <p:sp>
-        <p:nvSpPr>
-          <p:cNvPr id="9" name="TextBox 8"/>
-          <p:cNvSpPr txBox="1"/>
-          <p:nvPr/>
-        </p:nvSpPr>
-        <p:spPr>
-          <a:xfrm>
-            <a:off x="4389120" y="1920240"/>
-            <a:ext cx="3108960" cy="457200"/>
-          </a:xfrm>
-          <a:prstGeom prst="rect">
-            <a:avLst/>
-          </a:prstGeom>
-          <a:noFill/>
-        </p:spPr>
-        <p:txBody>
-          <a:bodyPr wrap="none">
-            <a:spAutoFit/>
-          </a:bodyPr>
-          <a:lstStyle/>
-          <a:p>
-            <a:pPr algn="ctr">
-              <a:defRPr sz="3000"/>
-            </a:pPr>
-            <a:r>
-              <a:t>🧠</a:t>
-            </a:r>
-          </a:p>
-        </p:txBody>
-      </p:sp>
-      <p:sp>
-        <p:nvSpPr>
-          <p:cNvPr id="10" name="TextBox 9"/>
-          <p:cNvSpPr txBox="1"/>
-          <p:nvPr/>
-        </p:nvSpPr>
-        <p:spPr>
-          <a:xfrm>
-            <a:off x="4389120" y="2377440"/>
-            <a:ext cx="3108960" cy="640080"/>
-          </a:xfrm>
-          <a:prstGeom prst="rect">
-            <a:avLst/>
-          </a:prstGeom>
-          <a:noFill/>
-        </p:spPr>
-        <p:txBody>
-          <a:bodyPr wrap="square">
-            <a:spAutoFit/>
-          </a:bodyPr>
-          <a:lstStyle/>
-          <a:p>
-            <a:pPr algn="ctr">
-              <a:defRPr sz="1800" b="1">
-                <a:solidFill>
-                  <a:srgbClr val="FFFFFF"/>
-                </a:solidFill>
-              </a:defRPr>
-            </a:pPr>
-            <a:r>
-              <a:t>Generate Memory</a:t>
-            </a:r>
-            <a:br/>
-            <a:r>
-              <a:t>from History</a:t>
-            </a:r>
-          </a:p>
-        </p:txBody>
-      </p:sp>
-      <p:sp>
-        <p:nvSpPr>
-          <p:cNvPr id="11" name="TextBox 10"/>
-          <p:cNvSpPr txBox="1"/>
-          <p:nvPr/>
-        </p:nvSpPr>
-        <p:spPr>
-          <a:xfrm>
-            <a:off x="4389120" y="3108960"/>
-            <a:ext cx="3108960" cy="1828800"/>
-          </a:xfrm>
-          <a:prstGeom prst="rect">
-            <a:avLst/>
-          </a:prstGeom>
-          <a:noFill/>
-        </p:spPr>
-        <p:txBody>
-          <a:bodyPr wrap="square">
-            <a:spAutoFit/>
-          </a:bodyPr>
-          <a:lstStyle/>
-          <a:p>
-            <a:pPr algn="ctr">
-              <a:defRPr sz="1400">
-                <a:solidFill>
-                  <a:srgbClr val="D1D5DB"/>
-                </a:solidFill>
-              </a:defRPr>
-            </a:pPr>
-            <a:r>
-              <a:t>Claude builds memory</a:t>
-            </a:r>
-            <a:br/>
-            <a:r>
-              <a:t>from your chat patterns.</a:t>
-            </a:r>
-            <a:br/>
-            <a:r>
-              <a:t>Remembers preferences,</a:t>
-            </a:r>
-            <a:br/>
-            <a:r>
-              <a:t>projects, and context.</a:t>
-            </a:r>
-            <a:br/>
-            <a:r>
-              <a:t>Controls both chats</a:t>
-            </a:r>
-            <a:br/>
-            <a:r>
-              <a:t>and Projects.</a:t>
-            </a:r>
-          </a:p>
-        </p:txBody>
-      </p:sp>
-      <p:sp>
-        <p:nvSpPr>
-          <p:cNvPr id="12" name="Rounded Rectangle 11"/>
-          <p:cNvSpPr/>
-          <p:nvPr/>
-        </p:nvSpPr>
-        <p:spPr>
-          <a:xfrm>
-            <a:off x="7955279" y="1737360"/>
-            <a:ext cx="3474720" cy="3474720"/>
-          </a:xfrm>
-          <a:prstGeom prst="roundRect">
-            <a:avLst/>
-          </a:prstGeom>
-          <a:solidFill>
-            <a:srgbClr val="141A2A"/>
-          </a:solidFill>
-          <a:ln w="19050">
-            <a:solidFill>
-              <a:srgbClr val="14B8A6"/>
-            </a:solidFill>
-          </a:ln>
-        </p:spPr>
-        <p:style>
-          <a:lnRef idx="1">
-            <a:schemeClr val="accent1"/>
-          </a:lnRef>
-          <a:fillRef idx="3">
-            <a:schemeClr val="accent1"/>
-          </a:fillRef>
-          <a:effectRef idx="2">
-            <a:schemeClr val="accent1"/>
-          </a:effectRef>
-          <a:fontRef idx="minor">
-            <a:schemeClr val="lt1"/>
-          </a:fontRef>
-        </p:style>
-        <p:txBody>
-          <a:bodyPr rtlCol="0" anchor="ctr"/>
-          <a:lstStyle/>
-          <a:p>
-            <a:pPr algn="ctr"/>
-          </a:p>
-        </p:txBody>
-      </p:sp>
-      <p:sp>
-        <p:nvSpPr>
-          <p:cNvPr id="13" name="TextBox 12"/>
-          <p:cNvSpPr txBox="1"/>
-          <p:nvPr/>
-        </p:nvSpPr>
-        <p:spPr>
-          <a:xfrm>
-            <a:off x="8138159" y="1920240"/>
-            <a:ext cx="3108960" cy="457200"/>
-          </a:xfrm>
-          <a:prstGeom prst="rect">
-            <a:avLst/>
-          </a:prstGeom>
-          <a:noFill/>
-        </p:spPr>
-        <p:txBody>
-          <a:bodyPr wrap="none">
-            <a:spAutoFit/>
-          </a:bodyPr>
-          <a:lstStyle/>
-          <a:p>
-            <a:pPr algn="ctr">
-              <a:defRPr sz="3000"/>
-            </a:pPr>
-            <a:r>
-              <a:t>👁️</a:t>
-            </a:r>
-          </a:p>
-        </p:txBody>
-      </p:sp>
-      <p:sp>
-        <p:nvSpPr>
-          <p:cNvPr id="14" name="TextBox 13"/>
-          <p:cNvSpPr txBox="1"/>
-          <p:nvPr/>
-        </p:nvSpPr>
-        <p:spPr>
-          <a:xfrm>
-            <a:off x="8138159" y="2377440"/>
-            <a:ext cx="3108960" cy="640080"/>
-          </a:xfrm>
-          <a:prstGeom prst="rect">
-            <a:avLst/>
-          </a:prstGeom>
-          <a:noFill/>
-        </p:spPr>
-        <p:txBody>
-          <a:bodyPr wrap="square">
-            <a:spAutoFit/>
-          </a:bodyPr>
-          <a:lstStyle/>
-          <a:p>
-            <a:pPr algn="ctr">
-              <a:defRPr sz="1800" b="1">
-                <a:solidFill>
-                  <a:srgbClr val="FFFFFF"/>
-                </a:solidFill>
-              </a:defRPr>
-            </a:pPr>
-            <a:r>
-              <a:t>View Your Memory</a:t>
-            </a:r>
-          </a:p>
-        </p:txBody>
-      </p:sp>
-      <p:sp>
-        <p:nvSpPr>
-          <p:cNvPr id="15" name="TextBox 14"/>
-          <p:cNvSpPr txBox="1"/>
-          <p:nvPr/>
-        </p:nvSpPr>
-        <p:spPr>
-          <a:xfrm>
-            <a:off x="8138159" y="3108960"/>
-            <a:ext cx="3108960" cy="1828800"/>
-          </a:xfrm>
-          <a:prstGeom prst="rect">
-            <a:avLst/>
-          </a:prstGeom>
-          <a:noFill/>
-        </p:spPr>
-        <p:txBody>
-          <a:bodyPr wrap="square">
-            <a:spAutoFit/>
-          </a:bodyPr>
-          <a:lstStyle/>
-          <a:p>
-            <a:pPr algn="ctr">
-              <a:defRPr sz="1400">
-                <a:solidFill>
-                  <a:srgbClr val="D1D5DB"/>
-                </a:solidFill>
-              </a:defRPr>
-            </a:pPr>
-            <a:r>
-              <a:t>See exactly what Claude</a:t>
-            </a:r>
-            <a:br/>
-            <a:r>
-              <a:t>remembers about you.</a:t>
-            </a:r>
-            <a:br/>
-            <a:r>
-              <a:t>Edit or delete entries.</a:t>
-            </a:r>
-            <a:br/>
-            <a:r>
-              <a:t>Full transparency —</a:t>
-            </a:r>
-            <a:br/>
-            <a:r>
-              <a:t>no hidden knowledge.</a:t>
-            </a:r>
-          </a:p>
-        </p:txBody>
-      </p:sp>
-      <p:sp>
-        <p:nvSpPr>
-          <p:cNvPr id="16" name="TextBox 15"/>
-          <p:cNvSpPr txBox="1"/>
-          <p:nvPr/>
-        </p:nvSpPr>
-        <p:spPr>
-          <a:xfrm>
-            <a:off x="457200" y="5486400"/>
-            <a:ext cx="11247120" cy="457200"/>
-          </a:xfrm>
-          <a:prstGeom prst="rect">
-            <a:avLst/>
-          </a:prstGeom>
-          <a:noFill/>
-        </p:spPr>
-        <p:txBody>
-          <a:bodyPr wrap="none">
-            <a:spAutoFit/>
-          </a:bodyPr>
-          <a:lstStyle/>
-          <a:p>
-            <a:pPr algn="ctr">
-              <a:defRPr sz="1500" i="1">
+              <a:defRPr sz="2000">
                 <a:solidFill>
                   <a:srgbClr val="14B8A6"/>
                 </a:solidFill>
               </a:defRPr>
             </a:pPr>
             <a:r>
-              <a:t>Settings → Memory → Enable both toggles for the best experience</a:t>
+              <a:t>scott@aiacopilot.com  •  aiacopilot.com</a:t>
             </a:r>
           </a:p>
         </p:txBody>

</xml_diff>

<commit_message>
Update Capabilities/Privacy slide + add Industry Report PDF for Lab 1
Capabilities card: added AI-powered artifacts, Skills
Privacy card: updated to match actual Settings page (training toggle,
export data, shared chats, memory preferences, location metadata, incognito)

New: labs/sample-data/Industry_Report_2026.pdf (12-page report for
Lab 1 Exercise 4 — PDF analysis & executive summary)
</commit_message>
<xml_diff>
--- a/slides/Day1_Claude_for_Business.pptx
+++ b/slides/Day1_Claude_for_Business.pptx
@@ -28529,7 +28529,7 @@
         <p:spPr>
           <a:xfrm>
             <a:off x="457200" y="1737360"/>
-            <a:ext cx="5303520" cy="3931920"/>
+            <a:ext cx="5303520" cy="4114800"/>
           </a:xfrm>
           <a:prstGeom prst="roundRect">
             <a:avLst/>
@@ -28609,7 +28609,7 @@
         <p:spPr>
           <a:xfrm>
             <a:off x="731520" y="2468880"/>
-            <a:ext cx="4754880" cy="2926080"/>
+            <a:ext cx="4754880" cy="3108960"/>
           </a:xfrm>
           <a:prstGeom prst="rect">
             <a:avLst/>
@@ -28624,9 +28624,9 @@
           <a:p>
             <a:pPr>
               <a:spcAft>
-                <a:spcPts val="800"/>
+                <a:spcPts val="600"/>
               </a:spcAft>
-              <a:defRPr sz="1600">
+              <a:defRPr sz="1500">
                 <a:solidFill>
                   <a:srgbClr val="D1D5DB"/>
                 </a:solidFill>
@@ -28639,39 +28639,39 @@
           <a:p>
             <a:pPr>
               <a:spcAft>
-                <a:spcPts val="800"/>
+                <a:spcPts val="600"/>
               </a:spcAft>
-              <a:defRPr sz="1600">
+              <a:defRPr sz="1500">
                 <a:solidFill>
                   <a:srgbClr val="D1D5DB"/>
                 </a:solidFill>
               </a:defRPr>
             </a:pPr>
             <a:r>
-              <a:t>✅  Code execution &amp; file creation — docs, spreadsheets, PPTs, PDFs</a:t>
+              <a:t>✅  AI-powered artifacts — interactive apps &amp; prototypes</a:t>
             </a:r>
           </a:p>
           <a:p>
             <a:pPr>
               <a:spcAft>
-                <a:spcPts val="800"/>
+                <a:spcPts val="600"/>
               </a:spcAft>
-              <a:defRPr sz="1600">
+              <a:defRPr sz="1500">
                 <a:solidFill>
                   <a:srgbClr val="D1D5DB"/>
                 </a:solidFill>
               </a:defRPr>
             </a:pPr>
             <a:r>
-              <a:t>✅  Web search — Claude finds current information automatically</a:t>
+              <a:t>✅  Code execution &amp; file creation</a:t>
             </a:r>
           </a:p>
           <a:p>
             <a:pPr>
               <a:spcAft>
-                <a:spcPts val="800"/>
+                <a:spcPts val="600"/>
               </a:spcAft>
-              <a:defRPr sz="1600">
+              <a:defRPr sz="1500">
                 <a:solidFill>
                   <a:srgbClr val="D1D5DB"/>
                 </a:solidFill>
@@ -28679,6 +28679,21 @@
             </a:pPr>
             <a:r>
               <a:t>✅  Memory — search past chats + learn from history</a:t>
+            </a:r>
+          </a:p>
+          <a:p>
+            <a:pPr>
+              <a:spcAft>
+                <a:spcPts val="600"/>
+              </a:spcAft>
+              <a:defRPr sz="1500">
+                <a:solidFill>
+                  <a:srgbClr val="D1D5DB"/>
+                </a:solidFill>
+              </a:defRPr>
+            </a:pPr>
+            <a:r>
+              <a:t>✅  Skills — repeatable instructions for any chat</a:t>
             </a:r>
           </a:p>
         </p:txBody>
@@ -28692,7 +28707,7 @@
         <p:spPr>
           <a:xfrm>
             <a:off x="6217920" y="1737360"/>
-            <a:ext cx="5303520" cy="3931920"/>
+            <a:ext cx="5303520" cy="4114800"/>
           </a:xfrm>
           <a:prstGeom prst="roundRect">
             <a:avLst/>
@@ -28758,7 +28773,7 @@
               </a:defRPr>
             </a:pPr>
             <a:r>
-              <a:t>Privacy Controls</a:t>
+              <a:t>Privacy Settings</a:t>
             </a:r>
           </a:p>
         </p:txBody>
@@ -28772,7 +28787,7 @@
         <p:spPr>
           <a:xfrm>
             <a:off x="6492240" y="2468880"/>
-            <a:ext cx="4754880" cy="2926080"/>
+            <a:ext cx="4754880" cy="3108960"/>
           </a:xfrm>
           <a:prstGeom prst="rect">
             <a:avLst/>
@@ -28787,61 +28802,91 @@
           <a:p>
             <a:pPr>
               <a:spcAft>
-                <a:spcPts val="800"/>
+                <a:spcPts val="600"/>
               </a:spcAft>
-              <a:defRPr sz="1600">
+              <a:defRPr sz="1500">
                 <a:solidFill>
                   <a:srgbClr val="D1D5DB"/>
                 </a:solidFill>
               </a:defRPr>
             </a:pPr>
             <a:r>
-              <a:t>🔒  Training opt-out — paid plans OFF by default</a:t>
+              <a:t>🔒  "Help improve Claude" — training toggle (OFF on paid)</a:t>
             </a:r>
           </a:p>
           <a:p>
             <a:pPr>
               <a:spcAft>
-                <a:spcPts val="800"/>
+                <a:spcPts val="600"/>
               </a:spcAft>
-              <a:defRPr sz="1600">
+              <a:defRPr sz="1500">
                 <a:solidFill>
                   <a:srgbClr val="D1D5DB"/>
                 </a:solidFill>
               </a:defRPr>
             </a:pPr>
             <a:r>
-              <a:t>🕶️  Incognito chats — not saved, not used for training, not added to memory</a:t>
+              <a:t>📦  Export data — download all your conversations</a:t>
             </a:r>
           </a:p>
           <a:p>
             <a:pPr>
               <a:spcAft>
-                <a:spcPts val="800"/>
+                <a:spcPts val="600"/>
               </a:spcAft>
-              <a:defRPr sz="1600">
+              <a:defRPr sz="1500">
                 <a:solidFill>
                   <a:srgbClr val="D1D5DB"/>
                 </a:solidFill>
               </a:defRPr>
             </a:pPr>
             <a:r>
-              <a:t>⚠️  30-day retention for abuse detection</a:t>
+              <a:t>🔗  Shared chats — control who sees what</a:t>
             </a:r>
           </a:p>
           <a:p>
             <a:pPr>
               <a:spcAft>
-                <a:spcPts val="800"/>
+                <a:spcPts val="600"/>
               </a:spcAft>
-              <a:defRPr sz="1600">
+              <a:defRPr sz="1500">
                 <a:solidFill>
                   <a:srgbClr val="D1D5DB"/>
                 </a:solidFill>
               </a:defRPr>
             </a:pPr>
             <a:r>
-              <a:t>🏢  Team/Enterprise — zero data retention, full isolation</a:t>
+              <a:t>🧠  Memory preferences — view, edit, delete memories</a:t>
+            </a:r>
+          </a:p>
+          <a:p>
+            <a:pPr>
+              <a:spcAft>
+                <a:spcPts val="600"/>
+              </a:spcAft>
+              <a:defRPr sz="1500">
+                <a:solidFill>
+                  <a:srgbClr val="D1D5DB"/>
+                </a:solidFill>
+              </a:defRPr>
+            </a:pPr>
+            <a:r>
+              <a:t>📍  Location metadata — coarse city/region (optional)</a:t>
+            </a:r>
+          </a:p>
+          <a:p>
+            <a:pPr>
+              <a:spcAft>
+                <a:spcPts val="600"/>
+              </a:spcAft>
+              <a:defRPr sz="1500">
+                <a:solidFill>
+                  <a:srgbClr val="D1D5DB"/>
+                </a:solidFill>
+              </a:defRPr>
+            </a:pPr>
+            <a:r>
+              <a:t>🕶️  Incognito chats — not saved, not trained on</a:t>
             </a:r>
           </a:p>
         </p:txBody>

</xml_diff>

<commit_message>
Day 1: Speaker notes on all 88 slides — verified complete
</commit_message>
<xml_diff>
--- a/slides/Day1_Claude_for_Business.pptx
+++ b/slides/Day1_Claude_for_Business.pptx
@@ -11092,6 +11092,57 @@
           <a:chExt cx="0" cy="0"/>
         </a:xfrm>
       </p:grpSpPr>
+      <p:sp>
+        <p:nvSpPr>
+          <p:cNvPr id="3" name="Notes Placeholder 2"/>
+          <p:cNvSpPr>
+            <a:spLocks noGrp="1"/>
+          </p:cNvSpPr>
+          <p:nvPr>
+            <p:ph type="body" idx="1"/>
+          </p:nvPr>
+        </p:nvSpPr>
+        <p:spPr/>
+        <p:txBody>
+          <a:bodyPr/>
+          <a:lstStyle/>
+          <a:p>
+            <a:r>
+              <a:t>[Duration: 1 minute]</a:t>
+            </a:r>
+          </a:p>
+          <a:p>
+            <a:r>
+              <a:t/>
+            </a:r>
+          </a:p>
+          <a:p>
+            <a:r>
+              <a:t>Thank you all for a great day. You have been an engaged and thoughtful group, and I am confident you will see real productivity gains starting this week.</a:t>
+            </a:r>
+          </a:p>
+          <a:p>
+            <a:r>
+              <a:t/>
+            </a:r>
+          </a:p>
+          <a:p>
+            <a:r>
+              <a:t>Remember: the key to success with AI is consistency. Use Claude a little every day, iterate your prompts, and build it into your routine. The skills you practiced today become second nature within two to three weeks.</a:t>
+            </a:r>
+          </a:p>
+          <a:p>
+            <a:r>
+              <a:t/>
+            </a:r>
+          </a:p>
+          <a:p>
+            <a:r>
+              <a:t>My contact information is on the screen. Do not hesitate to reach out with questions or success stories. Have a great rest of your day.</a:t>
+            </a:r>
+          </a:p>
+        </p:txBody>
+      </p:sp>
     </p:spTree>
   </p:cSld>
   <p:clrMapOvr>

</xml_diff>

<commit_message>
Day 1: Add Research, Use Style, Canva callouts to speaker notes
Slide 7 (Interface Tour): Research mode — deep multi-step investigation
Slide 33 (Preferences): Use Style — per-conversation style override
Slide 72 (Integrations): Canva — pull designs into Claude
</commit_message>
<xml_diff>
--- a/slides/Day1_Claude_for_Business.pptx
+++ b/slides/Day1_Claude_for_Business.pptx
@@ -6949,6 +6949,10 @@
           </p:nvPr>
         </p:nvSpPr>
         <p:spPr/>
+        <p:txBody>
+          <a:bodyPr/>
+          <a:p/>
+        </p:txBody>
       </p:sp>
       <p:sp>
         <p:nvSpPr>
@@ -6969,9 +6973,7 @@
               <a:t>TIME: 7 min</a:t>
             </a:r>
           </a:p>
-          <a:p>
-            <a:endParaRPr/>
-          </a:p>
+          <a:p/>
           <a:p>
             <a:r>
               <a:t>KEY POINTS:</a:t>
@@ -7012,9 +7014,7 @@
               <a:t>   * Artifacts panel: Appears when Claude generates code, documents, diagrams - you can edit inline</a:t>
             </a:r>
           </a:p>
-          <a:p>
-            <a:endParaRPr/>
-          </a:p>
+          <a:p/>
           <a:p>
             <a:r>
               <a:t>ASK THE CLASS:</a:t>
@@ -7030,9 +7030,7 @@
               <a:t>   [PAUSE for 30-60 seconds]</a:t>
             </a:r>
           </a:p>
-          <a:p>
-            <a:endParaRPr/>
-          </a:p>
+          <a:p/>
           <a:p>
             <a:r>
               <a:t>REAL-WORLD EXAMPLE:</a:t>
@@ -7043,9 +7041,7 @@
               <a:t>   Voice mode example: Instead of typing 'Analyze this sales data, find top 3 trends compared to last quarter, flag any products declining over 15%, create a chart' (takes 30+ seconds to type) - just speak it in 5 seconds. Huge time saver for complex prompts.</a:t>
             </a:r>
           </a:p>
-          <a:p>
-            <a:endParaRPr/>
-          </a:p>
+          <a:p/>
           <a:p>
             <a:r>
               <a:t>DEMO:</a:t>
@@ -7056,9 +7052,7 @@
               <a:t>   LIVE DEMO: Comprehensive UI walkthrough. Open claude.ai, systematically show every UI element students will use: (1) Left sidebar - New chat, Search, Code mode dropdown, Starred/Recents; (2) Chat window - Prompt area, Attachment button (+), Style buttons (Write/Learn/Code/Life stuff/Claude's choice); (3) Top right - Model selector, Voice mode button (microphone icon - emphasize this!); (4) Response area - Artifacts panel. Spend 2 minutes on Voice mode showing the mic button.</a:t>
             </a:r>
           </a:p>
-          <a:p>
-            <a:endParaRPr/>
-          </a:p>
+          <a:p/>
           <a:p>
             <a:r>
               <a:t>TRANSITION:</a:t>
@@ -7067,6 +7061,17 @@
           <a:p>
             <a:r>
               <a:t>   Voice mode is so powerful it deserves its own demo - let's dive deeper</a:t>
+            </a:r>
+          </a:p>
+          <a:p/>
+          <a:p>
+            <a:r>
+              <a:t>[ADDITIONAL CALLOUT: Research Mode]</a:t>
+            </a:r>
+          </a:p>
+          <a:p>
+            <a:r>
+              <a:t>See that Research option in the plus menu? This is Claude's deep research mode. Instead of a quick answer, Claude does multi-step investigation — searches multiple sources, synthesizes findings, takes a few minutes but gives you a thorough briefing. Think of it as assigning a research analyst a question. Great for competitive analysis, market research, or any question where you need depth over speed. We won't lab this today, but try it on your own — ask Claude to research a competitor or an industry trend.</a:t>
             </a:r>
           </a:p>
         </p:txBody>
@@ -7986,6 +7991,10 @@
           </p:nvPr>
         </p:nvSpPr>
         <p:spPr/>
+        <p:txBody>
+          <a:bodyPr/>
+          <a:p/>
+        </p:txBody>
       </p:sp>
       <p:sp>
         <p:nvSpPr>
@@ -8006,9 +8015,7 @@
               <a:t>TIME: 3 min</a:t>
             </a:r>
           </a:p>
-          <a:p>
-            <a:endParaRPr/>
-          </a:p>
+          <a:p/>
           <a:p>
             <a:r>
               <a:t>OPEN WITH:</a:t>
@@ -8019,9 +8026,7 @@
               <a:t>   Instead of uploading files, Claude can read directly from your tools</a:t>
             </a:r>
           </a:p>
-          <a:p>
-            <a:endParaRPr/>
-          </a:p>
+          <a:p/>
           <a:p>
             <a:r>
               <a:t>KEY POINTS:</a:t>
@@ -8047,9 +8052,7 @@
               <a:t>   * Stays in sync with live data</a:t>
             </a:r>
           </a:p>
-          <a:p>
-            <a:endParaRPr/>
-          </a:p>
+          <a:p/>
           <a:p>
             <a:r>
               <a:t>REAL-WORLD EXAMPLE:</a:t>
@@ -8060,9 +8063,7 @@
               <a:t>   Ask 'Review my Google Doc proposal' - Claude opens it, reads it, suggests edits. No download/upload.</a:t>
             </a:r>
           </a:p>
-          <a:p>
-            <a:endParaRPr/>
-          </a:p>
+          <a:p/>
           <a:p>
             <a:r>
               <a:t>TRANSITION:</a:t>
@@ -8071,6 +8072,17 @@
           <a:p>
             <a:r>
               <a:t>   Let's look at each integration</a:t>
+            </a:r>
+          </a:p>
+          <a:p/>
+          <a:p>
+            <a:r>
+              <a:t>[ADDITIONAL CALLOUT: Canva Integration]</a:t>
+            </a:r>
+          </a:p>
+          <a:p>
+            <a:r>
+              <a:t>One integration worth knowing about — Canva. In the plus menu, you'll see 'Add from Canva.' This lets you pull your Canva designs directly into Claude. Why does that matter? You can ask Claude to analyze a marketing flyer, suggest copy improvements, or adapt a design's text for a different audience — all without downloading and uploading files. If your team uses Canva for marketing materials, this is a time-saver.</a:t>
             </a:r>
           </a:p>
         </p:txBody>
@@ -9701,6 +9713,17 @@
           <a:p>
             <a:r>
               <a:t>Let's move on to a brand-new feature that takes personalization even further — Claude's Memory.</a:t>
+            </a:r>
+          </a:p>
+          <a:p/>
+          <a:p>
+            <a:r>
+              <a:t>[ADDITIONAL CALLOUT: Use Style]</a:t>
+            </a:r>
+          </a:p>
+          <a:p>
+            <a:r>
+              <a:t>Quick tip — in the plus menu at the bottom of any chat, you'll see 'Use style.' This lets you apply a preset writing style to that specific conversation. Anthropic includes defaults like Formal, Concise, and Explanatory, but you can also create your own custom styles. Think of it this way: Personal Preferences are your global defaults. Use Style is your per-conversation override. Writing a board report? Switch to Formal. Quick Slack message? Switch to Concise. Preferences set the baseline, styles let you flex.</a:t>
             </a:r>
           </a:p>
         </p:txBody>

</xml_diff>

<commit_message>
Day 1: Add 'Data Analysis Is Storytelling' slide — 5 categories framework
5 cards: Descriptive→Diagnostic→Predictive→Prescriptive→AI
Each with business example (Q4 sales scenario)
Bottom line: 'Claude handles all five. Quality depends on which level you ask for.'
Inserted after Section 3 divider. 89 slides.
</commit_message>
<xml_diff>
--- a/slides/Day1_Claude_for_Business.pptx
+++ b/slides/Day1_Claude_for_Business.pptx
@@ -53,6 +53,7 @@
     <p:sldId id="343" r:id="rId44"/>
     <p:sldId id="298" r:id="rId45"/>
     <p:sldId id="348" r:id="rId46"/>
+    <p:sldId id="356" r:id="rId100"/>
     <p:sldId id="277" r:id="rId47"/>
     <p:sldId id="315" r:id="rId48"/>
     <p:sldId id="279" r:id="rId49"/>
@@ -4480,6 +4481,31 @@
 </p:notes>
 </file>
 
+<file path=ppt/notesSlides/notesSlide31.xml><?xml version="1.0" encoding="utf-8"?>
+<p:notes xmlns:a="http://schemas.openxmlformats.org/drawingml/2006/main" xmlns:p="http://schemas.openxmlformats.org/presentationml/2006/main" xmlns:r="http://schemas.openxmlformats.org/officeDocument/2006/relationships">
+  <p:cSld>
+    <p:spTree>
+      <p:nvGrpSpPr>
+        <p:cNvPr id="1" name=""/>
+        <p:cNvGrpSpPr/>
+        <p:nvPr/>
+      </p:nvGrpSpPr>
+      <p:grpSpPr>
+        <a:xfrm>
+          <a:off x="0" y="0"/>
+          <a:ext cx="0" cy="0"/>
+          <a:chOff x="0" y="0"/>
+          <a:chExt cx="0" cy="0"/>
+        </a:xfrm>
+      </p:grpSpPr>
+    </p:spTree>
+  </p:cSld>
+  <p:clrMapOvr>
+    <a:masterClrMapping/>
+  </p:clrMapOvr>
+</p:notes>
+</file>
+
 <file path=ppt/notesSlides/notesSlide32.xml><?xml version="1.0" encoding="utf-8"?>
 <p:notes xmlns:a="http://schemas.openxmlformats.org/drawingml/2006/main" xmlns:r="http://schemas.openxmlformats.org/officeDocument/2006/relationships" xmlns:p="http://schemas.openxmlformats.org/presentationml/2006/main">
   <p:cSld>
@@ -51332,6 +51358,1082 @@
             </a:pPr>
             <a:r>
               <a:t>scott@aiacopilot.com  •  aiacopilot.com</a:t>
+            </a:r>
+          </a:p>
+        </p:txBody>
+      </p:sp>
+    </p:spTree>
+  </p:cSld>
+  <p:clrMapOvr>
+    <a:masterClrMapping/>
+  </p:clrMapOvr>
+</p:sld>
+</file>
+
+<file path=ppt/slides/slide89.xml><?xml version="1.0" encoding="utf-8"?>
+<p:sld xmlns:a="http://schemas.openxmlformats.org/drawingml/2006/main" xmlns:p="http://schemas.openxmlformats.org/presentationml/2006/main" xmlns:r="http://schemas.openxmlformats.org/officeDocument/2006/relationships">
+  <p:cSld>
+    <p:bg>
+      <p:bgPr>
+        <a:solidFill>
+          <a:srgbClr val="0B0F1A"/>
+        </a:solidFill>
+        <a:effectLst/>
+      </p:bgPr>
+    </p:bg>
+    <p:spTree>
+      <p:nvGrpSpPr>
+        <p:cNvPr id="1" name=""/>
+        <p:cNvGrpSpPr/>
+        <p:nvPr/>
+      </p:nvGrpSpPr>
+      <p:grpSpPr/>
+      <p:sp>
+        <p:nvSpPr>
+          <p:cNvPr id="2" name="TextBox 1"/>
+          <p:cNvSpPr txBox="1"/>
+          <p:nvPr/>
+        </p:nvSpPr>
+        <p:spPr>
+          <a:xfrm>
+            <a:off x="457200" y="274320"/>
+            <a:ext cx="11247120" cy="822960"/>
+          </a:xfrm>
+          <a:prstGeom prst="rect">
+            <a:avLst/>
+          </a:prstGeom>
+          <a:noFill/>
+        </p:spPr>
+        <p:txBody>
+          <a:bodyPr wrap="none">
+            <a:spAutoFit/>
+          </a:bodyPr>
+          <a:lstStyle/>
+          <a:p>
+            <a:pPr>
+              <a:defRPr sz="4000" b="1">
+                <a:solidFill>
+                  <a:srgbClr val="FFFFFF"/>
+                </a:solidFill>
+              </a:defRPr>
+            </a:pPr>
+            <a:r>
+              <a:t>Data Analysis Is Storytelling</a:t>
+            </a:r>
+          </a:p>
+        </p:txBody>
+      </p:sp>
+      <p:sp>
+        <p:nvSpPr>
+          <p:cNvPr id="3" name="TextBox 2"/>
+          <p:cNvSpPr txBox="1"/>
+          <p:nvPr/>
+        </p:nvSpPr>
+        <p:spPr>
+          <a:xfrm>
+            <a:off x="457200" y="1005840"/>
+            <a:ext cx="11247120" cy="457200"/>
+          </a:xfrm>
+          <a:prstGeom prst="rect">
+            <a:avLst/>
+          </a:prstGeom>
+          <a:noFill/>
+        </p:spPr>
+        <p:txBody>
+          <a:bodyPr wrap="none">
+            <a:spAutoFit/>
+          </a:bodyPr>
+          <a:lstStyle/>
+          <a:p>
+            <a:pPr>
+              <a:defRPr sz="1800" i="1">
+                <a:solidFill>
+                  <a:srgbClr val="9CA3AF"/>
+                </a:solidFill>
+              </a:defRPr>
+            </a:pPr>
+            <a:r>
+              <a:t>Know what to ask for — most people stop at level one</a:t>
+            </a:r>
+          </a:p>
+        </p:txBody>
+      </p:sp>
+      <p:sp>
+        <p:nvSpPr>
+          <p:cNvPr id="4" name="Rounded Rectangle 3"/>
+          <p:cNvSpPr/>
+          <p:nvPr/>
+        </p:nvSpPr>
+        <p:spPr>
+          <a:xfrm>
+            <a:off x="274320" y="1737360"/>
+            <a:ext cx="2103120" cy="3931920"/>
+          </a:xfrm>
+          <a:prstGeom prst="roundRect">
+            <a:avLst/>
+          </a:prstGeom>
+          <a:solidFill>
+            <a:srgbClr val="141A2A"/>
+          </a:solidFill>
+          <a:ln w="19050">
+            <a:solidFill>
+              <a:srgbClr val="14B8A6"/>
+            </a:solidFill>
+          </a:ln>
+        </p:spPr>
+        <p:style>
+          <a:lnRef idx="1">
+            <a:schemeClr val="accent1"/>
+          </a:lnRef>
+          <a:fillRef idx="3">
+            <a:schemeClr val="accent1"/>
+          </a:fillRef>
+          <a:effectRef idx="2">
+            <a:schemeClr val="accent1"/>
+          </a:effectRef>
+          <a:fontRef idx="minor">
+            <a:schemeClr val="lt1"/>
+          </a:fontRef>
+        </p:style>
+        <p:txBody>
+          <a:bodyPr rtlCol="0" anchor="ctr"/>
+          <a:lstStyle/>
+          <a:p>
+            <a:pPr algn="ctr"/>
+          </a:p>
+        </p:txBody>
+      </p:sp>
+      <p:sp>
+        <p:nvSpPr>
+          <p:cNvPr id="5" name="TextBox 4"/>
+          <p:cNvSpPr txBox="1"/>
+          <p:nvPr/>
+        </p:nvSpPr>
+        <p:spPr>
+          <a:xfrm>
+            <a:off x="365760" y="1920240"/>
+            <a:ext cx="1920240" cy="457200"/>
+          </a:xfrm>
+          <a:prstGeom prst="rect">
+            <a:avLst/>
+          </a:prstGeom>
+          <a:noFill/>
+        </p:spPr>
+        <p:txBody>
+          <a:bodyPr wrap="none">
+            <a:spAutoFit/>
+          </a:bodyPr>
+          <a:lstStyle/>
+          <a:p>
+            <a:pPr algn="ctr">
+              <a:defRPr sz="2800"/>
+            </a:pPr>
+            <a:r>
+              <a:t>📊</a:t>
+            </a:r>
+          </a:p>
+        </p:txBody>
+      </p:sp>
+      <p:sp>
+        <p:nvSpPr>
+          <p:cNvPr id="6" name="TextBox 5"/>
+          <p:cNvSpPr txBox="1"/>
+          <p:nvPr/>
+        </p:nvSpPr>
+        <p:spPr>
+          <a:xfrm>
+            <a:off x="365760" y="2377440"/>
+            <a:ext cx="1920240" cy="365760"/>
+          </a:xfrm>
+          <a:prstGeom prst="rect">
+            <a:avLst/>
+          </a:prstGeom>
+          <a:noFill/>
+        </p:spPr>
+        <p:txBody>
+          <a:bodyPr wrap="none">
+            <a:spAutoFit/>
+          </a:bodyPr>
+          <a:lstStyle/>
+          <a:p>
+            <a:pPr algn="ctr">
+              <a:defRPr sz="1800" b="1">
+                <a:solidFill>
+                  <a:srgbClr val="FFFFFF"/>
+                </a:solidFill>
+              </a:defRPr>
+            </a:pPr>
+            <a:r>
+              <a:t>Descriptive</a:t>
+            </a:r>
+          </a:p>
+        </p:txBody>
+      </p:sp>
+      <p:sp>
+        <p:nvSpPr>
+          <p:cNvPr id="7" name="TextBox 6"/>
+          <p:cNvSpPr txBox="1"/>
+          <p:nvPr/>
+        </p:nvSpPr>
+        <p:spPr>
+          <a:xfrm>
+            <a:off x="365760" y="2743200"/>
+            <a:ext cx="1920240" cy="365760"/>
+          </a:xfrm>
+          <a:prstGeom prst="rect">
+            <a:avLst/>
+          </a:prstGeom>
+          <a:noFill/>
+        </p:spPr>
+        <p:txBody>
+          <a:bodyPr wrap="none">
+            <a:spAutoFit/>
+          </a:bodyPr>
+          <a:lstStyle/>
+          <a:p>
+            <a:pPr algn="ctr">
+              <a:defRPr sz="1200" i="1">
+                <a:solidFill>
+                  <a:srgbClr val="14B8A6"/>
+                </a:solidFill>
+              </a:defRPr>
+            </a:pPr>
+            <a:r>
+              <a:t>Summarize past data</a:t>
+            </a:r>
+          </a:p>
+        </p:txBody>
+      </p:sp>
+      <p:sp>
+        <p:nvSpPr>
+          <p:cNvPr id="8" name="TextBox 7"/>
+          <p:cNvSpPr txBox="1"/>
+          <p:nvPr/>
+        </p:nvSpPr>
+        <p:spPr>
+          <a:xfrm>
+            <a:off x="365760" y="3200400"/>
+            <a:ext cx="1920240" cy="2194560"/>
+          </a:xfrm>
+          <a:prstGeom prst="rect">
+            <a:avLst/>
+          </a:prstGeom>
+          <a:noFill/>
+        </p:spPr>
+        <p:txBody>
+          <a:bodyPr wrap="square">
+            <a:spAutoFit/>
+          </a:bodyPr>
+          <a:lstStyle/>
+          <a:p>
+            <a:pPr algn="ctr">
+              <a:defRPr sz="1200">
+                <a:solidFill>
+                  <a:srgbClr val="D1D5DB"/>
+                </a:solidFill>
+              </a:defRPr>
+            </a:pPr>
+            <a:r>
+              <a:t>"What happened?"</a:t>
+            </a:r>
+            <a:br/>
+            <a:r>
+              <a:t>Q4 revenue was $2.1M</a:t>
+            </a:r>
+            <a:br/>
+            <a:r>
+              <a:t>across 4 regions</a:t>
+            </a:r>
+          </a:p>
+        </p:txBody>
+      </p:sp>
+      <p:sp>
+        <p:nvSpPr>
+          <p:cNvPr id="9" name="Rounded Rectangle 8"/>
+          <p:cNvSpPr/>
+          <p:nvPr/>
+        </p:nvSpPr>
+        <p:spPr>
+          <a:xfrm>
+            <a:off x="2560320" y="1737360"/>
+            <a:ext cx="2103120" cy="3931920"/>
+          </a:xfrm>
+          <a:prstGeom prst="roundRect">
+            <a:avLst/>
+          </a:prstGeom>
+          <a:solidFill>
+            <a:srgbClr val="141A2A"/>
+          </a:solidFill>
+          <a:ln w="19050">
+            <a:solidFill>
+              <a:srgbClr val="14B8A6"/>
+            </a:solidFill>
+          </a:ln>
+        </p:spPr>
+        <p:style>
+          <a:lnRef idx="1">
+            <a:schemeClr val="accent1"/>
+          </a:lnRef>
+          <a:fillRef idx="3">
+            <a:schemeClr val="accent1"/>
+          </a:fillRef>
+          <a:effectRef idx="2">
+            <a:schemeClr val="accent1"/>
+          </a:effectRef>
+          <a:fontRef idx="minor">
+            <a:schemeClr val="lt1"/>
+          </a:fontRef>
+        </p:style>
+        <p:txBody>
+          <a:bodyPr rtlCol="0" anchor="ctr"/>
+          <a:lstStyle/>
+          <a:p>
+            <a:pPr algn="ctr"/>
+          </a:p>
+        </p:txBody>
+      </p:sp>
+      <p:sp>
+        <p:nvSpPr>
+          <p:cNvPr id="10" name="TextBox 9"/>
+          <p:cNvSpPr txBox="1"/>
+          <p:nvPr/>
+        </p:nvSpPr>
+        <p:spPr>
+          <a:xfrm>
+            <a:off x="2651760" y="1920240"/>
+            <a:ext cx="1920240" cy="457200"/>
+          </a:xfrm>
+          <a:prstGeom prst="rect">
+            <a:avLst/>
+          </a:prstGeom>
+          <a:noFill/>
+        </p:spPr>
+        <p:txBody>
+          <a:bodyPr wrap="none">
+            <a:spAutoFit/>
+          </a:bodyPr>
+          <a:lstStyle/>
+          <a:p>
+            <a:pPr algn="ctr">
+              <a:defRPr sz="2800"/>
+            </a:pPr>
+            <a:r>
+              <a:t>🔍</a:t>
+            </a:r>
+          </a:p>
+        </p:txBody>
+      </p:sp>
+      <p:sp>
+        <p:nvSpPr>
+          <p:cNvPr id="11" name="TextBox 10"/>
+          <p:cNvSpPr txBox="1"/>
+          <p:nvPr/>
+        </p:nvSpPr>
+        <p:spPr>
+          <a:xfrm>
+            <a:off x="2651760" y="2377440"/>
+            <a:ext cx="1920240" cy="365760"/>
+          </a:xfrm>
+          <a:prstGeom prst="rect">
+            <a:avLst/>
+          </a:prstGeom>
+          <a:noFill/>
+        </p:spPr>
+        <p:txBody>
+          <a:bodyPr wrap="none">
+            <a:spAutoFit/>
+          </a:bodyPr>
+          <a:lstStyle/>
+          <a:p>
+            <a:pPr algn="ctr">
+              <a:defRPr sz="1800" b="1">
+                <a:solidFill>
+                  <a:srgbClr val="FFFFFF"/>
+                </a:solidFill>
+              </a:defRPr>
+            </a:pPr>
+            <a:r>
+              <a:t>Diagnostic</a:t>
+            </a:r>
+          </a:p>
+        </p:txBody>
+      </p:sp>
+      <p:sp>
+        <p:nvSpPr>
+          <p:cNvPr id="12" name="TextBox 11"/>
+          <p:cNvSpPr txBox="1"/>
+          <p:nvPr/>
+        </p:nvSpPr>
+        <p:spPr>
+          <a:xfrm>
+            <a:off x="2651760" y="2743200"/>
+            <a:ext cx="1920240" cy="365760"/>
+          </a:xfrm>
+          <a:prstGeom prst="rect">
+            <a:avLst/>
+          </a:prstGeom>
+          <a:noFill/>
+        </p:spPr>
+        <p:txBody>
+          <a:bodyPr wrap="none">
+            <a:spAutoFit/>
+          </a:bodyPr>
+          <a:lstStyle/>
+          <a:p>
+            <a:pPr algn="ctr">
+              <a:defRPr sz="1200" i="1">
+                <a:solidFill>
+                  <a:srgbClr val="14B8A6"/>
+                </a:solidFill>
+              </a:defRPr>
+            </a:pPr>
+            <a:r>
+              <a:t>Explain past data</a:t>
+            </a:r>
+          </a:p>
+        </p:txBody>
+      </p:sp>
+      <p:sp>
+        <p:nvSpPr>
+          <p:cNvPr id="13" name="TextBox 12"/>
+          <p:cNvSpPr txBox="1"/>
+          <p:nvPr/>
+        </p:nvSpPr>
+        <p:spPr>
+          <a:xfrm>
+            <a:off x="2651760" y="3200400"/>
+            <a:ext cx="1920240" cy="2194560"/>
+          </a:xfrm>
+          <a:prstGeom prst="rect">
+            <a:avLst/>
+          </a:prstGeom>
+          <a:noFill/>
+        </p:spPr>
+        <p:txBody>
+          <a:bodyPr wrap="square">
+            <a:spAutoFit/>
+          </a:bodyPr>
+          <a:lstStyle/>
+          <a:p>
+            <a:pPr algn="ctr">
+              <a:defRPr sz="1200">
+                <a:solidFill>
+                  <a:srgbClr val="D1D5DB"/>
+                </a:solidFill>
+              </a:defRPr>
+            </a:pPr>
+            <a:r>
+              <a:t>"Why did it happen?"</a:t>
+            </a:r>
+            <a:br/>
+            <a:r>
+              <a:t>Northeast dropped 15%</a:t>
+            </a:r>
+            <a:br/>
+            <a:r>
+              <a:t>due to rep turnover</a:t>
+            </a:r>
+          </a:p>
+        </p:txBody>
+      </p:sp>
+      <p:sp>
+        <p:nvSpPr>
+          <p:cNvPr id="14" name="Rounded Rectangle 13"/>
+          <p:cNvSpPr/>
+          <p:nvPr/>
+        </p:nvSpPr>
+        <p:spPr>
+          <a:xfrm>
+            <a:off x="4846320" y="1737360"/>
+            <a:ext cx="2103120" cy="3931920"/>
+          </a:xfrm>
+          <a:prstGeom prst="roundRect">
+            <a:avLst/>
+          </a:prstGeom>
+          <a:solidFill>
+            <a:srgbClr val="141A2A"/>
+          </a:solidFill>
+          <a:ln w="19050">
+            <a:solidFill>
+              <a:srgbClr val="14B8A6"/>
+            </a:solidFill>
+          </a:ln>
+        </p:spPr>
+        <p:style>
+          <a:lnRef idx="1">
+            <a:schemeClr val="accent1"/>
+          </a:lnRef>
+          <a:fillRef idx="3">
+            <a:schemeClr val="accent1"/>
+          </a:fillRef>
+          <a:effectRef idx="2">
+            <a:schemeClr val="accent1"/>
+          </a:effectRef>
+          <a:fontRef idx="minor">
+            <a:schemeClr val="lt1"/>
+          </a:fontRef>
+        </p:style>
+        <p:txBody>
+          <a:bodyPr rtlCol="0" anchor="ctr"/>
+          <a:lstStyle/>
+          <a:p>
+            <a:pPr algn="ctr"/>
+          </a:p>
+        </p:txBody>
+      </p:sp>
+      <p:sp>
+        <p:nvSpPr>
+          <p:cNvPr id="15" name="TextBox 14"/>
+          <p:cNvSpPr txBox="1"/>
+          <p:nvPr/>
+        </p:nvSpPr>
+        <p:spPr>
+          <a:xfrm>
+            <a:off x="4937759" y="1920240"/>
+            <a:ext cx="1920240" cy="457200"/>
+          </a:xfrm>
+          <a:prstGeom prst="rect">
+            <a:avLst/>
+          </a:prstGeom>
+          <a:noFill/>
+        </p:spPr>
+        <p:txBody>
+          <a:bodyPr wrap="none">
+            <a:spAutoFit/>
+          </a:bodyPr>
+          <a:lstStyle/>
+          <a:p>
+            <a:pPr algn="ctr">
+              <a:defRPr sz="2800"/>
+            </a:pPr>
+            <a:r>
+              <a:t>📈</a:t>
+            </a:r>
+          </a:p>
+        </p:txBody>
+      </p:sp>
+      <p:sp>
+        <p:nvSpPr>
+          <p:cNvPr id="16" name="TextBox 15"/>
+          <p:cNvSpPr txBox="1"/>
+          <p:nvPr/>
+        </p:nvSpPr>
+        <p:spPr>
+          <a:xfrm>
+            <a:off x="4937759" y="2377440"/>
+            <a:ext cx="1920240" cy="365760"/>
+          </a:xfrm>
+          <a:prstGeom prst="rect">
+            <a:avLst/>
+          </a:prstGeom>
+          <a:noFill/>
+        </p:spPr>
+        <p:txBody>
+          <a:bodyPr wrap="none">
+            <a:spAutoFit/>
+          </a:bodyPr>
+          <a:lstStyle/>
+          <a:p>
+            <a:pPr algn="ctr">
+              <a:defRPr sz="1800" b="1">
+                <a:solidFill>
+                  <a:srgbClr val="FFFFFF"/>
+                </a:solidFill>
+              </a:defRPr>
+            </a:pPr>
+            <a:r>
+              <a:t>Predictive</a:t>
+            </a:r>
+          </a:p>
+        </p:txBody>
+      </p:sp>
+      <p:sp>
+        <p:nvSpPr>
+          <p:cNvPr id="17" name="TextBox 16"/>
+          <p:cNvSpPr txBox="1"/>
+          <p:nvPr/>
+        </p:nvSpPr>
+        <p:spPr>
+          <a:xfrm>
+            <a:off x="4937759" y="2743200"/>
+            <a:ext cx="1920240" cy="365760"/>
+          </a:xfrm>
+          <a:prstGeom prst="rect">
+            <a:avLst/>
+          </a:prstGeom>
+          <a:noFill/>
+        </p:spPr>
+        <p:txBody>
+          <a:bodyPr wrap="none">
+            <a:spAutoFit/>
+          </a:bodyPr>
+          <a:lstStyle/>
+          <a:p>
+            <a:pPr algn="ctr">
+              <a:defRPr sz="1200" i="1">
+                <a:solidFill>
+                  <a:srgbClr val="14B8A6"/>
+                </a:solidFill>
+              </a:defRPr>
+            </a:pPr>
+            <a:r>
+              <a:t>Forecast future data</a:t>
+            </a:r>
+          </a:p>
+        </p:txBody>
+      </p:sp>
+      <p:sp>
+        <p:nvSpPr>
+          <p:cNvPr id="18" name="TextBox 17"/>
+          <p:cNvSpPr txBox="1"/>
+          <p:nvPr/>
+        </p:nvSpPr>
+        <p:spPr>
+          <a:xfrm>
+            <a:off x="4937759" y="3200400"/>
+            <a:ext cx="1920240" cy="2194560"/>
+          </a:xfrm>
+          <a:prstGeom prst="rect">
+            <a:avLst/>
+          </a:prstGeom>
+          <a:noFill/>
+        </p:spPr>
+        <p:txBody>
+          <a:bodyPr wrap="square">
+            <a:spAutoFit/>
+          </a:bodyPr>
+          <a:lstStyle/>
+          <a:p>
+            <a:pPr algn="ctr">
+              <a:defRPr sz="1200">
+                <a:solidFill>
+                  <a:srgbClr val="D1D5DB"/>
+                </a:solidFill>
+              </a:defRPr>
+            </a:pPr>
+            <a:r>
+              <a:t>"What will happen?"</a:t>
+            </a:r>
+            <a:br/>
+            <a:r>
+              <a:t>Q1 forecast: $2.4M</a:t>
+            </a:r>
+            <a:br/>
+            <a:r>
+              <a:t>based on pipeline</a:t>
+            </a:r>
+          </a:p>
+        </p:txBody>
+      </p:sp>
+      <p:sp>
+        <p:nvSpPr>
+          <p:cNvPr id="19" name="Rounded Rectangle 18"/>
+          <p:cNvSpPr/>
+          <p:nvPr/>
+        </p:nvSpPr>
+        <p:spPr>
+          <a:xfrm>
+            <a:off x="7132320" y="1737360"/>
+            <a:ext cx="2103120" cy="3931920"/>
+          </a:xfrm>
+          <a:prstGeom prst="roundRect">
+            <a:avLst/>
+          </a:prstGeom>
+          <a:solidFill>
+            <a:srgbClr val="141A2A"/>
+          </a:solidFill>
+          <a:ln w="19050">
+            <a:solidFill>
+              <a:srgbClr val="14B8A6"/>
+            </a:solidFill>
+          </a:ln>
+        </p:spPr>
+        <p:style>
+          <a:lnRef idx="1">
+            <a:schemeClr val="accent1"/>
+          </a:lnRef>
+          <a:fillRef idx="3">
+            <a:schemeClr val="accent1"/>
+          </a:fillRef>
+          <a:effectRef idx="2">
+            <a:schemeClr val="accent1"/>
+          </a:effectRef>
+          <a:fontRef idx="minor">
+            <a:schemeClr val="lt1"/>
+          </a:fontRef>
+        </p:style>
+        <p:txBody>
+          <a:bodyPr rtlCol="0" anchor="ctr"/>
+          <a:lstStyle/>
+          <a:p>
+            <a:pPr algn="ctr"/>
+          </a:p>
+        </p:txBody>
+      </p:sp>
+      <p:sp>
+        <p:nvSpPr>
+          <p:cNvPr id="20" name="TextBox 19"/>
+          <p:cNvSpPr txBox="1"/>
+          <p:nvPr/>
+        </p:nvSpPr>
+        <p:spPr>
+          <a:xfrm>
+            <a:off x="7223759" y="1920240"/>
+            <a:ext cx="1920240" cy="457200"/>
+          </a:xfrm>
+          <a:prstGeom prst="rect">
+            <a:avLst/>
+          </a:prstGeom>
+          <a:noFill/>
+        </p:spPr>
+        <p:txBody>
+          <a:bodyPr wrap="none">
+            <a:spAutoFit/>
+          </a:bodyPr>
+          <a:lstStyle/>
+          <a:p>
+            <a:pPr algn="ctr">
+              <a:defRPr sz="2800"/>
+            </a:pPr>
+            <a:r>
+              <a:t>💡</a:t>
+            </a:r>
+          </a:p>
+        </p:txBody>
+      </p:sp>
+      <p:sp>
+        <p:nvSpPr>
+          <p:cNvPr id="21" name="TextBox 20"/>
+          <p:cNvSpPr txBox="1"/>
+          <p:nvPr/>
+        </p:nvSpPr>
+        <p:spPr>
+          <a:xfrm>
+            <a:off x="7223759" y="2377440"/>
+            <a:ext cx="1920240" cy="365760"/>
+          </a:xfrm>
+          <a:prstGeom prst="rect">
+            <a:avLst/>
+          </a:prstGeom>
+          <a:noFill/>
+        </p:spPr>
+        <p:txBody>
+          <a:bodyPr wrap="none">
+            <a:spAutoFit/>
+          </a:bodyPr>
+          <a:lstStyle/>
+          <a:p>
+            <a:pPr algn="ctr">
+              <a:defRPr sz="1800" b="1">
+                <a:solidFill>
+                  <a:srgbClr val="FFFFFF"/>
+                </a:solidFill>
+              </a:defRPr>
+            </a:pPr>
+            <a:r>
+              <a:t>Prescriptive</a:t>
+            </a:r>
+          </a:p>
+        </p:txBody>
+      </p:sp>
+      <p:sp>
+        <p:nvSpPr>
+          <p:cNvPr id="22" name="TextBox 21"/>
+          <p:cNvSpPr txBox="1"/>
+          <p:nvPr/>
+        </p:nvSpPr>
+        <p:spPr>
+          <a:xfrm>
+            <a:off x="7223759" y="2743200"/>
+            <a:ext cx="1920240" cy="365760"/>
+          </a:xfrm>
+          <a:prstGeom prst="rect">
+            <a:avLst/>
+          </a:prstGeom>
+          <a:noFill/>
+        </p:spPr>
+        <p:txBody>
+          <a:bodyPr wrap="none">
+            <a:spAutoFit/>
+          </a:bodyPr>
+          <a:lstStyle/>
+          <a:p>
+            <a:pPr algn="ctr">
+              <a:defRPr sz="1200" i="1">
+                <a:solidFill>
+                  <a:srgbClr val="14B8A6"/>
+                </a:solidFill>
+              </a:defRPr>
+            </a:pPr>
+            <a:r>
+              <a:t>Optimize future data</a:t>
+            </a:r>
+          </a:p>
+        </p:txBody>
+      </p:sp>
+      <p:sp>
+        <p:nvSpPr>
+          <p:cNvPr id="23" name="TextBox 22"/>
+          <p:cNvSpPr txBox="1"/>
+          <p:nvPr/>
+        </p:nvSpPr>
+        <p:spPr>
+          <a:xfrm>
+            <a:off x="7223759" y="3200400"/>
+            <a:ext cx="1920240" cy="2194560"/>
+          </a:xfrm>
+          <a:prstGeom prst="rect">
+            <a:avLst/>
+          </a:prstGeom>
+          <a:noFill/>
+        </p:spPr>
+        <p:txBody>
+          <a:bodyPr wrap="square">
+            <a:spAutoFit/>
+          </a:bodyPr>
+          <a:lstStyle/>
+          <a:p>
+            <a:pPr algn="ctr">
+              <a:defRPr sz="1200">
+                <a:solidFill>
+                  <a:srgbClr val="D1D5DB"/>
+                </a:solidFill>
+              </a:defRPr>
+            </a:pPr>
+            <a:r>
+              <a:t>"What should we do?"</a:t>
+            </a:r>
+            <a:br/>
+            <a:r>
+              <a:t>Reallocate territory,</a:t>
+            </a:r>
+            <a:br/>
+            <a:r>
+              <a:t>hire 2 reps in NE</a:t>
+            </a:r>
+          </a:p>
+        </p:txBody>
+      </p:sp>
+      <p:sp>
+        <p:nvSpPr>
+          <p:cNvPr id="24" name="Rounded Rectangle 23"/>
+          <p:cNvSpPr/>
+          <p:nvPr/>
+        </p:nvSpPr>
+        <p:spPr>
+          <a:xfrm>
+            <a:off x="9418320" y="1737360"/>
+            <a:ext cx="2103120" cy="3931920"/>
+          </a:xfrm>
+          <a:prstGeom prst="roundRect">
+            <a:avLst/>
+          </a:prstGeom>
+          <a:solidFill>
+            <a:srgbClr val="141A2A"/>
+          </a:solidFill>
+          <a:ln w="19050">
+            <a:solidFill>
+              <a:srgbClr val="14B8A6"/>
+            </a:solidFill>
+          </a:ln>
+        </p:spPr>
+        <p:style>
+          <a:lnRef idx="1">
+            <a:schemeClr val="accent1"/>
+          </a:lnRef>
+          <a:fillRef idx="3">
+            <a:schemeClr val="accent1"/>
+          </a:fillRef>
+          <a:effectRef idx="2">
+            <a:schemeClr val="accent1"/>
+          </a:effectRef>
+          <a:fontRef idx="minor">
+            <a:schemeClr val="lt1"/>
+          </a:fontRef>
+        </p:style>
+        <p:txBody>
+          <a:bodyPr rtlCol="0" anchor="ctr"/>
+          <a:lstStyle/>
+          <a:p>
+            <a:pPr algn="ctr"/>
+          </a:p>
+        </p:txBody>
+      </p:sp>
+      <p:sp>
+        <p:nvSpPr>
+          <p:cNvPr id="25" name="TextBox 24"/>
+          <p:cNvSpPr txBox="1"/>
+          <p:nvPr/>
+        </p:nvSpPr>
+        <p:spPr>
+          <a:xfrm>
+            <a:off x="9509760" y="1920240"/>
+            <a:ext cx="1920240" cy="457200"/>
+          </a:xfrm>
+          <a:prstGeom prst="rect">
+            <a:avLst/>
+          </a:prstGeom>
+          <a:noFill/>
+        </p:spPr>
+        <p:txBody>
+          <a:bodyPr wrap="none">
+            <a:spAutoFit/>
+          </a:bodyPr>
+          <a:lstStyle/>
+          <a:p>
+            <a:pPr algn="ctr">
+              <a:defRPr sz="2800"/>
+            </a:pPr>
+            <a:r>
+              <a:t>🤖</a:t>
+            </a:r>
+          </a:p>
+        </p:txBody>
+      </p:sp>
+      <p:sp>
+        <p:nvSpPr>
+          <p:cNvPr id="26" name="TextBox 25"/>
+          <p:cNvSpPr txBox="1"/>
+          <p:nvPr/>
+        </p:nvSpPr>
+        <p:spPr>
+          <a:xfrm>
+            <a:off x="9509760" y="2377440"/>
+            <a:ext cx="1920240" cy="365760"/>
+          </a:xfrm>
+          <a:prstGeom prst="rect">
+            <a:avLst/>
+          </a:prstGeom>
+          <a:noFill/>
+        </p:spPr>
+        <p:txBody>
+          <a:bodyPr wrap="none">
+            <a:spAutoFit/>
+          </a:bodyPr>
+          <a:lstStyle/>
+          <a:p>
+            <a:pPr algn="ctr">
+              <a:defRPr sz="1800" b="1">
+                <a:solidFill>
+                  <a:srgbClr val="FFFFFF"/>
+                </a:solidFill>
+              </a:defRPr>
+            </a:pPr>
+            <a:r>
+              <a:t>AI</a:t>
+            </a:r>
+          </a:p>
+        </p:txBody>
+      </p:sp>
+      <p:sp>
+        <p:nvSpPr>
+          <p:cNvPr id="27" name="TextBox 26"/>
+          <p:cNvSpPr txBox="1"/>
+          <p:nvPr/>
+        </p:nvSpPr>
+        <p:spPr>
+          <a:xfrm>
+            <a:off x="9509760" y="2743200"/>
+            <a:ext cx="1920240" cy="365760"/>
+          </a:xfrm>
+          <a:prstGeom prst="rect">
+            <a:avLst/>
+          </a:prstGeom>
+          <a:noFill/>
+        </p:spPr>
+        <p:txBody>
+          <a:bodyPr wrap="none">
+            <a:spAutoFit/>
+          </a:bodyPr>
+          <a:lstStyle/>
+          <a:p>
+            <a:pPr algn="ctr">
+              <a:defRPr sz="1200" i="1">
+                <a:solidFill>
+                  <a:srgbClr val="14B8A6"/>
+                </a:solidFill>
+              </a:defRPr>
+            </a:pPr>
+            <a:r>
+              <a:t>Learn from data</a:t>
+            </a:r>
+          </a:p>
+        </p:txBody>
+      </p:sp>
+      <p:sp>
+        <p:nvSpPr>
+          <p:cNvPr id="28" name="TextBox 27"/>
+          <p:cNvSpPr txBox="1"/>
+          <p:nvPr/>
+        </p:nvSpPr>
+        <p:spPr>
+          <a:xfrm>
+            <a:off x="9509760" y="3200400"/>
+            <a:ext cx="1920240" cy="2194560"/>
+          </a:xfrm>
+          <a:prstGeom prst="rect">
+            <a:avLst/>
+          </a:prstGeom>
+          <a:noFill/>
+        </p:spPr>
+        <p:txBody>
+          <a:bodyPr wrap="square">
+            <a:spAutoFit/>
+          </a:bodyPr>
+          <a:lstStyle/>
+          <a:p>
+            <a:pPr algn="ctr">
+              <a:defRPr sz="1200">
+                <a:solidFill>
+                  <a:srgbClr val="D1D5DB"/>
+                </a:solidFill>
+              </a:defRPr>
+            </a:pPr>
+            <a:r>
+              <a:t>"What patterns exist?"</a:t>
+            </a:r>
+            <a:br/>
+            <a:r>
+              <a:t>3-year trend shows</a:t>
+            </a:r>
+            <a:br/>
+            <a:r>
+              <a:t>Q4 always dips 8-12%</a:t>
+            </a:r>
+          </a:p>
+        </p:txBody>
+      </p:sp>
+      <p:sp>
+        <p:nvSpPr>
+          <p:cNvPr id="29" name="TextBox 28"/>
+          <p:cNvSpPr txBox="1"/>
+          <p:nvPr/>
+        </p:nvSpPr>
+        <p:spPr>
+          <a:xfrm>
+            <a:off x="457200" y="5760720"/>
+            <a:ext cx="11247120" cy="365760"/>
+          </a:xfrm>
+          <a:prstGeom prst="rect">
+            <a:avLst/>
+          </a:prstGeom>
+          <a:noFill/>
+        </p:spPr>
+        <p:txBody>
+          <a:bodyPr wrap="none">
+            <a:spAutoFit/>
+          </a:bodyPr>
+          <a:lstStyle/>
+          <a:p>
+            <a:pPr algn="ctr">
+              <a:defRPr sz="1500" i="1">
+                <a:solidFill>
+                  <a:srgbClr val="14B8A6"/>
+                </a:solidFill>
+              </a:defRPr>
+            </a:pPr>
+            <a:r>
+              <a:t>Claude handles all five levels. The quality of your analysis depends on which level you ask for.</a:t>
             </a:r>
           </a:p>
         </p:txBody>

</xml_diff>

<commit_message>
Day 1: Add 3 Cowork slides — file operations, Done framework, AI Employee mindset
1. Claude Cowork: AI That Produces Actual Files (4 cards: file ops, real docs, research synthesis, AI employee)
2. The 'Done' Framework (3 questions: what does done look like, context, constraints)
3. The AI Employee Mindset (chatbot thinking vs delegation thinking)

Inserted before Lab 4 in Section 4. Day 1 now 97 slides.
Source: Claude Cowork Complete Guide.
</commit_message>
<xml_diff>
--- a/slides/Day1_Claude_for_Business.pptx
+++ b/slides/Day1_Claude_for_Business.pptx
@@ -90,6 +90,9 @@
     <p:sldId id="358" r:id="rId102"/>
     <p:sldId id="359" r:id="rId103"/>
     <p:sldId id="360" r:id="rId104"/>
+    <p:sldId id="362" r:id="rId106"/>
+    <p:sldId id="363" r:id="rId107"/>
+    <p:sldId id="364" r:id="rId108"/>
     <p:sldId id="361" r:id="rId105"/>
     <p:sldId id="325" r:id="rId77"/>
     <p:sldId id="326" r:id="rId78"/>
@@ -11436,6 +11439,81 @@
 </p:notes>
 </file>
 
+<file path=ppt/notesSlides/notesSlide95.xml><?xml version="1.0" encoding="utf-8"?>
+<p:notes xmlns:a="http://schemas.openxmlformats.org/drawingml/2006/main" xmlns:p="http://schemas.openxmlformats.org/presentationml/2006/main" xmlns:r="http://schemas.openxmlformats.org/officeDocument/2006/relationships">
+  <p:cSld>
+    <p:spTree>
+      <p:nvGrpSpPr>
+        <p:cNvPr id="1" name=""/>
+        <p:cNvGrpSpPr/>
+        <p:nvPr/>
+      </p:nvGrpSpPr>
+      <p:grpSpPr>
+        <a:xfrm>
+          <a:off x="0" y="0"/>
+          <a:ext cx="0" cy="0"/>
+          <a:chOff x="0" y="0"/>
+          <a:chExt cx="0" cy="0"/>
+        </a:xfrm>
+      </p:grpSpPr>
+    </p:spTree>
+  </p:cSld>
+  <p:clrMapOvr>
+    <a:masterClrMapping/>
+  </p:clrMapOvr>
+</p:notes>
+</file>
+
+<file path=ppt/notesSlides/notesSlide96.xml><?xml version="1.0" encoding="utf-8"?>
+<p:notes xmlns:a="http://schemas.openxmlformats.org/drawingml/2006/main" xmlns:p="http://schemas.openxmlformats.org/presentationml/2006/main" xmlns:r="http://schemas.openxmlformats.org/officeDocument/2006/relationships">
+  <p:cSld>
+    <p:spTree>
+      <p:nvGrpSpPr>
+        <p:cNvPr id="1" name=""/>
+        <p:cNvGrpSpPr/>
+        <p:nvPr/>
+      </p:nvGrpSpPr>
+      <p:grpSpPr>
+        <a:xfrm>
+          <a:off x="0" y="0"/>
+          <a:ext cx="0" cy="0"/>
+          <a:chOff x="0" y="0"/>
+          <a:chExt cx="0" cy="0"/>
+        </a:xfrm>
+      </p:grpSpPr>
+    </p:spTree>
+  </p:cSld>
+  <p:clrMapOvr>
+    <a:masterClrMapping/>
+  </p:clrMapOvr>
+</p:notes>
+</file>
+
+<file path=ppt/notesSlides/notesSlide97.xml><?xml version="1.0" encoding="utf-8"?>
+<p:notes xmlns:a="http://schemas.openxmlformats.org/drawingml/2006/main" xmlns:p="http://schemas.openxmlformats.org/presentationml/2006/main" xmlns:r="http://schemas.openxmlformats.org/officeDocument/2006/relationships">
+  <p:cSld>
+    <p:spTree>
+      <p:nvGrpSpPr>
+        <p:cNvPr id="1" name=""/>
+        <p:cNvGrpSpPr/>
+        <p:nvPr/>
+      </p:nvGrpSpPr>
+      <p:grpSpPr>
+        <a:xfrm>
+          <a:off x="0" y="0"/>
+          <a:ext cx="0" cy="0"/>
+          <a:chOff x="0" y="0"/>
+          <a:chExt cx="0" cy="0"/>
+        </a:xfrm>
+      </p:grpSpPr>
+    </p:spTree>
+  </p:cSld>
+  <p:clrMapOvr>
+    <a:masterClrMapping/>
+  </p:clrMapOvr>
+</p:notes>
+</file>
+
 <file path=ppt/slideLayouts/slideLayout1.xml><?xml version="1.0" encoding="utf-8"?>
 <p:sldLayout xmlns:a="http://schemas.openxmlformats.org/drawingml/2006/main" xmlns:r="http://schemas.openxmlformats.org/officeDocument/2006/relationships" xmlns:p="http://schemas.openxmlformats.org/presentationml/2006/main" type="title" preserve="1">
   <p:cSld name="Title Slide">
@@ -56337,6 +56415,2018 @@
             </a:pPr>
             <a:r>
               <a:t>scott@aiacopilot.com  •  aiacopilot.com</a:t>
+            </a:r>
+          </a:p>
+        </p:txBody>
+      </p:sp>
+    </p:spTree>
+  </p:cSld>
+  <p:clrMapOvr>
+    <a:masterClrMapping/>
+  </p:clrMapOvr>
+</p:sld>
+</file>
+
+<file path=ppt/slides/slide95.xml><?xml version="1.0" encoding="utf-8"?>
+<p:sld xmlns:a="http://schemas.openxmlformats.org/drawingml/2006/main" xmlns:p="http://schemas.openxmlformats.org/presentationml/2006/main" xmlns:r="http://schemas.openxmlformats.org/officeDocument/2006/relationships">
+  <p:cSld>
+    <p:bg>
+      <p:bgPr>
+        <a:solidFill>
+          <a:srgbClr val="0B0F1A"/>
+        </a:solidFill>
+        <a:effectLst/>
+      </p:bgPr>
+    </p:bg>
+    <p:spTree>
+      <p:nvGrpSpPr>
+        <p:cNvPr id="1" name=""/>
+        <p:cNvGrpSpPr/>
+        <p:nvPr/>
+      </p:nvGrpSpPr>
+      <p:grpSpPr/>
+      <p:sp>
+        <p:nvSpPr>
+          <p:cNvPr id="2" name="TextBox 1"/>
+          <p:cNvSpPr txBox="1"/>
+          <p:nvPr/>
+        </p:nvSpPr>
+        <p:spPr>
+          <a:xfrm>
+            <a:off x="457200" y="274320"/>
+            <a:ext cx="11247120" cy="822960"/>
+          </a:xfrm>
+          <a:prstGeom prst="rect">
+            <a:avLst/>
+          </a:prstGeom>
+          <a:noFill/>
+        </p:spPr>
+        <p:txBody>
+          <a:bodyPr wrap="none">
+            <a:spAutoFit/>
+          </a:bodyPr>
+          <a:lstStyle/>
+          <a:p>
+            <a:pPr>
+              <a:defRPr sz="4000" b="1">
+                <a:solidFill>
+                  <a:srgbClr val="FFFFFF"/>
+                </a:solidFill>
+              </a:defRPr>
+            </a:pPr>
+            <a:r>
+              <a:t>Claude Cowork: AI That Produces Actual Files</a:t>
+            </a:r>
+          </a:p>
+        </p:txBody>
+      </p:sp>
+      <p:sp>
+        <p:nvSpPr>
+          <p:cNvPr id="3" name="TextBox 2"/>
+          <p:cNvSpPr txBox="1"/>
+          <p:nvPr/>
+        </p:nvSpPr>
+        <p:spPr>
+          <a:xfrm>
+            <a:off x="457200" y="1005840"/>
+            <a:ext cx="11247120" cy="457200"/>
+          </a:xfrm>
+          <a:prstGeom prst="rect">
+            <a:avLst/>
+          </a:prstGeom>
+          <a:noFill/>
+        </p:spPr>
+        <p:txBody>
+          <a:bodyPr wrap="none">
+            <a:spAutoFit/>
+          </a:bodyPr>
+          <a:lstStyle/>
+          <a:p>
+            <a:pPr>
+              <a:defRPr sz="1800" i="1">
+                <a:solidFill>
+                  <a:srgbClr val="9CA3AF"/>
+                </a:solidFill>
+              </a:defRPr>
+            </a:pPr>
+            <a:r>
+              <a:t>Claude Code for non-developers — works with files on your computer</a:t>
+            </a:r>
+          </a:p>
+        </p:txBody>
+      </p:sp>
+      <p:sp>
+        <p:nvSpPr>
+          <p:cNvPr id="4" name="Rounded Rectangle 3"/>
+          <p:cNvSpPr/>
+          <p:nvPr/>
+        </p:nvSpPr>
+        <p:spPr>
+          <a:xfrm>
+            <a:off x="274320" y="1737360"/>
+            <a:ext cx="2743200" cy="3657600"/>
+          </a:xfrm>
+          <a:prstGeom prst="roundRect">
+            <a:avLst/>
+          </a:prstGeom>
+          <a:solidFill>
+            <a:srgbClr val="141A2A"/>
+          </a:solidFill>
+          <a:ln w="19050">
+            <a:solidFill>
+              <a:srgbClr val="14B8A6"/>
+            </a:solidFill>
+          </a:ln>
+        </p:spPr>
+        <p:style>
+          <a:lnRef idx="1">
+            <a:schemeClr val="accent1"/>
+          </a:lnRef>
+          <a:fillRef idx="3">
+            <a:schemeClr val="accent1"/>
+          </a:fillRef>
+          <a:effectRef idx="2">
+            <a:schemeClr val="accent1"/>
+          </a:effectRef>
+          <a:fontRef idx="minor">
+            <a:schemeClr val="lt1"/>
+          </a:fontRef>
+        </p:style>
+        <p:txBody>
+          <a:bodyPr rtlCol="0" anchor="ctr"/>
+          <a:lstStyle/>
+          <a:p>
+            <a:pPr algn="ctr"/>
+          </a:p>
+        </p:txBody>
+      </p:sp>
+      <p:sp>
+        <p:nvSpPr>
+          <p:cNvPr id="5" name="TextBox 4"/>
+          <p:cNvSpPr txBox="1"/>
+          <p:nvPr/>
+        </p:nvSpPr>
+        <p:spPr>
+          <a:xfrm>
+            <a:off x="457200" y="1874519"/>
+            <a:ext cx="2377440" cy="365760"/>
+          </a:xfrm>
+          <a:prstGeom prst="rect">
+            <a:avLst/>
+          </a:prstGeom>
+          <a:noFill/>
+        </p:spPr>
+        <p:txBody>
+          <a:bodyPr wrap="none">
+            <a:spAutoFit/>
+          </a:bodyPr>
+          <a:lstStyle/>
+          <a:p>
+            <a:pPr algn="ctr">
+              <a:defRPr sz="2600"/>
+            </a:pPr>
+            <a:r>
+              <a:t>📁</a:t>
+            </a:r>
+          </a:p>
+        </p:txBody>
+      </p:sp>
+      <p:sp>
+        <p:nvSpPr>
+          <p:cNvPr id="6" name="TextBox 5"/>
+          <p:cNvSpPr txBox="1"/>
+          <p:nvPr/>
+        </p:nvSpPr>
+        <p:spPr>
+          <a:xfrm>
+            <a:off x="457200" y="2240280"/>
+            <a:ext cx="2377440" cy="365760"/>
+          </a:xfrm>
+          <a:prstGeom prst="rect">
+            <a:avLst/>
+          </a:prstGeom>
+          <a:noFill/>
+        </p:spPr>
+        <p:txBody>
+          <a:bodyPr wrap="none">
+            <a:spAutoFit/>
+          </a:bodyPr>
+          <a:lstStyle/>
+          <a:p>
+            <a:pPr algn="ctr">
+              <a:defRPr sz="1600" b="1">
+                <a:solidFill>
+                  <a:srgbClr val="FFFFFF"/>
+                </a:solidFill>
+              </a:defRPr>
+            </a:pPr>
+            <a:r>
+              <a:t>File Operations</a:t>
+            </a:r>
+          </a:p>
+        </p:txBody>
+      </p:sp>
+      <p:sp>
+        <p:nvSpPr>
+          <p:cNvPr id="7" name="TextBox 6"/>
+          <p:cNvSpPr txBox="1"/>
+          <p:nvPr/>
+        </p:nvSpPr>
+        <p:spPr>
+          <a:xfrm>
+            <a:off x="457200" y="2651760"/>
+            <a:ext cx="2377440" cy="2560320"/>
+          </a:xfrm>
+          <a:prstGeom prst="rect">
+            <a:avLst/>
+          </a:prstGeom>
+          <a:noFill/>
+        </p:spPr>
+        <p:txBody>
+          <a:bodyPr wrap="square">
+            <a:spAutoFit/>
+          </a:bodyPr>
+          <a:lstStyle/>
+          <a:p>
+            <a:pPr algn="ctr">
+              <a:defRPr sz="1200">
+                <a:solidFill>
+                  <a:srgbClr val="D1D5DB"/>
+                </a:solidFill>
+              </a:defRPr>
+            </a:pPr>
+            <a:r>
+              <a:t>Organize 300+ files in minutes</a:t>
+            </a:r>
+            <a:br/>
+            <a:r>
+              <a:t>by reading actual contents —</a:t>
+            </a:r>
+            <a:br/>
+            <a:r>
+              <a:t>not just filenames.</a:t>
+            </a:r>
+            <a:br/>
+            <a:br/>
+            <a:r>
+              <a:t>Receipt photos → sorted</a:t>
+            </a:r>
+            <a:br/>
+            <a:r>
+              <a:t>by vendor, date, category</a:t>
+            </a:r>
+          </a:p>
+        </p:txBody>
+      </p:sp>
+      <p:sp>
+        <p:nvSpPr>
+          <p:cNvPr id="8" name="Rounded Rectangle 7"/>
+          <p:cNvSpPr/>
+          <p:nvPr/>
+        </p:nvSpPr>
+        <p:spPr>
+          <a:xfrm>
+            <a:off x="3200400" y="1737360"/>
+            <a:ext cx="2743200" cy="3657600"/>
+          </a:xfrm>
+          <a:prstGeom prst="roundRect">
+            <a:avLst/>
+          </a:prstGeom>
+          <a:solidFill>
+            <a:srgbClr val="141A2A"/>
+          </a:solidFill>
+          <a:ln w="19050">
+            <a:solidFill>
+              <a:srgbClr val="14B8A6"/>
+            </a:solidFill>
+          </a:ln>
+        </p:spPr>
+        <p:style>
+          <a:lnRef idx="1">
+            <a:schemeClr val="accent1"/>
+          </a:lnRef>
+          <a:fillRef idx="3">
+            <a:schemeClr val="accent1"/>
+          </a:fillRef>
+          <a:effectRef idx="2">
+            <a:schemeClr val="accent1"/>
+          </a:effectRef>
+          <a:fontRef idx="minor">
+            <a:schemeClr val="lt1"/>
+          </a:fontRef>
+        </p:style>
+        <p:txBody>
+          <a:bodyPr rtlCol="0" anchor="ctr"/>
+          <a:lstStyle/>
+          <a:p>
+            <a:pPr algn="ctr"/>
+          </a:p>
+        </p:txBody>
+      </p:sp>
+      <p:sp>
+        <p:nvSpPr>
+          <p:cNvPr id="9" name="TextBox 8"/>
+          <p:cNvSpPr txBox="1"/>
+          <p:nvPr/>
+        </p:nvSpPr>
+        <p:spPr>
+          <a:xfrm>
+            <a:off x="3383280" y="1874519"/>
+            <a:ext cx="2377440" cy="365760"/>
+          </a:xfrm>
+          <a:prstGeom prst="rect">
+            <a:avLst/>
+          </a:prstGeom>
+          <a:noFill/>
+        </p:spPr>
+        <p:txBody>
+          <a:bodyPr wrap="none">
+            <a:spAutoFit/>
+          </a:bodyPr>
+          <a:lstStyle/>
+          <a:p>
+            <a:pPr algn="ctr">
+              <a:defRPr sz="2600"/>
+            </a:pPr>
+            <a:r>
+              <a:t>📊</a:t>
+            </a:r>
+          </a:p>
+        </p:txBody>
+      </p:sp>
+      <p:sp>
+        <p:nvSpPr>
+          <p:cNvPr id="10" name="TextBox 9"/>
+          <p:cNvSpPr txBox="1"/>
+          <p:nvPr/>
+        </p:nvSpPr>
+        <p:spPr>
+          <a:xfrm>
+            <a:off x="3383280" y="2240280"/>
+            <a:ext cx="2377440" cy="365760"/>
+          </a:xfrm>
+          <a:prstGeom prst="rect">
+            <a:avLst/>
+          </a:prstGeom>
+          <a:noFill/>
+        </p:spPr>
+        <p:txBody>
+          <a:bodyPr wrap="none">
+            <a:spAutoFit/>
+          </a:bodyPr>
+          <a:lstStyle/>
+          <a:p>
+            <a:pPr algn="ctr">
+              <a:defRPr sz="1600" b="1">
+                <a:solidFill>
+                  <a:srgbClr val="FFFFFF"/>
+                </a:solidFill>
+              </a:defRPr>
+            </a:pPr>
+            <a:r>
+              <a:t>Real Documents</a:t>
+            </a:r>
+          </a:p>
+        </p:txBody>
+      </p:sp>
+      <p:sp>
+        <p:nvSpPr>
+          <p:cNvPr id="11" name="TextBox 10"/>
+          <p:cNvSpPr txBox="1"/>
+          <p:nvPr/>
+        </p:nvSpPr>
+        <p:spPr>
+          <a:xfrm>
+            <a:off x="3383280" y="2651760"/>
+            <a:ext cx="2377440" cy="2560320"/>
+          </a:xfrm>
+          <a:prstGeom prst="rect">
+            <a:avLst/>
+          </a:prstGeom>
+          <a:noFill/>
+        </p:spPr>
+        <p:txBody>
+          <a:bodyPr wrap="square">
+            <a:spAutoFit/>
+          </a:bodyPr>
+          <a:lstStyle/>
+          <a:p>
+            <a:pPr algn="ctr">
+              <a:defRPr sz="1200">
+                <a:solidFill>
+                  <a:srgbClr val="D1D5DB"/>
+                </a:solidFill>
+              </a:defRPr>
+            </a:pPr>
+            <a:r>
+              <a:t>Creates actual files:</a:t>
+            </a:r>
+            <a:br/>
+            <a:r>
+              <a:t>Excel with working formulas</a:t>
+            </a:r>
+            <a:br/>
+            <a:r>
+              <a:t>PowerPoint with real slides</a:t>
+            </a:r>
+            <a:br/>
+            <a:r>
+              <a:t>Word with proper formatting</a:t>
+            </a:r>
+            <a:br/>
+            <a:br/>
+            <a:r>
+              <a:t>Not text you copy-paste</a:t>
+            </a:r>
+          </a:p>
+        </p:txBody>
+      </p:sp>
+      <p:sp>
+        <p:nvSpPr>
+          <p:cNvPr id="12" name="Rounded Rectangle 11"/>
+          <p:cNvSpPr/>
+          <p:nvPr/>
+        </p:nvSpPr>
+        <p:spPr>
+          <a:xfrm>
+            <a:off x="6126480" y="1737360"/>
+            <a:ext cx="2743200" cy="3657600"/>
+          </a:xfrm>
+          <a:prstGeom prst="roundRect">
+            <a:avLst/>
+          </a:prstGeom>
+          <a:solidFill>
+            <a:srgbClr val="141A2A"/>
+          </a:solidFill>
+          <a:ln w="19050">
+            <a:solidFill>
+              <a:srgbClr val="14B8A6"/>
+            </a:solidFill>
+          </a:ln>
+        </p:spPr>
+        <p:style>
+          <a:lnRef idx="1">
+            <a:schemeClr val="accent1"/>
+          </a:lnRef>
+          <a:fillRef idx="3">
+            <a:schemeClr val="accent1"/>
+          </a:fillRef>
+          <a:effectRef idx="2">
+            <a:schemeClr val="accent1"/>
+          </a:effectRef>
+          <a:fontRef idx="minor">
+            <a:schemeClr val="lt1"/>
+          </a:fontRef>
+        </p:style>
+        <p:txBody>
+          <a:bodyPr rtlCol="0" anchor="ctr"/>
+          <a:lstStyle/>
+          <a:p>
+            <a:pPr algn="ctr"/>
+          </a:p>
+        </p:txBody>
+      </p:sp>
+      <p:sp>
+        <p:nvSpPr>
+          <p:cNvPr id="13" name="TextBox 12"/>
+          <p:cNvSpPr txBox="1"/>
+          <p:nvPr/>
+        </p:nvSpPr>
+        <p:spPr>
+          <a:xfrm>
+            <a:off x="6309360" y="1874519"/>
+            <a:ext cx="2377440" cy="365760"/>
+          </a:xfrm>
+          <a:prstGeom prst="rect">
+            <a:avLst/>
+          </a:prstGeom>
+          <a:noFill/>
+        </p:spPr>
+        <p:txBody>
+          <a:bodyPr wrap="none">
+            <a:spAutoFit/>
+          </a:bodyPr>
+          <a:lstStyle/>
+          <a:p>
+            <a:pPr algn="ctr">
+              <a:defRPr sz="2600"/>
+            </a:pPr>
+            <a:r>
+              <a:t>🔍</a:t>
+            </a:r>
+          </a:p>
+        </p:txBody>
+      </p:sp>
+      <p:sp>
+        <p:nvSpPr>
+          <p:cNvPr id="14" name="TextBox 13"/>
+          <p:cNvSpPr txBox="1"/>
+          <p:nvPr/>
+        </p:nvSpPr>
+        <p:spPr>
+          <a:xfrm>
+            <a:off x="6309360" y="2240280"/>
+            <a:ext cx="2377440" cy="365760"/>
+          </a:xfrm>
+          <a:prstGeom prst="rect">
+            <a:avLst/>
+          </a:prstGeom>
+          <a:noFill/>
+        </p:spPr>
+        <p:txBody>
+          <a:bodyPr wrap="none">
+            <a:spAutoFit/>
+          </a:bodyPr>
+          <a:lstStyle/>
+          <a:p>
+            <a:pPr algn="ctr">
+              <a:defRPr sz="1600" b="1">
+                <a:solidFill>
+                  <a:srgbClr val="FFFFFF"/>
+                </a:solidFill>
+              </a:defRPr>
+            </a:pPr>
+            <a:r>
+              <a:t>Research Synthesis</a:t>
+            </a:r>
+          </a:p>
+        </p:txBody>
+      </p:sp>
+      <p:sp>
+        <p:nvSpPr>
+          <p:cNvPr id="15" name="TextBox 14"/>
+          <p:cNvSpPr txBox="1"/>
+          <p:nvPr/>
+        </p:nvSpPr>
+        <p:spPr>
+          <a:xfrm>
+            <a:off x="6309360" y="2651760"/>
+            <a:ext cx="2377440" cy="2560320"/>
+          </a:xfrm>
+          <a:prstGeom prst="rect">
+            <a:avLst/>
+          </a:prstGeom>
+          <a:noFill/>
+        </p:spPr>
+        <p:txBody>
+          <a:bodyPr wrap="square">
+            <a:spAutoFit/>
+          </a:bodyPr>
+          <a:lstStyle/>
+          <a:p>
+            <a:pPr algn="ctr">
+              <a:defRPr sz="1200">
+                <a:solidFill>
+                  <a:srgbClr val="D1D5DB"/>
+                </a:solidFill>
+              </a:defRPr>
+            </a:pPr>
+            <a:r>
+              <a:t>Read 20 documents at once.</a:t>
+            </a:r>
+            <a:br/>
+            <a:r>
+              <a:t>Find patterns across sources.</a:t>
+            </a:r>
+            <a:br/>
+            <a:r>
+              <a:t>Cite specific files.</a:t>
+            </a:r>
+            <a:br/>
+            <a:r>
+              <a:t>Flag contradictions.</a:t>
+            </a:r>
+            <a:br/>
+            <a:br/>
+            <a:r>
+              <a:t>Hours of work → minutes</a:t>
+            </a:r>
+          </a:p>
+        </p:txBody>
+      </p:sp>
+      <p:sp>
+        <p:nvSpPr>
+          <p:cNvPr id="16" name="Rounded Rectangle 15"/>
+          <p:cNvSpPr/>
+          <p:nvPr/>
+        </p:nvSpPr>
+        <p:spPr>
+          <a:xfrm>
+            <a:off x="9052560" y="1737360"/>
+            <a:ext cx="2743200" cy="3657600"/>
+          </a:xfrm>
+          <a:prstGeom prst="roundRect">
+            <a:avLst/>
+          </a:prstGeom>
+          <a:solidFill>
+            <a:srgbClr val="141A2A"/>
+          </a:solidFill>
+          <a:ln w="19050">
+            <a:solidFill>
+              <a:srgbClr val="14B8A6"/>
+            </a:solidFill>
+          </a:ln>
+        </p:spPr>
+        <p:style>
+          <a:lnRef idx="1">
+            <a:schemeClr val="accent1"/>
+          </a:lnRef>
+          <a:fillRef idx="3">
+            <a:schemeClr val="accent1"/>
+          </a:fillRef>
+          <a:effectRef idx="2">
+            <a:schemeClr val="accent1"/>
+          </a:effectRef>
+          <a:fontRef idx="minor">
+            <a:schemeClr val="lt1"/>
+          </a:fontRef>
+        </p:style>
+        <p:txBody>
+          <a:bodyPr rtlCol="0" anchor="ctr"/>
+          <a:lstStyle/>
+          <a:p>
+            <a:pPr algn="ctr"/>
+          </a:p>
+        </p:txBody>
+      </p:sp>
+      <p:sp>
+        <p:nvSpPr>
+          <p:cNvPr id="17" name="TextBox 16"/>
+          <p:cNvSpPr txBox="1"/>
+          <p:nvPr/>
+        </p:nvSpPr>
+        <p:spPr>
+          <a:xfrm>
+            <a:off x="9235440" y="1874519"/>
+            <a:ext cx="2377440" cy="365760"/>
+          </a:xfrm>
+          <a:prstGeom prst="rect">
+            <a:avLst/>
+          </a:prstGeom>
+          <a:noFill/>
+        </p:spPr>
+        <p:txBody>
+          <a:bodyPr wrap="none">
+            <a:spAutoFit/>
+          </a:bodyPr>
+          <a:lstStyle/>
+          <a:p>
+            <a:pPr algn="ctr">
+              <a:defRPr sz="2600"/>
+            </a:pPr>
+            <a:r>
+              <a:t>🤖</a:t>
+            </a:r>
+          </a:p>
+        </p:txBody>
+      </p:sp>
+      <p:sp>
+        <p:nvSpPr>
+          <p:cNvPr id="18" name="TextBox 17"/>
+          <p:cNvSpPr txBox="1"/>
+          <p:nvPr/>
+        </p:nvSpPr>
+        <p:spPr>
+          <a:xfrm>
+            <a:off x="9235440" y="2240280"/>
+            <a:ext cx="2377440" cy="365760"/>
+          </a:xfrm>
+          <a:prstGeom prst="rect">
+            <a:avLst/>
+          </a:prstGeom>
+          <a:noFill/>
+        </p:spPr>
+        <p:txBody>
+          <a:bodyPr wrap="none">
+            <a:spAutoFit/>
+          </a:bodyPr>
+          <a:lstStyle/>
+          <a:p>
+            <a:pPr algn="ctr">
+              <a:defRPr sz="1600" b="1">
+                <a:solidFill>
+                  <a:srgbClr val="FFFFFF"/>
+                </a:solidFill>
+              </a:defRPr>
+            </a:pPr>
+            <a:r>
+              <a:t>AI Employee</a:t>
+            </a:r>
+          </a:p>
+        </p:txBody>
+      </p:sp>
+      <p:sp>
+        <p:nvSpPr>
+          <p:cNvPr id="19" name="TextBox 18"/>
+          <p:cNvSpPr txBox="1"/>
+          <p:nvPr/>
+        </p:nvSpPr>
+        <p:spPr>
+          <a:xfrm>
+            <a:off x="9235440" y="2651760"/>
+            <a:ext cx="2377440" cy="2560320"/>
+          </a:xfrm>
+          <a:prstGeom prst="rect">
+            <a:avLst/>
+          </a:prstGeom>
+          <a:noFill/>
+        </p:spPr>
+        <p:txBody>
+          <a:bodyPr wrap="square">
+            <a:spAutoFit/>
+          </a:bodyPr>
+          <a:lstStyle/>
+          <a:p>
+            <a:pPr algn="ctr">
+              <a:defRPr sz="1200">
+                <a:solidFill>
+                  <a:srgbClr val="D1D5DB"/>
+                </a:solidFill>
+              </a:defRPr>
+            </a:pPr>
+            <a:r>
+              <a:t>Delegate outcomes,</a:t>
+            </a:r>
+            <a:br/>
+            <a:r>
+              <a:t>not tasks. Step away.</a:t>
+            </a:r>
+            <a:br/>
+            <a:r>
+              <a:t>Come back to finished work.</a:t>
+            </a:r>
+            <a:br/>
+            <a:br/>
+            <a:r>
+              <a:t>Batch multiple tasks</a:t>
+            </a:r>
+            <a:br/>
+            <a:r>
+              <a:t>in a single session</a:t>
+            </a:r>
+          </a:p>
+        </p:txBody>
+      </p:sp>
+      <p:sp>
+        <p:nvSpPr>
+          <p:cNvPr id="20" name="TextBox 19"/>
+          <p:cNvSpPr txBox="1"/>
+          <p:nvPr/>
+        </p:nvSpPr>
+        <p:spPr>
+          <a:xfrm>
+            <a:off x="457200" y="5669280"/>
+            <a:ext cx="11247120" cy="457200"/>
+          </a:xfrm>
+          <a:prstGeom prst="rect">
+            <a:avLst/>
+          </a:prstGeom>
+          <a:noFill/>
+        </p:spPr>
+        <p:txBody>
+          <a:bodyPr wrap="none">
+            <a:spAutoFit/>
+          </a:bodyPr>
+          <a:lstStyle/>
+          <a:p>
+            <a:pPr algn="ctr">
+              <a:defRPr sz="1400" i="1">
+                <a:solidFill>
+                  <a:srgbClr val="14B8A6"/>
+                </a:solidFill>
+              </a:defRPr>
+            </a:pPr>
+            <a:r>
+              <a:t>macOS Desktop app • Claude Pro ($20/mo) • Research Preview • Grant access to one folder at a time</a:t>
+            </a:r>
+          </a:p>
+        </p:txBody>
+      </p:sp>
+    </p:spTree>
+  </p:cSld>
+  <p:clrMapOvr>
+    <a:masterClrMapping/>
+  </p:clrMapOvr>
+</p:sld>
+</file>
+
+<file path=ppt/slides/slide96.xml><?xml version="1.0" encoding="utf-8"?>
+<p:sld xmlns:a="http://schemas.openxmlformats.org/drawingml/2006/main" xmlns:p="http://schemas.openxmlformats.org/presentationml/2006/main" xmlns:r="http://schemas.openxmlformats.org/officeDocument/2006/relationships">
+  <p:cSld>
+    <p:bg>
+      <p:bgPr>
+        <a:solidFill>
+          <a:srgbClr val="0B0F1A"/>
+        </a:solidFill>
+        <a:effectLst/>
+      </p:bgPr>
+    </p:bg>
+    <p:spTree>
+      <p:nvGrpSpPr>
+        <p:cNvPr id="1" name=""/>
+        <p:cNvGrpSpPr/>
+        <p:nvPr/>
+      </p:nvGrpSpPr>
+      <p:grpSpPr/>
+      <p:sp>
+        <p:nvSpPr>
+          <p:cNvPr id="2" name="TextBox 1"/>
+          <p:cNvSpPr txBox="1"/>
+          <p:nvPr/>
+        </p:nvSpPr>
+        <p:spPr>
+          <a:xfrm>
+            <a:off x="457200" y="274320"/>
+            <a:ext cx="11247120" cy="822960"/>
+          </a:xfrm>
+          <a:prstGeom prst="rect">
+            <a:avLst/>
+          </a:prstGeom>
+          <a:noFill/>
+        </p:spPr>
+        <p:txBody>
+          <a:bodyPr wrap="none">
+            <a:spAutoFit/>
+          </a:bodyPr>
+          <a:lstStyle/>
+          <a:p>
+            <a:pPr>
+              <a:defRPr sz="4000" b="1">
+                <a:solidFill>
+                  <a:srgbClr val="FFFFFF"/>
+                </a:solidFill>
+              </a:defRPr>
+            </a:pPr>
+            <a:r>
+              <a:t>The "Done" Framework</a:t>
+            </a:r>
+          </a:p>
+        </p:txBody>
+      </p:sp>
+      <p:sp>
+        <p:nvSpPr>
+          <p:cNvPr id="3" name="TextBox 2"/>
+          <p:cNvSpPr txBox="1"/>
+          <p:nvPr/>
+        </p:nvSpPr>
+        <p:spPr>
+          <a:xfrm>
+            <a:off x="457200" y="1005840"/>
+            <a:ext cx="11247120" cy="457200"/>
+          </a:xfrm>
+          <a:prstGeom prst="rect">
+            <a:avLst/>
+          </a:prstGeom>
+          <a:noFill/>
+        </p:spPr>
+        <p:txBody>
+          <a:bodyPr wrap="none">
+            <a:spAutoFit/>
+          </a:bodyPr>
+          <a:lstStyle/>
+          <a:p>
+            <a:pPr>
+              <a:defRPr sz="1800" i="1">
+                <a:solidFill>
+                  <a:srgbClr val="9CA3AF"/>
+                </a:solidFill>
+              </a:defRPr>
+            </a:pPr>
+            <a:r>
+              <a:t>Before you delegate anything to AI, answer three questions</a:t>
+            </a:r>
+          </a:p>
+        </p:txBody>
+      </p:sp>
+      <p:sp>
+        <p:nvSpPr>
+          <p:cNvPr id="4" name="Oval 3"/>
+          <p:cNvSpPr/>
+          <p:nvPr/>
+        </p:nvSpPr>
+        <p:spPr>
+          <a:xfrm>
+            <a:off x="457200" y="1645920"/>
+            <a:ext cx="548640" cy="548640"/>
+          </a:xfrm>
+          <a:prstGeom prst="ellipse">
+            <a:avLst/>
+          </a:prstGeom>
+          <a:solidFill>
+            <a:srgbClr val="14B8A6"/>
+          </a:solidFill>
+          <a:ln>
+            <a:noFill/>
+          </a:ln>
+        </p:spPr>
+        <p:style>
+          <a:lnRef idx="1">
+            <a:schemeClr val="accent1"/>
+          </a:lnRef>
+          <a:fillRef idx="3">
+            <a:schemeClr val="accent1"/>
+          </a:fillRef>
+          <a:effectRef idx="2">
+            <a:schemeClr val="accent1"/>
+          </a:effectRef>
+          <a:fontRef idx="minor">
+            <a:schemeClr val="lt1"/>
+          </a:fontRef>
+        </p:style>
+        <p:txBody>
+          <a:bodyPr rtlCol="0" anchor="ctr"/>
+          <a:lstStyle/>
+          <a:p>
+            <a:pPr algn="ctr">
+              <a:defRPr sz="2200" b="1">
+                <a:solidFill>
+                  <a:srgbClr val="FFFFFF"/>
+                </a:solidFill>
+              </a:defRPr>
+            </a:pPr>
+            <a:r>
+              <a:t>1</a:t>
+            </a:r>
+          </a:p>
+        </p:txBody>
+      </p:sp>
+      <p:sp>
+        <p:nvSpPr>
+          <p:cNvPr id="5" name="TextBox 4"/>
+          <p:cNvSpPr txBox="1"/>
+          <p:nvPr/>
+        </p:nvSpPr>
+        <p:spPr>
+          <a:xfrm>
+            <a:off x="1188720" y="1554480"/>
+            <a:ext cx="3657600" cy="365760"/>
+          </a:xfrm>
+          <a:prstGeom prst="rect">
+            <a:avLst/>
+          </a:prstGeom>
+          <a:noFill/>
+        </p:spPr>
+        <p:txBody>
+          <a:bodyPr wrap="none">
+            <a:spAutoFit/>
+          </a:bodyPr>
+          <a:lstStyle/>
+          <a:p>
+            <a:pPr>
+              <a:defRPr sz="1800" b="1">
+                <a:solidFill>
+                  <a:srgbClr val="FFFFFF"/>
+                </a:solidFill>
+              </a:defRPr>
+            </a:pPr>
+            <a:r>
+              <a:t>What does "done" look like?</a:t>
+            </a:r>
+          </a:p>
+        </p:txBody>
+      </p:sp>
+      <p:sp>
+        <p:nvSpPr>
+          <p:cNvPr id="6" name="TextBox 5"/>
+          <p:cNvSpPr txBox="1"/>
+          <p:nvPr/>
+        </p:nvSpPr>
+        <p:spPr>
+          <a:xfrm>
+            <a:off x="1188720" y="1965960"/>
+            <a:ext cx="4572000" cy="365760"/>
+          </a:xfrm>
+          <a:prstGeom prst="rect">
+            <a:avLst/>
+          </a:prstGeom>
+          <a:noFill/>
+        </p:spPr>
+        <p:txBody>
+          <a:bodyPr wrap="none">
+            <a:spAutoFit/>
+          </a:bodyPr>
+          <a:lstStyle/>
+          <a:p>
+            <a:pPr>
+              <a:defRPr sz="1300">
+                <a:solidFill>
+                  <a:srgbClr val="9CA3AF"/>
+                </a:solidFill>
+              </a:defRPr>
+            </a:pPr>
+            <a:r>
+              <a:t>❌  "Create an expense report"</a:t>
+            </a:r>
+          </a:p>
+        </p:txBody>
+      </p:sp>
+      <p:sp>
+        <p:nvSpPr>
+          <p:cNvPr id="7" name="TextBox 6"/>
+          <p:cNvSpPr txBox="1"/>
+          <p:nvPr/>
+        </p:nvSpPr>
+        <p:spPr>
+          <a:xfrm>
+            <a:off x="6217920" y="1554480"/>
+            <a:ext cx="5486400" cy="1188720"/>
+          </a:xfrm>
+          <a:prstGeom prst="rect">
+            <a:avLst/>
+          </a:prstGeom>
+          <a:noFill/>
+        </p:spPr>
+        <p:txBody>
+          <a:bodyPr wrap="square">
+            <a:spAutoFit/>
+          </a:bodyPr>
+          <a:lstStyle/>
+          <a:p>
+            <a:pPr>
+              <a:defRPr sz="1300">
+                <a:solidFill>
+                  <a:srgbClr val="D1D5DB"/>
+                </a:solidFill>
+              </a:defRPr>
+            </a:pPr>
+            <a:r>
+              <a:t>✅  "Excel with columns for date, vendor,</a:t>
+            </a:r>
+            <a:br/>
+            <a:r>
+              <a:t>     amount, category — sorted by date,</a:t>
+            </a:r>
+            <a:br/>
+            <a:r>
+              <a:t>     sum total at bottom"</a:t>
+            </a:r>
+          </a:p>
+        </p:txBody>
+      </p:sp>
+      <p:sp>
+        <p:nvSpPr>
+          <p:cNvPr id="8" name="Oval 7"/>
+          <p:cNvSpPr/>
+          <p:nvPr/>
+        </p:nvSpPr>
+        <p:spPr>
+          <a:xfrm>
+            <a:off x="457200" y="3108960"/>
+            <a:ext cx="548640" cy="548640"/>
+          </a:xfrm>
+          <a:prstGeom prst="ellipse">
+            <a:avLst/>
+          </a:prstGeom>
+          <a:solidFill>
+            <a:srgbClr val="14B8A6"/>
+          </a:solidFill>
+          <a:ln>
+            <a:noFill/>
+          </a:ln>
+        </p:spPr>
+        <p:style>
+          <a:lnRef idx="1">
+            <a:schemeClr val="accent1"/>
+          </a:lnRef>
+          <a:fillRef idx="3">
+            <a:schemeClr val="accent1"/>
+          </a:fillRef>
+          <a:effectRef idx="2">
+            <a:schemeClr val="accent1"/>
+          </a:effectRef>
+          <a:fontRef idx="minor">
+            <a:schemeClr val="lt1"/>
+          </a:fontRef>
+        </p:style>
+        <p:txBody>
+          <a:bodyPr rtlCol="0" anchor="ctr"/>
+          <a:lstStyle/>
+          <a:p>
+            <a:pPr algn="ctr">
+              <a:defRPr sz="2200" b="1">
+                <a:solidFill>
+                  <a:srgbClr val="FFFFFF"/>
+                </a:solidFill>
+              </a:defRPr>
+            </a:pPr>
+            <a:r>
+              <a:t>2</a:t>
+            </a:r>
+          </a:p>
+        </p:txBody>
+      </p:sp>
+      <p:sp>
+        <p:nvSpPr>
+          <p:cNvPr id="9" name="TextBox 8"/>
+          <p:cNvSpPr txBox="1"/>
+          <p:nvPr/>
+        </p:nvSpPr>
+        <p:spPr>
+          <a:xfrm>
+            <a:off x="1188720" y="3017520"/>
+            <a:ext cx="3657600" cy="365760"/>
+          </a:xfrm>
+          <a:prstGeom prst="rect">
+            <a:avLst/>
+          </a:prstGeom>
+          <a:noFill/>
+        </p:spPr>
+        <p:txBody>
+          <a:bodyPr wrap="none">
+            <a:spAutoFit/>
+          </a:bodyPr>
+          <a:lstStyle/>
+          <a:p>
+            <a:pPr>
+              <a:defRPr sz="1800" b="1">
+                <a:solidFill>
+                  <a:srgbClr val="FFFFFF"/>
+                </a:solidFill>
+              </a:defRPr>
+            </a:pPr>
+            <a:r>
+              <a:t>What context does Claude need?</a:t>
+            </a:r>
+          </a:p>
+        </p:txBody>
+      </p:sp>
+      <p:sp>
+        <p:nvSpPr>
+          <p:cNvPr id="10" name="TextBox 9"/>
+          <p:cNvSpPr txBox="1"/>
+          <p:nvPr/>
+        </p:nvSpPr>
+        <p:spPr>
+          <a:xfrm>
+            <a:off x="1188720" y="3429000"/>
+            <a:ext cx="4572000" cy="365760"/>
+          </a:xfrm>
+          <a:prstGeom prst="rect">
+            <a:avLst/>
+          </a:prstGeom>
+          <a:noFill/>
+        </p:spPr>
+        <p:txBody>
+          <a:bodyPr wrap="none">
+            <a:spAutoFit/>
+          </a:bodyPr>
+          <a:lstStyle/>
+          <a:p>
+            <a:pPr>
+              <a:defRPr sz="1300">
+                <a:solidFill>
+                  <a:srgbClr val="9CA3AF"/>
+                </a:solidFill>
+              </a:defRPr>
+            </a:pPr>
+            <a:r>
+              <a:t>❌  (Assumes Claude knows your preferences)</a:t>
+            </a:r>
+          </a:p>
+        </p:txBody>
+      </p:sp>
+      <p:sp>
+        <p:nvSpPr>
+          <p:cNvPr id="11" name="TextBox 10"/>
+          <p:cNvSpPr txBox="1"/>
+          <p:nvPr/>
+        </p:nvSpPr>
+        <p:spPr>
+          <a:xfrm>
+            <a:off x="6217920" y="3017520"/>
+            <a:ext cx="5486400" cy="1188720"/>
+          </a:xfrm>
+          <a:prstGeom prst="rect">
+            <a:avLst/>
+          </a:prstGeom>
+          <a:noFill/>
+        </p:spPr>
+        <p:txBody>
+          <a:bodyPr wrap="square">
+            <a:spAutoFit/>
+          </a:bodyPr>
+          <a:lstStyle/>
+          <a:p>
+            <a:pPr>
+              <a:defRPr sz="1300">
+                <a:solidFill>
+                  <a:srgbClr val="D1D5DB"/>
+                </a:solidFill>
+              </a:defRPr>
+            </a:pPr>
+            <a:r>
+              <a:t>✅  "Use our company template.</a:t>
+            </a:r>
+            <a:br/>
+            <a:r>
+              <a:t>     Categories: Travel, Meals, Software,</a:t>
+            </a:r>
+            <a:br/>
+            <a:r>
+              <a:t>     Office. Flag anything over $500."</a:t>
+            </a:r>
+          </a:p>
+        </p:txBody>
+      </p:sp>
+      <p:sp>
+        <p:nvSpPr>
+          <p:cNvPr id="12" name="Oval 11"/>
+          <p:cNvSpPr/>
+          <p:nvPr/>
+        </p:nvSpPr>
+        <p:spPr>
+          <a:xfrm>
+            <a:off x="457200" y="4572000"/>
+            <a:ext cx="548640" cy="548640"/>
+          </a:xfrm>
+          <a:prstGeom prst="ellipse">
+            <a:avLst/>
+          </a:prstGeom>
+          <a:solidFill>
+            <a:srgbClr val="14B8A6"/>
+          </a:solidFill>
+          <a:ln>
+            <a:noFill/>
+          </a:ln>
+        </p:spPr>
+        <p:style>
+          <a:lnRef idx="1">
+            <a:schemeClr val="accent1"/>
+          </a:lnRef>
+          <a:fillRef idx="3">
+            <a:schemeClr val="accent1"/>
+          </a:fillRef>
+          <a:effectRef idx="2">
+            <a:schemeClr val="accent1"/>
+          </a:effectRef>
+          <a:fontRef idx="minor">
+            <a:schemeClr val="lt1"/>
+          </a:fontRef>
+        </p:style>
+        <p:txBody>
+          <a:bodyPr rtlCol="0" anchor="ctr"/>
+          <a:lstStyle/>
+          <a:p>
+            <a:pPr algn="ctr">
+              <a:defRPr sz="2200" b="1">
+                <a:solidFill>
+                  <a:srgbClr val="FFFFFF"/>
+                </a:solidFill>
+              </a:defRPr>
+            </a:pPr>
+            <a:r>
+              <a:t>3</a:t>
+            </a:r>
+          </a:p>
+        </p:txBody>
+      </p:sp>
+      <p:sp>
+        <p:nvSpPr>
+          <p:cNvPr id="13" name="TextBox 12"/>
+          <p:cNvSpPr txBox="1"/>
+          <p:nvPr/>
+        </p:nvSpPr>
+        <p:spPr>
+          <a:xfrm>
+            <a:off x="1188720" y="4480560"/>
+            <a:ext cx="3657600" cy="365760"/>
+          </a:xfrm>
+          <a:prstGeom prst="rect">
+            <a:avLst/>
+          </a:prstGeom>
+          <a:noFill/>
+        </p:spPr>
+        <p:txBody>
+          <a:bodyPr wrap="none">
+            <a:spAutoFit/>
+          </a:bodyPr>
+          <a:lstStyle/>
+          <a:p>
+            <a:pPr>
+              <a:defRPr sz="1800" b="1">
+                <a:solidFill>
+                  <a:srgbClr val="FFFFFF"/>
+                </a:solidFill>
+              </a:defRPr>
+            </a:pPr>
+            <a:r>
+              <a:t>What constraints matter?</a:t>
+            </a:r>
+          </a:p>
+        </p:txBody>
+      </p:sp>
+      <p:sp>
+        <p:nvSpPr>
+          <p:cNvPr id="14" name="TextBox 13"/>
+          <p:cNvSpPr txBox="1"/>
+          <p:nvPr/>
+        </p:nvSpPr>
+        <p:spPr>
+          <a:xfrm>
+            <a:off x="1188720" y="4892040"/>
+            <a:ext cx="4572000" cy="365760"/>
+          </a:xfrm>
+          <a:prstGeom prst="rect">
+            <a:avLst/>
+          </a:prstGeom>
+          <a:noFill/>
+        </p:spPr>
+        <p:txBody>
+          <a:bodyPr wrap="none">
+            <a:spAutoFit/>
+          </a:bodyPr>
+          <a:lstStyle/>
+          <a:p>
+            <a:pPr>
+              <a:defRPr sz="1300">
+                <a:solidFill>
+                  <a:srgbClr val="9CA3AF"/>
+                </a:solidFill>
+              </a:defRPr>
+            </a:pPr>
+            <a:r>
+              <a:t>❌  (No boundaries stated)</a:t>
+            </a:r>
+          </a:p>
+        </p:txBody>
+      </p:sp>
+      <p:sp>
+        <p:nvSpPr>
+          <p:cNvPr id="15" name="TextBox 14"/>
+          <p:cNvSpPr txBox="1"/>
+          <p:nvPr/>
+        </p:nvSpPr>
+        <p:spPr>
+          <a:xfrm>
+            <a:off x="6217920" y="4480560"/>
+            <a:ext cx="5486400" cy="1188720"/>
+          </a:xfrm>
+          <a:prstGeom prst="rect">
+            <a:avLst/>
+          </a:prstGeom>
+          <a:noFill/>
+        </p:spPr>
+        <p:txBody>
+          <a:bodyPr wrap="square">
+            <a:spAutoFit/>
+          </a:bodyPr>
+          <a:lstStyle/>
+          <a:p>
+            <a:pPr>
+              <a:defRPr sz="1300">
+                <a:solidFill>
+                  <a:srgbClr val="D1D5DB"/>
+                </a:solidFill>
+              </a:defRPr>
+            </a:pPr>
+            <a:r>
+              <a:t>✅  "Don't delete any files, just move them.</a:t>
+            </a:r>
+            <a:br/>
+            <a:r>
+              <a:t>     Keep original filenames with date prefix.</a:t>
+            </a:r>
+            <a:br/>
+            <a:r>
+              <a:t>     Only process files from the last 90 days."</a:t>
+            </a:r>
+          </a:p>
+        </p:txBody>
+      </p:sp>
+      <p:sp>
+        <p:nvSpPr>
+          <p:cNvPr id="16" name="TextBox 15"/>
+          <p:cNvSpPr txBox="1"/>
+          <p:nvPr/>
+        </p:nvSpPr>
+        <p:spPr>
+          <a:xfrm>
+            <a:off x="457200" y="5852160"/>
+            <a:ext cx="11247120" cy="365760"/>
+          </a:xfrm>
+          <a:prstGeom prst="rect">
+            <a:avLst/>
+          </a:prstGeom>
+          <a:noFill/>
+        </p:spPr>
+        <p:txBody>
+          <a:bodyPr wrap="none">
+            <a:spAutoFit/>
+          </a:bodyPr>
+          <a:lstStyle/>
+          <a:p>
+            <a:pPr algn="ctr">
+              <a:defRPr sz="1500" i="1">
+                <a:solidFill>
+                  <a:srgbClr val="14B8A6"/>
+                </a:solidFill>
+              </a:defRPr>
+            </a:pPr>
+            <a:r>
+              <a:t>Golden rule: Always say "don't delete anything" unless you specifically want deletions</a:t>
+            </a:r>
+          </a:p>
+        </p:txBody>
+      </p:sp>
+    </p:spTree>
+  </p:cSld>
+  <p:clrMapOvr>
+    <a:masterClrMapping/>
+  </p:clrMapOvr>
+</p:sld>
+</file>
+
+<file path=ppt/slides/slide97.xml><?xml version="1.0" encoding="utf-8"?>
+<p:sld xmlns:a="http://schemas.openxmlformats.org/drawingml/2006/main" xmlns:p="http://schemas.openxmlformats.org/presentationml/2006/main" xmlns:r="http://schemas.openxmlformats.org/officeDocument/2006/relationships">
+  <p:cSld>
+    <p:bg>
+      <p:bgPr>
+        <a:solidFill>
+          <a:srgbClr val="0B0F1A"/>
+        </a:solidFill>
+        <a:effectLst/>
+      </p:bgPr>
+    </p:bg>
+    <p:spTree>
+      <p:nvGrpSpPr>
+        <p:cNvPr id="1" name=""/>
+        <p:cNvGrpSpPr/>
+        <p:nvPr/>
+      </p:nvGrpSpPr>
+      <p:grpSpPr/>
+      <p:sp>
+        <p:nvSpPr>
+          <p:cNvPr id="2" name="TextBox 1"/>
+          <p:cNvSpPr txBox="1"/>
+          <p:nvPr/>
+        </p:nvSpPr>
+        <p:spPr>
+          <a:xfrm>
+            <a:off x="457200" y="274320"/>
+            <a:ext cx="11247120" cy="822960"/>
+          </a:xfrm>
+          <a:prstGeom prst="rect">
+            <a:avLst/>
+          </a:prstGeom>
+          <a:noFill/>
+        </p:spPr>
+        <p:txBody>
+          <a:bodyPr wrap="none">
+            <a:spAutoFit/>
+          </a:bodyPr>
+          <a:lstStyle/>
+          <a:p>
+            <a:pPr>
+              <a:defRPr sz="4000" b="1">
+                <a:solidFill>
+                  <a:srgbClr val="FFFFFF"/>
+                </a:solidFill>
+              </a:defRPr>
+            </a:pPr>
+            <a:r>
+              <a:t>The AI Employee Mindset</a:t>
+            </a:r>
+          </a:p>
+        </p:txBody>
+      </p:sp>
+      <p:sp>
+        <p:nvSpPr>
+          <p:cNvPr id="3" name="TextBox 2"/>
+          <p:cNvSpPr txBox="1"/>
+          <p:nvPr/>
+        </p:nvSpPr>
+        <p:spPr>
+          <a:xfrm>
+            <a:off x="457200" y="1005840"/>
+            <a:ext cx="11247120" cy="457200"/>
+          </a:xfrm>
+          <a:prstGeom prst="rect">
+            <a:avLst/>
+          </a:prstGeom>
+          <a:noFill/>
+        </p:spPr>
+        <p:txBody>
+          <a:bodyPr wrap="none">
+            <a:spAutoFit/>
+          </a:bodyPr>
+          <a:lstStyle/>
+          <a:p>
+            <a:pPr>
+              <a:defRPr sz="1800" i="1">
+                <a:solidFill>
+                  <a:srgbClr val="9CA3AF"/>
+                </a:solidFill>
+              </a:defRPr>
+            </a:pPr>
+            <a:r>
+              <a:t>Stop chatting. Start delegating.</a:t>
+            </a:r>
+          </a:p>
+        </p:txBody>
+      </p:sp>
+      <p:sp>
+        <p:nvSpPr>
+          <p:cNvPr id="4" name="Rounded Rectangle 3"/>
+          <p:cNvSpPr/>
+          <p:nvPr/>
+        </p:nvSpPr>
+        <p:spPr>
+          <a:xfrm>
+            <a:off x="457200" y="1645920"/>
+            <a:ext cx="5303520" cy="4114800"/>
+          </a:xfrm>
+          <a:prstGeom prst="roundRect">
+            <a:avLst/>
+          </a:prstGeom>
+          <a:solidFill>
+            <a:srgbClr val="141A2A"/>
+          </a:solidFill>
+          <a:ln w="19050">
+            <a:solidFill>
+              <a:srgbClr val="EF4444"/>
+            </a:solidFill>
+          </a:ln>
+        </p:spPr>
+        <p:style>
+          <a:lnRef idx="1">
+            <a:schemeClr val="accent1"/>
+          </a:lnRef>
+          <a:fillRef idx="3">
+            <a:schemeClr val="accent1"/>
+          </a:fillRef>
+          <a:effectRef idx="2">
+            <a:schemeClr val="accent1"/>
+          </a:effectRef>
+          <a:fontRef idx="minor">
+            <a:schemeClr val="lt1"/>
+          </a:fontRef>
+        </p:style>
+        <p:txBody>
+          <a:bodyPr rtlCol="0" anchor="ctr"/>
+          <a:lstStyle/>
+          <a:p>
+            <a:pPr algn="ctr"/>
+          </a:p>
+        </p:txBody>
+      </p:sp>
+      <p:sp>
+        <p:nvSpPr>
+          <p:cNvPr id="5" name="TextBox 4"/>
+          <p:cNvSpPr txBox="1"/>
+          <p:nvPr/>
+        </p:nvSpPr>
+        <p:spPr>
+          <a:xfrm>
+            <a:off x="731520" y="1828800"/>
+            <a:ext cx="4754880" cy="457200"/>
+          </a:xfrm>
+          <a:prstGeom prst="rect">
+            <a:avLst/>
+          </a:prstGeom>
+          <a:noFill/>
+        </p:spPr>
+        <p:txBody>
+          <a:bodyPr wrap="none">
+            <a:spAutoFit/>
+          </a:bodyPr>
+          <a:lstStyle/>
+          <a:p>
+            <a:pPr>
+              <a:defRPr sz="2000" b="1">
+                <a:solidFill>
+                  <a:srgbClr val="EF4444"/>
+                </a:solidFill>
+              </a:defRPr>
+            </a:pPr>
+            <a:r>
+              <a:t>❌ Chatbot Thinking</a:t>
+            </a:r>
+          </a:p>
+        </p:txBody>
+      </p:sp>
+      <p:sp>
+        <p:nvSpPr>
+          <p:cNvPr id="6" name="TextBox 5"/>
+          <p:cNvSpPr txBox="1"/>
+          <p:nvPr/>
+        </p:nvSpPr>
+        <p:spPr>
+          <a:xfrm>
+            <a:off x="731520" y="2468880"/>
+            <a:ext cx="4754880" cy="457200"/>
+          </a:xfrm>
+          <a:prstGeom prst="rect">
+            <a:avLst/>
+          </a:prstGeom>
+          <a:noFill/>
+        </p:spPr>
+        <p:txBody>
+          <a:bodyPr wrap="none">
+            <a:spAutoFit/>
+          </a:bodyPr>
+          <a:lstStyle/>
+          <a:p>
+            <a:pPr>
+              <a:defRPr sz="1500">
+                <a:solidFill>
+                  <a:srgbClr val="9CA3AF"/>
+                </a:solidFill>
+              </a:defRPr>
+            </a:pPr>
+            <a:r>
+              <a:t>Give task → Wait → Get result</a:t>
+            </a:r>
+          </a:p>
+        </p:txBody>
+      </p:sp>
+      <p:sp>
+        <p:nvSpPr>
+          <p:cNvPr id="7" name="TextBox 6"/>
+          <p:cNvSpPr txBox="1"/>
+          <p:nvPr/>
+        </p:nvSpPr>
+        <p:spPr>
+          <a:xfrm>
+            <a:off x="731520" y="2926080"/>
+            <a:ext cx="4754880" cy="457200"/>
+          </a:xfrm>
+          <a:prstGeom prst="rect">
+            <a:avLst/>
+          </a:prstGeom>
+          <a:noFill/>
+        </p:spPr>
+        <p:txBody>
+          <a:bodyPr wrap="none">
+            <a:spAutoFit/>
+          </a:bodyPr>
+          <a:lstStyle/>
+          <a:p>
+            <a:pPr>
+              <a:defRPr sz="1500">
+                <a:solidFill>
+                  <a:srgbClr val="9CA3AF"/>
+                </a:solidFill>
+              </a:defRPr>
+            </a:pPr>
+            <a:r>
+              <a:t>Give next task → Wait → Get result</a:t>
+            </a:r>
+          </a:p>
+        </p:txBody>
+      </p:sp>
+      <p:sp>
+        <p:nvSpPr>
+          <p:cNvPr id="8" name="TextBox 7"/>
+          <p:cNvSpPr txBox="1"/>
+          <p:nvPr/>
+        </p:nvSpPr>
+        <p:spPr>
+          <a:xfrm>
+            <a:off x="731520" y="3383280"/>
+            <a:ext cx="4754880" cy="457200"/>
+          </a:xfrm>
+          <a:prstGeom prst="rect">
+            <a:avLst/>
+          </a:prstGeom>
+          <a:noFill/>
+        </p:spPr>
+        <p:txBody>
+          <a:bodyPr wrap="none">
+            <a:spAutoFit/>
+          </a:bodyPr>
+          <a:lstStyle/>
+          <a:p>
+            <a:pPr>
+              <a:defRPr sz="1500">
+                <a:solidFill>
+                  <a:srgbClr val="9CA3AF"/>
+                </a:solidFill>
+              </a:defRPr>
+            </a:pPr>
+            <a:r>
+              <a:t>Give next task → Wait → Get result</a:t>
+            </a:r>
+          </a:p>
+        </p:txBody>
+      </p:sp>
+      <p:sp>
+        <p:nvSpPr>
+          <p:cNvPr id="9" name="TextBox 8"/>
+          <p:cNvSpPr txBox="1"/>
+          <p:nvPr/>
+        </p:nvSpPr>
+        <p:spPr>
+          <a:xfrm>
+            <a:off x="731520" y="3840480"/>
+            <a:ext cx="4754880" cy="457200"/>
+          </a:xfrm>
+          <a:prstGeom prst="rect">
+            <a:avLst/>
+          </a:prstGeom>
+          <a:noFill/>
+        </p:spPr>
+        <p:txBody>
+          <a:bodyPr wrap="none">
+            <a:spAutoFit/>
+          </a:bodyPr>
+          <a:lstStyle/>
+          <a:p>
+            <a:pPr>
+              <a:defRPr sz="1500">
+                <a:solidFill>
+                  <a:srgbClr val="9CA3AF"/>
+                </a:solidFill>
+              </a:defRPr>
+            </a:pPr>
+          </a:p>
+        </p:txBody>
+      </p:sp>
+      <p:sp>
+        <p:nvSpPr>
+          <p:cNvPr id="10" name="TextBox 9"/>
+          <p:cNvSpPr txBox="1"/>
+          <p:nvPr/>
+        </p:nvSpPr>
+        <p:spPr>
+          <a:xfrm>
+            <a:off x="731520" y="4297680"/>
+            <a:ext cx="4754880" cy="457200"/>
+          </a:xfrm>
+          <a:prstGeom prst="rect">
+            <a:avLst/>
+          </a:prstGeom>
+          <a:noFill/>
+        </p:spPr>
+        <p:txBody>
+          <a:bodyPr wrap="none">
+            <a:spAutoFit/>
+          </a:bodyPr>
+          <a:lstStyle/>
+          <a:p>
+            <a:pPr>
+              <a:defRPr sz="1500">
+                <a:solidFill>
+                  <a:srgbClr val="EF4444"/>
+                </a:solidFill>
+              </a:defRPr>
+            </a:pPr>
+            <a:r>
+              <a:t>3 sessions. 3 waits. Fragmented context.</a:t>
+            </a:r>
+          </a:p>
+        </p:txBody>
+      </p:sp>
+      <p:sp>
+        <p:nvSpPr>
+          <p:cNvPr id="11" name="Rounded Rectangle 10"/>
+          <p:cNvSpPr/>
+          <p:nvPr/>
+        </p:nvSpPr>
+        <p:spPr>
+          <a:xfrm>
+            <a:off x="6217920" y="1645920"/>
+            <a:ext cx="5303520" cy="4114800"/>
+          </a:xfrm>
+          <a:prstGeom prst="roundRect">
+            <a:avLst/>
+          </a:prstGeom>
+          <a:solidFill>
+            <a:srgbClr val="141A2A"/>
+          </a:solidFill>
+          <a:ln w="19050">
+            <a:solidFill>
+              <a:srgbClr val="14B8A6"/>
+            </a:solidFill>
+          </a:ln>
+        </p:spPr>
+        <p:style>
+          <a:lnRef idx="1">
+            <a:schemeClr val="accent1"/>
+          </a:lnRef>
+          <a:fillRef idx="3">
+            <a:schemeClr val="accent1"/>
+          </a:fillRef>
+          <a:effectRef idx="2">
+            <a:schemeClr val="accent1"/>
+          </a:effectRef>
+          <a:fontRef idx="minor">
+            <a:schemeClr val="lt1"/>
+          </a:fontRef>
+        </p:style>
+        <p:txBody>
+          <a:bodyPr rtlCol="0" anchor="ctr"/>
+          <a:lstStyle/>
+          <a:p>
+            <a:pPr algn="ctr"/>
+          </a:p>
+        </p:txBody>
+      </p:sp>
+      <p:sp>
+        <p:nvSpPr>
+          <p:cNvPr id="12" name="TextBox 11"/>
+          <p:cNvSpPr txBox="1"/>
+          <p:nvPr/>
+        </p:nvSpPr>
+        <p:spPr>
+          <a:xfrm>
+            <a:off x="6492240" y="1828800"/>
+            <a:ext cx="4754880" cy="457200"/>
+          </a:xfrm>
+          <a:prstGeom prst="rect">
+            <a:avLst/>
+          </a:prstGeom>
+          <a:noFill/>
+        </p:spPr>
+        <p:txBody>
+          <a:bodyPr wrap="none">
+            <a:spAutoFit/>
+          </a:bodyPr>
+          <a:lstStyle/>
+          <a:p>
+            <a:pPr>
+              <a:defRPr sz="2000" b="1">
+                <a:solidFill>
+                  <a:srgbClr val="14B8A6"/>
+                </a:solidFill>
+              </a:defRPr>
+            </a:pPr>
+            <a:r>
+              <a:t>✅ AI Employee Thinking</a:t>
+            </a:r>
+          </a:p>
+        </p:txBody>
+      </p:sp>
+      <p:sp>
+        <p:nvSpPr>
+          <p:cNvPr id="13" name="TextBox 12"/>
+          <p:cNvSpPr txBox="1"/>
+          <p:nvPr/>
+        </p:nvSpPr>
+        <p:spPr>
+          <a:xfrm>
+            <a:off x="6492240" y="2468880"/>
+            <a:ext cx="4754880" cy="457200"/>
+          </a:xfrm>
+          <a:prstGeom prst="rect">
+            <a:avLst/>
+          </a:prstGeom>
+          <a:noFill/>
+        </p:spPr>
+        <p:txBody>
+          <a:bodyPr wrap="none">
+            <a:spAutoFit/>
+          </a:bodyPr>
+          <a:lstStyle/>
+          <a:p>
+            <a:pPr>
+              <a:defRPr sz="1500">
+                <a:solidFill>
+                  <a:srgbClr val="D1D5DB"/>
+                </a:solidFill>
+              </a:defRPr>
+            </a:pPr>
+            <a:r>
+              <a:t>Brain dump ALL tasks in one prompt</a:t>
+            </a:r>
+          </a:p>
+        </p:txBody>
+      </p:sp>
+      <p:sp>
+        <p:nvSpPr>
+          <p:cNvPr id="14" name="TextBox 13"/>
+          <p:cNvSpPr txBox="1"/>
+          <p:nvPr/>
+        </p:nvSpPr>
+        <p:spPr>
+          <a:xfrm>
+            <a:off x="6492240" y="2926080"/>
+            <a:ext cx="4754880" cy="457200"/>
+          </a:xfrm>
+          <a:prstGeom prst="rect">
+            <a:avLst/>
+          </a:prstGeom>
+          <a:noFill/>
+        </p:spPr>
+        <p:txBody>
+          <a:bodyPr wrap="none">
+            <a:spAutoFit/>
+          </a:bodyPr>
+          <a:lstStyle/>
+          <a:p>
+            <a:pPr>
+              <a:defRPr sz="1500">
+                <a:solidFill>
+                  <a:srgbClr val="D1D5DB"/>
+                </a:solidFill>
+              </a:defRPr>
+            </a:pPr>
+            <a:r>
+              <a:t>Hand off → Go do your real work</a:t>
+            </a:r>
+          </a:p>
+        </p:txBody>
+      </p:sp>
+      <p:sp>
+        <p:nvSpPr>
+          <p:cNvPr id="15" name="TextBox 14"/>
+          <p:cNvSpPr txBox="1"/>
+          <p:nvPr/>
+        </p:nvSpPr>
+        <p:spPr>
+          <a:xfrm>
+            <a:off x="6492240" y="3383280"/>
+            <a:ext cx="4754880" cy="457200"/>
+          </a:xfrm>
+          <a:prstGeom prst="rect">
+            <a:avLst/>
+          </a:prstGeom>
+          <a:noFill/>
+        </p:spPr>
+        <p:txBody>
+          <a:bodyPr wrap="none">
+            <a:spAutoFit/>
+          </a:bodyPr>
+          <a:lstStyle/>
+          <a:p>
+            <a:pPr>
+              <a:defRPr sz="1500">
+                <a:solidFill>
+                  <a:srgbClr val="D1D5DB"/>
+                </a:solidFill>
+              </a:defRPr>
+            </a:pPr>
+            <a:r>
+              <a:t>Come back to finished results</a:t>
+            </a:r>
+          </a:p>
+        </p:txBody>
+      </p:sp>
+      <p:sp>
+        <p:nvSpPr>
+          <p:cNvPr id="16" name="TextBox 15"/>
+          <p:cNvSpPr txBox="1"/>
+          <p:nvPr/>
+        </p:nvSpPr>
+        <p:spPr>
+          <a:xfrm>
+            <a:off x="6492240" y="3840480"/>
+            <a:ext cx="4754880" cy="457200"/>
+          </a:xfrm>
+          <a:prstGeom prst="rect">
+            <a:avLst/>
+          </a:prstGeom>
+          <a:noFill/>
+        </p:spPr>
+        <p:txBody>
+          <a:bodyPr wrap="none">
+            <a:spAutoFit/>
+          </a:bodyPr>
+          <a:lstStyle/>
+          <a:p>
+            <a:pPr>
+              <a:defRPr sz="1500">
+                <a:solidFill>
+                  <a:srgbClr val="D1D5DB"/>
+                </a:solidFill>
+              </a:defRPr>
+            </a:pPr>
+            <a:r>
+              <a:t>Review → Give feedback → Iterate</a:t>
+            </a:r>
+          </a:p>
+        </p:txBody>
+      </p:sp>
+      <p:sp>
+        <p:nvSpPr>
+          <p:cNvPr id="17" name="TextBox 16"/>
+          <p:cNvSpPr txBox="1"/>
+          <p:nvPr/>
+        </p:nvSpPr>
+        <p:spPr>
+          <a:xfrm>
+            <a:off x="6492240" y="4297680"/>
+            <a:ext cx="4754880" cy="457200"/>
+          </a:xfrm>
+          <a:prstGeom prst="rect">
+            <a:avLst/>
+          </a:prstGeom>
+          <a:noFill/>
+        </p:spPr>
+        <p:txBody>
+          <a:bodyPr wrap="none">
+            <a:spAutoFit/>
+          </a:bodyPr>
+          <a:lstStyle/>
+          <a:p>
+            <a:pPr>
+              <a:defRPr sz="1500">
+                <a:solidFill>
+                  <a:srgbClr val="14B8A6"/>
+                </a:solidFill>
+              </a:defRPr>
+            </a:pPr>
+            <a:r>
+              <a:t>1 session. Batched. Full context.</a:t>
             </a:r>
           </a:p>
         </p:txBody>

</xml_diff>